<commit_message>
Make report slides pictorial with vector SVG icons
Add topical line icons to the section items across 12 content slides
(agenda, materials, process overview/detail, equipment, QC, mandatory
tests, incidents, safety, environment, conclusion). Icons are embedded
as native OOXML SVG (svgBlip) with PNG fallback, so they stay crisp and
recolorable in PowerPoint 2016+. Numbered markers become compact badges
or are replaced by the matching icon.

Also recolor the multi-color divider bars on slides 10/18/21 to a
monochrome green stack to match the deck's green/amber palette. Slide 1
is unchanged. Regenerate the PDF export accordingly.

Co-Authored-By: Claude Opus 4.8 <noreply@anthropic.com>
Claude-Session: https://claude.ai/code/session_01PbbxSyJEYscgmQfTL8vaUX
</commit_message>
<xml_diff>
--- a/SuHeo/Báo cáo thực tập - Sơn Hải Vân.pptx
+++ b/SuHeo/Báo cáo thực tập - Sơn Hải Vân.pptx
@@ -4173,7 +4173,7 @@
             </a:avLst>
           </a:prstGeom>
           <a:solidFill>
-            <a:srgbClr val="8C3B2E"/>
+            <a:srgbClr val="1F4E3D"/>
           </a:solidFill>
           <a:ln w="19050">
             <a:solidFill>
@@ -4221,7 +4221,7 @@
             </a:avLst>
           </a:prstGeom>
           <a:solidFill>
-            <a:srgbClr val="B56A3B"/>
+            <a:srgbClr val="3E8C6A"/>
           </a:solidFill>
           <a:ln w="19050">
             <a:solidFill>
@@ -4269,7 +4269,7 @@
             </a:avLst>
           </a:prstGeom>
           <a:solidFill>
-            <a:srgbClr val="4A4F54"/>
+            <a:srgbClr val="2C7A5A"/>
           </a:solidFill>
           <a:ln w="19050">
             <a:solidFill>
@@ -4365,7 +4365,7 @@
             </a:avLst>
           </a:prstGeom>
           <a:solidFill>
-            <a:srgbClr val="243B53"/>
+            <a:srgbClr val="14332A"/>
           </a:solidFill>
           <a:ln w="19050">
             <a:solidFill>
@@ -4986,8 +4986,8 @@
         </p:nvSpPr>
         <p:spPr>
           <a:xfrm>
-            <a:off x="1046988" y="2487168"/>
-            <a:ext cx="603504" cy="603504"/>
+            <a:off x="508640" y="2236000"/>
+            <a:ext cx="330000" cy="330000"/>
           </a:xfrm>
           <a:prstGeom prst="ellipse">
             <a:avLst/>
@@ -5030,8 +5030,8 @@
         </p:nvSpPr>
         <p:spPr>
           <a:xfrm>
-            <a:off x="1046988" y="2487168"/>
-            <a:ext cx="603504" cy="603504"/>
+            <a:off x="508640" y="2236000"/>
+            <a:ext cx="330000" cy="330000"/>
           </a:xfrm>
           <a:prstGeom prst="rect">
             <a:avLst/>
@@ -5046,7 +5046,7 @@
           <a:p>
             <a:pPr algn="ctr"/>
             <a:r>
-              <a:rPr sz="2000" b="1" i="0">
+              <a:rPr sz="1300" b="1" i="0">
                 <a:solidFill>
                   <a:srgbClr val="FFFFFF"/>
                 </a:solidFill>
@@ -5065,7 +5065,7 @@
         </p:nvSpPr>
         <p:spPr>
           <a:xfrm>
-            <a:off x="640080" y="3182112"/>
+            <a:off x="640080" y="3170000"/>
             <a:ext cx="1417320" cy="594360"/>
           </a:xfrm>
           <a:prstGeom prst="rect">
@@ -5196,8 +5196,8 @@
         </p:nvSpPr>
         <p:spPr>
           <a:xfrm>
-            <a:off x="2903220" y="2487168"/>
-            <a:ext cx="603504" cy="603504"/>
+            <a:off x="2364872" y="2236000"/>
+            <a:ext cx="330000" cy="330000"/>
           </a:xfrm>
           <a:prstGeom prst="ellipse">
             <a:avLst/>
@@ -5240,8 +5240,8 @@
         </p:nvSpPr>
         <p:spPr>
           <a:xfrm>
-            <a:off x="2903220" y="2487168"/>
-            <a:ext cx="603504" cy="603504"/>
+            <a:off x="2364872" y="2236000"/>
+            <a:ext cx="330000" cy="330000"/>
           </a:xfrm>
           <a:prstGeom prst="rect">
             <a:avLst/>
@@ -5256,7 +5256,7 @@
           <a:p>
             <a:pPr algn="ctr"/>
             <a:r>
-              <a:rPr sz="2000" b="1" i="0">
+              <a:rPr sz="1300" b="1" i="0">
                 <a:solidFill>
                   <a:srgbClr val="FFFFFF"/>
                 </a:solidFill>
@@ -5275,7 +5275,7 @@
         </p:nvSpPr>
         <p:spPr>
           <a:xfrm>
-            <a:off x="2496312" y="3182112"/>
+            <a:off x="2496312" y="3170000"/>
             <a:ext cx="1417320" cy="594360"/>
           </a:xfrm>
           <a:prstGeom prst="rect">
@@ -5406,8 +5406,8 @@
         </p:nvSpPr>
         <p:spPr>
           <a:xfrm>
-            <a:off x="4759452" y="2487168"/>
-            <a:ext cx="603504" cy="603504"/>
+            <a:off x="4221104" y="2236000"/>
+            <a:ext cx="330000" cy="330000"/>
           </a:xfrm>
           <a:prstGeom prst="ellipse">
             <a:avLst/>
@@ -5450,8 +5450,8 @@
         </p:nvSpPr>
         <p:spPr>
           <a:xfrm>
-            <a:off x="4759452" y="2487168"/>
-            <a:ext cx="603504" cy="603504"/>
+            <a:off x="4221104" y="2236000"/>
+            <a:ext cx="330000" cy="330000"/>
           </a:xfrm>
           <a:prstGeom prst="rect">
             <a:avLst/>
@@ -5466,7 +5466,7 @@
           <a:p>
             <a:pPr algn="ctr"/>
             <a:r>
-              <a:rPr sz="2000" b="1" i="0">
+              <a:rPr sz="1300" b="1" i="0">
                 <a:solidFill>
                   <a:srgbClr val="FFFFFF"/>
                 </a:solidFill>
@@ -5485,7 +5485,7 @@
         </p:nvSpPr>
         <p:spPr>
           <a:xfrm>
-            <a:off x="4352544" y="3182112"/>
+            <a:off x="4352544" y="3170000"/>
             <a:ext cx="1417320" cy="594360"/>
           </a:xfrm>
           <a:prstGeom prst="rect">
@@ -5616,8 +5616,8 @@
         </p:nvSpPr>
         <p:spPr>
           <a:xfrm>
-            <a:off x="6615684" y="2487168"/>
-            <a:ext cx="603504" cy="603504"/>
+            <a:off x="6077336" y="2236000"/>
+            <a:ext cx="330000" cy="330000"/>
           </a:xfrm>
           <a:prstGeom prst="ellipse">
             <a:avLst/>
@@ -5660,8 +5660,8 @@
         </p:nvSpPr>
         <p:spPr>
           <a:xfrm>
-            <a:off x="6615684" y="2487168"/>
-            <a:ext cx="603504" cy="603504"/>
+            <a:off x="6077336" y="2236000"/>
+            <a:ext cx="330000" cy="330000"/>
           </a:xfrm>
           <a:prstGeom prst="rect">
             <a:avLst/>
@@ -5676,7 +5676,7 @@
           <a:p>
             <a:pPr algn="ctr"/>
             <a:r>
-              <a:rPr sz="2000" b="1" i="0">
+              <a:rPr sz="1300" b="1" i="0">
                 <a:solidFill>
                   <a:srgbClr val="FFFFFF"/>
                 </a:solidFill>
@@ -5695,7 +5695,7 @@
         </p:nvSpPr>
         <p:spPr>
           <a:xfrm>
-            <a:off x="6208776" y="3182112"/>
+            <a:off x="6208776" y="3170000"/>
             <a:ext cx="1417320" cy="594360"/>
           </a:xfrm>
           <a:prstGeom prst="rect">
@@ -5826,8 +5826,8 @@
         </p:nvSpPr>
         <p:spPr>
           <a:xfrm>
-            <a:off x="8471916" y="2487168"/>
-            <a:ext cx="603504" cy="603504"/>
+            <a:off x="7933568" y="2236000"/>
+            <a:ext cx="330000" cy="330000"/>
           </a:xfrm>
           <a:prstGeom prst="ellipse">
             <a:avLst/>
@@ -5870,8 +5870,8 @@
         </p:nvSpPr>
         <p:spPr>
           <a:xfrm>
-            <a:off x="8471916" y="2487168"/>
-            <a:ext cx="603504" cy="603504"/>
+            <a:off x="7933568" y="2236000"/>
+            <a:ext cx="330000" cy="330000"/>
           </a:xfrm>
           <a:prstGeom prst="rect">
             <a:avLst/>
@@ -5886,7 +5886,7 @@
           <a:p>
             <a:pPr algn="ctr"/>
             <a:r>
-              <a:rPr sz="2000" b="1" i="0">
+              <a:rPr sz="1300" b="1" i="0">
                 <a:solidFill>
                   <a:srgbClr val="FFFFFF"/>
                 </a:solidFill>
@@ -5905,7 +5905,7 @@
         </p:nvSpPr>
         <p:spPr>
           <a:xfrm>
-            <a:off x="8065008" y="3182112"/>
+            <a:off x="8065008" y="3170000"/>
             <a:ext cx="1417320" cy="594360"/>
           </a:xfrm>
           <a:prstGeom prst="rect">
@@ -6036,8 +6036,8 @@
         </p:nvSpPr>
         <p:spPr>
           <a:xfrm>
-            <a:off x="10328148" y="2487168"/>
-            <a:ext cx="603504" cy="603504"/>
+            <a:off x="9789800" y="2236000"/>
+            <a:ext cx="330000" cy="330000"/>
           </a:xfrm>
           <a:prstGeom prst="ellipse">
             <a:avLst/>
@@ -6080,8 +6080,8 @@
         </p:nvSpPr>
         <p:spPr>
           <a:xfrm>
-            <a:off x="10328148" y="2487168"/>
-            <a:ext cx="603504" cy="603504"/>
+            <a:off x="9789800" y="2236000"/>
+            <a:ext cx="330000" cy="330000"/>
           </a:xfrm>
           <a:prstGeom prst="rect">
             <a:avLst/>
@@ -6096,7 +6096,7 @@
           <a:p>
             <a:pPr algn="ctr"/>
             <a:r>
-              <a:rPr sz="2000" b="1" i="0">
+              <a:rPr sz="1300" b="1" i="0">
                 <a:solidFill>
                   <a:srgbClr val="FFFFFF"/>
                 </a:solidFill>
@@ -6115,7 +6115,7 @@
         </p:nvSpPr>
         <p:spPr>
           <a:xfrm>
-            <a:off x="9921240" y="3182112"/>
+            <a:off x="9921240" y="3170000"/>
             <a:ext cx="1417320" cy="594360"/>
           </a:xfrm>
           <a:prstGeom prst="rect">
@@ -6338,6 +6338,186 @@
           </a:p>
         </p:txBody>
       </p:sp>
+      <p:pic>
+        <p:nvPicPr>
+          <p:cNvPr id="119" name="Picture 118" descr="dinh_luong_g.png"/>
+          <p:cNvPicPr>
+            <a:picLocks noChangeAspect="1"/>
+          </p:cNvPicPr>
+          <p:nvPr/>
+        </p:nvPicPr>
+        <p:blipFill>
+          <a:blip r:embed="rId2">
+            <a:extLst>
+              <a:ext uri="{96DAC541-7B7A-43D3-8B79-37D633B846F1}">
+                <ns0:svgBlip xmlns:ns0="http://schemas.microsoft.com/office/drawing/2016/SVG/main" r:embed="rId9"/>
+              </a:ext>
+            </a:extLst>
+          </a:blip>
+          <a:stretch>
+            <a:fillRect/>
+          </a:stretch>
+        </p:blipFill>
+        <p:spPr>
+          <a:xfrm>
+            <a:off x="1018740" y="2496000"/>
+            <a:ext cx="660000" cy="660000"/>
+          </a:xfrm>
+          <a:prstGeom prst="rect">
+            <a:avLst/>
+          </a:prstGeom>
+        </p:spPr>
+      </p:pic>
+      <p:pic>
+        <p:nvPicPr>
+          <p:cNvPr id="120" name="Picture 119" descr="danh_paste_g.png"/>
+          <p:cNvPicPr>
+            <a:picLocks noChangeAspect="1"/>
+          </p:cNvPicPr>
+          <p:nvPr/>
+        </p:nvPicPr>
+        <p:blipFill>
+          <a:blip r:embed="rId3">
+            <a:extLst>
+              <a:ext uri="{96DAC541-7B7A-43D3-8B79-37D633B846F1}">
+                <ns1:svgBlip xmlns:ns1="http://schemas.microsoft.com/office/drawing/2016/SVG/main" r:embed="rId8"/>
+              </a:ext>
+            </a:extLst>
+          </a:blip>
+          <a:stretch>
+            <a:fillRect/>
+          </a:stretch>
+        </p:blipFill>
+        <p:spPr>
+          <a:xfrm>
+            <a:off x="2874972" y="2496000"/>
+            <a:ext cx="660000" cy="660000"/>
+          </a:xfrm>
+          <a:prstGeom prst="rect">
+            <a:avLst/>
+          </a:prstGeom>
+        </p:spPr>
+      </p:pic>
+      <p:pic>
+        <p:nvPicPr>
+          <p:cNvPr id="121" name="Picture 120" descr="nghien_min_g.png"/>
+          <p:cNvPicPr>
+            <a:picLocks noChangeAspect="1"/>
+          </p:cNvPicPr>
+          <p:nvPr/>
+        </p:nvPicPr>
+        <p:blipFill>
+          <a:blip r:embed="rId4">
+            <a:extLst>
+              <a:ext uri="{96DAC541-7B7A-43D3-8B79-37D633B846F1}">
+                <ns2:svgBlip xmlns:ns2="http://schemas.microsoft.com/office/drawing/2016/SVG/main" r:embed="rId12"/>
+              </a:ext>
+            </a:extLst>
+          </a:blip>
+          <a:stretch>
+            <a:fillRect/>
+          </a:stretch>
+        </p:blipFill>
+        <p:spPr>
+          <a:xfrm>
+            <a:off x="4731204" y="2496000"/>
+            <a:ext cx="660000" cy="660000"/>
+          </a:xfrm>
+          <a:prstGeom prst="rect">
+            <a:avLst/>
+          </a:prstGeom>
+        </p:spPr>
+      </p:pic>
+      <p:pic>
+        <p:nvPicPr>
+          <p:cNvPr id="122" name="Picture 121" descr="ngam_u_g.png"/>
+          <p:cNvPicPr>
+            <a:picLocks noChangeAspect="1"/>
+          </p:cNvPicPr>
+          <p:nvPr/>
+        </p:nvPicPr>
+        <p:blipFill>
+          <a:blip r:embed="rId5">
+            <a:extLst>
+              <a:ext uri="{96DAC541-7B7A-43D3-8B79-37D633B846F1}">
+                <ns3:svgBlip xmlns:ns3="http://schemas.microsoft.com/office/drawing/2016/SVG/main" r:embed="rId11"/>
+              </a:ext>
+            </a:extLst>
+          </a:blip>
+          <a:stretch>
+            <a:fillRect/>
+          </a:stretch>
+        </p:blipFill>
+        <p:spPr>
+          <a:xfrm>
+            <a:off x="6587436" y="2496000"/>
+            <a:ext cx="660000" cy="660000"/>
+          </a:xfrm>
+          <a:prstGeom prst="rect">
+            <a:avLst/>
+          </a:prstGeom>
+        </p:spPr>
+      </p:pic>
+      <p:pic>
+        <p:nvPicPr>
+          <p:cNvPr id="123" name="Picture 122" descr="pha_loang_g.png"/>
+          <p:cNvPicPr>
+            <a:picLocks noChangeAspect="1"/>
+          </p:cNvPicPr>
+          <p:nvPr/>
+        </p:nvPicPr>
+        <p:blipFill>
+          <a:blip r:embed="rId6">
+            <a:extLst>
+              <a:ext uri="{96DAC541-7B7A-43D3-8B79-37D633B846F1}">
+                <ns4:svgBlip xmlns:ns4="http://schemas.microsoft.com/office/drawing/2016/SVG/main" r:embed="rId13"/>
+              </a:ext>
+            </a:extLst>
+          </a:blip>
+          <a:stretch>
+            <a:fillRect/>
+          </a:stretch>
+        </p:blipFill>
+        <p:spPr>
+          <a:xfrm>
+            <a:off x="8443668" y="2496000"/>
+            <a:ext cx="660000" cy="660000"/>
+          </a:xfrm>
+          <a:prstGeom prst="rect">
+            <a:avLst/>
+          </a:prstGeom>
+        </p:spPr>
+      </p:pic>
+      <p:pic>
+        <p:nvPicPr>
+          <p:cNvPr id="124" name="Picture 123" descr="loc_donggoi_g.png"/>
+          <p:cNvPicPr>
+            <a:picLocks noChangeAspect="1"/>
+          </p:cNvPicPr>
+          <p:nvPr/>
+        </p:nvPicPr>
+        <p:blipFill>
+          <a:blip r:embed="rId7">
+            <a:extLst>
+              <a:ext uri="{96DAC541-7B7A-43D3-8B79-37D633B846F1}">
+                <ns5:svgBlip xmlns:ns5="http://schemas.microsoft.com/office/drawing/2016/SVG/main" r:embed="rId10"/>
+              </a:ext>
+            </a:extLst>
+          </a:blip>
+          <a:stretch>
+            <a:fillRect/>
+          </a:stretch>
+        </p:blipFill>
+        <p:spPr>
+          <a:xfrm>
+            <a:off x="10299900" y="2496000"/>
+            <a:ext cx="660000" cy="660000"/>
+          </a:xfrm>
+          <a:prstGeom prst="rect">
+            <a:avLst/>
+          </a:prstGeom>
+        </p:spPr>
+      </p:pic>
     </p:spTree>
   </p:cSld>
   <p:clrMapOvr>
@@ -8315,7 +8495,7 @@
                 </a:solidFill>
                 <a:latin typeface="Cambria"/>
               </a:rPr>
-              <a:t>1</a:t>
+              <a:t/>
             </a:r>
           </a:p>
         </p:txBody>
@@ -8641,7 +8821,7 @@
                 </a:solidFill>
                 <a:latin typeface="Cambria"/>
               </a:rPr>
-              <a:t>2</a:t>
+              <a:t/>
             </a:r>
           </a:p>
         </p:txBody>
@@ -8967,7 +9147,7 @@
                 </a:solidFill>
                 <a:latin typeface="Cambria"/>
               </a:rPr>
-              <a:t>3</a:t>
+              <a:t/>
             </a:r>
           </a:p>
         </p:txBody>
@@ -9293,7 +9473,7 @@
                 </a:solidFill>
                 <a:latin typeface="Cambria"/>
               </a:rPr>
-              <a:t>4</a:t>
+              <a:t/>
             </a:r>
           </a:p>
         </p:txBody>
@@ -9619,7 +9799,7 @@
                 </a:solidFill>
                 <a:latin typeface="Cambria"/>
               </a:rPr>
-              <a:t>5</a:t>
+              <a:t/>
             </a:r>
           </a:p>
         </p:txBody>
@@ -9945,7 +10125,7 @@
                 </a:solidFill>
                 <a:latin typeface="Cambria"/>
               </a:rPr>
-              <a:t>6</a:t>
+              <a:t/>
             </a:r>
           </a:p>
         </p:txBody>
@@ -10223,6 +10403,186 @@
           </a:p>
         </p:txBody>
       </p:sp>
+      <p:pic>
+        <p:nvPicPr>
+          <p:cNvPr id="172" name="Picture 171" descr="dinh_luong_w.png"/>
+          <p:cNvPicPr>
+            <a:picLocks noChangeAspect="1"/>
+          </p:cNvPicPr>
+          <p:nvPr/>
+        </p:nvPicPr>
+        <p:blipFill>
+          <a:blip r:embed="rId2">
+            <a:extLst>
+              <a:ext uri="{96DAC541-7B7A-43D3-8B79-37D633B846F1}">
+                <ns0:svgBlip xmlns:ns0="http://schemas.microsoft.com/office/drawing/2016/SVG/main" r:embed="rId9"/>
+              </a:ext>
+            </a:extLst>
+          </a:blip>
+          <a:stretch>
+            <a:fillRect/>
+          </a:stretch>
+        </p:blipFill>
+        <p:spPr>
+          <a:xfrm>
+            <a:off x="795528" y="1673352"/>
+            <a:ext cx="246888" cy="246888"/>
+          </a:xfrm>
+          <a:prstGeom prst="rect">
+            <a:avLst/>
+          </a:prstGeom>
+        </p:spPr>
+      </p:pic>
+      <p:pic>
+        <p:nvPicPr>
+          <p:cNvPr id="173" name="Picture 172" descr="danh_paste_w.png"/>
+          <p:cNvPicPr>
+            <a:picLocks noChangeAspect="1"/>
+          </p:cNvPicPr>
+          <p:nvPr/>
+        </p:nvPicPr>
+        <p:blipFill>
+          <a:blip r:embed="rId3">
+            <a:extLst>
+              <a:ext uri="{96DAC541-7B7A-43D3-8B79-37D633B846F1}">
+                <ns1:svgBlip xmlns:ns1="http://schemas.microsoft.com/office/drawing/2016/SVG/main" r:embed="rId8"/>
+              </a:ext>
+            </a:extLst>
+          </a:blip>
+          <a:stretch>
+            <a:fillRect/>
+          </a:stretch>
+        </p:blipFill>
+        <p:spPr>
+          <a:xfrm>
+            <a:off x="795528" y="2441448"/>
+            <a:ext cx="246888" cy="246888"/>
+          </a:xfrm>
+          <a:prstGeom prst="rect">
+            <a:avLst/>
+          </a:prstGeom>
+        </p:spPr>
+      </p:pic>
+      <p:pic>
+        <p:nvPicPr>
+          <p:cNvPr id="174" name="Picture 173" descr="nghien_min_g.png"/>
+          <p:cNvPicPr>
+            <a:picLocks noChangeAspect="1"/>
+          </p:cNvPicPr>
+          <p:nvPr/>
+        </p:nvPicPr>
+        <p:blipFill>
+          <a:blip r:embed="rId4">
+            <a:extLst>
+              <a:ext uri="{96DAC541-7B7A-43D3-8B79-37D633B846F1}">
+                <ns2:svgBlip xmlns:ns2="http://schemas.microsoft.com/office/drawing/2016/SVG/main" r:embed="rId12"/>
+              </a:ext>
+            </a:extLst>
+          </a:blip>
+          <a:stretch>
+            <a:fillRect/>
+          </a:stretch>
+        </p:blipFill>
+        <p:spPr>
+          <a:xfrm>
+            <a:off x="795528" y="3209544"/>
+            <a:ext cx="246888" cy="246888"/>
+          </a:xfrm>
+          <a:prstGeom prst="rect">
+            <a:avLst/>
+          </a:prstGeom>
+        </p:spPr>
+      </p:pic>
+      <p:pic>
+        <p:nvPicPr>
+          <p:cNvPr id="175" name="Picture 174" descr="ngam_u_w.png"/>
+          <p:cNvPicPr>
+            <a:picLocks noChangeAspect="1"/>
+          </p:cNvPicPr>
+          <p:nvPr/>
+        </p:nvPicPr>
+        <p:blipFill>
+          <a:blip r:embed="rId5">
+            <a:extLst>
+              <a:ext uri="{96DAC541-7B7A-43D3-8B79-37D633B846F1}">
+                <ns3:svgBlip xmlns:ns3="http://schemas.microsoft.com/office/drawing/2016/SVG/main" r:embed="rId11"/>
+              </a:ext>
+            </a:extLst>
+          </a:blip>
+          <a:stretch>
+            <a:fillRect/>
+          </a:stretch>
+        </p:blipFill>
+        <p:spPr>
+          <a:xfrm>
+            <a:off x="795528" y="3977640"/>
+            <a:ext cx="246888" cy="246888"/>
+          </a:xfrm>
+          <a:prstGeom prst="rect">
+            <a:avLst/>
+          </a:prstGeom>
+        </p:spPr>
+      </p:pic>
+      <p:pic>
+        <p:nvPicPr>
+          <p:cNvPr id="176" name="Picture 175" descr="pha_loang_w.png"/>
+          <p:cNvPicPr>
+            <a:picLocks noChangeAspect="1"/>
+          </p:cNvPicPr>
+          <p:nvPr/>
+        </p:nvPicPr>
+        <p:blipFill>
+          <a:blip r:embed="rId6">
+            <a:extLst>
+              <a:ext uri="{96DAC541-7B7A-43D3-8B79-37D633B846F1}">
+                <ns4:svgBlip xmlns:ns4="http://schemas.microsoft.com/office/drawing/2016/SVG/main" r:embed="rId13"/>
+              </a:ext>
+            </a:extLst>
+          </a:blip>
+          <a:stretch>
+            <a:fillRect/>
+          </a:stretch>
+        </p:blipFill>
+        <p:spPr>
+          <a:xfrm>
+            <a:off x="795528" y="4745736"/>
+            <a:ext cx="246888" cy="246888"/>
+          </a:xfrm>
+          <a:prstGeom prst="rect">
+            <a:avLst/>
+          </a:prstGeom>
+        </p:spPr>
+      </p:pic>
+      <p:pic>
+        <p:nvPicPr>
+          <p:cNvPr id="177" name="Picture 176" descr="loc_donggoi_w.png"/>
+          <p:cNvPicPr>
+            <a:picLocks noChangeAspect="1"/>
+          </p:cNvPicPr>
+          <p:nvPr/>
+        </p:nvPicPr>
+        <p:blipFill>
+          <a:blip r:embed="rId7">
+            <a:extLst>
+              <a:ext uri="{96DAC541-7B7A-43D3-8B79-37D633B846F1}">
+                <ns5:svgBlip xmlns:ns5="http://schemas.microsoft.com/office/drawing/2016/SVG/main" r:embed="rId10"/>
+              </a:ext>
+            </a:extLst>
+          </a:blip>
+          <a:stretch>
+            <a:fillRect/>
+          </a:stretch>
+        </p:blipFill>
+        <p:spPr>
+          <a:xfrm>
+            <a:off x="795528" y="5513832"/>
+            <a:ext cx="246888" cy="246888"/>
+          </a:xfrm>
+          <a:prstGeom prst="rect">
+            <a:avLst/>
+          </a:prstGeom>
+        </p:spPr>
+      </p:pic>
     </p:spTree>
   </p:cSld>
   <p:clrMapOvr>
@@ -12439,8 +12799,8 @@
         </p:nvSpPr>
         <p:spPr>
           <a:xfrm>
-            <a:off x="777240" y="1463040"/>
-            <a:ext cx="3154680" cy="822960"/>
+            <a:off x="1277240" y="1463040"/>
+            <a:ext cx="2654680" cy="822960"/>
           </a:xfrm>
           <a:prstGeom prst="rect">
             <a:avLst/>
@@ -12803,8 +13163,8 @@
         </p:nvSpPr>
         <p:spPr>
           <a:xfrm>
-            <a:off x="4645152" y="1463040"/>
-            <a:ext cx="3154680" cy="822960"/>
+            <a:off x="5145152" y="1463040"/>
+            <a:ext cx="2654680" cy="822960"/>
           </a:xfrm>
           <a:prstGeom prst="rect">
             <a:avLst/>
@@ -13167,8 +13527,8 @@
         </p:nvSpPr>
         <p:spPr>
           <a:xfrm>
-            <a:off x="8513064" y="1463040"/>
-            <a:ext cx="3154680" cy="822960"/>
+            <a:off x="9013064" y="1463040"/>
+            <a:ext cx="2654680" cy="822960"/>
           </a:xfrm>
           <a:prstGeom prst="rect">
             <a:avLst/>
@@ -13455,6 +13815,96 @@
           </a:p>
         </p:txBody>
       </p:sp>
+      <p:pic>
+        <p:nvPicPr>
+          <p:cNvPr id="124" name="Picture 123" descr="danh_paste_w.png"/>
+          <p:cNvPicPr>
+            <a:picLocks noChangeAspect="1"/>
+          </p:cNvPicPr>
+          <p:nvPr/>
+        </p:nvPicPr>
+        <p:blipFill>
+          <a:blip r:embed="rId5">
+            <a:extLst>
+              <a:ext uri="{96DAC541-7B7A-43D3-8B79-37D633B846F1}">
+                <ns0:svgBlip xmlns:ns0="http://schemas.microsoft.com/office/drawing/2016/SVG/main" r:embed="rId8"/>
+              </a:ext>
+            </a:extLst>
+          </a:blip>
+          <a:stretch>
+            <a:fillRect/>
+          </a:stretch>
+        </p:blipFill>
+        <p:spPr>
+          <a:xfrm>
+            <a:off x="698640" y="1664520"/>
+            <a:ext cx="420000" cy="420000"/>
+          </a:xfrm>
+          <a:prstGeom prst="rect">
+            <a:avLst/>
+          </a:prstGeom>
+        </p:spPr>
+      </p:pic>
+      <p:pic>
+        <p:nvPicPr>
+          <p:cNvPr id="125" name="Picture 124" descr="nghien_min_w.png"/>
+          <p:cNvPicPr>
+            <a:picLocks noChangeAspect="1"/>
+          </p:cNvPicPr>
+          <p:nvPr/>
+        </p:nvPicPr>
+        <p:blipFill>
+          <a:blip r:embed="rId6">
+            <a:extLst>
+              <a:ext uri="{96DAC541-7B7A-43D3-8B79-37D633B846F1}">
+                <ns1:svgBlip xmlns:ns1="http://schemas.microsoft.com/office/drawing/2016/SVG/main" r:embed="rId9"/>
+              </a:ext>
+            </a:extLst>
+          </a:blip>
+          <a:stretch>
+            <a:fillRect/>
+          </a:stretch>
+        </p:blipFill>
+        <p:spPr>
+          <a:xfrm>
+            <a:off x="4566552" y="1664520"/>
+            <a:ext cx="420000" cy="420000"/>
+          </a:xfrm>
+          <a:prstGeom prst="rect">
+            <a:avLst/>
+          </a:prstGeom>
+        </p:spPr>
+      </p:pic>
+      <p:pic>
+        <p:nvPicPr>
+          <p:cNvPr id="126" name="Picture 125" descr="pha_loang_w.png"/>
+          <p:cNvPicPr>
+            <a:picLocks noChangeAspect="1"/>
+          </p:cNvPicPr>
+          <p:nvPr/>
+        </p:nvPicPr>
+        <p:blipFill>
+          <a:blip r:embed="rId7">
+            <a:extLst>
+              <a:ext uri="{96DAC541-7B7A-43D3-8B79-37D633B846F1}">
+                <ns2:svgBlip xmlns:ns2="http://schemas.microsoft.com/office/drawing/2016/SVG/main" r:embed="rId10"/>
+              </a:ext>
+            </a:extLst>
+          </a:blip>
+          <a:stretch>
+            <a:fillRect/>
+          </a:stretch>
+        </p:blipFill>
+        <p:spPr>
+          <a:xfrm>
+            <a:off x="8434464" y="1664520"/>
+            <a:ext cx="420000" cy="420000"/>
+          </a:xfrm>
+          <a:prstGeom prst="rect">
+            <a:avLst/>
+          </a:prstGeom>
+        </p:spPr>
+      </p:pic>
     </p:spTree>
   </p:cSld>
   <p:clrMapOvr>
@@ -15898,8 +16348,8 @@
         </p:nvSpPr>
         <p:spPr>
           <a:xfrm>
-            <a:off x="822960" y="1554480"/>
-            <a:ext cx="4937760" cy="822960"/>
+            <a:off x="1342960" y="1554480"/>
+            <a:ext cx="4417760" cy="822960"/>
           </a:xfrm>
           <a:prstGeom prst="rect">
             <a:avLst/>
@@ -16263,8 +16713,8 @@
         </p:nvSpPr>
         <p:spPr>
           <a:xfrm>
-            <a:off x="6492240" y="1554480"/>
-            <a:ext cx="4937760" cy="822960"/>
+            <a:off x="7012240" y="1554480"/>
+            <a:ext cx="4417760" cy="822960"/>
           </a:xfrm>
           <a:prstGeom prst="rect">
             <a:avLst/>
@@ -16527,6 +16977,66 @@
           </a:p>
         </p:txBody>
       </p:sp>
+      <p:pic>
+        <p:nvPicPr>
+          <p:cNvPr id="54" name="Picture 53" descr="stopwatch_w.png"/>
+          <p:cNvPicPr>
+            <a:picLocks noChangeAspect="1"/>
+          </p:cNvPicPr>
+          <p:nvPr/>
+        </p:nvPicPr>
+        <p:blipFill>
+          <a:blip r:embed="rId2">
+            <a:extLst>
+              <a:ext uri="{96DAC541-7B7A-43D3-8B79-37D633B846F1}">
+                <ns0:svgBlip xmlns:ns0="http://schemas.microsoft.com/office/drawing/2016/SVG/main" r:embed="rId5"/>
+              </a:ext>
+            </a:extLst>
+          </a:blip>
+          <a:stretch>
+            <a:fillRect/>
+          </a:stretch>
+        </p:blipFill>
+        <p:spPr>
+          <a:xfrm>
+            <a:off x="698640" y="1750960"/>
+            <a:ext cx="430000" cy="430000"/>
+          </a:xfrm>
+          <a:prstGeom prst="rect">
+            <a:avLst/>
+          </a:prstGeom>
+        </p:spPr>
+      </p:pic>
+      <p:pic>
+        <p:nvPicPr>
+          <p:cNvPr id="55" name="Picture 54" descr="microscope_w.png"/>
+          <p:cNvPicPr>
+            <a:picLocks noChangeAspect="1"/>
+          </p:cNvPicPr>
+          <p:nvPr/>
+        </p:nvPicPr>
+        <p:blipFill>
+          <a:blip r:embed="rId3">
+            <a:extLst>
+              <a:ext uri="{96DAC541-7B7A-43D3-8B79-37D633B846F1}">
+                <ns1:svgBlip xmlns:ns1="http://schemas.microsoft.com/office/drawing/2016/SVG/main" r:embed="rId4"/>
+              </a:ext>
+            </a:extLst>
+          </a:blip>
+          <a:stretch>
+            <a:fillRect/>
+          </a:stretch>
+        </p:blipFill>
+        <p:spPr>
+          <a:xfrm>
+            <a:off x="6367920" y="1750960"/>
+            <a:ext cx="430000" cy="430000"/>
+          </a:xfrm>
+          <a:prstGeom prst="rect">
+            <a:avLst/>
+          </a:prstGeom>
+        </p:spPr>
+      </p:pic>
     </p:spTree>
   </p:cSld>
   <p:clrMapOvr>
@@ -17675,7 +18185,7 @@
                 </a:solidFill>
                 <a:latin typeface="Cambria"/>
               </a:rPr>
-              <a:t>1</a:t>
+              <a:t/>
             </a:r>
           </a:p>
         </p:txBody>
@@ -17941,7 +18451,7 @@
                 </a:solidFill>
                 <a:latin typeface="Cambria"/>
               </a:rPr>
-              <a:t>2</a:t>
+              <a:t/>
             </a:r>
           </a:p>
         </p:txBody>
@@ -18207,7 +18717,7 @@
                 </a:solidFill>
                 <a:latin typeface="Cambria"/>
               </a:rPr>
-              <a:t>3</a:t>
+              <a:t/>
             </a:r>
           </a:p>
         </p:txBody>
@@ -18375,6 +18885,96 @@
           </a:p>
         </p:txBody>
       </p:sp>
+      <p:pic>
+        <p:nvPicPr>
+          <p:cNvPr id="94" name="Picture 93" descr="adhesion_w.png"/>
+          <p:cNvPicPr>
+            <a:picLocks noChangeAspect="1"/>
+          </p:cNvPicPr>
+          <p:nvPr/>
+        </p:nvPicPr>
+        <p:blipFill>
+          <a:blip r:embed="rId2">
+            <a:extLst>
+              <a:ext uri="{96DAC541-7B7A-43D3-8B79-37D633B846F1}">
+                <ns0:svgBlip xmlns:ns0="http://schemas.microsoft.com/office/drawing/2016/SVG/main" r:embed="rId5"/>
+              </a:ext>
+            </a:extLst>
+          </a:blip>
+          <a:stretch>
+            <a:fillRect/>
+          </a:stretch>
+        </p:blipFill>
+        <p:spPr>
+          <a:xfrm>
+            <a:off x="954440" y="2454056"/>
+            <a:ext cx="560000" cy="560000"/>
+          </a:xfrm>
+          <a:prstGeom prst="rect">
+            <a:avLst/>
+          </a:prstGeom>
+        </p:spPr>
+      </p:pic>
+      <p:pic>
+        <p:nvPicPr>
+          <p:cNvPr id="95" name="Picture 94" descr="salt_spray_w.png"/>
+          <p:cNvPicPr>
+            <a:picLocks noChangeAspect="1"/>
+          </p:cNvPicPr>
+          <p:nvPr/>
+        </p:nvPicPr>
+        <p:blipFill>
+          <a:blip r:embed="rId3">
+            <a:extLst>
+              <a:ext uri="{96DAC541-7B7A-43D3-8B79-37D633B846F1}">
+                <ns1:svgBlip xmlns:ns1="http://schemas.microsoft.com/office/drawing/2016/SVG/main" r:embed="rId6"/>
+              </a:ext>
+            </a:extLst>
+          </a:blip>
+          <a:stretch>
+            <a:fillRect/>
+          </a:stretch>
+        </p:blipFill>
+        <p:spPr>
+          <a:xfrm>
+            <a:off x="954440" y="3752504"/>
+            <a:ext cx="560000" cy="560000"/>
+          </a:xfrm>
+          <a:prstGeom prst="rect">
+            <a:avLst/>
+          </a:prstGeom>
+        </p:spPr>
+      </p:pic>
+      <p:pic>
+        <p:nvPicPr>
+          <p:cNvPr id="96" name="Picture 95" descr="sun_uv_w.png"/>
+          <p:cNvPicPr>
+            <a:picLocks noChangeAspect="1"/>
+          </p:cNvPicPr>
+          <p:nvPr/>
+        </p:nvPicPr>
+        <p:blipFill>
+          <a:blip r:embed="rId4">
+            <a:extLst>
+              <a:ext uri="{96DAC541-7B7A-43D3-8B79-37D633B846F1}">
+                <ns2:svgBlip xmlns:ns2="http://schemas.microsoft.com/office/drawing/2016/SVG/main" r:embed="rId7"/>
+              </a:ext>
+            </a:extLst>
+          </a:blip>
+          <a:stretch>
+            <a:fillRect/>
+          </a:stretch>
+        </p:blipFill>
+        <p:spPr>
+          <a:xfrm>
+            <a:off x="954440" y="5050952"/>
+            <a:ext cx="560000" cy="560000"/>
+          </a:xfrm>
+          <a:prstGeom prst="rect">
+            <a:avLst/>
+          </a:prstGeom>
+        </p:spPr>
+      </p:pic>
     </p:spTree>
   </p:cSld>
   <p:clrMapOvr>
@@ -22547,7 +23147,7 @@
             </a:avLst>
           </a:prstGeom>
           <a:solidFill>
-            <a:srgbClr val="8C3B2E"/>
+            <a:srgbClr val="1F4E3D"/>
           </a:solidFill>
           <a:ln w="19050">
             <a:solidFill>
@@ -22595,7 +23195,7 @@
             </a:avLst>
           </a:prstGeom>
           <a:solidFill>
-            <a:srgbClr val="B56A3B"/>
+            <a:srgbClr val="3E8C6A"/>
           </a:solidFill>
           <a:ln w="19050">
             <a:solidFill>
@@ -22643,7 +23243,7 @@
             </a:avLst>
           </a:prstGeom>
           <a:solidFill>
-            <a:srgbClr val="4A4F54"/>
+            <a:srgbClr val="2C7A5A"/>
           </a:solidFill>
           <a:ln w="19050">
             <a:solidFill>
@@ -22739,7 +23339,7 @@
             </a:avLst>
           </a:prstGeom>
           <a:solidFill>
-            <a:srgbClr val="243B53"/>
+            <a:srgbClr val="14332A"/>
           </a:solidFill>
           <a:ln w="19050">
             <a:solidFill>
@@ -25869,7 +26469,7 @@
                 </a:solidFill>
                 <a:latin typeface="Cambria"/>
               </a:rPr>
-              <a:t>1</a:t>
+              <a:t/>
             </a:r>
           </a:p>
         </p:txBody>
@@ -26018,7 +26618,7 @@
                 </a:solidFill>
                 <a:latin typeface="Cambria"/>
               </a:rPr>
-              <a:t>2</a:t>
+              <a:t/>
             </a:r>
           </a:p>
         </p:txBody>
@@ -26167,7 +26767,7 @@
                 </a:solidFill>
                 <a:latin typeface="Cambria"/>
               </a:rPr>
-              <a:t>3</a:t>
+              <a:t/>
             </a:r>
           </a:p>
         </p:txBody>
@@ -26316,7 +26916,7 @@
                 </a:solidFill>
                 <a:latin typeface="Cambria"/>
               </a:rPr>
-              <a:t>4</a:t>
+              <a:t/>
             </a:r>
           </a:p>
         </p:txBody>
@@ -26465,7 +27065,7 @@
                 </a:solidFill>
                 <a:latin typeface="Cambria"/>
               </a:rPr>
-              <a:t>5</a:t>
+              <a:t/>
             </a:r>
           </a:p>
         </p:txBody>
@@ -26614,7 +27214,7 @@
                 </a:solidFill>
                 <a:latin typeface="Cambria"/>
               </a:rPr>
-              <a:t>6</a:t>
+              <a:t/>
             </a:r>
           </a:p>
         </p:txBody>
@@ -26724,6 +27324,186 @@
           </a:p>
         </p:txBody>
       </p:sp>
+      <p:pic>
+        <p:nvPicPr>
+          <p:cNvPr id="124" name="Picture 123" descr="company_w.png"/>
+          <p:cNvPicPr>
+            <a:picLocks noChangeAspect="1"/>
+          </p:cNvPicPr>
+          <p:nvPr/>
+        </p:nvPicPr>
+        <p:blipFill>
+          <a:blip r:embed="rId3">
+            <a:extLst>
+              <a:ext uri="{96DAC541-7B7A-43D3-8B79-37D633B846F1}">
+                <ns0:svgBlip xmlns:ns0="http://schemas.microsoft.com/office/drawing/2016/SVG/main" r:embed="rId9"/>
+              </a:ext>
+            </a:extLst>
+          </a:blip>
+          <a:stretch>
+            <a:fillRect/>
+          </a:stretch>
+        </p:blipFill>
+        <p:spPr>
+          <a:xfrm>
+            <a:off x="4638935" y="944759"/>
+            <a:ext cx="414771" cy="414771"/>
+          </a:xfrm>
+          <a:prstGeom prst="rect">
+            <a:avLst/>
+          </a:prstGeom>
+        </p:spPr>
+      </p:pic>
+      <p:pic>
+        <p:nvPicPr>
+          <p:cNvPr id="125" name="Picture 124" descr="materials_w.png"/>
+          <p:cNvPicPr>
+            <a:picLocks noChangeAspect="1"/>
+          </p:cNvPicPr>
+          <p:nvPr/>
+        </p:nvPicPr>
+        <p:blipFill>
+          <a:blip r:embed="rId4">
+            <a:extLst>
+              <a:ext uri="{96DAC541-7B7A-43D3-8B79-37D633B846F1}">
+                <ns1:svgBlip xmlns:ns1="http://schemas.microsoft.com/office/drawing/2016/SVG/main" r:embed="rId11"/>
+              </a:ext>
+            </a:extLst>
+          </a:blip>
+          <a:stretch>
+            <a:fillRect/>
+          </a:stretch>
+        </p:blipFill>
+        <p:spPr>
+          <a:xfrm>
+            <a:off x="4638935" y="1831727"/>
+            <a:ext cx="414771" cy="414771"/>
+          </a:xfrm>
+          <a:prstGeom prst="rect">
+            <a:avLst/>
+          </a:prstGeom>
+        </p:spPr>
+      </p:pic>
+      <p:pic>
+        <p:nvPicPr>
+          <p:cNvPr id="126" name="Picture 125" descr="gear_proc_w.png"/>
+          <p:cNvPicPr>
+            <a:picLocks noChangeAspect="1"/>
+          </p:cNvPicPr>
+          <p:nvPr/>
+        </p:nvPicPr>
+        <p:blipFill>
+          <a:blip r:embed="rId5">
+            <a:extLst>
+              <a:ext uri="{96DAC541-7B7A-43D3-8B79-37D633B846F1}">
+                <ns2:svgBlip xmlns:ns2="http://schemas.microsoft.com/office/drawing/2016/SVG/main" r:embed="rId10"/>
+              </a:ext>
+            </a:extLst>
+          </a:blip>
+          <a:stretch>
+            <a:fillRect/>
+          </a:stretch>
+        </p:blipFill>
+        <p:spPr>
+          <a:xfrm>
+            <a:off x="4638935" y="2718695"/>
+            <a:ext cx="414771" cy="414771"/>
+          </a:xfrm>
+          <a:prstGeom prst="rect">
+            <a:avLst/>
+          </a:prstGeom>
+        </p:spPr>
+      </p:pic>
+      <p:pic>
+        <p:nvPicPr>
+          <p:cNvPr id="127" name="Picture 126" descr="quality_check_w.png"/>
+          <p:cNvPicPr>
+            <a:picLocks noChangeAspect="1"/>
+          </p:cNvPicPr>
+          <p:nvPr/>
+        </p:nvPicPr>
+        <p:blipFill>
+          <a:blip r:embed="rId6">
+            <a:extLst>
+              <a:ext uri="{96DAC541-7B7A-43D3-8B79-37D633B846F1}">
+                <ns3:svgBlip xmlns:ns3="http://schemas.microsoft.com/office/drawing/2016/SVG/main" r:embed="rId12"/>
+              </a:ext>
+            </a:extLst>
+          </a:blip>
+          <a:stretch>
+            <a:fillRect/>
+          </a:stretch>
+        </p:blipFill>
+        <p:spPr>
+          <a:xfrm>
+            <a:off x="4638935" y="3605663"/>
+            <a:ext cx="414771" cy="414771"/>
+          </a:xfrm>
+          <a:prstGeom prst="rect">
+            <a:avLst/>
+          </a:prstGeom>
+        </p:spPr>
+      </p:pic>
+      <p:pic>
+        <p:nvPicPr>
+          <p:cNvPr id="128" name="Picture 127" descr="warning_tri_g.png"/>
+          <p:cNvPicPr>
+            <a:picLocks noChangeAspect="1"/>
+          </p:cNvPicPr>
+          <p:nvPr/>
+        </p:nvPicPr>
+        <p:blipFill>
+          <a:blip r:embed="rId7">
+            <a:extLst>
+              <a:ext uri="{96DAC541-7B7A-43D3-8B79-37D633B846F1}">
+                <ns4:svgBlip xmlns:ns4="http://schemas.microsoft.com/office/drawing/2016/SVG/main" r:embed="rId14"/>
+              </a:ext>
+            </a:extLst>
+          </a:blip>
+          <a:stretch>
+            <a:fillRect/>
+          </a:stretch>
+        </p:blipFill>
+        <p:spPr>
+          <a:xfrm>
+            <a:off x="4638935" y="4492631"/>
+            <a:ext cx="414771" cy="414771"/>
+          </a:xfrm>
+          <a:prstGeom prst="rect">
+            <a:avLst/>
+          </a:prstGeom>
+        </p:spPr>
+      </p:pic>
+      <p:pic>
+        <p:nvPicPr>
+          <p:cNvPr id="129" name="Picture 128" descr="safety_shield_w.png"/>
+          <p:cNvPicPr>
+            <a:picLocks noChangeAspect="1"/>
+          </p:cNvPicPr>
+          <p:nvPr/>
+        </p:nvPicPr>
+        <p:blipFill>
+          <a:blip r:embed="rId8">
+            <a:extLst>
+              <a:ext uri="{96DAC541-7B7A-43D3-8B79-37D633B846F1}">
+                <ns5:svgBlip xmlns:ns5="http://schemas.microsoft.com/office/drawing/2016/SVG/main" r:embed="rId13"/>
+              </a:ext>
+            </a:extLst>
+          </a:blip>
+          <a:stretch>
+            <a:fillRect/>
+          </a:stretch>
+        </p:blipFill>
+        <p:spPr>
+          <a:xfrm>
+            <a:off x="4638935" y="5379599"/>
+            <a:ext cx="414771" cy="414771"/>
+          </a:xfrm>
+          <a:prstGeom prst="rect">
+            <a:avLst/>
+          </a:prstGeom>
+        </p:spPr>
+      </p:pic>
     </p:spTree>
   </p:cSld>
   <p:clrMapOvr>
@@ -31354,7 +32134,7 @@
             </a:avLst>
           </a:prstGeom>
           <a:solidFill>
-            <a:srgbClr val="8C3B2E"/>
+            <a:srgbClr val="1F4E3D"/>
           </a:solidFill>
           <a:ln w="19050">
             <a:solidFill>
@@ -31402,7 +32182,7 @@
             </a:avLst>
           </a:prstGeom>
           <a:solidFill>
-            <a:srgbClr val="B56A3B"/>
+            <a:srgbClr val="3E8C6A"/>
           </a:solidFill>
           <a:ln w="19050">
             <a:solidFill>
@@ -31450,7 +32230,7 @@
             </a:avLst>
           </a:prstGeom>
           <a:solidFill>
-            <a:srgbClr val="4A4F54"/>
+            <a:srgbClr val="2C7A5A"/>
           </a:solidFill>
           <a:ln w="19050">
             <a:solidFill>
@@ -31546,7 +32326,7 @@
             </a:avLst>
           </a:prstGeom>
           <a:solidFill>
-            <a:srgbClr val="243B53"/>
+            <a:srgbClr val="14332A"/>
           </a:solidFill>
           <a:ln w="19050">
             <a:solidFill>
@@ -32233,7 +33013,7 @@
                 </a:solidFill>
                 <a:latin typeface="Cambria"/>
               </a:rPr>
-              <a:t>!</a:t>
+              <a:t/>
             </a:r>
           </a:p>
         </p:txBody>
@@ -32495,7 +33275,7 @@
                 </a:solidFill>
                 <a:latin typeface="Cambria"/>
               </a:rPr>
-              <a:t>!</a:t>
+              <a:t/>
             </a:r>
           </a:p>
         </p:txBody>
@@ -32757,7 +33537,7 @@
                 </a:solidFill>
                 <a:latin typeface="Cambria"/>
               </a:rPr>
-              <a:t>!</a:t>
+              <a:t/>
             </a:r>
           </a:p>
         </p:txBody>
@@ -33019,7 +33799,7 @@
                 </a:solidFill>
                 <a:latin typeface="Cambria"/>
               </a:rPr>
-              <a:t>!</a:t>
+              <a:t/>
             </a:r>
           </a:p>
         </p:txBody>
@@ -33229,6 +34009,126 @@
           </a:p>
         </p:txBody>
       </p:sp>
+      <p:pic>
+        <p:nvPicPr>
+          <p:cNvPr id="104" name="Picture 103" descr="flame_g.png"/>
+          <p:cNvPicPr>
+            <a:picLocks noChangeAspect="1"/>
+          </p:cNvPicPr>
+          <p:nvPr/>
+        </p:nvPicPr>
+        <p:blipFill>
+          <a:blip r:embed="rId2">
+            <a:extLst>
+              <a:ext uri="{96DAC541-7B7A-43D3-8B79-37D633B846F1}">
+                <ns0:svgBlip xmlns:ns0="http://schemas.microsoft.com/office/drawing/2016/SVG/main" r:embed="rId7"/>
+              </a:ext>
+            </a:extLst>
+          </a:blip>
+          <a:stretch>
+            <a:fillRect/>
+          </a:stretch>
+        </p:blipFill>
+        <p:spPr>
+          <a:xfrm>
+            <a:off x="925373" y="1931213"/>
+            <a:ext cx="307238" cy="307238"/>
+          </a:xfrm>
+          <a:prstGeom prst="rect">
+            <a:avLst/>
+          </a:prstGeom>
+        </p:spPr>
+      </p:pic>
+      <p:pic>
+        <p:nvPicPr>
+          <p:cNvPr id="105" name="Picture 104" descr="gasmask_g.png"/>
+          <p:cNvPicPr>
+            <a:picLocks noChangeAspect="1"/>
+          </p:cNvPicPr>
+          <p:nvPr/>
+        </p:nvPicPr>
+        <p:blipFill>
+          <a:blip r:embed="rId3">
+            <a:extLst>
+              <a:ext uri="{96DAC541-7B7A-43D3-8B79-37D633B846F1}">
+                <ns1:svgBlip xmlns:ns1="http://schemas.microsoft.com/office/drawing/2016/SVG/main" r:embed="rId8"/>
+              </a:ext>
+            </a:extLst>
+          </a:blip>
+          <a:stretch>
+            <a:fillRect/>
+          </a:stretch>
+        </p:blipFill>
+        <p:spPr>
+          <a:xfrm>
+            <a:off x="6548933" y="1931213"/>
+            <a:ext cx="307238" cy="307238"/>
+          </a:xfrm>
+          <a:prstGeom prst="rect">
+            <a:avLst/>
+          </a:prstGeom>
+        </p:spPr>
+      </p:pic>
+      <p:pic>
+        <p:nvPicPr>
+          <p:cNvPr id="106" name="Picture 105" descr="chemical_glove_g.png"/>
+          <p:cNvPicPr>
+            <a:picLocks noChangeAspect="1"/>
+          </p:cNvPicPr>
+          <p:nvPr/>
+        </p:nvPicPr>
+        <p:blipFill>
+          <a:blip r:embed="rId4">
+            <a:extLst>
+              <a:ext uri="{96DAC541-7B7A-43D3-8B79-37D633B846F1}">
+                <ns2:svgBlip xmlns:ns2="http://schemas.microsoft.com/office/drawing/2016/SVG/main" r:embed="rId6"/>
+              </a:ext>
+            </a:extLst>
+          </a:blip>
+          <a:stretch>
+            <a:fillRect/>
+          </a:stretch>
+        </p:blipFill>
+        <p:spPr>
+          <a:xfrm>
+            <a:off x="925373" y="4171493"/>
+            <a:ext cx="307238" cy="307238"/>
+          </a:xfrm>
+          <a:prstGeom prst="rect">
+            <a:avLst/>
+          </a:prstGeom>
+        </p:spPr>
+      </p:pic>
+      <p:pic>
+        <p:nvPicPr>
+          <p:cNvPr id="107" name="Picture 106" descr="gear_proc_g.png"/>
+          <p:cNvPicPr>
+            <a:picLocks noChangeAspect="1"/>
+          </p:cNvPicPr>
+          <p:nvPr/>
+        </p:nvPicPr>
+        <p:blipFill>
+          <a:blip r:embed="rId5">
+            <a:extLst>
+              <a:ext uri="{96DAC541-7B7A-43D3-8B79-37D633B846F1}">
+                <ns3:svgBlip xmlns:ns3="http://schemas.microsoft.com/office/drawing/2016/SVG/main" r:embed="rId9"/>
+              </a:ext>
+            </a:extLst>
+          </a:blip>
+          <a:stretch>
+            <a:fillRect/>
+          </a:stretch>
+        </p:blipFill>
+        <p:spPr>
+          <a:xfrm>
+            <a:off x="6548933" y="4171493"/>
+            <a:ext cx="307238" cy="307238"/>
+          </a:xfrm>
+          <a:prstGeom prst="rect">
+            <a:avLst/>
+          </a:prstGeom>
+        </p:spPr>
+      </p:pic>
     </p:spTree>
   </p:cSld>
   <p:clrMapOvr>
@@ -35017,8 +35917,8 @@
         </p:nvSpPr>
         <p:spPr>
           <a:xfrm>
-            <a:off x="731520" y="1664207"/>
-            <a:ext cx="2606040" cy="1152144"/>
+            <a:off x="1351520" y="1664207"/>
+            <a:ext cx="1986040" cy="1152144"/>
           </a:xfrm>
           <a:prstGeom prst="rect">
             <a:avLst/>
@@ -35273,8 +36173,8 @@
         </p:nvSpPr>
         <p:spPr>
           <a:xfrm>
-            <a:off x="731520" y="3145536"/>
-            <a:ext cx="2606040" cy="1152144"/>
+            <a:off x="1351520" y="3145536"/>
+            <a:ext cx="1986040" cy="1152144"/>
           </a:xfrm>
           <a:prstGeom prst="rect">
             <a:avLst/>
@@ -35529,8 +36429,8 @@
         </p:nvSpPr>
         <p:spPr>
           <a:xfrm>
-            <a:off x="731520" y="4626864"/>
-            <a:ext cx="2606040" cy="1152144"/>
+            <a:off x="1351520" y="4626864"/>
+            <a:ext cx="1986040" cy="1152144"/>
           </a:xfrm>
           <a:prstGeom prst="rect">
             <a:avLst/>
@@ -35713,6 +36613,96 @@
           </a:p>
         </p:txBody>
       </p:sp>
+      <p:pic>
+        <p:nvPicPr>
+          <p:cNvPr id="64" name="Picture 63" descr="smoke_air_w.png"/>
+          <p:cNvPicPr>
+            <a:picLocks noChangeAspect="1"/>
+          </p:cNvPicPr>
+          <p:nvPr/>
+        </p:nvPicPr>
+        <p:blipFill>
+          <a:blip r:embed="rId2">
+            <a:extLst>
+              <a:ext uri="{96DAC541-7B7A-43D3-8B79-37D633B846F1}">
+                <ns0:svgBlip xmlns:ns0="http://schemas.microsoft.com/office/drawing/2016/SVG/main" r:embed="rId5"/>
+              </a:ext>
+            </a:extLst>
+          </a:blip>
+          <a:stretch>
+            <a:fillRect/>
+          </a:stretch>
+        </p:blipFill>
+        <p:spPr>
+          <a:xfrm>
+            <a:off x="698640" y="2000280"/>
+            <a:ext cx="480000" cy="480000"/>
+          </a:xfrm>
+          <a:prstGeom prst="rect">
+            <a:avLst/>
+          </a:prstGeom>
+        </p:spPr>
+      </p:pic>
+      <p:pic>
+        <p:nvPicPr>
+          <p:cNvPr id="65" name="Picture 64" descr="water_waste_w.png"/>
+          <p:cNvPicPr>
+            <a:picLocks noChangeAspect="1"/>
+          </p:cNvPicPr>
+          <p:nvPr/>
+        </p:nvPicPr>
+        <p:blipFill>
+          <a:blip r:embed="rId3">
+            <a:extLst>
+              <a:ext uri="{96DAC541-7B7A-43D3-8B79-37D633B846F1}">
+                <ns1:svgBlip xmlns:ns1="http://schemas.microsoft.com/office/drawing/2016/SVG/main" r:embed="rId7"/>
+              </a:ext>
+            </a:extLst>
+          </a:blip>
+          <a:stretch>
+            <a:fillRect/>
+          </a:stretch>
+        </p:blipFill>
+        <p:spPr>
+          <a:xfrm>
+            <a:off x="698640" y="3481608"/>
+            <a:ext cx="480000" cy="480000"/>
+          </a:xfrm>
+          <a:prstGeom prst="rect">
+            <a:avLst/>
+          </a:prstGeom>
+        </p:spPr>
+      </p:pic>
+      <p:pic>
+        <p:nvPicPr>
+          <p:cNvPr id="66" name="Picture 65" descr="solid_waste_w.png"/>
+          <p:cNvPicPr>
+            <a:picLocks noChangeAspect="1"/>
+          </p:cNvPicPr>
+          <p:nvPr/>
+        </p:nvPicPr>
+        <p:blipFill>
+          <a:blip r:embed="rId4">
+            <a:extLst>
+              <a:ext uri="{96DAC541-7B7A-43D3-8B79-37D633B846F1}">
+                <ns2:svgBlip xmlns:ns2="http://schemas.microsoft.com/office/drawing/2016/SVG/main" r:embed="rId6"/>
+              </a:ext>
+            </a:extLst>
+          </a:blip>
+          <a:stretch>
+            <a:fillRect/>
+          </a:stretch>
+        </p:blipFill>
+        <p:spPr>
+          <a:xfrm>
+            <a:off x="698640" y="4962936"/>
+            <a:ext cx="480000" cy="480000"/>
+          </a:xfrm>
+          <a:prstGeom prst="rect">
+            <a:avLst/>
+          </a:prstGeom>
+        </p:spPr>
+      </p:pic>
     </p:spTree>
   </p:cSld>
   <p:clrMapOvr>
@@ -36724,7 +37714,7 @@
                 </a:solidFill>
                 <a:latin typeface="Cambria"/>
               </a:rPr>
-              <a:t>1</a:t>
+              <a:t/>
             </a:r>
           </a:p>
         </p:txBody>
@@ -36904,7 +37894,7 @@
                 </a:solidFill>
                 <a:latin typeface="Cambria"/>
               </a:rPr>
-              <a:t>2</a:t>
+              <a:t/>
             </a:r>
           </a:p>
         </p:txBody>
@@ -37084,7 +38074,7 @@
                 </a:solidFill>
                 <a:latin typeface="Cambria"/>
               </a:rPr>
-              <a:t>3</a:t>
+              <a:t/>
             </a:r>
           </a:p>
         </p:txBody>
@@ -37179,6 +38169,96 @@
           </a:p>
         </p:txBody>
       </p:sp>
+      <p:pic>
+        <p:nvPicPr>
+          <p:cNvPr id="49" name="Picture 48" descr="grad_check_g.png"/>
+          <p:cNvPicPr>
+            <a:picLocks noChangeAspect="1"/>
+          </p:cNvPicPr>
+          <p:nvPr/>
+        </p:nvPicPr>
+        <p:blipFill>
+          <a:blip r:embed="rId2">
+            <a:extLst>
+              <a:ext uri="{96DAC541-7B7A-43D3-8B79-37D633B846F1}">
+                <ns0:svgBlip xmlns:ns0="http://schemas.microsoft.com/office/drawing/2016/SVG/main" r:embed="rId5"/>
+              </a:ext>
+            </a:extLst>
+          </a:blip>
+          <a:stretch>
+            <a:fillRect/>
+          </a:stretch>
+        </p:blipFill>
+        <p:spPr>
+          <a:xfrm>
+            <a:off x="1182320" y="2462480"/>
+            <a:ext cx="332841" cy="332841"/>
+          </a:xfrm>
+          <a:prstGeom prst="rect">
+            <a:avLst/>
+          </a:prstGeom>
+        </p:spPr>
+      </p:pic>
+      <p:pic>
+        <p:nvPicPr>
+          <p:cNvPr id="50" name="Picture 49" descr="palette_g.png"/>
+          <p:cNvPicPr>
+            <a:picLocks noChangeAspect="1"/>
+          </p:cNvPicPr>
+          <p:nvPr/>
+        </p:nvPicPr>
+        <p:blipFill>
+          <a:blip r:embed="rId3">
+            <a:extLst>
+              <a:ext uri="{96DAC541-7B7A-43D3-8B79-37D633B846F1}">
+                <ns1:svgBlip xmlns:ns1="http://schemas.microsoft.com/office/drawing/2016/SVG/main" r:embed="rId6"/>
+              </a:ext>
+            </a:extLst>
+          </a:blip>
+          <a:stretch>
+            <a:fillRect/>
+          </a:stretch>
+        </p:blipFill>
+        <p:spPr>
+          <a:xfrm>
+            <a:off x="1182320" y="3834080"/>
+            <a:ext cx="332841" cy="332841"/>
+          </a:xfrm>
+          <a:prstGeom prst="rect">
+            <a:avLst/>
+          </a:prstGeom>
+        </p:spPr>
+      </p:pic>
+      <p:pic>
+        <p:nvPicPr>
+          <p:cNvPr id="51" name="Picture 50" descr="qr_code_g.png"/>
+          <p:cNvPicPr>
+            <a:picLocks noChangeAspect="1"/>
+          </p:cNvPicPr>
+          <p:nvPr/>
+        </p:nvPicPr>
+        <p:blipFill>
+          <a:blip r:embed="rId4">
+            <a:extLst>
+              <a:ext uri="{96DAC541-7B7A-43D3-8B79-37D633B846F1}">
+                <ns2:svgBlip xmlns:ns2="http://schemas.microsoft.com/office/drawing/2016/SVG/main" r:embed="rId7"/>
+              </a:ext>
+            </a:extLst>
+          </a:blip>
+          <a:stretch>
+            <a:fillRect/>
+          </a:stretch>
+        </p:blipFill>
+        <p:spPr>
+          <a:xfrm>
+            <a:off x="1182320" y="5205680"/>
+            <a:ext cx="332841" cy="332841"/>
+          </a:xfrm>
+          <a:prstGeom prst="rect">
+            <a:avLst/>
+          </a:prstGeom>
+        </p:spPr>
+      </p:pic>
     </p:spTree>
   </p:cSld>
   <p:clrMapOvr>
@@ -38682,8 +39762,8 @@
         </p:nvSpPr>
         <p:spPr>
           <a:xfrm>
-            <a:off x="5029200" y="1600200"/>
-            <a:ext cx="6400800" cy="457200"/>
+            <a:off x="5589200" y="1600200"/>
+            <a:ext cx="5840800" cy="457200"/>
           </a:xfrm>
           <a:prstGeom prst="rect">
             <a:avLst/>
@@ -38717,8 +39797,8 @@
         </p:nvSpPr>
         <p:spPr>
           <a:xfrm>
-            <a:off x="5029200" y="2057400"/>
-            <a:ext cx="6400800" cy="640080"/>
+            <a:off x="5589200" y="2057400"/>
+            <a:ext cx="5840800" cy="640080"/>
           </a:xfrm>
           <a:prstGeom prst="rect">
             <a:avLst/>
@@ -38850,8 +39930,8 @@
         </p:nvSpPr>
         <p:spPr>
           <a:xfrm>
-            <a:off x="5029200" y="3182112"/>
-            <a:ext cx="6400800" cy="457200"/>
+            <a:off x="5589200" y="3182112"/>
+            <a:ext cx="5840800" cy="457200"/>
           </a:xfrm>
           <a:prstGeom prst="rect">
             <a:avLst/>
@@ -38885,8 +39965,8 @@
         </p:nvSpPr>
         <p:spPr>
           <a:xfrm>
-            <a:off x="5029200" y="3639312"/>
-            <a:ext cx="6400800" cy="640080"/>
+            <a:off x="5589200" y="3639312"/>
+            <a:ext cx="5840800" cy="640080"/>
           </a:xfrm>
           <a:prstGeom prst="rect">
             <a:avLst/>
@@ -39018,8 +40098,8 @@
         </p:nvSpPr>
         <p:spPr>
           <a:xfrm>
-            <a:off x="5029200" y="4764024"/>
-            <a:ext cx="6400800" cy="457200"/>
+            <a:off x="5589200" y="4764024"/>
+            <a:ext cx="5840800" cy="457200"/>
           </a:xfrm>
           <a:prstGeom prst="rect">
             <a:avLst/>
@@ -39053,8 +40133,8 @@
         </p:nvSpPr>
         <p:spPr>
           <a:xfrm>
-            <a:off x="5029200" y="5221224"/>
-            <a:ext cx="6400800" cy="640080"/>
+            <a:off x="5589200" y="5221224"/>
+            <a:ext cx="5840800" cy="640080"/>
           </a:xfrm>
           <a:prstGeom prst="rect">
             <a:avLst/>
@@ -39119,6 +40199,96 @@
           </a:p>
         </p:txBody>
       </p:sp>
+      <p:pic>
+        <p:nvPicPr>
+          <p:cNvPr id="64" name="Picture 63" descr="history_clock_g.png"/>
+          <p:cNvPicPr>
+            <a:picLocks noChangeAspect="1"/>
+          </p:cNvPicPr>
+          <p:nvPr/>
+        </p:nvPicPr>
+        <p:blipFill>
+          <a:blip r:embed="rId3">
+            <a:extLst>
+              <a:ext uri="{96DAC541-7B7A-43D3-8B79-37D633B846F1}">
+                <ns0:svgBlip xmlns:ns0="http://schemas.microsoft.com/office/drawing/2016/SVG/main" r:embed="rId7"/>
+              </a:ext>
+            </a:extLst>
+          </a:blip>
+          <a:stretch>
+            <a:fillRect/>
+          </a:stretch>
+        </p:blipFill>
+        <p:spPr>
+          <a:xfrm>
+            <a:off x="4813440" y="1905980"/>
+            <a:ext cx="440000" cy="440000"/>
+          </a:xfrm>
+          <a:prstGeom prst="rect">
+            <a:avLst/>
+          </a:prstGeom>
+        </p:spPr>
+      </p:pic>
+      <p:pic>
+        <p:nvPicPr>
+          <p:cNvPr id="65" name="Picture 64" descr="paint_can_g.png"/>
+          <p:cNvPicPr>
+            <a:picLocks noChangeAspect="1"/>
+          </p:cNvPicPr>
+          <p:nvPr/>
+        </p:nvPicPr>
+        <p:blipFill>
+          <a:blip r:embed="rId4">
+            <a:extLst>
+              <a:ext uri="{96DAC541-7B7A-43D3-8B79-37D633B846F1}">
+                <ns1:svgBlip xmlns:ns1="http://schemas.microsoft.com/office/drawing/2016/SVG/main" r:embed="rId8"/>
+              </a:ext>
+            </a:extLst>
+          </a:blip>
+          <a:stretch>
+            <a:fillRect/>
+          </a:stretch>
+        </p:blipFill>
+        <p:spPr>
+          <a:xfrm>
+            <a:off x="4813440" y="3487892"/>
+            <a:ext cx="440000" cy="440000"/>
+          </a:xfrm>
+          <a:prstGeom prst="rect">
+            <a:avLst/>
+          </a:prstGeom>
+        </p:spPr>
+      </p:pic>
+      <p:pic>
+        <p:nvPicPr>
+          <p:cNvPr id="66" name="Picture 65" descr="factory_g.png"/>
+          <p:cNvPicPr>
+            <a:picLocks noChangeAspect="1"/>
+          </p:cNvPicPr>
+          <p:nvPr/>
+        </p:nvPicPr>
+        <p:blipFill>
+          <a:blip r:embed="rId5">
+            <a:extLst>
+              <a:ext uri="{96DAC541-7B7A-43D3-8B79-37D633B846F1}">
+                <ns2:svgBlip xmlns:ns2="http://schemas.microsoft.com/office/drawing/2016/SVG/main" r:embed="rId6"/>
+              </a:ext>
+            </a:extLst>
+          </a:blip>
+          <a:stretch>
+            <a:fillRect/>
+          </a:stretch>
+        </p:blipFill>
+        <p:spPr>
+          <a:xfrm>
+            <a:off x="4813440" y="5069804"/>
+            <a:ext cx="440000" cy="440000"/>
+          </a:xfrm>
+          <a:prstGeom prst="rect">
+            <a:avLst/>
+          </a:prstGeom>
+        </p:spPr>
+      </p:pic>
     </p:spTree>
   </p:cSld>
   <p:clrMapOvr>
@@ -40339,8 +41509,8 @@
         </p:nvSpPr>
         <p:spPr>
           <a:xfrm>
-            <a:off x="804672" y="1554480"/>
-            <a:ext cx="3154680" cy="777240"/>
+            <a:off x="1324672" y="1554480"/>
+            <a:ext cx="2634680" cy="777240"/>
           </a:xfrm>
           <a:prstGeom prst="rect">
             <a:avLst/>
@@ -40658,8 +41828,8 @@
         </p:nvSpPr>
         <p:spPr>
           <a:xfrm>
-            <a:off x="4672584" y="1554480"/>
-            <a:ext cx="3154680" cy="777240"/>
+            <a:off x="5192584" y="1554480"/>
+            <a:ext cx="2634680" cy="777240"/>
           </a:xfrm>
           <a:prstGeom prst="rect">
             <a:avLst/>
@@ -40977,8 +42147,8 @@
         </p:nvSpPr>
         <p:spPr>
           <a:xfrm>
-            <a:off x="8540496" y="1554480"/>
-            <a:ext cx="3154680" cy="777240"/>
+            <a:off x="9060496" y="1554480"/>
+            <a:ext cx="2634680" cy="777240"/>
           </a:xfrm>
           <a:prstGeom prst="rect">
             <a:avLst/>
@@ -41220,6 +42390,96 @@
           </a:p>
         </p:txBody>
       </p:sp>
+      <p:pic>
+        <p:nvPicPr>
+          <p:cNvPr id="94" name="Picture 93" descr="target_w.png"/>
+          <p:cNvPicPr>
+            <a:picLocks noChangeAspect="1"/>
+          </p:cNvPicPr>
+          <p:nvPr/>
+        </p:nvPicPr>
+        <p:blipFill>
+          <a:blip r:embed="rId2">
+            <a:extLst>
+              <a:ext uri="{96DAC541-7B7A-43D3-8B79-37D633B846F1}">
+                <ns0:svgBlip xmlns:ns0="http://schemas.microsoft.com/office/drawing/2016/SVG/main" r:embed="rId7"/>
+              </a:ext>
+            </a:extLst>
+          </a:blip>
+          <a:stretch>
+            <a:fillRect/>
+          </a:stretch>
+        </p:blipFill>
+        <p:spPr>
+          <a:xfrm>
+            <a:off x="698640" y="1728100"/>
+            <a:ext cx="430000" cy="430000"/>
+          </a:xfrm>
+          <a:prstGeom prst="rect">
+            <a:avLst/>
+          </a:prstGeom>
+        </p:spPr>
+      </p:pic>
+      <p:pic>
+        <p:nvPicPr>
+          <p:cNvPr id="95" name="Picture 94" descr="org_chart_w.png"/>
+          <p:cNvPicPr>
+            <a:picLocks noChangeAspect="1"/>
+          </p:cNvPicPr>
+          <p:nvPr/>
+        </p:nvPicPr>
+        <p:blipFill>
+          <a:blip r:embed="rId3">
+            <a:extLst>
+              <a:ext uri="{96DAC541-7B7A-43D3-8B79-37D633B846F1}">
+                <ns1:svgBlip xmlns:ns1="http://schemas.microsoft.com/office/drawing/2016/SVG/main" r:embed="rId6"/>
+              </a:ext>
+            </a:extLst>
+          </a:blip>
+          <a:stretch>
+            <a:fillRect/>
+          </a:stretch>
+        </p:blipFill>
+        <p:spPr>
+          <a:xfrm>
+            <a:off x="4566552" y="1728100"/>
+            <a:ext cx="430000" cy="430000"/>
+          </a:xfrm>
+          <a:prstGeom prst="rect">
+            <a:avLst/>
+          </a:prstGeom>
+        </p:spPr>
+      </p:pic>
+      <p:pic>
+        <p:nvPicPr>
+          <p:cNvPr id="96" name="Picture 95" descr="customers_w.png"/>
+          <p:cNvPicPr>
+            <a:picLocks noChangeAspect="1"/>
+          </p:cNvPicPr>
+          <p:nvPr/>
+        </p:nvPicPr>
+        <p:blipFill>
+          <a:blip r:embed="rId4">
+            <a:extLst>
+              <a:ext uri="{96DAC541-7B7A-43D3-8B79-37D633B846F1}">
+                <ns2:svgBlip xmlns:ns2="http://schemas.microsoft.com/office/drawing/2016/SVG/main" r:embed="rId5"/>
+              </a:ext>
+            </a:extLst>
+          </a:blip>
+          <a:stretch>
+            <a:fillRect/>
+          </a:stretch>
+        </p:blipFill>
+        <p:spPr>
+          <a:xfrm>
+            <a:off x="8434464" y="1728100"/>
+            <a:ext cx="430000" cy="430000"/>
+          </a:xfrm>
+          <a:prstGeom prst="rect">
+            <a:avLst/>
+          </a:prstGeom>
+        </p:spPr>
+      </p:pic>
     </p:spTree>
   </p:cSld>
   <p:clrMapOvr>
@@ -43213,7 +44473,7 @@
                 </a:solidFill>
                 <a:latin typeface="Cambria"/>
               </a:rPr>
-              <a:t>1</a:t>
+              <a:t/>
             </a:r>
           </a:p>
         </p:txBody>
@@ -43495,7 +44755,7 @@
                 </a:solidFill>
                 <a:latin typeface="Cambria"/>
               </a:rPr>
-              <a:t>2</a:t>
+              <a:t/>
             </a:r>
           </a:p>
         </p:txBody>
@@ -43777,7 +45037,7 @@
                 </a:solidFill>
                 <a:latin typeface="Cambria"/>
               </a:rPr>
-              <a:t>3</a:t>
+              <a:t/>
             </a:r>
           </a:p>
         </p:txBody>
@@ -44059,7 +45319,7 @@
                 </a:solidFill>
                 <a:latin typeface="Cambria"/>
               </a:rPr>
-              <a:t>4</a:t>
+              <a:t/>
             </a:r>
           </a:p>
         </p:txBody>
@@ -44293,6 +45553,126 @@
           </a:p>
         </p:txBody>
       </p:sp>
+      <p:pic>
+        <p:nvPicPr>
+          <p:cNvPr id="84" name="Picture 83" descr="resin_w.png"/>
+          <p:cNvPicPr>
+            <a:picLocks noChangeAspect="1"/>
+          </p:cNvPicPr>
+          <p:nvPr/>
+        </p:nvPicPr>
+        <p:blipFill>
+          <a:blip r:embed="rId2">
+            <a:extLst>
+              <a:ext uri="{96DAC541-7B7A-43D3-8B79-37D633B846F1}">
+                <ns0:svgBlip xmlns:ns0="http://schemas.microsoft.com/office/drawing/2016/SVG/main" r:embed="rId8"/>
+              </a:ext>
+            </a:extLst>
+          </a:blip>
+          <a:stretch>
+            <a:fillRect/>
+          </a:stretch>
+        </p:blipFill>
+        <p:spPr>
+          <a:xfrm>
+            <a:off x="918058" y="1814170"/>
+            <a:ext cx="358444" cy="358444"/>
+          </a:xfrm>
+          <a:prstGeom prst="rect">
+            <a:avLst/>
+          </a:prstGeom>
+        </p:spPr>
+      </p:pic>
+      <p:pic>
+        <p:nvPicPr>
+          <p:cNvPr id="85" name="Picture 84" descr="solvent_w.png"/>
+          <p:cNvPicPr>
+            <a:picLocks noChangeAspect="1"/>
+          </p:cNvPicPr>
+          <p:nvPr/>
+        </p:nvPicPr>
+        <p:blipFill>
+          <a:blip r:embed="rId3">
+            <a:extLst>
+              <a:ext uri="{96DAC541-7B7A-43D3-8B79-37D633B846F1}">
+                <ns1:svgBlip xmlns:ns1="http://schemas.microsoft.com/office/drawing/2016/SVG/main" r:embed="rId9"/>
+              </a:ext>
+            </a:extLst>
+          </a:blip>
+          <a:stretch>
+            <a:fillRect/>
+          </a:stretch>
+        </p:blipFill>
+        <p:spPr>
+          <a:xfrm>
+            <a:off x="918058" y="2948026"/>
+            <a:ext cx="358444" cy="358444"/>
+          </a:xfrm>
+          <a:prstGeom prst="rect">
+            <a:avLst/>
+          </a:prstGeom>
+        </p:spPr>
+      </p:pic>
+      <p:pic>
+        <p:nvPicPr>
+          <p:cNvPr id="86" name="Picture 85" descr="pigment_g.png"/>
+          <p:cNvPicPr>
+            <a:picLocks noChangeAspect="1"/>
+          </p:cNvPicPr>
+          <p:nvPr/>
+        </p:nvPicPr>
+        <p:blipFill>
+          <a:blip r:embed="rId4">
+            <a:extLst>
+              <a:ext uri="{96DAC541-7B7A-43D3-8B79-37D633B846F1}">
+                <ns2:svgBlip xmlns:ns2="http://schemas.microsoft.com/office/drawing/2016/SVG/main" r:embed="rId7"/>
+              </a:ext>
+            </a:extLst>
+          </a:blip>
+          <a:stretch>
+            <a:fillRect/>
+          </a:stretch>
+        </p:blipFill>
+        <p:spPr>
+          <a:xfrm>
+            <a:off x="918058" y="4081882"/>
+            <a:ext cx="358444" cy="358444"/>
+          </a:xfrm>
+          <a:prstGeom prst="rect">
+            <a:avLst/>
+          </a:prstGeom>
+        </p:spPr>
+      </p:pic>
+      <p:pic>
+        <p:nvPicPr>
+          <p:cNvPr id="87" name="Picture 86" descr="additive_w.png"/>
+          <p:cNvPicPr>
+            <a:picLocks noChangeAspect="1"/>
+          </p:cNvPicPr>
+          <p:nvPr/>
+        </p:nvPicPr>
+        <p:blipFill>
+          <a:blip r:embed="rId5">
+            <a:extLst>
+              <a:ext uri="{96DAC541-7B7A-43D3-8B79-37D633B846F1}">
+                <ns3:svgBlip xmlns:ns3="http://schemas.microsoft.com/office/drawing/2016/SVG/main" r:embed="rId6"/>
+              </a:ext>
+            </a:extLst>
+          </a:blip>
+          <a:stretch>
+            <a:fillRect/>
+          </a:stretch>
+        </p:blipFill>
+        <p:spPr>
+          <a:xfrm>
+            <a:off x="918058" y="5215738"/>
+            <a:ext cx="358444" cy="358444"/>
+          </a:xfrm>
+          <a:prstGeom prst="rect">
+            <a:avLst/>
+          </a:prstGeom>
+        </p:spPr>
+      </p:pic>
     </p:spTree>
   </p:cSld>
   <p:clrMapOvr>

</xml_diff>

<commit_message>
Add data-viz charts to materials slides
Introduce SVG range-bar charts (native svgBlip + PNG fallback, editable-
crisp in PowerPoint and rendered in the PDF export):
- Slide 8: horizontal range bars with a 30-70% axis for Alkyd oil
  content, visualizing gay < trung binh < beo at a glance (replaces the
  plain numeric column).
- Slide 7: proportion mini-bars under each component's % badge to show
  relative magnitude (resin widest, additive a dot).

Regenerate the PDF export.

Co-Authored-By: Claude Opus 4.8 <noreply@anthropic.com>
Claude-Session: https://claude.ai/code/session_01PbbxSyJEYscgmQfTL8vaUX
</commit_message>
<xml_diff>
--- a/SuHeo/Báo cáo thực tập - Sơn Hải Vân.pptx
+++ b/SuHeo/Báo cáo thực tập - Sơn Hải Vân.pptx
@@ -6518,6 +6518,186 @@
           </a:prstGeom>
         </p:spPr>
       </p:pic>
+      <p:pic>
+        <p:nvPicPr>
+          <p:cNvPr id="125" name="Picture 124" descr="image.png"/>
+          <p:cNvPicPr>
+            <a:picLocks noChangeAspect="1"/>
+          </p:cNvPicPr>
+          <p:nvPr/>
+        </p:nvPicPr>
+        <p:blipFill>
+          <a:blip r:embed="rId2">
+            <a:extLst>
+              <a:ext uri="{96DAC541-7B7A-43D3-8B79-37D633B846F1}">
+                <ns0:svgBlip xmlns:ns0="http://schemas.microsoft.com/office/drawing/2016/SVG/main" r:embed="rId15"/>
+              </a:ext>
+            </a:extLst>
+          </a:blip>
+          <a:stretch>
+            <a:fillRect/>
+          </a:stretch>
+        </p:blipFill>
+        <p:spPr>
+          <a:xfrm>
+            <a:off x="1018740" y="2496000"/>
+            <a:ext cx="660000" cy="660000"/>
+          </a:xfrm>
+          <a:prstGeom prst="rect">
+            <a:avLst/>
+          </a:prstGeom>
+        </p:spPr>
+      </p:pic>
+      <p:pic>
+        <p:nvPicPr>
+          <p:cNvPr id="126" name="Picture 125" descr="image.png"/>
+          <p:cNvPicPr>
+            <a:picLocks noChangeAspect="1"/>
+          </p:cNvPicPr>
+          <p:nvPr/>
+        </p:nvPicPr>
+        <p:blipFill>
+          <a:blip r:embed="rId3">
+            <a:extLst>
+              <a:ext uri="{96DAC541-7B7A-43D3-8B79-37D633B846F1}">
+                <ns1:svgBlip xmlns:ns1="http://schemas.microsoft.com/office/drawing/2016/SVG/main" r:embed="rId14"/>
+              </a:ext>
+            </a:extLst>
+          </a:blip>
+          <a:stretch>
+            <a:fillRect/>
+          </a:stretch>
+        </p:blipFill>
+        <p:spPr>
+          <a:xfrm>
+            <a:off x="2874972" y="2496000"/>
+            <a:ext cx="660000" cy="660000"/>
+          </a:xfrm>
+          <a:prstGeom prst="rect">
+            <a:avLst/>
+          </a:prstGeom>
+        </p:spPr>
+      </p:pic>
+      <p:pic>
+        <p:nvPicPr>
+          <p:cNvPr id="127" name="Picture 126" descr="image.png"/>
+          <p:cNvPicPr>
+            <a:picLocks noChangeAspect="1"/>
+          </p:cNvPicPr>
+          <p:nvPr/>
+        </p:nvPicPr>
+        <p:blipFill>
+          <a:blip r:embed="rId4">
+            <a:extLst>
+              <a:ext uri="{96DAC541-7B7A-43D3-8B79-37D633B846F1}">
+                <ns2:svgBlip xmlns:ns2="http://schemas.microsoft.com/office/drawing/2016/SVG/main" r:embed="rId18"/>
+              </a:ext>
+            </a:extLst>
+          </a:blip>
+          <a:stretch>
+            <a:fillRect/>
+          </a:stretch>
+        </p:blipFill>
+        <p:spPr>
+          <a:xfrm>
+            <a:off x="4731204" y="2496000"/>
+            <a:ext cx="660000" cy="660000"/>
+          </a:xfrm>
+          <a:prstGeom prst="rect">
+            <a:avLst/>
+          </a:prstGeom>
+        </p:spPr>
+      </p:pic>
+      <p:pic>
+        <p:nvPicPr>
+          <p:cNvPr id="128" name="Picture 127" descr="image.png"/>
+          <p:cNvPicPr>
+            <a:picLocks noChangeAspect="1"/>
+          </p:cNvPicPr>
+          <p:nvPr/>
+        </p:nvPicPr>
+        <p:blipFill>
+          <a:blip r:embed="rId5">
+            <a:extLst>
+              <a:ext uri="{96DAC541-7B7A-43D3-8B79-37D633B846F1}">
+                <ns3:svgBlip xmlns:ns3="http://schemas.microsoft.com/office/drawing/2016/SVG/main" r:embed="rId17"/>
+              </a:ext>
+            </a:extLst>
+          </a:blip>
+          <a:stretch>
+            <a:fillRect/>
+          </a:stretch>
+        </p:blipFill>
+        <p:spPr>
+          <a:xfrm>
+            <a:off x="6587436" y="2496000"/>
+            <a:ext cx="660000" cy="660000"/>
+          </a:xfrm>
+          <a:prstGeom prst="rect">
+            <a:avLst/>
+          </a:prstGeom>
+        </p:spPr>
+      </p:pic>
+      <p:pic>
+        <p:nvPicPr>
+          <p:cNvPr id="129" name="Picture 128" descr="image.png"/>
+          <p:cNvPicPr>
+            <a:picLocks noChangeAspect="1"/>
+          </p:cNvPicPr>
+          <p:nvPr/>
+        </p:nvPicPr>
+        <p:blipFill>
+          <a:blip r:embed="rId6">
+            <a:extLst>
+              <a:ext uri="{96DAC541-7B7A-43D3-8B79-37D633B846F1}">
+                <ns4:svgBlip xmlns:ns4="http://schemas.microsoft.com/office/drawing/2016/SVG/main" r:embed="rId19"/>
+              </a:ext>
+            </a:extLst>
+          </a:blip>
+          <a:stretch>
+            <a:fillRect/>
+          </a:stretch>
+        </p:blipFill>
+        <p:spPr>
+          <a:xfrm>
+            <a:off x="8443668" y="2496000"/>
+            <a:ext cx="660000" cy="660000"/>
+          </a:xfrm>
+          <a:prstGeom prst="rect">
+            <a:avLst/>
+          </a:prstGeom>
+        </p:spPr>
+      </p:pic>
+      <p:pic>
+        <p:nvPicPr>
+          <p:cNvPr id="130" name="Picture 129" descr="image.png"/>
+          <p:cNvPicPr>
+            <a:picLocks noChangeAspect="1"/>
+          </p:cNvPicPr>
+          <p:nvPr/>
+        </p:nvPicPr>
+        <p:blipFill>
+          <a:blip r:embed="rId7">
+            <a:extLst>
+              <a:ext uri="{96DAC541-7B7A-43D3-8B79-37D633B846F1}">
+                <ns5:svgBlip xmlns:ns5="http://schemas.microsoft.com/office/drawing/2016/SVG/main" r:embed="rId16"/>
+              </a:ext>
+            </a:extLst>
+          </a:blip>
+          <a:stretch>
+            <a:fillRect/>
+          </a:stretch>
+        </p:blipFill>
+        <p:spPr>
+          <a:xfrm>
+            <a:off x="10299900" y="2496000"/>
+            <a:ext cx="660000" cy="660000"/>
+          </a:xfrm>
+          <a:prstGeom prst="rect">
+            <a:avLst/>
+          </a:prstGeom>
+        </p:spPr>
+      </p:pic>
     </p:spTree>
   </p:cSld>
   <p:clrMapOvr>
@@ -10583,6 +10763,186 @@
           </a:prstGeom>
         </p:spPr>
       </p:pic>
+      <p:pic>
+        <p:nvPicPr>
+          <p:cNvPr id="178" name="Picture 177" descr="image.png"/>
+          <p:cNvPicPr>
+            <a:picLocks noChangeAspect="1"/>
+          </p:cNvPicPr>
+          <p:nvPr/>
+        </p:nvPicPr>
+        <p:blipFill>
+          <a:blip r:embed="rId2">
+            <a:extLst>
+              <a:ext uri="{96DAC541-7B7A-43D3-8B79-37D633B846F1}">
+                <ns0:svgBlip xmlns:ns0="http://schemas.microsoft.com/office/drawing/2016/SVG/main" r:embed="rId15"/>
+              </a:ext>
+            </a:extLst>
+          </a:blip>
+          <a:stretch>
+            <a:fillRect/>
+          </a:stretch>
+        </p:blipFill>
+        <p:spPr>
+          <a:xfrm>
+            <a:off x="795528" y="1673352"/>
+            <a:ext cx="246888" cy="246888"/>
+          </a:xfrm>
+          <a:prstGeom prst="rect">
+            <a:avLst/>
+          </a:prstGeom>
+        </p:spPr>
+      </p:pic>
+      <p:pic>
+        <p:nvPicPr>
+          <p:cNvPr id="179" name="Picture 178" descr="image.png"/>
+          <p:cNvPicPr>
+            <a:picLocks noChangeAspect="1"/>
+          </p:cNvPicPr>
+          <p:nvPr/>
+        </p:nvPicPr>
+        <p:blipFill>
+          <a:blip r:embed="rId3">
+            <a:extLst>
+              <a:ext uri="{96DAC541-7B7A-43D3-8B79-37D633B846F1}">
+                <ns1:svgBlip xmlns:ns1="http://schemas.microsoft.com/office/drawing/2016/SVG/main" r:embed="rId14"/>
+              </a:ext>
+            </a:extLst>
+          </a:blip>
+          <a:stretch>
+            <a:fillRect/>
+          </a:stretch>
+        </p:blipFill>
+        <p:spPr>
+          <a:xfrm>
+            <a:off x="795528" y="2441448"/>
+            <a:ext cx="246888" cy="246888"/>
+          </a:xfrm>
+          <a:prstGeom prst="rect">
+            <a:avLst/>
+          </a:prstGeom>
+        </p:spPr>
+      </p:pic>
+      <p:pic>
+        <p:nvPicPr>
+          <p:cNvPr id="180" name="Picture 179" descr="image.png"/>
+          <p:cNvPicPr>
+            <a:picLocks noChangeAspect="1"/>
+          </p:cNvPicPr>
+          <p:nvPr/>
+        </p:nvPicPr>
+        <p:blipFill>
+          <a:blip r:embed="rId4">
+            <a:extLst>
+              <a:ext uri="{96DAC541-7B7A-43D3-8B79-37D633B846F1}">
+                <ns2:svgBlip xmlns:ns2="http://schemas.microsoft.com/office/drawing/2016/SVG/main" r:embed="rId18"/>
+              </a:ext>
+            </a:extLst>
+          </a:blip>
+          <a:stretch>
+            <a:fillRect/>
+          </a:stretch>
+        </p:blipFill>
+        <p:spPr>
+          <a:xfrm>
+            <a:off x="795528" y="3209544"/>
+            <a:ext cx="246888" cy="246888"/>
+          </a:xfrm>
+          <a:prstGeom prst="rect">
+            <a:avLst/>
+          </a:prstGeom>
+        </p:spPr>
+      </p:pic>
+      <p:pic>
+        <p:nvPicPr>
+          <p:cNvPr id="181" name="Picture 180" descr="image.png"/>
+          <p:cNvPicPr>
+            <a:picLocks noChangeAspect="1"/>
+          </p:cNvPicPr>
+          <p:nvPr/>
+        </p:nvPicPr>
+        <p:blipFill>
+          <a:blip r:embed="rId5">
+            <a:extLst>
+              <a:ext uri="{96DAC541-7B7A-43D3-8B79-37D633B846F1}">
+                <ns3:svgBlip xmlns:ns3="http://schemas.microsoft.com/office/drawing/2016/SVG/main" r:embed="rId17"/>
+              </a:ext>
+            </a:extLst>
+          </a:blip>
+          <a:stretch>
+            <a:fillRect/>
+          </a:stretch>
+        </p:blipFill>
+        <p:spPr>
+          <a:xfrm>
+            <a:off x="795528" y="3977640"/>
+            <a:ext cx="246888" cy="246888"/>
+          </a:xfrm>
+          <a:prstGeom prst="rect">
+            <a:avLst/>
+          </a:prstGeom>
+        </p:spPr>
+      </p:pic>
+      <p:pic>
+        <p:nvPicPr>
+          <p:cNvPr id="182" name="Picture 181" descr="image.png"/>
+          <p:cNvPicPr>
+            <a:picLocks noChangeAspect="1"/>
+          </p:cNvPicPr>
+          <p:nvPr/>
+        </p:nvPicPr>
+        <p:blipFill>
+          <a:blip r:embed="rId6">
+            <a:extLst>
+              <a:ext uri="{96DAC541-7B7A-43D3-8B79-37D633B846F1}">
+                <ns4:svgBlip xmlns:ns4="http://schemas.microsoft.com/office/drawing/2016/SVG/main" r:embed="rId19"/>
+              </a:ext>
+            </a:extLst>
+          </a:blip>
+          <a:stretch>
+            <a:fillRect/>
+          </a:stretch>
+        </p:blipFill>
+        <p:spPr>
+          <a:xfrm>
+            <a:off x="795528" y="4745736"/>
+            <a:ext cx="246888" cy="246888"/>
+          </a:xfrm>
+          <a:prstGeom prst="rect">
+            <a:avLst/>
+          </a:prstGeom>
+        </p:spPr>
+      </p:pic>
+      <p:pic>
+        <p:nvPicPr>
+          <p:cNvPr id="183" name="Picture 182" descr="image.png"/>
+          <p:cNvPicPr>
+            <a:picLocks noChangeAspect="1"/>
+          </p:cNvPicPr>
+          <p:nvPr/>
+        </p:nvPicPr>
+        <p:blipFill>
+          <a:blip r:embed="rId7">
+            <a:extLst>
+              <a:ext uri="{96DAC541-7B7A-43D3-8B79-37D633B846F1}">
+                <ns5:svgBlip xmlns:ns5="http://schemas.microsoft.com/office/drawing/2016/SVG/main" r:embed="rId16"/>
+              </a:ext>
+            </a:extLst>
+          </a:blip>
+          <a:stretch>
+            <a:fillRect/>
+          </a:stretch>
+        </p:blipFill>
+        <p:spPr>
+          <a:xfrm>
+            <a:off x="795528" y="5513832"/>
+            <a:ext cx="246888" cy="246888"/>
+          </a:xfrm>
+          <a:prstGeom prst="rect">
+            <a:avLst/>
+          </a:prstGeom>
+        </p:spPr>
+      </p:pic>
     </p:spTree>
   </p:cSld>
   <p:clrMapOvr>
@@ -12799,8 +13159,8 @@
         </p:nvSpPr>
         <p:spPr>
           <a:xfrm>
-            <a:off x="1277240" y="1463040"/>
-            <a:ext cx="2654680" cy="822960"/>
+            <a:off x="1777240" y="1463040"/>
+            <a:ext cx="2154680" cy="822960"/>
           </a:xfrm>
           <a:prstGeom prst="rect">
             <a:avLst/>
@@ -13163,8 +13523,8 @@
         </p:nvSpPr>
         <p:spPr>
           <a:xfrm>
-            <a:off x="5145152" y="1463040"/>
-            <a:ext cx="2654680" cy="822960"/>
+            <a:off x="5645152" y="1463040"/>
+            <a:ext cx="2154680" cy="822960"/>
           </a:xfrm>
           <a:prstGeom prst="rect">
             <a:avLst/>
@@ -13527,8 +13887,8 @@
         </p:nvSpPr>
         <p:spPr>
           <a:xfrm>
-            <a:off x="9013064" y="1463040"/>
-            <a:ext cx="2654680" cy="822960"/>
+            <a:off x="9513064" y="1463040"/>
+            <a:ext cx="2154680" cy="822960"/>
           </a:xfrm>
           <a:prstGeom prst="rect">
             <a:avLst/>
@@ -13888,6 +14248,96 @@
             <a:extLst>
               <a:ext uri="{96DAC541-7B7A-43D3-8B79-37D633B846F1}">
                 <ns2:svgBlip xmlns:ns2="http://schemas.microsoft.com/office/drawing/2016/SVG/main" r:embed="rId10"/>
+              </a:ext>
+            </a:extLst>
+          </a:blip>
+          <a:stretch>
+            <a:fillRect/>
+          </a:stretch>
+        </p:blipFill>
+        <p:spPr>
+          <a:xfrm>
+            <a:off x="8434464" y="1664520"/>
+            <a:ext cx="420000" cy="420000"/>
+          </a:xfrm>
+          <a:prstGeom prst="rect">
+            <a:avLst/>
+          </a:prstGeom>
+        </p:spPr>
+      </p:pic>
+      <p:pic>
+        <p:nvPicPr>
+          <p:cNvPr id="127" name="Picture 126" descr="image.png"/>
+          <p:cNvPicPr>
+            <a:picLocks noChangeAspect="1"/>
+          </p:cNvPicPr>
+          <p:nvPr/>
+        </p:nvPicPr>
+        <p:blipFill>
+          <a:blip r:embed="rId5">
+            <a:extLst>
+              <a:ext uri="{96DAC541-7B7A-43D3-8B79-37D633B846F1}">
+                <ns0:svgBlip xmlns:ns0="http://schemas.microsoft.com/office/drawing/2016/SVG/main" r:embed="rId11"/>
+              </a:ext>
+            </a:extLst>
+          </a:blip>
+          <a:stretch>
+            <a:fillRect/>
+          </a:stretch>
+        </p:blipFill>
+        <p:spPr>
+          <a:xfrm>
+            <a:off x="698640" y="1664520"/>
+            <a:ext cx="420000" cy="420000"/>
+          </a:xfrm>
+          <a:prstGeom prst="rect">
+            <a:avLst/>
+          </a:prstGeom>
+        </p:spPr>
+      </p:pic>
+      <p:pic>
+        <p:nvPicPr>
+          <p:cNvPr id="128" name="Picture 127" descr="image.png"/>
+          <p:cNvPicPr>
+            <a:picLocks noChangeAspect="1"/>
+          </p:cNvPicPr>
+          <p:nvPr/>
+        </p:nvPicPr>
+        <p:blipFill>
+          <a:blip r:embed="rId6">
+            <a:extLst>
+              <a:ext uri="{96DAC541-7B7A-43D3-8B79-37D633B846F1}">
+                <ns1:svgBlip xmlns:ns1="http://schemas.microsoft.com/office/drawing/2016/SVG/main" r:embed="rId12"/>
+              </a:ext>
+            </a:extLst>
+          </a:blip>
+          <a:stretch>
+            <a:fillRect/>
+          </a:stretch>
+        </p:blipFill>
+        <p:spPr>
+          <a:xfrm>
+            <a:off x="4566552" y="1664520"/>
+            <a:ext cx="420000" cy="420000"/>
+          </a:xfrm>
+          <a:prstGeom prst="rect">
+            <a:avLst/>
+          </a:prstGeom>
+        </p:spPr>
+      </p:pic>
+      <p:pic>
+        <p:nvPicPr>
+          <p:cNvPr id="129" name="Picture 128" descr="image.png"/>
+          <p:cNvPicPr>
+            <a:picLocks noChangeAspect="1"/>
+          </p:cNvPicPr>
+          <p:nvPr/>
+        </p:nvPicPr>
+        <p:blipFill>
+          <a:blip r:embed="rId7">
+            <a:extLst>
+              <a:ext uri="{96DAC541-7B7A-43D3-8B79-37D633B846F1}">
+                <ns2:svgBlip xmlns:ns2="http://schemas.microsoft.com/office/drawing/2016/SVG/main" r:embed="rId13"/>
               </a:ext>
             </a:extLst>
           </a:blip>
@@ -16348,8 +16798,8 @@
         </p:nvSpPr>
         <p:spPr>
           <a:xfrm>
-            <a:off x="1342960" y="1554480"/>
-            <a:ext cx="4417760" cy="822960"/>
+            <a:off x="1862960" y="1554480"/>
+            <a:ext cx="3897760" cy="822960"/>
           </a:xfrm>
           <a:prstGeom prst="rect">
             <a:avLst/>
@@ -16713,8 +17163,8 @@
         </p:nvSpPr>
         <p:spPr>
           <a:xfrm>
-            <a:off x="7012240" y="1554480"/>
-            <a:ext cx="4417760" cy="822960"/>
+            <a:off x="7532240" y="1554480"/>
+            <a:ext cx="3897760" cy="822960"/>
           </a:xfrm>
           <a:prstGeom prst="rect">
             <a:avLst/>
@@ -17020,6 +17470,66 @@
             <a:extLst>
               <a:ext uri="{96DAC541-7B7A-43D3-8B79-37D633B846F1}">
                 <ns1:svgBlip xmlns:ns1="http://schemas.microsoft.com/office/drawing/2016/SVG/main" r:embed="rId4"/>
+              </a:ext>
+            </a:extLst>
+          </a:blip>
+          <a:stretch>
+            <a:fillRect/>
+          </a:stretch>
+        </p:blipFill>
+        <p:spPr>
+          <a:xfrm>
+            <a:off x="6367920" y="1750960"/>
+            <a:ext cx="430000" cy="430000"/>
+          </a:xfrm>
+          <a:prstGeom prst="rect">
+            <a:avLst/>
+          </a:prstGeom>
+        </p:spPr>
+      </p:pic>
+      <p:pic>
+        <p:nvPicPr>
+          <p:cNvPr id="56" name="Picture 55" descr="image.png"/>
+          <p:cNvPicPr>
+            <a:picLocks noChangeAspect="1"/>
+          </p:cNvPicPr>
+          <p:nvPr/>
+        </p:nvPicPr>
+        <p:blipFill>
+          <a:blip r:embed="rId2">
+            <a:extLst>
+              <a:ext uri="{96DAC541-7B7A-43D3-8B79-37D633B846F1}">
+                <ns0:svgBlip xmlns:ns0="http://schemas.microsoft.com/office/drawing/2016/SVG/main" r:embed="rId7"/>
+              </a:ext>
+            </a:extLst>
+          </a:blip>
+          <a:stretch>
+            <a:fillRect/>
+          </a:stretch>
+        </p:blipFill>
+        <p:spPr>
+          <a:xfrm>
+            <a:off x="698640" y="1750960"/>
+            <a:ext cx="430000" cy="430000"/>
+          </a:xfrm>
+          <a:prstGeom prst="rect">
+            <a:avLst/>
+          </a:prstGeom>
+        </p:spPr>
+      </p:pic>
+      <p:pic>
+        <p:nvPicPr>
+          <p:cNvPr id="57" name="Picture 56" descr="image.png"/>
+          <p:cNvPicPr>
+            <a:picLocks noChangeAspect="1"/>
+          </p:cNvPicPr>
+          <p:nvPr/>
+        </p:nvPicPr>
+        <p:blipFill>
+          <a:blip r:embed="rId3">
+            <a:extLst>
+              <a:ext uri="{96DAC541-7B7A-43D3-8B79-37D633B846F1}">
+                <ns1:svgBlip xmlns:ns1="http://schemas.microsoft.com/office/drawing/2016/SVG/main" r:embed="rId6"/>
               </a:ext>
             </a:extLst>
           </a:blip>
@@ -18975,6 +19485,96 @@
           </a:prstGeom>
         </p:spPr>
       </p:pic>
+      <p:pic>
+        <p:nvPicPr>
+          <p:cNvPr id="97" name="Picture 96" descr="image.png"/>
+          <p:cNvPicPr>
+            <a:picLocks noChangeAspect="1"/>
+          </p:cNvPicPr>
+          <p:nvPr/>
+        </p:nvPicPr>
+        <p:blipFill>
+          <a:blip r:embed="rId2">
+            <a:extLst>
+              <a:ext uri="{96DAC541-7B7A-43D3-8B79-37D633B846F1}">
+                <ns0:svgBlip xmlns:ns0="http://schemas.microsoft.com/office/drawing/2016/SVG/main" r:embed="rId8"/>
+              </a:ext>
+            </a:extLst>
+          </a:blip>
+          <a:stretch>
+            <a:fillRect/>
+          </a:stretch>
+        </p:blipFill>
+        <p:spPr>
+          <a:xfrm>
+            <a:off x="954440" y="2454056"/>
+            <a:ext cx="560000" cy="560000"/>
+          </a:xfrm>
+          <a:prstGeom prst="rect">
+            <a:avLst/>
+          </a:prstGeom>
+        </p:spPr>
+      </p:pic>
+      <p:pic>
+        <p:nvPicPr>
+          <p:cNvPr id="98" name="Picture 97" descr="image.png"/>
+          <p:cNvPicPr>
+            <a:picLocks noChangeAspect="1"/>
+          </p:cNvPicPr>
+          <p:nvPr/>
+        </p:nvPicPr>
+        <p:blipFill>
+          <a:blip r:embed="rId3">
+            <a:extLst>
+              <a:ext uri="{96DAC541-7B7A-43D3-8B79-37D633B846F1}">
+                <ns1:svgBlip xmlns:ns1="http://schemas.microsoft.com/office/drawing/2016/SVG/main" r:embed="rId9"/>
+              </a:ext>
+            </a:extLst>
+          </a:blip>
+          <a:stretch>
+            <a:fillRect/>
+          </a:stretch>
+        </p:blipFill>
+        <p:spPr>
+          <a:xfrm>
+            <a:off x="954440" y="3752504"/>
+            <a:ext cx="560000" cy="560000"/>
+          </a:xfrm>
+          <a:prstGeom prst="rect">
+            <a:avLst/>
+          </a:prstGeom>
+        </p:spPr>
+      </p:pic>
+      <p:pic>
+        <p:nvPicPr>
+          <p:cNvPr id="99" name="Picture 98" descr="image.png"/>
+          <p:cNvPicPr>
+            <a:picLocks noChangeAspect="1"/>
+          </p:cNvPicPr>
+          <p:nvPr/>
+        </p:nvPicPr>
+        <p:blipFill>
+          <a:blip r:embed="rId4">
+            <a:extLst>
+              <a:ext uri="{96DAC541-7B7A-43D3-8B79-37D633B846F1}">
+                <ns2:svgBlip xmlns:ns2="http://schemas.microsoft.com/office/drawing/2016/SVG/main" r:embed="rId10"/>
+              </a:ext>
+            </a:extLst>
+          </a:blip>
+          <a:stretch>
+            <a:fillRect/>
+          </a:stretch>
+        </p:blipFill>
+        <p:spPr>
+          <a:xfrm>
+            <a:off x="954440" y="5050952"/>
+            <a:ext cx="560000" cy="560000"/>
+          </a:xfrm>
+          <a:prstGeom prst="rect">
+            <a:avLst/>
+          </a:prstGeom>
+        </p:spPr>
+      </p:pic>
     </p:spTree>
   </p:cSld>
   <p:clrMapOvr>
@@ -27504,6 +28104,186 @@
           </a:prstGeom>
         </p:spPr>
       </p:pic>
+      <p:pic>
+        <p:nvPicPr>
+          <p:cNvPr id="130" name="Picture 129" descr="image.png"/>
+          <p:cNvPicPr>
+            <a:picLocks noChangeAspect="1"/>
+          </p:cNvPicPr>
+          <p:nvPr/>
+        </p:nvPicPr>
+        <p:blipFill>
+          <a:blip r:embed="rId3">
+            <a:extLst>
+              <a:ext uri="{96DAC541-7B7A-43D3-8B79-37D633B846F1}">
+                <ns0:svgBlip xmlns:ns0="http://schemas.microsoft.com/office/drawing/2016/SVG/main" r:embed="rId15"/>
+              </a:ext>
+            </a:extLst>
+          </a:blip>
+          <a:stretch>
+            <a:fillRect/>
+          </a:stretch>
+        </p:blipFill>
+        <p:spPr>
+          <a:xfrm>
+            <a:off x="4638935" y="944759"/>
+            <a:ext cx="414771" cy="414771"/>
+          </a:xfrm>
+          <a:prstGeom prst="rect">
+            <a:avLst/>
+          </a:prstGeom>
+        </p:spPr>
+      </p:pic>
+      <p:pic>
+        <p:nvPicPr>
+          <p:cNvPr id="131" name="Picture 130" descr="image.png"/>
+          <p:cNvPicPr>
+            <a:picLocks noChangeAspect="1"/>
+          </p:cNvPicPr>
+          <p:nvPr/>
+        </p:nvPicPr>
+        <p:blipFill>
+          <a:blip r:embed="rId4">
+            <a:extLst>
+              <a:ext uri="{96DAC541-7B7A-43D3-8B79-37D633B846F1}">
+                <ns1:svgBlip xmlns:ns1="http://schemas.microsoft.com/office/drawing/2016/SVG/main" r:embed="rId17"/>
+              </a:ext>
+            </a:extLst>
+          </a:blip>
+          <a:stretch>
+            <a:fillRect/>
+          </a:stretch>
+        </p:blipFill>
+        <p:spPr>
+          <a:xfrm>
+            <a:off x="4638935" y="1831727"/>
+            <a:ext cx="414771" cy="414771"/>
+          </a:xfrm>
+          <a:prstGeom prst="rect">
+            <a:avLst/>
+          </a:prstGeom>
+        </p:spPr>
+      </p:pic>
+      <p:pic>
+        <p:nvPicPr>
+          <p:cNvPr id="132" name="Picture 131" descr="image.png"/>
+          <p:cNvPicPr>
+            <a:picLocks noChangeAspect="1"/>
+          </p:cNvPicPr>
+          <p:nvPr/>
+        </p:nvPicPr>
+        <p:blipFill>
+          <a:blip r:embed="rId5">
+            <a:extLst>
+              <a:ext uri="{96DAC541-7B7A-43D3-8B79-37D633B846F1}">
+                <ns2:svgBlip xmlns:ns2="http://schemas.microsoft.com/office/drawing/2016/SVG/main" r:embed="rId16"/>
+              </a:ext>
+            </a:extLst>
+          </a:blip>
+          <a:stretch>
+            <a:fillRect/>
+          </a:stretch>
+        </p:blipFill>
+        <p:spPr>
+          <a:xfrm>
+            <a:off x="4638935" y="2718695"/>
+            <a:ext cx="414771" cy="414771"/>
+          </a:xfrm>
+          <a:prstGeom prst="rect">
+            <a:avLst/>
+          </a:prstGeom>
+        </p:spPr>
+      </p:pic>
+      <p:pic>
+        <p:nvPicPr>
+          <p:cNvPr id="133" name="Picture 132" descr="image.png"/>
+          <p:cNvPicPr>
+            <a:picLocks noChangeAspect="1"/>
+          </p:cNvPicPr>
+          <p:nvPr/>
+        </p:nvPicPr>
+        <p:blipFill>
+          <a:blip r:embed="rId6">
+            <a:extLst>
+              <a:ext uri="{96DAC541-7B7A-43D3-8B79-37D633B846F1}">
+                <ns3:svgBlip xmlns:ns3="http://schemas.microsoft.com/office/drawing/2016/SVG/main" r:embed="rId18"/>
+              </a:ext>
+            </a:extLst>
+          </a:blip>
+          <a:stretch>
+            <a:fillRect/>
+          </a:stretch>
+        </p:blipFill>
+        <p:spPr>
+          <a:xfrm>
+            <a:off x="4638935" y="3605663"/>
+            <a:ext cx="414771" cy="414771"/>
+          </a:xfrm>
+          <a:prstGeom prst="rect">
+            <a:avLst/>
+          </a:prstGeom>
+        </p:spPr>
+      </p:pic>
+      <p:pic>
+        <p:nvPicPr>
+          <p:cNvPr id="134" name="Picture 133" descr="image.png"/>
+          <p:cNvPicPr>
+            <a:picLocks noChangeAspect="1"/>
+          </p:cNvPicPr>
+          <p:nvPr/>
+        </p:nvPicPr>
+        <p:blipFill>
+          <a:blip r:embed="rId7">
+            <a:extLst>
+              <a:ext uri="{96DAC541-7B7A-43D3-8B79-37D633B846F1}">
+                <ns4:svgBlip xmlns:ns4="http://schemas.microsoft.com/office/drawing/2016/SVG/main" r:embed="rId20"/>
+              </a:ext>
+            </a:extLst>
+          </a:blip>
+          <a:stretch>
+            <a:fillRect/>
+          </a:stretch>
+        </p:blipFill>
+        <p:spPr>
+          <a:xfrm>
+            <a:off x="4638935" y="4492631"/>
+            <a:ext cx="414771" cy="414771"/>
+          </a:xfrm>
+          <a:prstGeom prst="rect">
+            <a:avLst/>
+          </a:prstGeom>
+        </p:spPr>
+      </p:pic>
+      <p:pic>
+        <p:nvPicPr>
+          <p:cNvPr id="135" name="Picture 134" descr="image.png"/>
+          <p:cNvPicPr>
+            <a:picLocks noChangeAspect="1"/>
+          </p:cNvPicPr>
+          <p:nvPr/>
+        </p:nvPicPr>
+        <p:blipFill>
+          <a:blip r:embed="rId8">
+            <a:extLst>
+              <a:ext uri="{96DAC541-7B7A-43D3-8B79-37D633B846F1}">
+                <ns5:svgBlip xmlns:ns5="http://schemas.microsoft.com/office/drawing/2016/SVG/main" r:embed="rId19"/>
+              </a:ext>
+            </a:extLst>
+          </a:blip>
+          <a:stretch>
+            <a:fillRect/>
+          </a:stretch>
+        </p:blipFill>
+        <p:spPr>
+          <a:xfrm>
+            <a:off x="4638935" y="5379599"/>
+            <a:ext cx="414771" cy="414771"/>
+          </a:xfrm>
+          <a:prstGeom prst="rect">
+            <a:avLst/>
+          </a:prstGeom>
+        </p:spPr>
+      </p:pic>
     </p:spTree>
   </p:cSld>
   <p:clrMapOvr>
@@ -34129,6 +34909,126 @@
           </a:prstGeom>
         </p:spPr>
       </p:pic>
+      <p:pic>
+        <p:nvPicPr>
+          <p:cNvPr id="108" name="Picture 107" descr="image.png"/>
+          <p:cNvPicPr>
+            <a:picLocks noChangeAspect="1"/>
+          </p:cNvPicPr>
+          <p:nvPr/>
+        </p:nvPicPr>
+        <p:blipFill>
+          <a:blip r:embed="rId2">
+            <a:extLst>
+              <a:ext uri="{96DAC541-7B7A-43D3-8B79-37D633B846F1}">
+                <ns0:svgBlip xmlns:ns0="http://schemas.microsoft.com/office/drawing/2016/SVG/main" r:embed="rId11"/>
+              </a:ext>
+            </a:extLst>
+          </a:blip>
+          <a:stretch>
+            <a:fillRect/>
+          </a:stretch>
+        </p:blipFill>
+        <p:spPr>
+          <a:xfrm>
+            <a:off x="925373" y="1931213"/>
+            <a:ext cx="307238" cy="307238"/>
+          </a:xfrm>
+          <a:prstGeom prst="rect">
+            <a:avLst/>
+          </a:prstGeom>
+        </p:spPr>
+      </p:pic>
+      <p:pic>
+        <p:nvPicPr>
+          <p:cNvPr id="109" name="Picture 108" descr="image.png"/>
+          <p:cNvPicPr>
+            <a:picLocks noChangeAspect="1"/>
+          </p:cNvPicPr>
+          <p:nvPr/>
+        </p:nvPicPr>
+        <p:blipFill>
+          <a:blip r:embed="rId3">
+            <a:extLst>
+              <a:ext uri="{96DAC541-7B7A-43D3-8B79-37D633B846F1}">
+                <ns1:svgBlip xmlns:ns1="http://schemas.microsoft.com/office/drawing/2016/SVG/main" r:embed="rId12"/>
+              </a:ext>
+            </a:extLst>
+          </a:blip>
+          <a:stretch>
+            <a:fillRect/>
+          </a:stretch>
+        </p:blipFill>
+        <p:spPr>
+          <a:xfrm>
+            <a:off x="6548933" y="1931213"/>
+            <a:ext cx="307238" cy="307238"/>
+          </a:xfrm>
+          <a:prstGeom prst="rect">
+            <a:avLst/>
+          </a:prstGeom>
+        </p:spPr>
+      </p:pic>
+      <p:pic>
+        <p:nvPicPr>
+          <p:cNvPr id="110" name="Picture 109" descr="image.png"/>
+          <p:cNvPicPr>
+            <a:picLocks noChangeAspect="1"/>
+          </p:cNvPicPr>
+          <p:nvPr/>
+        </p:nvPicPr>
+        <p:blipFill>
+          <a:blip r:embed="rId4">
+            <a:extLst>
+              <a:ext uri="{96DAC541-7B7A-43D3-8B79-37D633B846F1}">
+                <ns2:svgBlip xmlns:ns2="http://schemas.microsoft.com/office/drawing/2016/SVG/main" r:embed="rId10"/>
+              </a:ext>
+            </a:extLst>
+          </a:blip>
+          <a:stretch>
+            <a:fillRect/>
+          </a:stretch>
+        </p:blipFill>
+        <p:spPr>
+          <a:xfrm>
+            <a:off x="925373" y="4171493"/>
+            <a:ext cx="307238" cy="307238"/>
+          </a:xfrm>
+          <a:prstGeom prst="rect">
+            <a:avLst/>
+          </a:prstGeom>
+        </p:spPr>
+      </p:pic>
+      <p:pic>
+        <p:nvPicPr>
+          <p:cNvPr id="111" name="Picture 110" descr="image.png"/>
+          <p:cNvPicPr>
+            <a:picLocks noChangeAspect="1"/>
+          </p:cNvPicPr>
+          <p:nvPr/>
+        </p:nvPicPr>
+        <p:blipFill>
+          <a:blip r:embed="rId5">
+            <a:extLst>
+              <a:ext uri="{96DAC541-7B7A-43D3-8B79-37D633B846F1}">
+                <ns3:svgBlip xmlns:ns3="http://schemas.microsoft.com/office/drawing/2016/SVG/main" r:embed="rId13"/>
+              </a:ext>
+            </a:extLst>
+          </a:blip>
+          <a:stretch>
+            <a:fillRect/>
+          </a:stretch>
+        </p:blipFill>
+        <p:spPr>
+          <a:xfrm>
+            <a:off x="6548933" y="4171493"/>
+            <a:ext cx="307238" cy="307238"/>
+          </a:xfrm>
+          <a:prstGeom prst="rect">
+            <a:avLst/>
+          </a:prstGeom>
+        </p:spPr>
+      </p:pic>
     </p:spTree>
   </p:cSld>
   <p:clrMapOvr>
@@ -35917,8 +36817,8 @@
         </p:nvSpPr>
         <p:spPr>
           <a:xfrm>
-            <a:off x="1351520" y="1664207"/>
-            <a:ext cx="1986040" cy="1152144"/>
+            <a:off x="1971520" y="1664207"/>
+            <a:ext cx="1366040" cy="1152144"/>
           </a:xfrm>
           <a:prstGeom prst="rect">
             <a:avLst/>
@@ -36173,8 +37073,8 @@
         </p:nvSpPr>
         <p:spPr>
           <a:xfrm>
-            <a:off x="1351520" y="3145536"/>
-            <a:ext cx="1986040" cy="1152144"/>
+            <a:off x="1971520" y="3145536"/>
+            <a:ext cx="1366040" cy="1152144"/>
           </a:xfrm>
           <a:prstGeom prst="rect">
             <a:avLst/>
@@ -36429,8 +37329,8 @@
         </p:nvSpPr>
         <p:spPr>
           <a:xfrm>
-            <a:off x="1351520" y="4626864"/>
-            <a:ext cx="1986040" cy="1152144"/>
+            <a:off x="1971520" y="4626864"/>
+            <a:ext cx="1366040" cy="1152144"/>
           </a:xfrm>
           <a:prstGeom prst="rect">
             <a:avLst/>
@@ -36686,6 +37586,96 @@
             <a:extLst>
               <a:ext uri="{96DAC541-7B7A-43D3-8B79-37D633B846F1}">
                 <ns2:svgBlip xmlns:ns2="http://schemas.microsoft.com/office/drawing/2016/SVG/main" r:embed="rId6"/>
+              </a:ext>
+            </a:extLst>
+          </a:blip>
+          <a:stretch>
+            <a:fillRect/>
+          </a:stretch>
+        </p:blipFill>
+        <p:spPr>
+          <a:xfrm>
+            <a:off x="698640" y="4962936"/>
+            <a:ext cx="480000" cy="480000"/>
+          </a:xfrm>
+          <a:prstGeom prst="rect">
+            <a:avLst/>
+          </a:prstGeom>
+        </p:spPr>
+      </p:pic>
+      <p:pic>
+        <p:nvPicPr>
+          <p:cNvPr id="67" name="Picture 66" descr="image.png"/>
+          <p:cNvPicPr>
+            <a:picLocks noChangeAspect="1"/>
+          </p:cNvPicPr>
+          <p:nvPr/>
+        </p:nvPicPr>
+        <p:blipFill>
+          <a:blip r:embed="rId2">
+            <a:extLst>
+              <a:ext uri="{96DAC541-7B7A-43D3-8B79-37D633B846F1}">
+                <ns0:svgBlip xmlns:ns0="http://schemas.microsoft.com/office/drawing/2016/SVG/main" r:embed="rId8"/>
+              </a:ext>
+            </a:extLst>
+          </a:blip>
+          <a:stretch>
+            <a:fillRect/>
+          </a:stretch>
+        </p:blipFill>
+        <p:spPr>
+          <a:xfrm>
+            <a:off x="698640" y="2000280"/>
+            <a:ext cx="480000" cy="480000"/>
+          </a:xfrm>
+          <a:prstGeom prst="rect">
+            <a:avLst/>
+          </a:prstGeom>
+        </p:spPr>
+      </p:pic>
+      <p:pic>
+        <p:nvPicPr>
+          <p:cNvPr id="68" name="Picture 67" descr="image.png"/>
+          <p:cNvPicPr>
+            <a:picLocks noChangeAspect="1"/>
+          </p:cNvPicPr>
+          <p:nvPr/>
+        </p:nvPicPr>
+        <p:blipFill>
+          <a:blip r:embed="rId3">
+            <a:extLst>
+              <a:ext uri="{96DAC541-7B7A-43D3-8B79-37D633B846F1}">
+                <ns1:svgBlip xmlns:ns1="http://schemas.microsoft.com/office/drawing/2016/SVG/main" r:embed="rId10"/>
+              </a:ext>
+            </a:extLst>
+          </a:blip>
+          <a:stretch>
+            <a:fillRect/>
+          </a:stretch>
+        </p:blipFill>
+        <p:spPr>
+          <a:xfrm>
+            <a:off x="698640" y="3481608"/>
+            <a:ext cx="480000" cy="480000"/>
+          </a:xfrm>
+          <a:prstGeom prst="rect">
+            <a:avLst/>
+          </a:prstGeom>
+        </p:spPr>
+      </p:pic>
+      <p:pic>
+        <p:nvPicPr>
+          <p:cNvPr id="69" name="Picture 68" descr="image.png"/>
+          <p:cNvPicPr>
+            <a:picLocks noChangeAspect="1"/>
+          </p:cNvPicPr>
+          <p:nvPr/>
+        </p:nvPicPr>
+        <p:blipFill>
+          <a:blip r:embed="rId4">
+            <a:extLst>
+              <a:ext uri="{96DAC541-7B7A-43D3-8B79-37D633B846F1}">
+                <ns2:svgBlip xmlns:ns2="http://schemas.microsoft.com/office/drawing/2016/SVG/main" r:embed="rId9"/>
               </a:ext>
             </a:extLst>
           </a:blip>
@@ -38259,6 +39249,96 @@
           </a:prstGeom>
         </p:spPr>
       </p:pic>
+      <p:pic>
+        <p:nvPicPr>
+          <p:cNvPr id="52" name="Picture 51" descr="image.png"/>
+          <p:cNvPicPr>
+            <a:picLocks noChangeAspect="1"/>
+          </p:cNvPicPr>
+          <p:nvPr/>
+        </p:nvPicPr>
+        <p:blipFill>
+          <a:blip r:embed="rId2">
+            <a:extLst>
+              <a:ext uri="{96DAC541-7B7A-43D3-8B79-37D633B846F1}">
+                <ns0:svgBlip xmlns:ns0="http://schemas.microsoft.com/office/drawing/2016/SVG/main" r:embed="rId8"/>
+              </a:ext>
+            </a:extLst>
+          </a:blip>
+          <a:stretch>
+            <a:fillRect/>
+          </a:stretch>
+        </p:blipFill>
+        <p:spPr>
+          <a:xfrm>
+            <a:off x="1182320" y="2462480"/>
+            <a:ext cx="332841" cy="332841"/>
+          </a:xfrm>
+          <a:prstGeom prst="rect">
+            <a:avLst/>
+          </a:prstGeom>
+        </p:spPr>
+      </p:pic>
+      <p:pic>
+        <p:nvPicPr>
+          <p:cNvPr id="53" name="Picture 52" descr="image.png"/>
+          <p:cNvPicPr>
+            <a:picLocks noChangeAspect="1"/>
+          </p:cNvPicPr>
+          <p:nvPr/>
+        </p:nvPicPr>
+        <p:blipFill>
+          <a:blip r:embed="rId3">
+            <a:extLst>
+              <a:ext uri="{96DAC541-7B7A-43D3-8B79-37D633B846F1}">
+                <ns1:svgBlip xmlns:ns1="http://schemas.microsoft.com/office/drawing/2016/SVG/main" r:embed="rId9"/>
+              </a:ext>
+            </a:extLst>
+          </a:blip>
+          <a:stretch>
+            <a:fillRect/>
+          </a:stretch>
+        </p:blipFill>
+        <p:spPr>
+          <a:xfrm>
+            <a:off x="1182320" y="3834080"/>
+            <a:ext cx="332841" cy="332841"/>
+          </a:xfrm>
+          <a:prstGeom prst="rect">
+            <a:avLst/>
+          </a:prstGeom>
+        </p:spPr>
+      </p:pic>
+      <p:pic>
+        <p:nvPicPr>
+          <p:cNvPr id="54" name="Picture 53" descr="image.png"/>
+          <p:cNvPicPr>
+            <a:picLocks noChangeAspect="1"/>
+          </p:cNvPicPr>
+          <p:nvPr/>
+        </p:nvPicPr>
+        <p:blipFill>
+          <a:blip r:embed="rId4">
+            <a:extLst>
+              <a:ext uri="{96DAC541-7B7A-43D3-8B79-37D633B846F1}">
+                <ns2:svgBlip xmlns:ns2="http://schemas.microsoft.com/office/drawing/2016/SVG/main" r:embed="rId10"/>
+              </a:ext>
+            </a:extLst>
+          </a:blip>
+          <a:stretch>
+            <a:fillRect/>
+          </a:stretch>
+        </p:blipFill>
+        <p:spPr>
+          <a:xfrm>
+            <a:off x="1182320" y="5205680"/>
+            <a:ext cx="332841" cy="332841"/>
+          </a:xfrm>
+          <a:prstGeom prst="rect">
+            <a:avLst/>
+          </a:prstGeom>
+        </p:spPr>
+      </p:pic>
     </p:spTree>
   </p:cSld>
   <p:clrMapOvr>
@@ -39762,8 +40842,8 @@
         </p:nvSpPr>
         <p:spPr>
           <a:xfrm>
-            <a:off x="5589200" y="1600200"/>
-            <a:ext cx="5840800" cy="457200"/>
+            <a:off x="6149200" y="1600200"/>
+            <a:ext cx="5280800" cy="457200"/>
           </a:xfrm>
           <a:prstGeom prst="rect">
             <a:avLst/>
@@ -39797,8 +40877,8 @@
         </p:nvSpPr>
         <p:spPr>
           <a:xfrm>
-            <a:off x="5589200" y="2057400"/>
-            <a:ext cx="5840800" cy="640080"/>
+            <a:off x="6149200" y="2057400"/>
+            <a:ext cx="5280800" cy="640080"/>
           </a:xfrm>
           <a:prstGeom prst="rect">
             <a:avLst/>
@@ -39930,8 +41010,8 @@
         </p:nvSpPr>
         <p:spPr>
           <a:xfrm>
-            <a:off x="5589200" y="3182112"/>
-            <a:ext cx="5840800" cy="457200"/>
+            <a:off x="6149200" y="3182112"/>
+            <a:ext cx="5280800" cy="457200"/>
           </a:xfrm>
           <a:prstGeom prst="rect">
             <a:avLst/>
@@ -39965,8 +41045,8 @@
         </p:nvSpPr>
         <p:spPr>
           <a:xfrm>
-            <a:off x="5589200" y="3639312"/>
-            <a:ext cx="5840800" cy="640080"/>
+            <a:off x="6149200" y="3639312"/>
+            <a:ext cx="5280800" cy="640080"/>
           </a:xfrm>
           <a:prstGeom prst="rect">
             <a:avLst/>
@@ -40098,8 +41178,8 @@
         </p:nvSpPr>
         <p:spPr>
           <a:xfrm>
-            <a:off x="5589200" y="4764024"/>
-            <a:ext cx="5840800" cy="457200"/>
+            <a:off x="6149200" y="4764024"/>
+            <a:ext cx="5280800" cy="457200"/>
           </a:xfrm>
           <a:prstGeom prst="rect">
             <a:avLst/>
@@ -40133,8 +41213,8 @@
         </p:nvSpPr>
         <p:spPr>
           <a:xfrm>
-            <a:off x="5589200" y="5221224"/>
-            <a:ext cx="5840800" cy="640080"/>
+            <a:off x="6149200" y="5221224"/>
+            <a:ext cx="5280800" cy="640080"/>
           </a:xfrm>
           <a:prstGeom prst="rect">
             <a:avLst/>
@@ -40272,6 +41352,96 @@
             <a:extLst>
               <a:ext uri="{96DAC541-7B7A-43D3-8B79-37D633B846F1}">
                 <ns2:svgBlip xmlns:ns2="http://schemas.microsoft.com/office/drawing/2016/SVG/main" r:embed="rId6"/>
+              </a:ext>
+            </a:extLst>
+          </a:blip>
+          <a:stretch>
+            <a:fillRect/>
+          </a:stretch>
+        </p:blipFill>
+        <p:spPr>
+          <a:xfrm>
+            <a:off x="4813440" y="5069804"/>
+            <a:ext cx="440000" cy="440000"/>
+          </a:xfrm>
+          <a:prstGeom prst="rect">
+            <a:avLst/>
+          </a:prstGeom>
+        </p:spPr>
+      </p:pic>
+      <p:pic>
+        <p:nvPicPr>
+          <p:cNvPr id="67" name="Picture 66" descr="image.png"/>
+          <p:cNvPicPr>
+            <a:picLocks noChangeAspect="1"/>
+          </p:cNvPicPr>
+          <p:nvPr/>
+        </p:nvPicPr>
+        <p:blipFill>
+          <a:blip r:embed="rId3">
+            <a:extLst>
+              <a:ext uri="{96DAC541-7B7A-43D3-8B79-37D633B846F1}">
+                <ns0:svgBlip xmlns:ns0="http://schemas.microsoft.com/office/drawing/2016/SVG/main" r:embed="rId10"/>
+              </a:ext>
+            </a:extLst>
+          </a:blip>
+          <a:stretch>
+            <a:fillRect/>
+          </a:stretch>
+        </p:blipFill>
+        <p:spPr>
+          <a:xfrm>
+            <a:off x="4813440" y="1905980"/>
+            <a:ext cx="440000" cy="440000"/>
+          </a:xfrm>
+          <a:prstGeom prst="rect">
+            <a:avLst/>
+          </a:prstGeom>
+        </p:spPr>
+      </p:pic>
+      <p:pic>
+        <p:nvPicPr>
+          <p:cNvPr id="68" name="Picture 67" descr="image.png"/>
+          <p:cNvPicPr>
+            <a:picLocks noChangeAspect="1"/>
+          </p:cNvPicPr>
+          <p:nvPr/>
+        </p:nvPicPr>
+        <p:blipFill>
+          <a:blip r:embed="rId4">
+            <a:extLst>
+              <a:ext uri="{96DAC541-7B7A-43D3-8B79-37D633B846F1}">
+                <ns1:svgBlip xmlns:ns1="http://schemas.microsoft.com/office/drawing/2016/SVG/main" r:embed="rId11"/>
+              </a:ext>
+            </a:extLst>
+          </a:blip>
+          <a:stretch>
+            <a:fillRect/>
+          </a:stretch>
+        </p:blipFill>
+        <p:spPr>
+          <a:xfrm>
+            <a:off x="4813440" y="3487892"/>
+            <a:ext cx="440000" cy="440000"/>
+          </a:xfrm>
+          <a:prstGeom prst="rect">
+            <a:avLst/>
+          </a:prstGeom>
+        </p:spPr>
+      </p:pic>
+      <p:pic>
+        <p:nvPicPr>
+          <p:cNvPr id="69" name="Picture 68" descr="image.png"/>
+          <p:cNvPicPr>
+            <a:picLocks noChangeAspect="1"/>
+          </p:cNvPicPr>
+          <p:nvPr/>
+        </p:nvPicPr>
+        <p:blipFill>
+          <a:blip r:embed="rId5">
+            <a:extLst>
+              <a:ext uri="{96DAC541-7B7A-43D3-8B79-37D633B846F1}">
+                <ns2:svgBlip xmlns:ns2="http://schemas.microsoft.com/office/drawing/2016/SVG/main" r:embed="rId9"/>
               </a:ext>
             </a:extLst>
           </a:blip>
@@ -41509,8 +42679,8 @@
         </p:nvSpPr>
         <p:spPr>
           <a:xfrm>
-            <a:off x="1324672" y="1554480"/>
-            <a:ext cx="2634680" cy="777240"/>
+            <a:off x="1844672" y="1554480"/>
+            <a:ext cx="2114680" cy="777240"/>
           </a:xfrm>
           <a:prstGeom prst="rect">
             <a:avLst/>
@@ -41828,8 +42998,8 @@
         </p:nvSpPr>
         <p:spPr>
           <a:xfrm>
-            <a:off x="5192584" y="1554480"/>
-            <a:ext cx="2634680" cy="777240"/>
+            <a:off x="5712584" y="1554480"/>
+            <a:ext cx="2114680" cy="777240"/>
           </a:xfrm>
           <a:prstGeom prst="rect">
             <a:avLst/>
@@ -42147,8 +43317,8 @@
         </p:nvSpPr>
         <p:spPr>
           <a:xfrm>
-            <a:off x="9060496" y="1554480"/>
-            <a:ext cx="2634680" cy="777240"/>
+            <a:off x="9580496" y="1554480"/>
+            <a:ext cx="2114680" cy="777240"/>
           </a:xfrm>
           <a:prstGeom prst="rect">
             <a:avLst/>
@@ -42463,6 +43633,96 @@
             <a:extLst>
               <a:ext uri="{96DAC541-7B7A-43D3-8B79-37D633B846F1}">
                 <ns2:svgBlip xmlns:ns2="http://schemas.microsoft.com/office/drawing/2016/SVG/main" r:embed="rId5"/>
+              </a:ext>
+            </a:extLst>
+          </a:blip>
+          <a:stretch>
+            <a:fillRect/>
+          </a:stretch>
+        </p:blipFill>
+        <p:spPr>
+          <a:xfrm>
+            <a:off x="8434464" y="1728100"/>
+            <a:ext cx="430000" cy="430000"/>
+          </a:xfrm>
+          <a:prstGeom prst="rect">
+            <a:avLst/>
+          </a:prstGeom>
+        </p:spPr>
+      </p:pic>
+      <p:pic>
+        <p:nvPicPr>
+          <p:cNvPr id="97" name="Picture 96" descr="image.png"/>
+          <p:cNvPicPr>
+            <a:picLocks noChangeAspect="1"/>
+          </p:cNvPicPr>
+          <p:nvPr/>
+        </p:nvPicPr>
+        <p:blipFill>
+          <a:blip r:embed="rId2">
+            <a:extLst>
+              <a:ext uri="{96DAC541-7B7A-43D3-8B79-37D633B846F1}">
+                <ns0:svgBlip xmlns:ns0="http://schemas.microsoft.com/office/drawing/2016/SVG/main" r:embed="rId10"/>
+              </a:ext>
+            </a:extLst>
+          </a:blip>
+          <a:stretch>
+            <a:fillRect/>
+          </a:stretch>
+        </p:blipFill>
+        <p:spPr>
+          <a:xfrm>
+            <a:off x="698640" y="1728100"/>
+            <a:ext cx="430000" cy="430000"/>
+          </a:xfrm>
+          <a:prstGeom prst="rect">
+            <a:avLst/>
+          </a:prstGeom>
+        </p:spPr>
+      </p:pic>
+      <p:pic>
+        <p:nvPicPr>
+          <p:cNvPr id="98" name="Picture 97" descr="image.png"/>
+          <p:cNvPicPr>
+            <a:picLocks noChangeAspect="1"/>
+          </p:cNvPicPr>
+          <p:nvPr/>
+        </p:nvPicPr>
+        <p:blipFill>
+          <a:blip r:embed="rId3">
+            <a:extLst>
+              <a:ext uri="{96DAC541-7B7A-43D3-8B79-37D633B846F1}">
+                <ns1:svgBlip xmlns:ns1="http://schemas.microsoft.com/office/drawing/2016/SVG/main" r:embed="rId9"/>
+              </a:ext>
+            </a:extLst>
+          </a:blip>
+          <a:stretch>
+            <a:fillRect/>
+          </a:stretch>
+        </p:blipFill>
+        <p:spPr>
+          <a:xfrm>
+            <a:off x="4566552" y="1728100"/>
+            <a:ext cx="430000" cy="430000"/>
+          </a:xfrm>
+          <a:prstGeom prst="rect">
+            <a:avLst/>
+          </a:prstGeom>
+        </p:spPr>
+      </p:pic>
+      <p:pic>
+        <p:nvPicPr>
+          <p:cNvPr id="99" name="Picture 98" descr="image.png"/>
+          <p:cNvPicPr>
+            <a:picLocks noChangeAspect="1"/>
+          </p:cNvPicPr>
+          <p:nvPr/>
+        </p:nvPicPr>
+        <p:blipFill>
+          <a:blip r:embed="rId4">
+            <a:extLst>
+              <a:ext uri="{96DAC541-7B7A-43D3-8B79-37D633B846F1}">
+                <ns2:svgBlip xmlns:ns2="http://schemas.microsoft.com/office/drawing/2016/SVG/main" r:embed="rId8"/>
               </a:ext>
             </a:extLst>
           </a:blip>
@@ -45673,6 +46933,246 @@
           </a:prstGeom>
         </p:spPr>
       </p:pic>
+      <p:pic>
+        <p:nvPicPr>
+          <p:cNvPr id="88" name="Picture 87" descr="image.png"/>
+          <p:cNvPicPr>
+            <a:picLocks noChangeAspect="1"/>
+          </p:cNvPicPr>
+          <p:nvPr/>
+        </p:nvPicPr>
+        <p:blipFill>
+          <a:blip r:embed="rId2">
+            <a:extLst>
+              <a:ext uri="{96DAC541-7B7A-43D3-8B79-37D633B846F1}">
+                <ns0:svgBlip xmlns:ns0="http://schemas.microsoft.com/office/drawing/2016/SVG/main" r:embed="rId20"/>
+              </a:ext>
+            </a:extLst>
+          </a:blip>
+          <a:stretch>
+            <a:fillRect/>
+          </a:stretch>
+        </p:blipFill>
+        <p:spPr>
+          <a:xfrm>
+            <a:off x="918058" y="1814170"/>
+            <a:ext cx="358444" cy="358444"/>
+          </a:xfrm>
+          <a:prstGeom prst="rect">
+            <a:avLst/>
+          </a:prstGeom>
+        </p:spPr>
+      </p:pic>
+      <p:pic>
+        <p:nvPicPr>
+          <p:cNvPr id="89" name="Picture 88" descr="image.png"/>
+          <p:cNvPicPr>
+            <a:picLocks noChangeAspect="1"/>
+          </p:cNvPicPr>
+          <p:nvPr/>
+        </p:nvPicPr>
+        <p:blipFill>
+          <a:blip r:embed="rId3">
+            <a:extLst>
+              <a:ext uri="{96DAC541-7B7A-43D3-8B79-37D633B846F1}">
+                <ns1:svgBlip xmlns:ns1="http://schemas.microsoft.com/office/drawing/2016/SVG/main" r:embed="rId21"/>
+              </a:ext>
+            </a:extLst>
+          </a:blip>
+          <a:stretch>
+            <a:fillRect/>
+          </a:stretch>
+        </p:blipFill>
+        <p:spPr>
+          <a:xfrm>
+            <a:off x="918058" y="2948026"/>
+            <a:ext cx="358444" cy="358444"/>
+          </a:xfrm>
+          <a:prstGeom prst="rect">
+            <a:avLst/>
+          </a:prstGeom>
+        </p:spPr>
+      </p:pic>
+      <p:pic>
+        <p:nvPicPr>
+          <p:cNvPr id="90" name="Picture 89" descr="image.png"/>
+          <p:cNvPicPr>
+            <a:picLocks noChangeAspect="1"/>
+          </p:cNvPicPr>
+          <p:nvPr/>
+        </p:nvPicPr>
+        <p:blipFill>
+          <a:blip r:embed="rId4">
+            <a:extLst>
+              <a:ext uri="{96DAC541-7B7A-43D3-8B79-37D633B846F1}">
+                <ns2:svgBlip xmlns:ns2="http://schemas.microsoft.com/office/drawing/2016/SVG/main" r:embed="rId19"/>
+              </a:ext>
+            </a:extLst>
+          </a:blip>
+          <a:stretch>
+            <a:fillRect/>
+          </a:stretch>
+        </p:blipFill>
+        <p:spPr>
+          <a:xfrm>
+            <a:off x="918058" y="4081882"/>
+            <a:ext cx="358444" cy="358444"/>
+          </a:xfrm>
+          <a:prstGeom prst="rect">
+            <a:avLst/>
+          </a:prstGeom>
+        </p:spPr>
+      </p:pic>
+      <p:pic>
+        <p:nvPicPr>
+          <p:cNvPr id="91" name="Picture 90" descr="image.png"/>
+          <p:cNvPicPr>
+            <a:picLocks noChangeAspect="1"/>
+          </p:cNvPicPr>
+          <p:nvPr/>
+        </p:nvPicPr>
+        <p:blipFill>
+          <a:blip r:embed="rId5">
+            <a:extLst>
+              <a:ext uri="{96DAC541-7B7A-43D3-8B79-37D633B846F1}">
+                <ns3:svgBlip xmlns:ns3="http://schemas.microsoft.com/office/drawing/2016/SVG/main" r:embed="rId14"/>
+              </a:ext>
+            </a:extLst>
+          </a:blip>
+          <a:stretch>
+            <a:fillRect/>
+          </a:stretch>
+        </p:blipFill>
+        <p:spPr>
+          <a:xfrm>
+            <a:off x="918058" y="5215738"/>
+            <a:ext cx="358444" cy="358444"/>
+          </a:xfrm>
+          <a:prstGeom prst="rect">
+            <a:avLst/>
+          </a:prstGeom>
+        </p:spPr>
+      </p:pic>
+      <p:pic>
+        <p:nvPicPr>
+          <p:cNvPr id="92" name="Picture 91" descr="chart7_nhua.png"/>
+          <p:cNvPicPr>
+            <a:picLocks noChangeAspect="1"/>
+          </p:cNvPicPr>
+          <p:nvPr/>
+        </p:nvPicPr>
+        <p:blipFill>
+          <a:blip r:embed="rId10">
+            <a:extLst>
+              <a:ext uri="{96DAC541-7B7A-43D3-8B79-37D633B846F1}">
+                <ns4:svgBlip xmlns:ns4="http://schemas.microsoft.com/office/drawing/2016/SVG/main" r:embed="rId17"/>
+              </a:ext>
+            </a:extLst>
+          </a:blip>
+          <a:stretch>
+            <a:fillRect/>
+          </a:stretch>
+        </p:blipFill>
+        <p:spPr>
+          <a:xfrm>
+            <a:off x="3931920" y="2264280"/>
+            <a:ext cx="1234440" cy="145890"/>
+          </a:xfrm>
+          <a:prstGeom prst="rect">
+            <a:avLst/>
+          </a:prstGeom>
+        </p:spPr>
+      </p:pic>
+      <p:pic>
+        <p:nvPicPr>
+          <p:cNvPr id="93" name="Picture 92" descr="chart7_dungmoi.png"/>
+          <p:cNvPicPr>
+            <a:picLocks noChangeAspect="1"/>
+          </p:cNvPicPr>
+          <p:nvPr/>
+        </p:nvPicPr>
+        <p:blipFill>
+          <a:blip r:embed="rId11">
+            <a:extLst>
+              <a:ext uri="{96DAC541-7B7A-43D3-8B79-37D633B846F1}">
+                <ns5:svgBlip xmlns:ns5="http://schemas.microsoft.com/office/drawing/2016/SVG/main" r:embed="rId16"/>
+              </a:ext>
+            </a:extLst>
+          </a:blip>
+          <a:stretch>
+            <a:fillRect/>
+          </a:stretch>
+        </p:blipFill>
+        <p:spPr>
+          <a:xfrm>
+            <a:off x="3931920" y="3398136"/>
+            <a:ext cx="1234440" cy="145890"/>
+          </a:xfrm>
+          <a:prstGeom prst="rect">
+            <a:avLst/>
+          </a:prstGeom>
+        </p:spPr>
+      </p:pic>
+      <p:pic>
+        <p:nvPicPr>
+          <p:cNvPr id="94" name="Picture 93" descr="chart7_bot.png"/>
+          <p:cNvPicPr>
+            <a:picLocks noChangeAspect="1"/>
+          </p:cNvPicPr>
+          <p:nvPr/>
+        </p:nvPicPr>
+        <p:blipFill>
+          <a:blip r:embed="rId12">
+            <a:extLst>
+              <a:ext uri="{96DAC541-7B7A-43D3-8B79-37D633B846F1}">
+                <ns6:svgBlip xmlns:ns6="http://schemas.microsoft.com/office/drawing/2016/SVG/main" r:embed="rId15"/>
+              </a:ext>
+            </a:extLst>
+          </a:blip>
+          <a:stretch>
+            <a:fillRect/>
+          </a:stretch>
+        </p:blipFill>
+        <p:spPr>
+          <a:xfrm>
+            <a:off x="3931920" y="4531992"/>
+            <a:ext cx="1234440" cy="145890"/>
+          </a:xfrm>
+          <a:prstGeom prst="rect">
+            <a:avLst/>
+          </a:prstGeom>
+        </p:spPr>
+      </p:pic>
+      <p:pic>
+        <p:nvPicPr>
+          <p:cNvPr id="95" name="Picture 94" descr="chart7_phugia.png"/>
+          <p:cNvPicPr>
+            <a:picLocks noChangeAspect="1"/>
+          </p:cNvPicPr>
+          <p:nvPr/>
+        </p:nvPicPr>
+        <p:blipFill>
+          <a:blip r:embed="rId13">
+            <a:extLst>
+              <a:ext uri="{96DAC541-7B7A-43D3-8B79-37D633B846F1}">
+                <ns7:svgBlip xmlns:ns7="http://schemas.microsoft.com/office/drawing/2016/SVG/main" r:embed="rId18"/>
+              </a:ext>
+            </a:extLst>
+          </a:blip>
+          <a:stretch>
+            <a:fillRect/>
+          </a:stretch>
+        </p:blipFill>
+        <p:spPr>
+          <a:xfrm>
+            <a:off x="3931920" y="5665848"/>
+            <a:ext cx="1234440" cy="145890"/>
+          </a:xfrm>
+          <a:prstGeom prst="rect">
+            <a:avLst/>
+          </a:prstGeom>
+        </p:spPr>
+      </p:pic>
     </p:spTree>
   </p:cSld>
   <p:clrMapOvr>
@@ -47129,7 +48629,7 @@
                 </a:solidFill>
                 <a:latin typeface="Calibri"/>
               </a:rPr>
-              <a:t>30–45%</a:t>
+              <a:t/>
             </a:r>
           </a:p>
         </p:txBody>
@@ -47332,7 +48832,7 @@
                 </a:solidFill>
                 <a:latin typeface="Calibri"/>
               </a:rPr>
-              <a:t>46–55%</a:t>
+              <a:t/>
             </a:r>
           </a:p>
         </p:txBody>
@@ -47535,7 +49035,7 @@
                 </a:solidFill>
                 <a:latin typeface="Calibri"/>
               </a:rPr>
-              <a:t>56–70%</a:t>
+              <a:t/>
             </a:r>
           </a:p>
         </p:txBody>
@@ -47697,6 +49197,96 @@
           </a:p>
         </p:txBody>
       </p:sp>
+      <p:pic>
+        <p:nvPicPr>
+          <p:cNvPr id="64" name="Picture 63" descr="chart8_gay.png"/>
+          <p:cNvPicPr>
+            <a:picLocks noChangeAspect="1"/>
+          </p:cNvPicPr>
+          <p:nvPr/>
+        </p:nvPicPr>
+        <p:blipFill>
+          <a:blip r:embed="rId2">
+            <a:extLst>
+              <a:ext uri="{96DAC541-7B7A-43D3-8B79-37D633B846F1}">
+                <ns0:svgBlip xmlns:ns0="http://schemas.microsoft.com/office/drawing/2016/SVG/main" r:embed="rId6"/>
+              </a:ext>
+            </a:extLst>
+          </a:blip>
+          <a:stretch>
+            <a:fillRect/>
+          </a:stretch>
+        </p:blipFill>
+        <p:spPr>
+          <a:xfrm>
+            <a:off x="3931920" y="2416310"/>
+            <a:ext cx="2100000" cy="470900"/>
+          </a:xfrm>
+          <a:prstGeom prst="rect">
+            <a:avLst/>
+          </a:prstGeom>
+        </p:spPr>
+      </p:pic>
+      <p:pic>
+        <p:nvPicPr>
+          <p:cNvPr id="65" name="Picture 64" descr="chart8_trung.png"/>
+          <p:cNvPicPr>
+            <a:picLocks noChangeAspect="1"/>
+          </p:cNvPicPr>
+          <p:nvPr/>
+        </p:nvPicPr>
+        <p:blipFill>
+          <a:blip r:embed="rId3">
+            <a:extLst>
+              <a:ext uri="{96DAC541-7B7A-43D3-8B79-37D633B846F1}">
+                <ns1:svgBlip xmlns:ns1="http://schemas.microsoft.com/office/drawing/2016/SVG/main" r:embed="rId7"/>
+              </a:ext>
+            </a:extLst>
+          </a:blip>
+          <a:stretch>
+            <a:fillRect/>
+          </a:stretch>
+        </p:blipFill>
+        <p:spPr>
+          <a:xfrm>
+            <a:off x="3931920" y="3422150"/>
+            <a:ext cx="2100000" cy="470900"/>
+          </a:xfrm>
+          <a:prstGeom prst="rect">
+            <a:avLst/>
+          </a:prstGeom>
+        </p:spPr>
+      </p:pic>
+      <p:pic>
+        <p:nvPicPr>
+          <p:cNvPr id="66" name="Picture 65" descr="chart8_beo.png"/>
+          <p:cNvPicPr>
+            <a:picLocks noChangeAspect="1"/>
+          </p:cNvPicPr>
+          <p:nvPr/>
+        </p:nvPicPr>
+        <p:blipFill>
+          <a:blip r:embed="rId4">
+            <a:extLst>
+              <a:ext uri="{96DAC541-7B7A-43D3-8B79-37D633B846F1}">
+                <ns2:svgBlip xmlns:ns2="http://schemas.microsoft.com/office/drawing/2016/SVG/main" r:embed="rId5"/>
+              </a:ext>
+            </a:extLst>
+          </a:blip>
+          <a:stretch>
+            <a:fillRect/>
+          </a:stretch>
+        </p:blipFill>
+        <p:spPr>
+          <a:xfrm>
+            <a:off x="3931920" y="4427990"/>
+            <a:ext cx="2100000" cy="470900"/>
+          </a:xfrm>
+          <a:prstGeom prst="rect">
+            <a:avLst/>
+          </a:prstGeom>
+        </p:spPr>
+      </p:pic>
     </p:spTree>
   </p:cSld>
   <p:clrMapOvr>

</xml_diff>

<commit_message>
Lower content font floor to 20pt
Scale content text down (~0.83x) with a 20pt minimum instead of 24pt,
per request. Titles, section numbers, and dividers keep their larger
sizes so hierarchy is preserved; audited zero content runs below 20pt.
Regenerate the PDF export.

Co-Authored-By: Claude Opus 4.8 <noreply@anthropic.com>
Claude-Session: https://claude.ai/code/session_01PbbxSyJEYscgmQfTL8vaUX
</commit_message>
<xml_diff>
--- a/SuHeo/Báo cáo thực tập - Sơn Hải Vân.pptx
+++ b/SuHeo/Báo cáo thực tập - Sơn Hải Vân.pptx
@@ -3282,7 +3282,7 @@
           <a:lstStyle/>
           <a:p>
             <a:r>
-              <a:rPr sz="2400" b="1" i="0">
+              <a:rPr sz="2000" b="1" i="0">
                 <a:solidFill>
                   <a:srgbClr val="CFE2D8"/>
                 </a:solidFill>
@@ -3391,7 +3391,7 @@
           <a:lstStyle/>
           <a:p>
             <a:r>
-              <a:rPr sz="2400" b="0" i="0">
+              <a:rPr sz="2000" b="0" i="0">
                 <a:solidFill>
                   <a:srgbClr val="CFE2D8"/>
                 </a:solidFill>
@@ -3401,7 +3401,7 @@
           </a:p>
           <a:p>
             <a:r>
-              <a:rPr sz="2400" b="0" i="0">
+              <a:rPr sz="2000" b="0" i="0">
                 <a:solidFill>
                   <a:srgbClr val="CFE2D8"/>
                 </a:solidFill>
@@ -3548,7 +3548,7 @@
           <a:lstStyle/>
           <a:p>
             <a:r>
-              <a:rPr sz="2400" b="1" i="0">
+              <a:rPr sz="2000" b="1" i="0">
                 <a:solidFill>
                   <a:srgbClr val="C88A2E"/>
                 </a:solidFill>
@@ -3799,7 +3799,7 @@
           <a:lstStyle/>
           <a:p>
             <a:r>
-              <a:rPr sz="2600" b="1" i="0">
+              <a:rPr sz="2158" b="1" i="0">
                 <a:solidFill>
                   <a:srgbClr val="1F4E3D"/>
                 </a:solidFill>
@@ -3862,7 +3862,7 @@
           <a:lstStyle/>
           <a:p>
             <a:r>
-              <a:rPr sz="2400" b="0" i="0">
+              <a:rPr sz="2000" b="0" i="0">
                 <a:solidFill>
                   <a:srgbClr val="34404A"/>
                 </a:solidFill>
@@ -3939,7 +3939,7 @@
           <a:lstStyle/>
           <a:p>
             <a:r>
-              <a:rPr sz="2600" b="1" i="0">
+              <a:rPr sz="2158" b="1" i="0">
                 <a:solidFill>
                   <a:srgbClr val="1F4E3D"/>
                 </a:solidFill>
@@ -4002,7 +4002,7 @@
           <a:lstStyle/>
           <a:p>
             <a:r>
-              <a:rPr sz="2400" b="0" i="0">
+              <a:rPr sz="2000" b="0" i="0">
                 <a:solidFill>
                   <a:srgbClr val="34404A"/>
                 </a:solidFill>
@@ -4079,7 +4079,7 @@
           <a:lstStyle/>
           <a:p>
             <a:r>
-              <a:rPr sz="2600" b="1" i="0">
+              <a:rPr sz="2158" b="1" i="0">
                 <a:solidFill>
                   <a:srgbClr val="1F4E3D"/>
                 </a:solidFill>
@@ -4142,7 +4142,7 @@
           <a:lstStyle/>
           <a:p>
             <a:r>
-              <a:rPr sz="2400" b="0" i="0">
+              <a:rPr sz="2000" b="0" i="0">
                 <a:solidFill>
                   <a:srgbClr val="34404A"/>
                 </a:solidFill>
@@ -4289,7 +4289,7 @@
           <a:lstStyle/>
           <a:p>
             <a:r>
-              <a:rPr sz="2400" b="1" i="0">
+              <a:rPr sz="2000" b="1" i="0">
                 <a:solidFill>
                   <a:srgbClr val="C88A2E"/>
                 </a:solidFill>
@@ -4540,7 +4540,7 @@
           <a:lstStyle/>
           <a:p>
             <a:r>
-              <a:rPr sz="2500" b="1" i="0">
+              <a:rPr sz="2075" b="1" i="0">
                 <a:solidFill>
                   <a:srgbClr val="FFFFFF"/>
                 </a:solidFill>
@@ -4550,7 +4550,7 @@
           </a:p>
           <a:p>
             <a:r>
-              <a:rPr sz="2400" b="0" i="0">
+              <a:rPr sz="2000" b="0" i="0">
                 <a:solidFill>
                   <a:srgbClr val="EAF3EE"/>
                 </a:solidFill>
@@ -4627,7 +4627,7 @@
           <a:lstStyle/>
           <a:p>
             <a:r>
-              <a:rPr sz="2500" b="1" i="0">
+              <a:rPr sz="2075" b="1" i="0">
                 <a:solidFill>
                   <a:srgbClr val="FFFFFF"/>
                 </a:solidFill>
@@ -4637,7 +4637,7 @@
           </a:p>
           <a:p>
             <a:r>
-              <a:rPr sz="2400" b="0" i="0">
+              <a:rPr sz="2000" b="0" i="0">
                 <a:solidFill>
                   <a:srgbClr val="EAF3EE"/>
                 </a:solidFill>
@@ -4714,7 +4714,7 @@
           <a:lstStyle/>
           <a:p>
             <a:r>
-              <a:rPr sz="2500" b="1" i="0">
+              <a:rPr sz="2075" b="1" i="0">
                 <a:solidFill>
                   <a:srgbClr val="FFFFFF"/>
                 </a:solidFill>
@@ -4724,7 +4724,7 @@
           </a:p>
           <a:p>
             <a:r>
-              <a:rPr sz="2400" b="0" i="0">
+              <a:rPr sz="2000" b="0" i="0">
                 <a:solidFill>
                   <a:srgbClr val="EAF3EE"/>
                 </a:solidFill>
@@ -4801,7 +4801,7 @@
           <a:lstStyle/>
           <a:p>
             <a:r>
-              <a:rPr sz="2500" b="1" i="0">
+              <a:rPr sz="2075" b="1" i="0">
                 <a:solidFill>
                   <a:srgbClr val="FFFFFF"/>
                 </a:solidFill>
@@ -4811,7 +4811,7 @@
           </a:p>
           <a:p>
             <a:r>
-              <a:rPr sz="2400" b="0" i="0">
+              <a:rPr sz="2000" b="0" i="0">
                 <a:solidFill>
                   <a:srgbClr val="EAF3EE"/>
                 </a:solidFill>
@@ -5051,7 +5051,7 @@
           <a:lstStyle/>
           <a:p>
             <a:r>
-              <a:rPr sz="2400" b="1" i="0">
+              <a:rPr sz="2000" b="1" i="0">
                 <a:solidFill>
                   <a:srgbClr val="C88A2E"/>
                 </a:solidFill>
@@ -5231,7 +5231,7 @@
           <a:lstStyle/>
           <a:p>
             <a:r>
-              <a:rPr sz="2400" b="1" i="0">
+              <a:rPr sz="2000" b="1" i="0">
                 <a:solidFill>
                   <a:srgbClr val="C88A2E"/>
                 </a:solidFill>
@@ -5556,7 +5556,7 @@
           <a:lstStyle/>
           <a:p>
             <a:r>
-              <a:rPr sz="2500" b="1" i="0">
+              <a:rPr sz="2075" b="1" i="0">
                 <a:solidFill>
                   <a:srgbClr val="1F4E3D"/>
                 </a:solidFill>
@@ -5566,7 +5566,7 @@
           </a:p>
           <a:p>
             <a:r>
-              <a:rPr sz="2400" b="0" i="0">
+              <a:rPr sz="2000" b="0" i="0">
                 <a:solidFill>
                   <a:srgbClr val="34404A"/>
                 </a:solidFill>
@@ -5717,7 +5717,7 @@
           <a:lstStyle/>
           <a:p>
             <a:r>
-              <a:rPr sz="2500" b="1" i="0">
+              <a:rPr sz="2075" b="1" i="0">
                 <a:solidFill>
                   <a:srgbClr val="1F4E3D"/>
                 </a:solidFill>
@@ -5727,7 +5727,7 @@
           </a:p>
           <a:p>
             <a:r>
-              <a:rPr sz="2400" b="0" i="0">
+              <a:rPr sz="2000" b="0" i="0">
                 <a:solidFill>
                   <a:srgbClr val="34404A"/>
                 </a:solidFill>
@@ -5878,7 +5878,7 @@
           <a:lstStyle/>
           <a:p>
             <a:r>
-              <a:rPr sz="2500" b="1" i="0">
+              <a:rPr sz="2075" b="1" i="0">
                 <a:solidFill>
                   <a:srgbClr val="1F4E3D"/>
                 </a:solidFill>
@@ -5888,7 +5888,7 @@
           </a:p>
           <a:p>
             <a:r>
-              <a:rPr sz="2400" b="0" i="0">
+              <a:rPr sz="2000" b="0" i="0">
                 <a:solidFill>
                   <a:srgbClr val="34404A"/>
                 </a:solidFill>
@@ -6039,7 +6039,7 @@
           <a:lstStyle/>
           <a:p>
             <a:r>
-              <a:rPr sz="2500" b="1" i="0">
+              <a:rPr sz="2075" b="1" i="0">
                 <a:solidFill>
                   <a:srgbClr val="1F4E3D"/>
                 </a:solidFill>
@@ -6049,7 +6049,7 @@
           </a:p>
           <a:p>
             <a:r>
-              <a:rPr sz="2400" b="0" i="0">
+              <a:rPr sz="2000" b="0" i="0">
                 <a:solidFill>
                   <a:srgbClr val="34404A"/>
                 </a:solidFill>
@@ -6200,7 +6200,7 @@
           <a:lstStyle/>
           <a:p>
             <a:r>
-              <a:rPr sz="2500" b="1" i="0">
+              <a:rPr sz="2075" b="1" i="0">
                 <a:solidFill>
                   <a:srgbClr val="1F4E3D"/>
                 </a:solidFill>
@@ -6210,7 +6210,7 @@
           </a:p>
           <a:p>
             <a:r>
-              <a:rPr sz="2400" b="0" i="0">
+              <a:rPr sz="2000" b="0" i="0">
                 <a:solidFill>
                   <a:srgbClr val="34404A"/>
                 </a:solidFill>
@@ -6361,7 +6361,7 @@
           <a:lstStyle/>
           <a:p>
             <a:r>
-              <a:rPr sz="2500" b="1" i="0">
+              <a:rPr sz="2075" b="1" i="0">
                 <a:solidFill>
                   <a:srgbClr val="1F4E3D"/>
                 </a:solidFill>
@@ -6371,7 +6371,7 @@
           </a:p>
           <a:p>
             <a:r>
-              <a:rPr sz="2400" b="0" i="0">
+              <a:rPr sz="2000" b="0" i="0">
                 <a:solidFill>
                   <a:srgbClr val="34404A"/>
                 </a:solidFill>
@@ -6518,7 +6518,7 @@
           <a:lstStyle/>
           <a:p>
             <a:r>
-              <a:rPr sz="2400" b="1" i="0">
+              <a:rPr sz="2000" b="1" i="0">
                 <a:solidFill>
                   <a:srgbClr val="C88A2E"/>
                 </a:solidFill>
@@ -6869,7 +6869,7 @@
           <a:lstStyle/>
           <a:p>
             <a:r>
-              <a:rPr sz="2400" b="1" i="0">
+              <a:rPr sz="2000" b="1" i="0">
                 <a:solidFill>
                   <a:srgbClr val="C88A2E"/>
                 </a:solidFill>
@@ -7238,7 +7238,7 @@
           <a:lstStyle/>
           <a:p>
             <a:r>
-              <a:rPr sz="2500" b="1" i="0">
+              <a:rPr sz="2075" b="1" i="0">
                 <a:solidFill>
                   <a:srgbClr val="1F4E3D"/>
                 </a:solidFill>
@@ -7248,7 +7248,7 @@
           </a:p>
           <a:p>
             <a:r>
-              <a:rPr sz="2400" b="0" i="0">
+              <a:rPr sz="2000" b="0" i="0">
                 <a:solidFill>
                   <a:srgbClr val="34404A"/>
                 </a:solidFill>
@@ -7258,7 +7258,7 @@
           </a:p>
           <a:p>
             <a:r>
-              <a:rPr sz="2400" b="0" i="0">
+              <a:rPr sz="2000" b="0" i="0">
                 <a:solidFill>
                   <a:srgbClr val="34404A"/>
                 </a:solidFill>
@@ -7453,7 +7453,7 @@
           <a:lstStyle/>
           <a:p>
             <a:r>
-              <a:rPr sz="2500" b="1" i="0">
+              <a:rPr sz="2075" b="1" i="0">
                 <a:solidFill>
                   <a:srgbClr val="1F4E3D"/>
                 </a:solidFill>
@@ -7463,7 +7463,7 @@
           </a:p>
           <a:p>
             <a:r>
-              <a:rPr sz="2400" b="0" i="0">
+              <a:rPr sz="2000" b="0" i="0">
                 <a:solidFill>
                   <a:srgbClr val="34404A"/>
                 </a:solidFill>
@@ -7473,7 +7473,7 @@
           </a:p>
           <a:p>
             <a:r>
-              <a:rPr sz="2400" b="0" i="0">
+              <a:rPr sz="2000" b="0" i="0">
                 <a:solidFill>
                   <a:srgbClr val="34404A"/>
                 </a:solidFill>
@@ -7668,7 +7668,7 @@
           <a:lstStyle/>
           <a:p>
             <a:r>
-              <a:rPr sz="2500" b="1" i="0">
+              <a:rPr sz="2075" b="1" i="0">
                 <a:solidFill>
                   <a:srgbClr val="1F4E3D"/>
                 </a:solidFill>
@@ -7678,7 +7678,7 @@
           </a:p>
           <a:p>
             <a:r>
-              <a:rPr sz="2400" b="0" i="0">
+              <a:rPr sz="2000" b="0" i="0">
                 <a:solidFill>
                   <a:srgbClr val="34404A"/>
                 </a:solidFill>
@@ -7688,7 +7688,7 @@
           </a:p>
           <a:p>
             <a:r>
-              <a:rPr sz="2400" b="0" i="0">
+              <a:rPr sz="2000" b="0" i="0">
                 <a:solidFill>
                   <a:srgbClr val="34404A"/>
                 </a:solidFill>
@@ -7835,7 +7835,7 @@
           <a:lstStyle/>
           <a:p>
             <a:r>
-              <a:rPr sz="2400" b="1" i="0">
+              <a:rPr sz="2000" b="1" i="0">
                 <a:solidFill>
                   <a:srgbClr val="C88A2E"/>
                 </a:solidFill>
@@ -8204,7 +8204,7 @@
           <a:lstStyle/>
           <a:p>
             <a:r>
-              <a:rPr sz="2500" b="1" i="0">
+              <a:rPr sz="2075" b="1" i="0">
                 <a:solidFill>
                   <a:srgbClr val="1F4E3D"/>
                 </a:solidFill>
@@ -8214,7 +8214,7 @@
           </a:p>
           <a:p>
             <a:r>
-              <a:rPr sz="2400" b="0" i="0">
+              <a:rPr sz="2000" b="0" i="0">
                 <a:solidFill>
                   <a:srgbClr val="34404A"/>
                 </a:solidFill>
@@ -8224,7 +8224,7 @@
           </a:p>
           <a:p>
             <a:r>
-              <a:rPr sz="2400" b="0" i="0">
+              <a:rPr sz="2000" b="0" i="0">
                 <a:solidFill>
                   <a:srgbClr val="34404A"/>
                 </a:solidFill>
@@ -8419,7 +8419,7 @@
           <a:lstStyle/>
           <a:p>
             <a:r>
-              <a:rPr sz="2500" b="1" i="0">
+              <a:rPr sz="2075" b="1" i="0">
                 <a:solidFill>
                   <a:srgbClr val="1F4E3D"/>
                 </a:solidFill>
@@ -8429,7 +8429,7 @@
           </a:p>
           <a:p>
             <a:r>
-              <a:rPr sz="2400" b="0" i="0">
+              <a:rPr sz="2000" b="0" i="0">
                 <a:solidFill>
                   <a:srgbClr val="34404A"/>
                 </a:solidFill>
@@ -8439,7 +8439,7 @@
           </a:p>
           <a:p>
             <a:r>
-              <a:rPr sz="2400" b="0" i="0">
+              <a:rPr sz="2000" b="0" i="0">
                 <a:solidFill>
                   <a:srgbClr val="34404A"/>
                 </a:solidFill>
@@ -8634,7 +8634,7 @@
           <a:lstStyle/>
           <a:p>
             <a:r>
-              <a:rPr sz="2500" b="1" i="0">
+              <a:rPr sz="2075" b="1" i="0">
                 <a:solidFill>
                   <a:srgbClr val="1F4E3D"/>
                 </a:solidFill>
@@ -8644,7 +8644,7 @@
           </a:p>
           <a:p>
             <a:r>
-              <a:rPr sz="2400" b="0" i="0">
+              <a:rPr sz="2000" b="0" i="0">
                 <a:solidFill>
                   <a:srgbClr val="34404A"/>
                 </a:solidFill>
@@ -8654,7 +8654,7 @@
           </a:p>
           <a:p>
             <a:r>
-              <a:rPr sz="2400" b="0" i="0">
+              <a:rPr sz="2000" b="0" i="0">
                 <a:solidFill>
                   <a:srgbClr val="34404A"/>
                 </a:solidFill>
@@ -8801,7 +8801,7 @@
           <a:lstStyle/>
           <a:p>
             <a:r>
-              <a:rPr sz="2400" b="1" i="0">
+              <a:rPr sz="2000" b="1" i="0">
                 <a:solidFill>
                   <a:srgbClr val="C88A2E"/>
                 </a:solidFill>
@@ -9027,7 +9027,7 @@
           <a:p>
             <a:pPr algn="ctr"/>
             <a:r>
-              <a:rPr sz="2400" b="1" i="0">
+              <a:rPr sz="2000" b="1" i="0">
                 <a:solidFill>
                   <a:srgbClr val="FFFFFF"/>
                 </a:solidFill>
@@ -9172,7 +9172,7 @@
           <a:lstStyle/>
           <a:p>
             <a:r>
-              <a:rPr sz="2400" b="1" i="0">
+              <a:rPr sz="2000" b="1" i="0">
                 <a:solidFill>
                   <a:srgbClr val="1F4E3D"/>
                 </a:solidFill>
@@ -9182,7 +9182,7 @@
           </a:p>
           <a:p>
             <a:r>
-              <a:rPr sz="2400" b="0" i="0">
+              <a:rPr sz="2000" b="0" i="0">
                 <a:solidFill>
                   <a:srgbClr val="34404A"/>
                 </a:solidFill>
@@ -9303,7 +9303,7 @@
           <a:lstStyle/>
           <a:p>
             <a:r>
-              <a:rPr sz="2400" b="1" i="0">
+              <a:rPr sz="2000" b="1" i="0">
                 <a:solidFill>
                   <a:srgbClr val="1F4E3D"/>
                 </a:solidFill>
@@ -9313,7 +9313,7 @@
           </a:p>
           <a:p>
             <a:r>
-              <a:rPr sz="2400" b="0" i="0">
+              <a:rPr sz="2000" b="0" i="0">
                 <a:solidFill>
                   <a:srgbClr val="34404A"/>
                 </a:solidFill>
@@ -9434,7 +9434,7 @@
           <a:lstStyle/>
           <a:p>
             <a:r>
-              <a:rPr sz="2400" b="1" i="0">
+              <a:rPr sz="2000" b="1" i="0">
                 <a:solidFill>
                   <a:srgbClr val="1F4E3D"/>
                 </a:solidFill>
@@ -9444,7 +9444,7 @@
           </a:p>
           <a:p>
             <a:r>
-              <a:rPr sz="2400" b="0" i="0">
+              <a:rPr sz="2000" b="0" i="0">
                 <a:solidFill>
                   <a:srgbClr val="34404A"/>
                 </a:solidFill>
@@ -9591,7 +9591,7 @@
           <a:lstStyle/>
           <a:p>
             <a:r>
-              <a:rPr sz="2400" b="1" i="0">
+              <a:rPr sz="2000" b="1" i="0">
                 <a:solidFill>
                   <a:srgbClr val="C88A2E"/>
                 </a:solidFill>
@@ -9817,7 +9817,7 @@
           <a:p>
             <a:pPr algn="ctr"/>
             <a:r>
-              <a:rPr sz="2400" b="1" i="0">
+              <a:rPr sz="2000" b="1" i="0">
                 <a:solidFill>
                   <a:srgbClr val="FFFFFF"/>
                 </a:solidFill>
@@ -9937,7 +9937,7 @@
           <a:p>
             <a:pPr algn="ctr"/>
             <a:r>
-              <a:rPr sz="2400" b="1" i="0">
+              <a:rPr sz="2000" b="1" i="0">
                 <a:solidFill>
                   <a:srgbClr val="FFFFFF"/>
                 </a:solidFill>
@@ -9970,7 +9970,7 @@
           <a:lstStyle/>
           <a:p>
             <a:r>
-              <a:rPr sz="2500" b="1" i="0">
+              <a:rPr sz="2075" b="1" i="0">
                 <a:solidFill>
                   <a:srgbClr val="1F4E3D"/>
                 </a:solidFill>
@@ -9980,7 +9980,7 @@
           </a:p>
           <a:p>
             <a:r>
-              <a:rPr sz="2400" b="0" i="0">
+              <a:rPr sz="2000" b="0" i="0">
                 <a:solidFill>
                   <a:srgbClr val="34404A"/>
                 </a:solidFill>
@@ -10032,7 +10032,7 @@
           <a:p>
             <a:pPr algn="ctr"/>
             <a:r>
-              <a:rPr sz="2400" b="1" i="0">
+              <a:rPr sz="2000" b="1" i="0">
                 <a:solidFill>
                   <a:srgbClr val="FFFFFF"/>
                 </a:solidFill>
@@ -10065,7 +10065,7 @@
           <a:lstStyle/>
           <a:p>
             <a:r>
-              <a:rPr sz="2500" b="1" i="0">
+              <a:rPr sz="2075" b="1" i="0">
                 <a:solidFill>
                   <a:srgbClr val="1F4E3D"/>
                 </a:solidFill>
@@ -10075,7 +10075,7 @@
           </a:p>
           <a:p>
             <a:r>
-              <a:rPr sz="2400" b="0" i="0">
+              <a:rPr sz="2000" b="0" i="0">
                 <a:solidFill>
                   <a:srgbClr val="34404A"/>
                 </a:solidFill>
@@ -10127,7 +10127,7 @@
           <a:p>
             <a:pPr algn="ctr"/>
             <a:r>
-              <a:rPr sz="2400" b="1" i="0">
+              <a:rPr sz="2000" b="1" i="0">
                 <a:solidFill>
                   <a:srgbClr val="FFFFFF"/>
                 </a:solidFill>
@@ -10160,7 +10160,7 @@
           <a:lstStyle/>
           <a:p>
             <a:r>
-              <a:rPr sz="2500" b="1" i="0">
+              <a:rPr sz="2075" b="1" i="0">
                 <a:solidFill>
                   <a:srgbClr val="1F4E3D"/>
                 </a:solidFill>
@@ -10170,7 +10170,7 @@
           </a:p>
           <a:p>
             <a:r>
-              <a:rPr sz="2400" b="0" i="0">
+              <a:rPr sz="2000" b="0" i="0">
                 <a:solidFill>
                   <a:srgbClr val="34404A"/>
                 </a:solidFill>
@@ -10317,7 +10317,7 @@
           <a:lstStyle/>
           <a:p>
             <a:r>
-              <a:rPr sz="2400" b="1" i="0">
+              <a:rPr sz="2000" b="1" i="0">
                 <a:solidFill>
                   <a:srgbClr val="C88A2E"/>
                 </a:solidFill>
@@ -10543,7 +10543,7 @@
           <a:p>
             <a:pPr algn="ctr"/>
             <a:r>
-              <a:rPr sz="2400" b="1" i="0">
+              <a:rPr sz="2000" b="1" i="0">
                 <a:solidFill>
                   <a:srgbClr val="FFFFFF"/>
                 </a:solidFill>
@@ -10644,7 +10644,7 @@
           <a:lstStyle/>
           <a:p>
             <a:r>
-              <a:rPr sz="2400" b="1" i="0">
+              <a:rPr sz="2000" b="1" i="0">
                 <a:solidFill>
                   <a:srgbClr val="C88A2E"/>
                 </a:solidFill>
@@ -10721,7 +10721,7 @@
           <a:lstStyle/>
           <a:p>
             <a:r>
-              <a:rPr sz="2400" b="1" i="0">
+              <a:rPr sz="2000" b="1" i="0">
                 <a:solidFill>
                   <a:srgbClr val="1F4E3D"/>
                 </a:solidFill>
@@ -10731,7 +10731,7 @@
           </a:p>
           <a:p>
             <a:r>
-              <a:rPr sz="2400" b="0" i="0">
+              <a:rPr sz="2000" b="0" i="0">
                 <a:solidFill>
                   <a:srgbClr val="34404A"/>
                 </a:solidFill>
@@ -10808,7 +10808,7 @@
           <a:lstStyle/>
           <a:p>
             <a:r>
-              <a:rPr sz="2400" b="1" i="0">
+              <a:rPr sz="2000" b="1" i="0">
                 <a:solidFill>
                   <a:srgbClr val="1F4E3D"/>
                 </a:solidFill>
@@ -10818,7 +10818,7 @@
           </a:p>
           <a:p>
             <a:r>
-              <a:rPr sz="2400" b="0" i="0">
+              <a:rPr sz="2000" b="0" i="0">
                 <a:solidFill>
                   <a:srgbClr val="34404A"/>
                 </a:solidFill>
@@ -10895,7 +10895,7 @@
           <a:lstStyle/>
           <a:p>
             <a:r>
-              <a:rPr sz="2400" b="1" i="0">
+              <a:rPr sz="2000" b="1" i="0">
                 <a:solidFill>
                   <a:srgbClr val="1F4E3D"/>
                 </a:solidFill>
@@ -10905,7 +10905,7 @@
           </a:p>
           <a:p>
             <a:r>
-              <a:rPr sz="2400" b="0" i="0">
+              <a:rPr sz="2000" b="0" i="0">
                 <a:solidFill>
                   <a:srgbClr val="34404A"/>
                 </a:solidFill>
@@ -11052,7 +11052,7 @@
           <a:lstStyle/>
           <a:p>
             <a:r>
-              <a:rPr sz="2400" b="1" i="0">
+              <a:rPr sz="2000" b="1" i="0">
                 <a:solidFill>
                   <a:srgbClr val="C88A2E"/>
                 </a:solidFill>
@@ -11333,7 +11333,7 @@
           <a:lstStyle/>
           <a:p>
             <a:r>
-              <a:rPr sz="2500" b="0" i="0">
+              <a:rPr sz="2075" b="0" i="0">
                 <a:solidFill>
                   <a:srgbClr val="14332A"/>
                 </a:solidFill>
@@ -11440,7 +11440,7 @@
           <a:lstStyle/>
           <a:p>
             <a:r>
-              <a:rPr sz="2500" b="0" i="0">
+              <a:rPr sz="2075" b="0" i="0">
                 <a:solidFill>
                   <a:srgbClr val="14332A"/>
                 </a:solidFill>
@@ -11547,7 +11547,7 @@
           <a:lstStyle/>
           <a:p>
             <a:r>
-              <a:rPr sz="2500" b="0" i="0">
+              <a:rPr sz="2075" b="0" i="0">
                 <a:solidFill>
                   <a:srgbClr val="14332A"/>
                 </a:solidFill>
@@ -11654,7 +11654,7 @@
           <a:lstStyle/>
           <a:p>
             <a:r>
-              <a:rPr sz="2500" b="0" i="0">
+              <a:rPr sz="2075" b="0" i="0">
                 <a:solidFill>
                   <a:srgbClr val="14332A"/>
                 </a:solidFill>
@@ -11761,7 +11761,7 @@
           <a:lstStyle/>
           <a:p>
             <a:r>
-              <a:rPr sz="2500" b="0" i="0">
+              <a:rPr sz="2075" b="0" i="0">
                 <a:solidFill>
                   <a:srgbClr val="14332A"/>
                 </a:solidFill>
@@ -11868,7 +11868,7 @@
           <a:lstStyle/>
           <a:p>
             <a:r>
-              <a:rPr sz="2500" b="0" i="0">
+              <a:rPr sz="2075" b="0" i="0">
                 <a:solidFill>
                   <a:srgbClr val="14332A"/>
                 </a:solidFill>
@@ -12108,7 +12108,7 @@
           <a:lstStyle/>
           <a:p>
             <a:r>
-              <a:rPr sz="2400" b="1" i="0">
+              <a:rPr sz="2000" b="1" i="0">
                 <a:solidFill>
                   <a:srgbClr val="C88A2E"/>
                 </a:solidFill>
@@ -12288,7 +12288,7 @@
           <a:lstStyle/>
           <a:p>
             <a:r>
-              <a:rPr sz="2400" b="1" i="0">
+              <a:rPr sz="2000" b="1" i="0">
                 <a:solidFill>
                   <a:srgbClr val="C88A2E"/>
                 </a:solidFill>
@@ -12569,7 +12569,7 @@
           <a:lstStyle/>
           <a:p>
             <a:r>
-              <a:rPr sz="2400" b="0" i="1">
+              <a:rPr sz="2000" b="0" i="1">
                 <a:solidFill>
                   <a:srgbClr val="34404A"/>
                 </a:solidFill>
@@ -12602,7 +12602,7 @@
           <a:lstStyle/>
           <a:p>
             <a:r>
-              <a:rPr sz="2400" b="1" i="0">
+              <a:rPr sz="2000" b="1" i="0">
                 <a:solidFill>
                   <a:srgbClr val="2C7A5A"/>
                 </a:solidFill>
@@ -12610,7 +12610,7 @@
               <a:t>✔  </a:t>
             </a:r>
             <a:r>
-              <a:rPr sz="2400" b="0" i="0">
+              <a:rPr sz="2000" b="0" i="0">
                 <a:solidFill>
                   <a:srgbClr val="14332A"/>
                 </a:solidFill>
@@ -12643,7 +12643,7 @@
           <a:lstStyle/>
           <a:p>
             <a:r>
-              <a:rPr sz="2400" b="1" i="0">
+              <a:rPr sz="2000" b="1" i="0">
                 <a:solidFill>
                   <a:srgbClr val="2C7A5A"/>
                 </a:solidFill>
@@ -12651,7 +12651,7 @@
               <a:t>✔  </a:t>
             </a:r>
             <a:r>
-              <a:rPr sz="2400" b="0" i="0">
+              <a:rPr sz="2000" b="0" i="0">
                 <a:solidFill>
                   <a:srgbClr val="14332A"/>
                 </a:solidFill>
@@ -12684,7 +12684,7 @@
           <a:lstStyle/>
           <a:p>
             <a:r>
-              <a:rPr sz="2400" b="1" i="0">
+              <a:rPr sz="2000" b="1" i="0">
                 <a:solidFill>
                   <a:srgbClr val="2C7A5A"/>
                 </a:solidFill>
@@ -12692,7 +12692,7 @@
               <a:t>✔  </a:t>
             </a:r>
             <a:r>
-              <a:rPr sz="2400" b="0" i="0">
+              <a:rPr sz="2000" b="0" i="0">
                 <a:solidFill>
                   <a:srgbClr val="14332A"/>
                 </a:solidFill>
@@ -12725,7 +12725,7 @@
           <a:lstStyle/>
           <a:p>
             <a:r>
-              <a:rPr sz="2400" b="1" i="0">
+              <a:rPr sz="2000" b="1" i="0">
                 <a:solidFill>
                   <a:srgbClr val="2C7A5A"/>
                 </a:solidFill>
@@ -12733,7 +12733,7 @@
               <a:t>✔  </a:t>
             </a:r>
             <a:r>
-              <a:rPr sz="2400" b="0" i="0">
+              <a:rPr sz="2000" b="0" i="0">
                 <a:solidFill>
                   <a:srgbClr val="14332A"/>
                 </a:solidFill>
@@ -12766,7 +12766,7 @@
           <a:lstStyle/>
           <a:p>
             <a:r>
-              <a:rPr sz="2400" b="1" i="0">
+              <a:rPr sz="2000" b="1" i="0">
                 <a:solidFill>
                   <a:srgbClr val="2C7A5A"/>
                 </a:solidFill>
@@ -12774,7 +12774,7 @@
               <a:t>✔  </a:t>
             </a:r>
             <a:r>
-              <a:rPr sz="2400" b="0" i="0">
+              <a:rPr sz="2000" b="0" i="0">
                 <a:solidFill>
                   <a:srgbClr val="14332A"/>
                 </a:solidFill>
@@ -12807,7 +12807,7 @@
           <a:lstStyle/>
           <a:p>
             <a:r>
-              <a:rPr sz="2400" b="1" i="0">
+              <a:rPr sz="2000" b="1" i="0">
                 <a:solidFill>
                   <a:srgbClr val="2C7A5A"/>
                 </a:solidFill>
@@ -12815,7 +12815,7 @@
               <a:t>✔  </a:t>
             </a:r>
             <a:r>
-              <a:rPr sz="2400" b="0" i="0">
+              <a:rPr sz="2000" b="0" i="0">
                 <a:solidFill>
                   <a:srgbClr val="14332A"/>
                 </a:solidFill>
@@ -12962,7 +12962,7 @@
           <a:lstStyle/>
           <a:p>
             <a:r>
-              <a:rPr sz="2400" b="1" i="0">
+              <a:rPr sz="2000" b="1" i="0">
                 <a:solidFill>
                   <a:srgbClr val="C88A2E"/>
                 </a:solidFill>
@@ -13243,7 +13243,7 @@
           <a:lstStyle/>
           <a:p>
             <a:r>
-              <a:rPr sz="2400" b="0" i="1">
+              <a:rPr sz="2000" b="0" i="1">
                 <a:solidFill>
                   <a:srgbClr val="34404A"/>
                 </a:solidFill>
@@ -13276,7 +13276,7 @@
           <a:lstStyle/>
           <a:p>
             <a:r>
-              <a:rPr sz="2400" b="1" i="0">
+              <a:rPr sz="2000" b="1" i="0">
                 <a:solidFill>
                   <a:srgbClr val="2C7A5A"/>
                 </a:solidFill>
@@ -13284,7 +13284,7 @@
               <a:t>✔  </a:t>
             </a:r>
             <a:r>
-              <a:rPr sz="2400" b="0" i="0">
+              <a:rPr sz="2000" b="0" i="0">
                 <a:solidFill>
                   <a:srgbClr val="14332A"/>
                 </a:solidFill>
@@ -13317,7 +13317,7 @@
           <a:lstStyle/>
           <a:p>
             <a:r>
-              <a:rPr sz="2400" b="1" i="0">
+              <a:rPr sz="2000" b="1" i="0">
                 <a:solidFill>
                   <a:srgbClr val="2C7A5A"/>
                 </a:solidFill>
@@ -13325,7 +13325,7 @@
               <a:t>✔  </a:t>
             </a:r>
             <a:r>
-              <a:rPr sz="2400" b="0" i="0">
+              <a:rPr sz="2000" b="0" i="0">
                 <a:solidFill>
                   <a:srgbClr val="14332A"/>
                 </a:solidFill>
@@ -13358,7 +13358,7 @@
           <a:lstStyle/>
           <a:p>
             <a:r>
-              <a:rPr sz="2400" b="1" i="0">
+              <a:rPr sz="2000" b="1" i="0">
                 <a:solidFill>
                   <a:srgbClr val="2C7A5A"/>
                 </a:solidFill>
@@ -13366,7 +13366,7 @@
               <a:t>✔  </a:t>
             </a:r>
             <a:r>
-              <a:rPr sz="2400" b="0" i="0">
+              <a:rPr sz="2000" b="0" i="0">
                 <a:solidFill>
                   <a:srgbClr val="14332A"/>
                 </a:solidFill>
@@ -13399,7 +13399,7 @@
           <a:lstStyle/>
           <a:p>
             <a:r>
-              <a:rPr sz="2400" b="1" i="0">
+              <a:rPr sz="2000" b="1" i="0">
                 <a:solidFill>
                   <a:srgbClr val="2C7A5A"/>
                 </a:solidFill>
@@ -13407,7 +13407,7 @@
               <a:t>✔  </a:t>
             </a:r>
             <a:r>
-              <a:rPr sz="2400" b="0" i="0">
+              <a:rPr sz="2000" b="0" i="0">
                 <a:solidFill>
                   <a:srgbClr val="14332A"/>
                 </a:solidFill>
@@ -13440,7 +13440,7 @@
           <a:lstStyle/>
           <a:p>
             <a:r>
-              <a:rPr sz="2400" b="1" i="0">
+              <a:rPr sz="2000" b="1" i="0">
                 <a:solidFill>
                   <a:srgbClr val="2C7A5A"/>
                 </a:solidFill>
@@ -13448,7 +13448,7 @@
               <a:t>✔  </a:t>
             </a:r>
             <a:r>
-              <a:rPr sz="2400" b="0" i="0">
+              <a:rPr sz="2000" b="0" i="0">
                 <a:solidFill>
                   <a:srgbClr val="14332A"/>
                 </a:solidFill>
@@ -13481,7 +13481,7 @@
           <a:lstStyle/>
           <a:p>
             <a:r>
-              <a:rPr sz="2400" b="1" i="0">
+              <a:rPr sz="2000" b="1" i="0">
                 <a:solidFill>
                   <a:srgbClr val="2C7A5A"/>
                 </a:solidFill>
@@ -13489,7 +13489,7 @@
               <a:t>✔  </a:t>
             </a:r>
             <a:r>
-              <a:rPr sz="2400" b="0" i="0">
+              <a:rPr sz="2000" b="0" i="0">
                 <a:solidFill>
                   <a:srgbClr val="14332A"/>
                 </a:solidFill>
@@ -13636,7 +13636,7 @@
           <a:lstStyle/>
           <a:p>
             <a:r>
-              <a:rPr sz="2400" b="1" i="0">
+              <a:rPr sz="2000" b="1" i="0">
                 <a:solidFill>
                   <a:srgbClr val="C88A2E"/>
                 </a:solidFill>
@@ -13987,7 +13987,7 @@
           <a:lstStyle/>
           <a:p>
             <a:r>
-              <a:rPr sz="2400" b="1" i="0">
+              <a:rPr sz="2000" b="1" i="0">
                 <a:solidFill>
                   <a:srgbClr val="C88A2E"/>
                 </a:solidFill>
@@ -14356,7 +14356,7 @@
           <a:lstStyle/>
           <a:p>
             <a:r>
-              <a:rPr sz="2500" b="1" i="0">
+              <a:rPr sz="2075" b="1" i="0">
                 <a:solidFill>
                   <a:srgbClr val="1F4E3D"/>
                 </a:solidFill>
@@ -14366,7 +14366,7 @@
           </a:p>
           <a:p>
             <a:r>
-              <a:rPr sz="2400" b="0" i="0">
+              <a:rPr sz="2000" b="0" i="0">
                 <a:solidFill>
                   <a:srgbClr val="34404A"/>
                 </a:solidFill>
@@ -14561,7 +14561,7 @@
           <a:lstStyle/>
           <a:p>
             <a:r>
-              <a:rPr sz="2500" b="1" i="0">
+              <a:rPr sz="2075" b="1" i="0">
                 <a:solidFill>
                   <a:srgbClr val="1F4E3D"/>
                 </a:solidFill>
@@ -14571,7 +14571,7 @@
           </a:p>
           <a:p>
             <a:r>
-              <a:rPr sz="2400" b="0" i="0">
+              <a:rPr sz="2000" b="0" i="0">
                 <a:solidFill>
                   <a:srgbClr val="34404A"/>
                 </a:solidFill>
@@ -14766,7 +14766,7 @@
           <a:lstStyle/>
           <a:p>
             <a:r>
-              <a:rPr sz="2500" b="1" i="0">
+              <a:rPr sz="2075" b="1" i="0">
                 <a:solidFill>
                   <a:srgbClr val="1F4E3D"/>
                 </a:solidFill>
@@ -14776,7 +14776,7 @@
           </a:p>
           <a:p>
             <a:r>
-              <a:rPr sz="2400" b="0" i="0">
+              <a:rPr sz="2000" b="0" i="0">
                 <a:solidFill>
                   <a:srgbClr val="34404A"/>
                 </a:solidFill>
@@ -14923,7 +14923,7 @@
           <a:lstStyle/>
           <a:p>
             <a:r>
-              <a:rPr sz="2400" b="1" i="0">
+              <a:rPr sz="2000" b="1" i="0">
                 <a:solidFill>
                   <a:srgbClr val="C88A2E"/>
                 </a:solidFill>
@@ -15204,7 +15204,7 @@
           <a:lstStyle/>
           <a:p>
             <a:r>
-              <a:rPr sz="2500" b="1" i="0">
+              <a:rPr sz="2075" b="1" i="0">
                 <a:solidFill>
                   <a:srgbClr val="1F4E3D"/>
                 </a:solidFill>
@@ -15214,7 +15214,7 @@
           </a:p>
           <a:p>
             <a:r>
-              <a:rPr sz="2400" b="0" i="0">
+              <a:rPr sz="2000" b="0" i="0">
                 <a:solidFill>
                   <a:srgbClr val="34404A"/>
                 </a:solidFill>
@@ -15321,7 +15321,7 @@
           <a:lstStyle/>
           <a:p>
             <a:r>
-              <a:rPr sz="2500" b="1" i="0">
+              <a:rPr sz="2075" b="1" i="0">
                 <a:solidFill>
                   <a:srgbClr val="1F4E3D"/>
                 </a:solidFill>
@@ -15331,7 +15331,7 @@
           </a:p>
           <a:p>
             <a:r>
-              <a:rPr sz="2400" b="0" i="0">
+              <a:rPr sz="2000" b="0" i="0">
                 <a:solidFill>
                   <a:srgbClr val="34404A"/>
                 </a:solidFill>
@@ -15438,7 +15438,7 @@
           <a:lstStyle/>
           <a:p>
             <a:r>
-              <a:rPr sz="2500" b="1" i="0">
+              <a:rPr sz="2075" b="1" i="0">
                 <a:solidFill>
                   <a:srgbClr val="1F4E3D"/>
                 </a:solidFill>
@@ -15448,7 +15448,7 @@
           </a:p>
           <a:p>
             <a:r>
-              <a:rPr sz="2400" b="0" i="0">
+              <a:rPr sz="2000" b="0" i="0">
                 <a:solidFill>
                   <a:srgbClr val="34404A"/>
                 </a:solidFill>
@@ -15688,7 +15688,7 @@
           <a:lstStyle/>
           <a:p>
             <a:r>
-              <a:rPr sz="2400" b="1" i="0">
+              <a:rPr sz="2000" b="1" i="0">
                 <a:solidFill>
                   <a:srgbClr val="C88A2E"/>
                 </a:solidFill>
@@ -15868,7 +15868,7 @@
           <a:lstStyle/>
           <a:p>
             <a:r>
-              <a:rPr sz="2400" b="1" i="0">
+              <a:rPr sz="2000" b="1" i="0">
                 <a:solidFill>
                   <a:srgbClr val="C88A2E"/>
                 </a:solidFill>
@@ -16237,7 +16237,7 @@
           <a:lstStyle/>
           <a:p>
             <a:r>
-              <a:rPr sz="2500" b="1" i="0">
+              <a:rPr sz="2075" b="1" i="0">
                 <a:solidFill>
                   <a:srgbClr val="1F4E3D"/>
                 </a:solidFill>
@@ -16247,7 +16247,7 @@
           </a:p>
           <a:p>
             <a:r>
-              <a:rPr sz="2400" b="0" i="0">
+              <a:rPr sz="2000" b="0" i="0">
                 <a:solidFill>
                   <a:srgbClr val="34404A"/>
                 </a:solidFill>
@@ -16257,7 +16257,7 @@
           </a:p>
           <a:p>
             <a:r>
-              <a:rPr sz="2400" b="0" i="0">
+              <a:rPr sz="2000" b="0" i="0">
                 <a:solidFill>
                   <a:srgbClr val="34404A"/>
                 </a:solidFill>
@@ -16452,7 +16452,7 @@
           <a:lstStyle/>
           <a:p>
             <a:r>
-              <a:rPr sz="2500" b="1" i="0">
+              <a:rPr sz="2075" b="1" i="0">
                 <a:solidFill>
                   <a:srgbClr val="1F4E3D"/>
                 </a:solidFill>
@@ -16462,7 +16462,7 @@
           </a:p>
           <a:p>
             <a:r>
-              <a:rPr sz="2400" b="0" i="0">
+              <a:rPr sz="2000" b="0" i="0">
                 <a:solidFill>
                   <a:srgbClr val="34404A"/>
                 </a:solidFill>
@@ -16472,7 +16472,7 @@
           </a:p>
           <a:p>
             <a:r>
-              <a:rPr sz="2400" b="0" i="0">
+              <a:rPr sz="2000" b="0" i="0">
                 <a:solidFill>
                   <a:srgbClr val="34404A"/>
                 </a:solidFill>
@@ -16619,7 +16619,7 @@
           <a:lstStyle/>
           <a:p>
             <a:r>
-              <a:rPr sz="2400" b="1" i="0">
+              <a:rPr sz="2000" b="1" i="0">
                 <a:solidFill>
                   <a:srgbClr val="C88A2E"/>
                 </a:solidFill>
@@ -16988,7 +16988,7 @@
           <a:lstStyle/>
           <a:p>
             <a:r>
-              <a:rPr sz="2500" b="1" i="0">
+              <a:rPr sz="2075" b="1" i="0">
                 <a:solidFill>
                   <a:srgbClr val="1F4E3D"/>
                 </a:solidFill>
@@ -16998,7 +16998,7 @@
           </a:p>
           <a:p>
             <a:r>
-              <a:rPr sz="2400" b="0" i="0">
+              <a:rPr sz="2000" b="0" i="0">
                 <a:solidFill>
                   <a:srgbClr val="34404A"/>
                 </a:solidFill>
@@ -17008,7 +17008,7 @@
           </a:p>
           <a:p>
             <a:r>
-              <a:rPr sz="2400" b="0" i="0">
+              <a:rPr sz="2000" b="0" i="0">
                 <a:solidFill>
                   <a:srgbClr val="34404A"/>
                 </a:solidFill>
@@ -17203,7 +17203,7 @@
           <a:lstStyle/>
           <a:p>
             <a:r>
-              <a:rPr sz="2500" b="1" i="0">
+              <a:rPr sz="2075" b="1" i="0">
                 <a:solidFill>
                   <a:srgbClr val="1F4E3D"/>
                 </a:solidFill>
@@ -17213,7 +17213,7 @@
           </a:p>
           <a:p>
             <a:r>
-              <a:rPr sz="2400" b="0" i="0">
+              <a:rPr sz="2000" b="0" i="0">
                 <a:solidFill>
                   <a:srgbClr val="34404A"/>
                 </a:solidFill>
@@ -17223,7 +17223,7 @@
           </a:p>
           <a:p>
             <a:r>
-              <a:rPr sz="2400" b="0" i="0">
+              <a:rPr sz="2000" b="0" i="0">
                 <a:solidFill>
                   <a:srgbClr val="34404A"/>
                 </a:solidFill>
@@ -17370,7 +17370,7 @@
           <a:lstStyle/>
           <a:p>
             <a:r>
-              <a:rPr sz="2400" b="1" i="0">
+              <a:rPr sz="2000" b="1" i="0">
                 <a:solidFill>
                   <a:srgbClr val="C88A2E"/>
                 </a:solidFill>
@@ -17651,7 +17651,7 @@
           <a:lstStyle/>
           <a:p>
             <a:r>
-              <a:rPr sz="2500" b="1" i="0">
+              <a:rPr sz="2075" b="1" i="0">
                 <a:solidFill>
                   <a:srgbClr val="1F4E3D"/>
                 </a:solidFill>
@@ -17661,7 +17661,7 @@
           </a:p>
           <a:p>
             <a:r>
-              <a:rPr sz="2400" b="0" i="0">
+              <a:rPr sz="2000" b="0" i="0">
                 <a:solidFill>
                   <a:srgbClr val="34404A"/>
                 </a:solidFill>
@@ -17768,7 +17768,7 @@
           <a:lstStyle/>
           <a:p>
             <a:r>
-              <a:rPr sz="2500" b="1" i="0">
+              <a:rPr sz="2075" b="1" i="0">
                 <a:solidFill>
                   <a:srgbClr val="1F4E3D"/>
                 </a:solidFill>
@@ -17778,7 +17778,7 @@
           </a:p>
           <a:p>
             <a:r>
-              <a:rPr sz="2400" b="0" i="0">
+              <a:rPr sz="2000" b="0" i="0">
                 <a:solidFill>
                   <a:srgbClr val="34404A"/>
                 </a:solidFill>
@@ -17885,7 +17885,7 @@
           <a:lstStyle/>
           <a:p>
             <a:r>
-              <a:rPr sz="2500" b="1" i="0">
+              <a:rPr sz="2075" b="1" i="0">
                 <a:solidFill>
                   <a:srgbClr val="1F4E3D"/>
                 </a:solidFill>
@@ -17895,7 +17895,7 @@
           </a:p>
           <a:p>
             <a:r>
-              <a:rPr sz="2400" b="0" i="0">
+              <a:rPr sz="2000" b="0" i="0">
                 <a:solidFill>
                   <a:srgbClr val="34404A"/>
                 </a:solidFill>
@@ -18135,7 +18135,7 @@
           <a:lstStyle/>
           <a:p>
             <a:r>
-              <a:rPr sz="2400" b="1" i="0">
+              <a:rPr sz="2000" b="1" i="0">
                 <a:solidFill>
                   <a:srgbClr val="C88A2E"/>
                 </a:solidFill>
@@ -18408,7 +18408,7 @@
           <a:lstStyle/>
           <a:p>
             <a:r>
-              <a:rPr sz="2400" b="1" i="0">
+              <a:rPr sz="2000" b="1" i="0">
                 <a:solidFill>
                   <a:srgbClr val="C88A2E"/>
                 </a:solidFill>
@@ -18588,7 +18588,7 @@
           <a:lstStyle/>
           <a:p>
             <a:r>
-              <a:rPr sz="2400" b="1" i="0">
+              <a:rPr sz="2000" b="1" i="0">
                 <a:solidFill>
                   <a:srgbClr val="C88A2E"/>
                 </a:solidFill>
@@ -18913,7 +18913,7 @@
           <a:lstStyle/>
           <a:p>
             <a:r>
-              <a:rPr sz="2500" b="1" i="0">
+              <a:rPr sz="2075" b="1" i="0">
                 <a:solidFill>
                   <a:srgbClr val="1F4E3D"/>
                 </a:solidFill>
@@ -18923,7 +18923,7 @@
           </a:p>
           <a:p>
             <a:r>
-              <a:rPr sz="2400" b="1" i="0">
+              <a:rPr sz="2000" b="1" i="0">
                 <a:solidFill>
                   <a:srgbClr val="C88A2E"/>
                 </a:solidFill>
@@ -18931,7 +18931,7 @@
               <a:t>Nguy cơ: </a:t>
             </a:r>
             <a:r>
-              <a:rPr sz="2400" b="0" i="0">
+              <a:rPr sz="2000" b="0" i="0">
                 <a:solidFill>
                   <a:srgbClr val="34404A"/>
                 </a:solidFill>
@@ -18941,7 +18941,7 @@
           </a:p>
           <a:p>
             <a:r>
-              <a:rPr sz="2400" b="1" i="0">
+              <a:rPr sz="2000" b="1" i="0">
                 <a:solidFill>
                   <a:srgbClr val="2C7A5A"/>
                 </a:solidFill>
@@ -18949,7 +18949,7 @@
               <a:t>Biện pháp: </a:t>
             </a:r>
             <a:r>
-              <a:rPr sz="2400" b="0" i="0">
+              <a:rPr sz="2000" b="0" i="0">
                 <a:solidFill>
                   <a:srgbClr val="34404A"/>
                 </a:solidFill>
@@ -19100,7 +19100,7 @@
           <a:lstStyle/>
           <a:p>
             <a:r>
-              <a:rPr sz="2500" b="1" i="0">
+              <a:rPr sz="2075" b="1" i="0">
                 <a:solidFill>
                   <a:srgbClr val="1F4E3D"/>
                 </a:solidFill>
@@ -19110,7 +19110,7 @@
           </a:p>
           <a:p>
             <a:r>
-              <a:rPr sz="2400" b="1" i="0">
+              <a:rPr sz="2000" b="1" i="0">
                 <a:solidFill>
                   <a:srgbClr val="C88A2E"/>
                 </a:solidFill>
@@ -19118,7 +19118,7 @@
               <a:t>Nguy cơ: </a:t>
             </a:r>
             <a:r>
-              <a:rPr sz="2400" b="0" i="0">
+              <a:rPr sz="2000" b="0" i="0">
                 <a:solidFill>
                   <a:srgbClr val="34404A"/>
                 </a:solidFill>
@@ -19128,7 +19128,7 @@
           </a:p>
           <a:p>
             <a:r>
-              <a:rPr sz="2400" b="1" i="0">
+              <a:rPr sz="2000" b="1" i="0">
                 <a:solidFill>
                   <a:srgbClr val="2C7A5A"/>
                 </a:solidFill>
@@ -19136,7 +19136,7 @@
               <a:t>Biện pháp: </a:t>
             </a:r>
             <a:r>
-              <a:rPr sz="2400" b="0" i="0">
+              <a:rPr sz="2000" b="0" i="0">
                 <a:solidFill>
                   <a:srgbClr val="34404A"/>
                 </a:solidFill>
@@ -19283,7 +19283,7 @@
           <a:lstStyle/>
           <a:p>
             <a:r>
-              <a:rPr sz="2400" b="1" i="0">
+              <a:rPr sz="2000" b="1" i="0">
                 <a:solidFill>
                   <a:srgbClr val="C88A2E"/>
                 </a:solidFill>
@@ -19608,7 +19608,7 @@
           <a:lstStyle/>
           <a:p>
             <a:r>
-              <a:rPr sz="2500" b="1" i="0">
+              <a:rPr sz="2075" b="1" i="0">
                 <a:solidFill>
                   <a:srgbClr val="1F4E3D"/>
                 </a:solidFill>
@@ -19618,7 +19618,7 @@
           </a:p>
           <a:p>
             <a:r>
-              <a:rPr sz="2400" b="1" i="0">
+              <a:rPr sz="2000" b="1" i="0">
                 <a:solidFill>
                   <a:srgbClr val="C88A2E"/>
                 </a:solidFill>
@@ -19626,7 +19626,7 @@
               <a:t>Nguy cơ: </a:t>
             </a:r>
             <a:r>
-              <a:rPr sz="2400" b="0" i="0">
+              <a:rPr sz="2000" b="0" i="0">
                 <a:solidFill>
                   <a:srgbClr val="34404A"/>
                 </a:solidFill>
@@ -19636,7 +19636,7 @@
           </a:p>
           <a:p>
             <a:r>
-              <a:rPr sz="2400" b="1" i="0">
+              <a:rPr sz="2000" b="1" i="0">
                 <a:solidFill>
                   <a:srgbClr val="2C7A5A"/>
                 </a:solidFill>
@@ -19644,7 +19644,7 @@
               <a:t>Biện pháp: </a:t>
             </a:r>
             <a:r>
-              <a:rPr sz="2400" b="0" i="0">
+              <a:rPr sz="2000" b="0" i="0">
                 <a:solidFill>
                   <a:srgbClr val="34404A"/>
                 </a:solidFill>
@@ -19795,7 +19795,7 @@
           <a:lstStyle/>
           <a:p>
             <a:r>
-              <a:rPr sz="2500" b="1" i="0">
+              <a:rPr sz="2075" b="1" i="0">
                 <a:solidFill>
                   <a:srgbClr val="1F4E3D"/>
                 </a:solidFill>
@@ -19805,7 +19805,7 @@
           </a:p>
           <a:p>
             <a:r>
-              <a:rPr sz="2400" b="1" i="0">
+              <a:rPr sz="2000" b="1" i="0">
                 <a:solidFill>
                   <a:srgbClr val="C88A2E"/>
                 </a:solidFill>
@@ -19813,7 +19813,7 @@
               <a:t>Nguy cơ: </a:t>
             </a:r>
             <a:r>
-              <a:rPr sz="2400" b="0" i="0">
+              <a:rPr sz="2000" b="0" i="0">
                 <a:solidFill>
                   <a:srgbClr val="34404A"/>
                 </a:solidFill>
@@ -19823,7 +19823,7 @@
           </a:p>
           <a:p>
             <a:r>
-              <a:rPr sz="2400" b="1" i="0">
+              <a:rPr sz="2000" b="1" i="0">
                 <a:solidFill>
                   <a:srgbClr val="2C7A5A"/>
                 </a:solidFill>
@@ -19831,7 +19831,7 @@
               <a:t>Biện pháp: </a:t>
             </a:r>
             <a:r>
-              <a:rPr sz="2400" b="0" i="0">
+              <a:rPr sz="2000" b="0" i="0">
                 <a:solidFill>
                   <a:srgbClr val="34404A"/>
                 </a:solidFill>
@@ -19978,7 +19978,7 @@
           <a:lstStyle/>
           <a:p>
             <a:r>
-              <a:rPr sz="2400" b="1" i="0">
+              <a:rPr sz="2000" b="1" i="0">
                 <a:solidFill>
                   <a:srgbClr val="C88A2E"/>
                 </a:solidFill>
@@ -20347,7 +20347,7 @@
           <a:lstStyle/>
           <a:p>
             <a:r>
-              <a:rPr sz="2500" b="1" i="0">
+              <a:rPr sz="2075" b="1" i="0">
                 <a:solidFill>
                   <a:srgbClr val="1F4E3D"/>
                 </a:solidFill>
@@ -20357,7 +20357,7 @@
           </a:p>
           <a:p>
             <a:r>
-              <a:rPr sz="2400" b="0" i="0">
+              <a:rPr sz="2000" b="0" i="0">
                 <a:solidFill>
                   <a:srgbClr val="34404A"/>
                 </a:solidFill>
@@ -20552,7 +20552,7 @@
           <a:lstStyle/>
           <a:p>
             <a:r>
-              <a:rPr sz="2500" b="1" i="0">
+              <a:rPr sz="2075" b="1" i="0">
                 <a:solidFill>
                   <a:srgbClr val="1F4E3D"/>
                 </a:solidFill>
@@ -20562,7 +20562,7 @@
           </a:p>
           <a:p>
             <a:r>
-              <a:rPr sz="2400" b="0" i="0">
+              <a:rPr sz="2000" b="0" i="0">
                 <a:solidFill>
                   <a:srgbClr val="34404A"/>
                 </a:solidFill>
@@ -20757,7 +20757,7 @@
           <a:lstStyle/>
           <a:p>
             <a:r>
-              <a:rPr sz="2500" b="1" i="0">
+              <a:rPr sz="2075" b="1" i="0">
                 <a:solidFill>
                   <a:srgbClr val="1F4E3D"/>
                 </a:solidFill>
@@ -20767,7 +20767,7 @@
           </a:p>
           <a:p>
             <a:r>
-              <a:rPr sz="2400" b="0" i="0">
+              <a:rPr sz="2000" b="0" i="0">
                 <a:solidFill>
                   <a:srgbClr val="34404A"/>
                 </a:solidFill>
@@ -20914,7 +20914,7 @@
           <a:lstStyle/>
           <a:p>
             <a:r>
-              <a:rPr sz="2400" b="1" i="0">
+              <a:rPr sz="2000" b="1" i="0">
                 <a:solidFill>
                   <a:srgbClr val="C88A2E"/>
                 </a:solidFill>
@@ -21195,7 +21195,7 @@
           <a:lstStyle/>
           <a:p>
             <a:r>
-              <a:rPr sz="2500" b="1" i="0">
+              <a:rPr sz="2075" b="1" i="0">
                 <a:solidFill>
                   <a:srgbClr val="1F4E3D"/>
                 </a:solidFill>
@@ -21205,7 +21205,7 @@
           </a:p>
           <a:p>
             <a:r>
-              <a:rPr sz="2400" b="0" i="0">
+              <a:rPr sz="2000" b="0" i="0">
                 <a:solidFill>
                   <a:srgbClr val="34404A"/>
                 </a:solidFill>
@@ -21312,7 +21312,7 @@
           <a:lstStyle/>
           <a:p>
             <a:r>
-              <a:rPr sz="2500" b="1" i="0">
+              <a:rPr sz="2075" b="1" i="0">
                 <a:solidFill>
                   <a:srgbClr val="1F4E3D"/>
                 </a:solidFill>
@@ -21322,7 +21322,7 @@
           </a:p>
           <a:p>
             <a:r>
-              <a:rPr sz="2400" b="0" i="0">
+              <a:rPr sz="2000" b="0" i="0">
                 <a:solidFill>
                   <a:srgbClr val="34404A"/>
                 </a:solidFill>
@@ -21429,7 +21429,7 @@
           <a:lstStyle/>
           <a:p>
             <a:r>
-              <a:rPr sz="2500" b="1" i="0">
+              <a:rPr sz="2075" b="1" i="0">
                 <a:solidFill>
                   <a:srgbClr val="1F4E3D"/>
                 </a:solidFill>
@@ -21439,7 +21439,7 @@
           </a:p>
           <a:p>
             <a:r>
-              <a:rPr sz="2400" b="0" i="0">
+              <a:rPr sz="2000" b="0" i="0">
                 <a:solidFill>
                   <a:srgbClr val="34404A"/>
                 </a:solidFill>
@@ -21807,7 +21807,7 @@
           <a:lstStyle/>
           <a:p>
             <a:r>
-              <a:rPr sz="2400" b="1" i="0">
+              <a:rPr sz="2000" b="1" i="0">
                 <a:solidFill>
                   <a:srgbClr val="C88A2E"/>
                 </a:solidFill>
@@ -22088,7 +22088,7 @@
           <a:lstStyle/>
           <a:p>
             <a:r>
-              <a:rPr sz="2500" b="1" i="0">
+              <a:rPr sz="2075" b="1" i="0">
                 <a:solidFill>
                   <a:srgbClr val="1F4E3D"/>
                 </a:solidFill>
@@ -22098,7 +22098,7 @@
           </a:p>
           <a:p>
             <a:r>
-              <a:rPr sz="2400" b="0" i="0">
+              <a:rPr sz="2000" b="0" i="0">
                 <a:solidFill>
                   <a:srgbClr val="34404A"/>
                 </a:solidFill>
@@ -22205,7 +22205,7 @@
           <a:lstStyle/>
           <a:p>
             <a:r>
-              <a:rPr sz="2500" b="1" i="0">
+              <a:rPr sz="2075" b="1" i="0">
                 <a:solidFill>
                   <a:srgbClr val="1F4E3D"/>
                 </a:solidFill>
@@ -22215,7 +22215,7 @@
           </a:p>
           <a:p>
             <a:r>
-              <a:rPr sz="2400" b="0" i="0">
+              <a:rPr sz="2000" b="0" i="0">
                 <a:solidFill>
                   <a:srgbClr val="34404A"/>
                 </a:solidFill>
@@ -22322,7 +22322,7 @@
           <a:lstStyle/>
           <a:p>
             <a:r>
-              <a:rPr sz="2500" b="1" i="0">
+              <a:rPr sz="2075" b="1" i="0">
                 <a:solidFill>
                   <a:srgbClr val="1F4E3D"/>
                 </a:solidFill>
@@ -22332,7 +22332,7 @@
           </a:p>
           <a:p>
             <a:r>
-              <a:rPr sz="2400" b="0" i="0">
+              <a:rPr sz="2000" b="0" i="0">
                 <a:solidFill>
                   <a:srgbClr val="34404A"/>
                 </a:solidFill>
@@ -22479,7 +22479,7 @@
           <a:lstStyle/>
           <a:p>
             <a:r>
-              <a:rPr sz="2400" b="1" i="0">
+              <a:rPr sz="2000" b="1" i="0">
                 <a:solidFill>
                   <a:srgbClr val="C88A2E"/>
                 </a:solidFill>
@@ -22830,7 +22830,7 @@
           <a:lstStyle/>
           <a:p>
             <a:r>
-              <a:rPr sz="2400" b="1" i="0">
+              <a:rPr sz="2000" b="1" i="0">
                 <a:solidFill>
                   <a:srgbClr val="C88A2E"/>
                 </a:solidFill>
@@ -23111,7 +23111,7 @@
           <a:lstStyle/>
           <a:p>
             <a:r>
-              <a:rPr sz="2500" b="0" i="0">
+              <a:rPr sz="2075" b="0" i="0">
                 <a:solidFill>
                   <a:srgbClr val="14332A"/>
                 </a:solidFill>
@@ -23218,7 +23218,7 @@
           <a:lstStyle/>
           <a:p>
             <a:r>
-              <a:rPr sz="2500" b="0" i="0">
+              <a:rPr sz="2075" b="0" i="0">
                 <a:solidFill>
                   <a:srgbClr val="14332A"/>
                 </a:solidFill>
@@ -23325,7 +23325,7 @@
           <a:lstStyle/>
           <a:p>
             <a:r>
-              <a:rPr sz="2500" b="0" i="0">
+              <a:rPr sz="2075" b="0" i="0">
                 <a:solidFill>
                   <a:srgbClr val="14332A"/>
                 </a:solidFill>
@@ -23432,7 +23432,7 @@
           <a:lstStyle/>
           <a:p>
             <a:r>
-              <a:rPr sz="2500" b="0" i="0">
+              <a:rPr sz="2075" b="0" i="0">
                 <a:solidFill>
                   <a:srgbClr val="14332A"/>
                 </a:solidFill>
@@ -23672,7 +23672,7 @@
           <a:lstStyle/>
           <a:p>
             <a:r>
-              <a:rPr sz="2400" b="1" i="0">
+              <a:rPr sz="2000" b="1" i="0">
                 <a:solidFill>
                   <a:srgbClr val="C88A2E"/>
                 </a:solidFill>
@@ -23852,7 +23852,7 @@
           <a:lstStyle/>
           <a:p>
             <a:r>
-              <a:rPr sz="2400" b="1" i="0">
+              <a:rPr sz="2000" b="1" i="0">
                 <a:solidFill>
                   <a:srgbClr val="C88A2E"/>
                 </a:solidFill>
@@ -24133,7 +24133,7 @@
           <a:lstStyle/>
           <a:p>
             <a:r>
-              <a:rPr sz="2500" b="1" i="0">
+              <a:rPr sz="2075" b="1" i="0">
                 <a:solidFill>
                   <a:srgbClr val="1F4E3D"/>
                 </a:solidFill>
@@ -24143,7 +24143,7 @@
           </a:p>
           <a:p>
             <a:r>
-              <a:rPr sz="2400" b="0" i="0">
+              <a:rPr sz="2000" b="0" i="0">
                 <a:solidFill>
                   <a:srgbClr val="34404A"/>
                 </a:solidFill>
@@ -24250,7 +24250,7 @@
           <a:lstStyle/>
           <a:p>
             <a:r>
-              <a:rPr sz="2500" b="1" i="0">
+              <a:rPr sz="2075" b="1" i="0">
                 <a:solidFill>
                   <a:srgbClr val="1F4E3D"/>
                 </a:solidFill>
@@ -24260,7 +24260,7 @@
           </a:p>
           <a:p>
             <a:r>
-              <a:rPr sz="2400" b="0" i="0">
+              <a:rPr sz="2000" b="0" i="0">
                 <a:solidFill>
                   <a:srgbClr val="34404A"/>
                 </a:solidFill>
@@ -24367,7 +24367,7 @@
           <a:lstStyle/>
           <a:p>
             <a:r>
-              <a:rPr sz="2500" b="1" i="0">
+              <a:rPr sz="2075" b="1" i="0">
                 <a:solidFill>
                   <a:srgbClr val="1F4E3D"/>
                 </a:solidFill>
@@ -24377,7 +24377,7 @@
           </a:p>
           <a:p>
             <a:r>
-              <a:rPr sz="2400" b="0" i="0">
+              <a:rPr sz="2000" b="0" i="0">
                 <a:solidFill>
                   <a:srgbClr val="34404A"/>
                 </a:solidFill>
@@ -24484,7 +24484,7 @@
           <a:lstStyle/>
           <a:p>
             <a:r>
-              <a:rPr sz="2500" b="1" i="0">
+              <a:rPr sz="2075" b="1" i="0">
                 <a:solidFill>
                   <a:srgbClr val="1F4E3D"/>
                 </a:solidFill>
@@ -24494,7 +24494,7 @@
           </a:p>
           <a:p>
             <a:r>
-              <a:rPr sz="2400" b="0" i="0">
+              <a:rPr sz="2000" b="0" i="0">
                 <a:solidFill>
                   <a:srgbClr val="34404A"/>
                 </a:solidFill>
@@ -24641,7 +24641,7 @@
           <a:lstStyle/>
           <a:p>
             <a:r>
-              <a:rPr sz="2400" b="1" i="0">
+              <a:rPr sz="2000" b="1" i="0">
                 <a:solidFill>
                   <a:srgbClr val="C88A2E"/>
                 </a:solidFill>
@@ -24879,7 +24879,7 @@
           <a:p>
             <a:pPr algn="ctr"/>
             <a:r>
-              <a:rPr sz="2400" b="0" i="1">
+              <a:rPr sz="2000" b="0" i="1">
                 <a:solidFill>
                   <a:srgbClr val="5B6E66"/>
                 </a:solidFill>

</xml_diff>

<commit_message>
Redraw process flowchart as icon-box serpentine
Replace the linear flow strip with a two-row serpentine: large step
boxes each carrying its process icon, number badge and name; inline
Kiem tra checkpoints; a raw-material input box, a dilution top-up note,
and a finished-product box (topcoat/primer).

Regenerate the PDF export.

Co-Authored-By: Claude Opus 4.8 <noreply@anthropic.com>
Claude-Session: https://claude.ai/code/session_01PbbxSyJEYscgmQfTL8vaUX
</commit_message>
<xml_diff>
--- a/SuHeo/Báo cáo thực tập - Sơn Hải Vân.pptx
+++ b/SuHeo/Báo cáo thực tập - Sơn Hải Vân.pptx
@@ -7009,48 +7009,14 @@
         </p:blipFill>
         <p:spPr>
           <a:xfrm>
-            <a:off x="495847" y="1830000"/>
-            <a:ext cx="11200000" cy="4348235"/>
+            <a:off x="1891457" y="1855000"/>
+            <a:ext cx="8408780" cy="4420000"/>
           </a:xfrm>
           <a:prstGeom prst="rect">
             <a:avLst/>
           </a:prstGeom>
         </p:spPr>
       </p:pic>
-      <p:sp>
-        <p:nvSpPr>
-          <p:cNvPr id="13" name="TextBox 12"/>
-          <p:cNvSpPr txBox="1"/>
-          <p:nvPr/>
-        </p:nvSpPr>
-        <p:spPr>
-          <a:xfrm>
-            <a:off x="700000" y="6080000"/>
-            <a:ext cx="10800000" cy="360000"/>
-          </a:xfrm>
-          <a:prstGeom prst="rect">
-            <a:avLst/>
-          </a:prstGeom>
-          <a:noFill/>
-        </p:spPr>
-        <p:txBody>
-          <a:bodyPr wrap="square" lIns="50000" rIns="50000" tIns="20000" bIns="20000">
-            <a:spAutoFit/>
-          </a:bodyPr>
-          <a:lstStyle/>
-          <a:p>
-            <a:pPr algn="ctr"/>
-            <a:r>
-              <a:rPr sz="2000" b="0" i="1">
-                <a:solidFill>
-                  <a:srgbClr val="5B6E66"/>
-                </a:solidFill>
-              </a:rPr>
-              <a:t>Đầu vào → 6 công đoạn (có điểm Kiểm tra) → sản phẩm sơn phủ / sơn lót</a:t>
-            </a:r>
-          </a:p>
-        </p:txBody>
-      </p:sp>
     </p:spTree>
   </p:cSld>
   <p:clrMapOvr>

</xml_diff>

<commit_message>
Add illustrative photos to marine, safety and environment slides
Bring in freely-licensed Wikimedia Commons photos on selected content
slides: a cargo ship for the marine three-coat system, a worker in PPE
for the workplace-safety slide, and an aeration/treatment plant for the
waste-control slide. Each sits in a framed panel beside the text with a
short caption; layouts reflow so nothing is clipped.

Regenerate the PDF export.

Co-Authored-By: Claude Opus 4.8 <noreply@anthropic.com>
Claude-Session: https://claude.ai/code/session_01PbbxSyJEYscgmQfTL8vaUX
</commit_message>
<xml_diff>
--- a/SuHeo/Báo cáo thực tập - Sơn Hải Vân.pptx
+++ b/SuHeo/Báo cáo thực tập - Sơn Hải Vân.pptx
@@ -4287,7 +4287,7 @@
           <a:blip r:embed="rId2">
             <a:extLst>
               <a:ext uri="{96DAC541-7B7A-43D3-8B79-37D633B846F1}">
-                <ns0:svgBlip xmlns:ns0="http://schemas.microsoft.com/office/drawing/2016/SVG/main" r:embed="rId6"/>
+                <ns0:svgBlip xmlns:ns0="http://schemas.microsoft.com/office/drawing/2016/SVG/main" r:embed="rId7"/>
               </a:ext>
             </a:extLst>
           </a:blip>
@@ -4317,7 +4317,7 @@
           <a:blip r:embed="rId3">
             <a:extLst>
               <a:ext uri="{96DAC541-7B7A-43D3-8B79-37D633B846F1}">
-                <ns1:svgBlip xmlns:ns1="http://schemas.microsoft.com/office/drawing/2016/SVG/main" r:embed="rId7"/>
+                <ns1:svgBlip xmlns:ns1="http://schemas.microsoft.com/office/drawing/2016/SVG/main" r:embed="rId8"/>
               </a:ext>
             </a:extLst>
           </a:blip>
@@ -4465,7 +4465,7 @@
           <a:blip r:embed="rId4">
             <a:extLst>
               <a:ext uri="{96DAC541-7B7A-43D3-8B79-37D633B846F1}">
-                <ns2:svgBlip xmlns:ns2="http://schemas.microsoft.com/office/drawing/2016/SVG/main" r:embed="rId5"/>
+                <ns2:svgBlip xmlns:ns2="http://schemas.microsoft.com/office/drawing/2016/SVG/main" r:embed="rId6"/>
               </a:ext>
             </a:extLst>
           </a:blip>
@@ -4603,7 +4603,7 @@
         <p:spPr>
           <a:xfrm>
             <a:off x="548640" y="1830000"/>
-            <a:ext cx="11090000" cy="1020000"/>
+            <a:ext cx="6550000" cy="1020000"/>
           </a:xfrm>
           <a:prstGeom prst="roundRect">
             <a:avLst/>
@@ -4646,8 +4646,8 @@
         </p:nvSpPr>
         <p:spPr>
           <a:xfrm>
-            <a:off x="900000" y="1830000"/>
-            <a:ext cx="10300000" cy="1020000"/>
+            <a:off x="820000" y="1830000"/>
+            <a:ext cx="6130000" cy="1020000"/>
           </a:xfrm>
           <a:prstGeom prst="rect">
             <a:avLst/>
@@ -4661,7 +4661,7 @@
           <a:lstStyle/>
           <a:p>
             <a:r>
-              <a:rPr sz="2075" b="1" i="0">
+              <a:rPr sz="2000" b="1" i="0">
                 <a:solidFill>
                   <a:srgbClr val="FFFFFF"/>
                 </a:solidFill>
@@ -4690,7 +4690,7 @@
         <p:spPr>
           <a:xfrm>
             <a:off x="548640" y="2980000"/>
-            <a:ext cx="11090000" cy="1020000"/>
+            <a:ext cx="6550000" cy="1020000"/>
           </a:xfrm>
           <a:prstGeom prst="roundRect">
             <a:avLst/>
@@ -4733,8 +4733,8 @@
         </p:nvSpPr>
         <p:spPr>
           <a:xfrm>
-            <a:off x="900000" y="2980000"/>
-            <a:ext cx="10300000" cy="1020000"/>
+            <a:off x="820000" y="2980000"/>
+            <a:ext cx="6130000" cy="1020000"/>
           </a:xfrm>
           <a:prstGeom prst="rect">
             <a:avLst/>
@@ -4748,7 +4748,7 @@
           <a:lstStyle/>
           <a:p>
             <a:r>
-              <a:rPr sz="2075" b="1" i="0">
+              <a:rPr sz="2000" b="1" i="0">
                 <a:solidFill>
                   <a:srgbClr val="FFFFFF"/>
                 </a:solidFill>
@@ -4777,7 +4777,7 @@
         <p:spPr>
           <a:xfrm>
             <a:off x="548640" y="4130000"/>
-            <a:ext cx="11090000" cy="1020000"/>
+            <a:ext cx="6550000" cy="1020000"/>
           </a:xfrm>
           <a:prstGeom prst="roundRect">
             <a:avLst/>
@@ -4820,8 +4820,8 @@
         </p:nvSpPr>
         <p:spPr>
           <a:xfrm>
-            <a:off x="900000" y="4130000"/>
-            <a:ext cx="10300000" cy="1020000"/>
+            <a:off x="820000" y="4130000"/>
+            <a:ext cx="6130000" cy="1020000"/>
           </a:xfrm>
           <a:prstGeom prst="rect">
             <a:avLst/>
@@ -4835,7 +4835,7 @@
           <a:lstStyle/>
           <a:p>
             <a:r>
-              <a:rPr sz="2075" b="1" i="0">
+              <a:rPr sz="2000" b="1" i="0">
                 <a:solidFill>
                   <a:srgbClr val="FFFFFF"/>
                 </a:solidFill>
@@ -4864,7 +4864,7 @@
         <p:spPr>
           <a:xfrm>
             <a:off x="548640" y="5280000"/>
-            <a:ext cx="11090000" cy="1020000"/>
+            <a:ext cx="6550000" cy="1020000"/>
           </a:xfrm>
           <a:prstGeom prst="roundRect">
             <a:avLst/>
@@ -4907,8 +4907,8 @@
         </p:nvSpPr>
         <p:spPr>
           <a:xfrm>
-            <a:off x="900000" y="5280000"/>
-            <a:ext cx="10300000" cy="1020000"/>
+            <a:off x="820000" y="5280000"/>
+            <a:ext cx="6130000" cy="1020000"/>
           </a:xfrm>
           <a:prstGeom prst="rect">
             <a:avLst/>
@@ -4922,7 +4922,7 @@
           <a:lstStyle/>
           <a:p>
             <a:r>
-              <a:rPr sz="2075" b="1" i="0">
+              <a:rPr sz="2000" b="1" i="0">
                 <a:solidFill>
                   <a:srgbClr val="FFFFFF"/>
                 </a:solidFill>
@@ -4938,6 +4938,108 @@
                 </a:solidFill>
               </a:rPr>
               <a:t>Đã xử lý bề mặt</a:t>
+            </a:r>
+          </a:p>
+        </p:txBody>
+      </p:sp>
+      <p:sp>
+        <p:nvSpPr>
+          <p:cNvPr id="20" name="Rectangle 19"/>
+          <p:cNvSpPr/>
+          <p:nvPr/>
+        </p:nvSpPr>
+        <p:spPr>
+          <a:xfrm>
+            <a:off x="7386000" y="2196217"/>
+            <a:ext cx="4288000" cy="3737565"/>
+          </a:xfrm>
+          <a:prstGeom prst="rect">
+            <a:avLst/>
+          </a:prstGeom>
+          <a:solidFill>
+            <a:srgbClr val="1F4E3D"/>
+          </a:solidFill>
+          <a:ln>
+            <a:noFill/>
+          </a:ln>
+          <a:effectLst/>
+        </p:spPr>
+        <p:style>
+          <a:lnRef idx="1">
+            <a:schemeClr val="accent1"/>
+          </a:lnRef>
+          <a:fillRef idx="3">
+            <a:schemeClr val="accent1"/>
+          </a:fillRef>
+          <a:effectRef idx="2">
+            <a:schemeClr val="accent1"/>
+          </a:effectRef>
+          <a:fontRef idx="minor">
+            <a:schemeClr val="lt1"/>
+          </a:fontRef>
+        </p:style>
+        <p:txBody>
+          <a:bodyPr rtlCol="0" anchor="ctr"/>
+          <a:lstStyle/>
+          <a:p>
+            <a:pPr algn="ctr"/>
+          </a:p>
+        </p:txBody>
+      </p:sp>
+      <p:pic>
+        <p:nvPicPr>
+          <p:cNvPr id="21" name="Picture 20" descr="ship_c.jpg"/>
+          <p:cNvPicPr>
+            <a:picLocks noChangeAspect="1"/>
+          </p:cNvPicPr>
+          <p:nvPr/>
+        </p:nvPicPr>
+        <p:blipFill>
+          <a:blip r:embed="rId5"/>
+          <a:stretch>
+            <a:fillRect/>
+          </a:stretch>
+        </p:blipFill>
+        <p:spPr>
+          <a:xfrm>
+            <a:off x="7420000" y="2230217"/>
+            <a:ext cx="4220000" cy="3669565"/>
+          </a:xfrm>
+          <a:prstGeom prst="rect">
+            <a:avLst/>
+          </a:prstGeom>
+        </p:spPr>
+      </p:pic>
+      <p:sp>
+        <p:nvSpPr>
+          <p:cNvPr id="22" name="TextBox 21"/>
+          <p:cNvSpPr txBox="1"/>
+          <p:nvPr/>
+        </p:nvSpPr>
+        <p:spPr>
+          <a:xfrm>
+            <a:off x="7386000" y="5949782"/>
+            <a:ext cx="4288000" cy="300000"/>
+          </a:xfrm>
+          <a:prstGeom prst="rect">
+            <a:avLst/>
+          </a:prstGeom>
+          <a:noFill/>
+        </p:spPr>
+        <p:txBody>
+          <a:bodyPr wrap="square" lIns="50000" rIns="50000" tIns="20000" bIns="20000">
+            <a:spAutoFit/>
+          </a:bodyPr>
+          <a:lstStyle/>
+          <a:p>
+            <a:pPr algn="ctr"/>
+            <a:r>
+              <a:rPr sz="1500" b="0" i="1">
+                <a:solidFill>
+                  <a:srgbClr val="5B6E66"/>
+                </a:solidFill>
+              </a:rPr>
+              <a:t>Sơn phủ bảo vệ thân tàu (minh họa)</a:t>
             </a:r>
           </a:p>
         </p:txBody>
@@ -21591,7 +21693,7 @@
           <a:blip r:embed="rId2">
             <a:extLst>
               <a:ext uri="{96DAC541-7B7A-43D3-8B79-37D633B846F1}">
-                <ns0:svgBlip xmlns:ns0="http://schemas.microsoft.com/office/drawing/2016/SVG/main" r:embed="rId10"/>
+                <ns0:svgBlip xmlns:ns0="http://schemas.microsoft.com/office/drawing/2016/SVG/main" r:embed="rId11"/>
               </a:ext>
             </a:extLst>
           </a:blip>
@@ -21621,7 +21723,7 @@
           <a:blip r:embed="rId3">
             <a:extLst>
               <a:ext uri="{96DAC541-7B7A-43D3-8B79-37D633B846F1}">
-                <ns1:svgBlip xmlns:ns1="http://schemas.microsoft.com/office/drawing/2016/SVG/main" r:embed="rId11"/>
+                <ns1:svgBlip xmlns:ns1="http://schemas.microsoft.com/office/drawing/2016/SVG/main" r:embed="rId12"/>
               </a:ext>
             </a:extLst>
           </a:blip>
@@ -21769,7 +21871,7 @@
           <a:blip r:embed="rId4">
             <a:extLst>
               <a:ext uri="{96DAC541-7B7A-43D3-8B79-37D633B846F1}">
-                <ns2:svgBlip xmlns:ns2="http://schemas.microsoft.com/office/drawing/2016/SVG/main" r:embed="rId7"/>
+                <ns2:svgBlip xmlns:ns2="http://schemas.microsoft.com/office/drawing/2016/SVG/main" r:embed="rId8"/>
               </a:ext>
             </a:extLst>
           </a:blip>
@@ -21907,7 +22009,7 @@
         <p:spPr>
           <a:xfrm>
             <a:off x="548640" y="1830000"/>
-            <a:ext cx="11090000" cy="2120000"/>
+            <a:ext cx="7050000" cy="2120000"/>
           </a:xfrm>
           <a:prstGeom prst="roundRect">
             <a:avLst/>
@@ -21950,8 +22052,8 @@
         </p:nvSpPr>
         <p:spPr>
           <a:xfrm>
-            <a:off x="820000" y="2390000"/>
-            <a:ext cx="1000000" cy="1000000"/>
+            <a:off x="820000" y="2415000"/>
+            <a:ext cx="950000" cy="950000"/>
           </a:xfrm>
           <a:prstGeom prst="ellipse">
             <a:avLst/>
@@ -21998,7 +22100,7 @@
           <a:blip r:embed="rId5">
             <a:extLst>
               <a:ext uri="{96DAC541-7B7A-43D3-8B79-37D633B846F1}">
-                <ns3:svgBlip xmlns:ns3="http://schemas.microsoft.com/office/drawing/2016/SVG/main" r:embed="rId8"/>
+                <ns3:svgBlip xmlns:ns3="http://schemas.microsoft.com/office/drawing/2016/SVG/main" r:embed="rId9"/>
               </a:ext>
             </a:extLst>
           </a:blip>
@@ -22008,8 +22110,8 @@
         </p:blipFill>
         <p:spPr>
           <a:xfrm>
-            <a:off x="1020000" y="2590000"/>
-            <a:ext cx="600000" cy="600000"/>
+            <a:off x="1010000" y="2605000"/>
+            <a:ext cx="570000" cy="570000"/>
           </a:xfrm>
           <a:prstGeom prst="rect">
             <a:avLst/>
@@ -22024,8 +22126,8 @@
         </p:nvSpPr>
         <p:spPr>
           <a:xfrm>
-            <a:off x="2100000" y="1950000"/>
-            <a:ext cx="9200000" cy="1880000"/>
+            <a:off x="1900000" y="1940000"/>
+            <a:ext cx="5550000" cy="1900000"/>
           </a:xfrm>
           <a:prstGeom prst="rect">
             <a:avLst/>
@@ -22039,7 +22141,7 @@
           <a:lstStyle/>
           <a:p>
             <a:r>
-              <a:rPr sz="2075" b="1" i="0">
+              <a:rPr sz="2000" b="1" i="0">
                 <a:solidFill>
                   <a:srgbClr val="1F4E3D"/>
                 </a:solidFill>
@@ -22094,7 +22196,7 @@
         <p:spPr>
           <a:xfrm>
             <a:off x="548640" y="4180000"/>
-            <a:ext cx="11090000" cy="2120000"/>
+            <a:ext cx="7050000" cy="2120000"/>
           </a:xfrm>
           <a:prstGeom prst="roundRect">
             <a:avLst/>
@@ -22137,8 +22239,8 @@
         </p:nvSpPr>
         <p:spPr>
           <a:xfrm>
-            <a:off x="820000" y="4740000"/>
-            <a:ext cx="1000000" cy="1000000"/>
+            <a:off x="820000" y="4765000"/>
+            <a:ext cx="950000" cy="950000"/>
           </a:xfrm>
           <a:prstGeom prst="ellipse">
             <a:avLst/>
@@ -22185,7 +22287,7 @@
           <a:blip r:embed="rId6">
             <a:extLst>
               <a:ext uri="{96DAC541-7B7A-43D3-8B79-37D633B846F1}">
-                <ns4:svgBlip xmlns:ns4="http://schemas.microsoft.com/office/drawing/2016/SVG/main" r:embed="rId9"/>
+                <ns4:svgBlip xmlns:ns4="http://schemas.microsoft.com/office/drawing/2016/SVG/main" r:embed="rId10"/>
               </a:ext>
             </a:extLst>
           </a:blip>
@@ -22195,8 +22297,8 @@
         </p:blipFill>
         <p:spPr>
           <a:xfrm>
-            <a:off x="1020000" y="4940000"/>
-            <a:ext cx="600000" cy="600000"/>
+            <a:off x="1010000" y="4955000"/>
+            <a:ext cx="570000" cy="570000"/>
           </a:xfrm>
           <a:prstGeom prst="rect">
             <a:avLst/>
@@ -22211,8 +22313,8 @@
         </p:nvSpPr>
         <p:spPr>
           <a:xfrm>
-            <a:off x="2100000" y="4300000"/>
-            <a:ext cx="9200000" cy="1880000"/>
+            <a:off x="1900000" y="4290000"/>
+            <a:ext cx="5550000" cy="1900000"/>
           </a:xfrm>
           <a:prstGeom prst="rect">
             <a:avLst/>
@@ -22226,7 +22328,7 @@
           <a:lstStyle/>
           <a:p>
             <a:r>
-              <a:rPr sz="2075" b="1" i="0">
+              <a:rPr sz="2000" b="1" i="0">
                 <a:solidFill>
                   <a:srgbClr val="1F4E3D"/>
                 </a:solidFill>
@@ -22268,6 +22370,108 @@
                 </a:solidFill>
               </a:rPr>
               <a:t>thông gió cưỡng bức, mặt nạ, quan trắc không khí</a:t>
+            </a:r>
+          </a:p>
+        </p:txBody>
+      </p:sp>
+      <p:sp>
+        <p:nvSpPr>
+          <p:cNvPr id="20" name="Rectangle 19"/>
+          <p:cNvSpPr/>
+          <p:nvPr/>
+        </p:nvSpPr>
+        <p:spPr>
+          <a:xfrm>
+            <a:off x="7864640" y="2404712"/>
+            <a:ext cx="3808000" cy="3320575"/>
+          </a:xfrm>
+          <a:prstGeom prst="rect">
+            <a:avLst/>
+          </a:prstGeom>
+          <a:solidFill>
+            <a:srgbClr val="1F4E3D"/>
+          </a:solidFill>
+          <a:ln>
+            <a:noFill/>
+          </a:ln>
+          <a:effectLst/>
+        </p:spPr>
+        <p:style>
+          <a:lnRef idx="1">
+            <a:schemeClr val="accent1"/>
+          </a:lnRef>
+          <a:fillRef idx="3">
+            <a:schemeClr val="accent1"/>
+          </a:fillRef>
+          <a:effectRef idx="2">
+            <a:schemeClr val="accent1"/>
+          </a:effectRef>
+          <a:fontRef idx="minor">
+            <a:schemeClr val="lt1"/>
+          </a:fontRef>
+        </p:style>
+        <p:txBody>
+          <a:bodyPr rtlCol="0" anchor="ctr"/>
+          <a:lstStyle/>
+          <a:p>
+            <a:pPr algn="ctr"/>
+          </a:p>
+        </p:txBody>
+      </p:sp>
+      <p:pic>
+        <p:nvPicPr>
+          <p:cNvPr id="21" name="Picture 20" descr="ppe_c.jpg"/>
+          <p:cNvPicPr>
+            <a:picLocks noChangeAspect="1"/>
+          </p:cNvPicPr>
+          <p:nvPr/>
+        </p:nvPicPr>
+        <p:blipFill>
+          <a:blip r:embed="rId7"/>
+          <a:stretch>
+            <a:fillRect/>
+          </a:stretch>
+        </p:blipFill>
+        <p:spPr>
+          <a:xfrm>
+            <a:off x="7898640" y="2438712"/>
+            <a:ext cx="3740000" cy="3252575"/>
+          </a:xfrm>
+          <a:prstGeom prst="rect">
+            <a:avLst/>
+          </a:prstGeom>
+        </p:spPr>
+      </p:pic>
+      <p:sp>
+        <p:nvSpPr>
+          <p:cNvPr id="22" name="TextBox 21"/>
+          <p:cNvSpPr txBox="1"/>
+          <p:nvPr/>
+        </p:nvSpPr>
+        <p:spPr>
+          <a:xfrm>
+            <a:off x="7864640" y="5741287"/>
+            <a:ext cx="3808000" cy="300000"/>
+          </a:xfrm>
+          <a:prstGeom prst="rect">
+            <a:avLst/>
+          </a:prstGeom>
+          <a:noFill/>
+        </p:spPr>
+        <p:txBody>
+          <a:bodyPr wrap="square" lIns="50000" rIns="50000" tIns="20000" bIns="20000">
+            <a:spAutoFit/>
+          </a:bodyPr>
+          <a:lstStyle/>
+          <a:p>
+            <a:pPr algn="ctr"/>
+            <a:r>
+              <a:rPr sz="1500" b="0" i="1">
+                <a:solidFill>
+                  <a:srgbClr val="5B6E66"/>
+                </a:solidFill>
+              </a:rPr>
+              <a:t>Trang bị bảo hộ khi làm việc</a:t>
             </a:r>
           </a:p>
         </p:txBody>
@@ -22705,8 +22909,8 @@
         </p:nvSpPr>
         <p:spPr>
           <a:xfrm>
-            <a:off x="820000" y="2390000"/>
-            <a:ext cx="1000000" cy="1000000"/>
+            <a:off x="820000" y="2415000"/>
+            <a:ext cx="950000" cy="950000"/>
           </a:xfrm>
           <a:prstGeom prst="ellipse">
             <a:avLst/>
@@ -22763,8 +22967,8 @@
         </p:blipFill>
         <p:spPr>
           <a:xfrm>
-            <a:off x="1020000" y="2590000"/>
-            <a:ext cx="600000" cy="600000"/>
+            <a:off x="1010000" y="2605000"/>
+            <a:ext cx="570000" cy="570000"/>
           </a:xfrm>
           <a:prstGeom prst="rect">
             <a:avLst/>
@@ -22779,8 +22983,8 @@
         </p:nvSpPr>
         <p:spPr>
           <a:xfrm>
-            <a:off x="2100000" y="1950000"/>
-            <a:ext cx="9200000" cy="1880000"/>
+            <a:off x="1900000" y="1940000"/>
+            <a:ext cx="9590000" cy="1900000"/>
           </a:xfrm>
           <a:prstGeom prst="rect">
             <a:avLst/>
@@ -22794,7 +22998,7 @@
           <a:lstStyle/>
           <a:p>
             <a:r>
-              <a:rPr sz="2075" b="1" i="0">
+              <a:rPr sz="2000" b="1" i="0">
                 <a:solidFill>
                   <a:srgbClr val="1F4E3D"/>
                 </a:solidFill>
@@ -22892,8 +23096,8 @@
         </p:nvSpPr>
         <p:spPr>
           <a:xfrm>
-            <a:off x="820000" y="4740000"/>
-            <a:ext cx="1000000" cy="1000000"/>
+            <a:off x="820000" y="4765000"/>
+            <a:ext cx="950000" cy="950000"/>
           </a:xfrm>
           <a:prstGeom prst="ellipse">
             <a:avLst/>
@@ -22950,8 +23154,8 @@
         </p:blipFill>
         <p:spPr>
           <a:xfrm>
-            <a:off x="1020000" y="4940000"/>
-            <a:ext cx="600000" cy="600000"/>
+            <a:off x="1010000" y="4955000"/>
+            <a:ext cx="570000" cy="570000"/>
           </a:xfrm>
           <a:prstGeom prst="rect">
             <a:avLst/>
@@ -22966,8 +23170,8 @@
         </p:nvSpPr>
         <p:spPr>
           <a:xfrm>
-            <a:off x="2100000" y="4300000"/>
-            <a:ext cx="9200000" cy="1880000"/>
+            <a:off x="1900000" y="4290000"/>
+            <a:ext cx="9590000" cy="1900000"/>
           </a:xfrm>
           <a:prstGeom prst="rect">
             <a:avLst/>
@@ -22981,7 +23185,7 @@
           <a:lstStyle/>
           <a:p>
             <a:r>
-              <a:rPr sz="2075" b="1" i="0">
+              <a:rPr sz="2000" b="1" i="0">
                 <a:solidFill>
                   <a:srgbClr val="1F4E3D"/>
                 </a:solidFill>
@@ -23101,7 +23305,7 @@
           <a:blip r:embed="rId2">
             <a:extLst>
               <a:ext uri="{96DAC541-7B7A-43D3-8B79-37D633B846F1}">
-                <ns0:svgBlip xmlns:ns0="http://schemas.microsoft.com/office/drawing/2016/SVG/main" r:embed="rId9"/>
+                <ns0:svgBlip xmlns:ns0="http://schemas.microsoft.com/office/drawing/2016/SVG/main" r:embed="rId10"/>
               </a:ext>
             </a:extLst>
           </a:blip>
@@ -23131,7 +23335,7 @@
           <a:blip r:embed="rId3">
             <a:extLst>
               <a:ext uri="{96DAC541-7B7A-43D3-8B79-37D633B846F1}">
-                <ns1:svgBlip xmlns:ns1="http://schemas.microsoft.com/office/drawing/2016/SVG/main" r:embed="rId12"/>
+                <ns1:svgBlip xmlns:ns1="http://schemas.microsoft.com/office/drawing/2016/SVG/main" r:embed="rId13"/>
               </a:ext>
             </a:extLst>
           </a:blip>
@@ -23279,7 +23483,7 @@
           <a:blip r:embed="rId4">
             <a:extLst>
               <a:ext uri="{96DAC541-7B7A-43D3-8B79-37D633B846F1}">
-                <ns2:svgBlip xmlns:ns2="http://schemas.microsoft.com/office/drawing/2016/SVG/main" r:embed="rId8"/>
+                <ns2:svgBlip xmlns:ns2="http://schemas.microsoft.com/office/drawing/2016/SVG/main" r:embed="rId9"/>
               </a:ext>
             </a:extLst>
           </a:blip>
@@ -23410,14 +23614,116 @@
       </p:sp>
       <p:sp>
         <p:nvSpPr>
-          <p:cNvPr id="12" name="Rounded Rectangle 11"/>
+          <p:cNvPr id="12" name="Rectangle 11"/>
           <p:cNvSpPr/>
           <p:nvPr/>
         </p:nvSpPr>
         <p:spPr>
           <a:xfrm>
-            <a:off x="548640" y="1830000"/>
-            <a:ext cx="3496666" cy="4470000"/>
+            <a:off x="514640" y="2138808"/>
+            <a:ext cx="4418000" cy="3852383"/>
+          </a:xfrm>
+          <a:prstGeom prst="rect">
+            <a:avLst/>
+          </a:prstGeom>
+          <a:solidFill>
+            <a:srgbClr val="1F4E3D"/>
+          </a:solidFill>
+          <a:ln>
+            <a:noFill/>
+          </a:ln>
+          <a:effectLst/>
+        </p:spPr>
+        <p:style>
+          <a:lnRef idx="1">
+            <a:schemeClr val="accent1"/>
+          </a:lnRef>
+          <a:fillRef idx="3">
+            <a:schemeClr val="accent1"/>
+          </a:fillRef>
+          <a:effectRef idx="2">
+            <a:schemeClr val="accent1"/>
+          </a:effectRef>
+          <a:fontRef idx="minor">
+            <a:schemeClr val="lt1"/>
+          </a:fontRef>
+        </p:style>
+        <p:txBody>
+          <a:bodyPr rtlCol="0" anchor="ctr"/>
+          <a:lstStyle/>
+          <a:p>
+            <a:pPr algn="ctr"/>
+          </a:p>
+        </p:txBody>
+      </p:sp>
+      <p:pic>
+        <p:nvPicPr>
+          <p:cNvPr id="13" name="Picture 12" descr="waste_c.jpg"/>
+          <p:cNvPicPr>
+            <a:picLocks noChangeAspect="1"/>
+          </p:cNvPicPr>
+          <p:nvPr/>
+        </p:nvPicPr>
+        <p:blipFill>
+          <a:blip r:embed="rId5"/>
+          <a:stretch>
+            <a:fillRect/>
+          </a:stretch>
+        </p:blipFill>
+        <p:spPr>
+          <a:xfrm>
+            <a:off x="548640" y="2172808"/>
+            <a:ext cx="4350000" cy="3784383"/>
+          </a:xfrm>
+          <a:prstGeom prst="rect">
+            <a:avLst/>
+          </a:prstGeom>
+        </p:spPr>
+      </p:pic>
+      <p:sp>
+        <p:nvSpPr>
+          <p:cNvPr id="14" name="TextBox 13"/>
+          <p:cNvSpPr txBox="1"/>
+          <p:nvPr/>
+        </p:nvSpPr>
+        <p:spPr>
+          <a:xfrm>
+            <a:off x="514640" y="6007191"/>
+            <a:ext cx="4418000" cy="300000"/>
+          </a:xfrm>
+          <a:prstGeom prst="rect">
+            <a:avLst/>
+          </a:prstGeom>
+          <a:noFill/>
+        </p:spPr>
+        <p:txBody>
+          <a:bodyPr wrap="square" lIns="50000" rIns="50000" tIns="20000" bIns="20000">
+            <a:spAutoFit/>
+          </a:bodyPr>
+          <a:lstStyle/>
+          <a:p>
+            <a:pPr algn="ctr"/>
+            <a:r>
+              <a:rPr sz="1500" b="0" i="1">
+                <a:solidFill>
+                  <a:srgbClr val="5B6E66"/>
+                </a:solidFill>
+              </a:rPr>
+              <a:t>Hệ thống xử lý nước thải</a:t>
+            </a:r>
+          </a:p>
+        </p:txBody>
+      </p:sp>
+      <p:sp>
+        <p:nvSpPr>
+          <p:cNvPr id="15" name="Rounded Rectangle 14"/>
+          <p:cNvSpPr/>
+          <p:nvPr/>
+        </p:nvSpPr>
+        <p:spPr>
+          <a:xfrm>
+            <a:off x="5218640" y="1830000"/>
+            <a:ext cx="6420000" cy="1336666"/>
           </a:xfrm>
           <a:prstGeom prst="roundRect">
             <a:avLst/>
@@ -23454,16 +23760,60 @@
       </p:sp>
       <p:sp>
         <p:nvSpPr>
-          <p:cNvPr id="13" name="Rounded Rectangle 12"/>
+          <p:cNvPr id="16" name="Rounded Rectangle 15"/>
           <p:cNvSpPr/>
           <p:nvPr/>
         </p:nvSpPr>
         <p:spPr>
           <a:xfrm>
-            <a:off x="548640" y="1830000"/>
-            <a:ext cx="3496666" cy="130000"/>
+            <a:off x="5218640" y="1830000"/>
+            <a:ext cx="80000" cy="1336666"/>
           </a:xfrm>
           <a:prstGeom prst="roundRect">
+            <a:avLst/>
+          </a:prstGeom>
+          <a:solidFill>
+            <a:srgbClr val="2C7A5A"/>
+          </a:solidFill>
+          <a:ln>
+            <a:noFill/>
+          </a:ln>
+          <a:effectLst/>
+        </p:spPr>
+        <p:style>
+          <a:lnRef idx="1">
+            <a:schemeClr val="accent1"/>
+          </a:lnRef>
+          <a:fillRef idx="3">
+            <a:schemeClr val="accent1"/>
+          </a:fillRef>
+          <a:effectRef idx="2">
+            <a:schemeClr val="accent1"/>
+          </a:effectRef>
+          <a:fontRef idx="minor">
+            <a:schemeClr val="lt1"/>
+          </a:fontRef>
+        </p:style>
+        <p:txBody>
+          <a:bodyPr rtlCol="0" anchor="ctr"/>
+          <a:lstStyle/>
+          <a:p>
+            <a:pPr algn="ctr"/>
+          </a:p>
+        </p:txBody>
+      </p:sp>
+      <p:sp>
+        <p:nvSpPr>
+          <p:cNvPr id="17" name="Oval 16"/>
+          <p:cNvSpPr/>
+          <p:nvPr/>
+        </p:nvSpPr>
+        <p:spPr>
+          <a:xfrm>
+            <a:off x="5498640" y="2188333"/>
+            <a:ext cx="620000" cy="620000"/>
+          </a:xfrm>
+          <a:prstGeom prst="ellipse">
             <a:avLst/>
           </a:prstGeom>
           <a:solidFill>
@@ -23496,16 +23846,177 @@
           </a:p>
         </p:txBody>
       </p:sp>
-      <p:sp>
-        <p:nvSpPr>
-          <p:cNvPr id="14" name="Oval 13"/>
+      <p:pic>
+        <p:nvPicPr>
+          <p:cNvPr id="18" name="Picture 17" descr="smoke_air_w.png"/>
+          <p:cNvPicPr>
+            <a:picLocks noChangeAspect="1"/>
+          </p:cNvPicPr>
+          <p:nvPr/>
+        </p:nvPicPr>
+        <p:blipFill>
+          <a:blip r:embed="rId6">
+            <a:extLst>
+              <a:ext uri="{96DAC541-7B7A-43D3-8B79-37D633B846F1}">
+                <ns3:svgBlip xmlns:ns3="http://schemas.microsoft.com/office/drawing/2016/SVG/main" r:embed="rId11"/>
+              </a:ext>
+            </a:extLst>
+          </a:blip>
+          <a:stretch>
+            <a:fillRect/>
+          </a:stretch>
+        </p:blipFill>
+        <p:spPr>
+          <a:xfrm>
+            <a:off x="5622640" y="2312333"/>
+            <a:ext cx="372000" cy="372000"/>
+          </a:xfrm>
+          <a:prstGeom prst="rect">
+            <a:avLst/>
+          </a:prstGeom>
+        </p:spPr>
+      </p:pic>
+      <p:sp>
+        <p:nvSpPr>
+          <p:cNvPr id="19" name="TextBox 18"/>
+          <p:cNvSpPr txBox="1"/>
+          <p:nvPr/>
+        </p:nvSpPr>
+        <p:spPr>
+          <a:xfrm>
+            <a:off x="6438640" y="1830000"/>
+            <a:ext cx="4900000" cy="1336666"/>
+          </a:xfrm>
+          <a:prstGeom prst="rect">
+            <a:avLst/>
+          </a:prstGeom>
+          <a:noFill/>
+        </p:spPr>
+        <p:txBody>
+          <a:bodyPr wrap="square" lIns="50000" rIns="50000" tIns="20000" bIns="20000" anchor="ctr">
+            <a:spAutoFit/>
+          </a:bodyPr>
+          <a:lstStyle/>
+          <a:p>
+            <a:r>
+              <a:rPr sz="2000" b="1" i="0">
+                <a:solidFill>
+                  <a:srgbClr val="1F4E3D"/>
+                </a:solidFill>
+              </a:rPr>
+              <a:t>Khí thải — hơi VOC</a:t>
+            </a:r>
+          </a:p>
+          <a:p>
+            <a:r>
+              <a:rPr sz="2000" b="0" i="0">
+                <a:solidFill>
+                  <a:srgbClr val="34404A"/>
+                </a:solidFill>
+              </a:rPr>
+              <a:t>Chụp hút → than hoạt tính / buồng đốt</a:t>
+            </a:r>
+          </a:p>
+        </p:txBody>
+      </p:sp>
+      <p:sp>
+        <p:nvSpPr>
+          <p:cNvPr id="20" name="Rounded Rectangle 19"/>
           <p:cNvSpPr/>
           <p:nvPr/>
         </p:nvSpPr>
         <p:spPr>
           <a:xfrm>
-            <a:off x="1906973" y="2210000"/>
-            <a:ext cx="780000" cy="780000"/>
+            <a:off x="5218640" y="3396666"/>
+            <a:ext cx="6420000" cy="1336666"/>
+          </a:xfrm>
+          <a:prstGeom prst="roundRect">
+            <a:avLst/>
+          </a:prstGeom>
+          <a:solidFill>
+            <a:srgbClr val="EEF4F0"/>
+          </a:solidFill>
+          <a:ln>
+            <a:noFill/>
+          </a:ln>
+          <a:effectLst/>
+        </p:spPr>
+        <p:style>
+          <a:lnRef idx="1">
+            <a:schemeClr val="accent1"/>
+          </a:lnRef>
+          <a:fillRef idx="3">
+            <a:schemeClr val="accent1"/>
+          </a:fillRef>
+          <a:effectRef idx="2">
+            <a:schemeClr val="accent1"/>
+          </a:effectRef>
+          <a:fontRef idx="minor">
+            <a:schemeClr val="lt1"/>
+          </a:fontRef>
+        </p:style>
+        <p:txBody>
+          <a:bodyPr rtlCol="0" anchor="ctr"/>
+          <a:lstStyle/>
+          <a:p>
+            <a:pPr algn="ctr"/>
+          </a:p>
+        </p:txBody>
+      </p:sp>
+      <p:sp>
+        <p:nvSpPr>
+          <p:cNvPr id="21" name="Rounded Rectangle 20"/>
+          <p:cNvSpPr/>
+          <p:nvPr/>
+        </p:nvSpPr>
+        <p:spPr>
+          <a:xfrm>
+            <a:off x="5218640" y="3396666"/>
+            <a:ext cx="80000" cy="1336666"/>
+          </a:xfrm>
+          <a:prstGeom prst="roundRect">
+            <a:avLst/>
+          </a:prstGeom>
+          <a:solidFill>
+            <a:srgbClr val="2C7A5A"/>
+          </a:solidFill>
+          <a:ln>
+            <a:noFill/>
+          </a:ln>
+          <a:effectLst/>
+        </p:spPr>
+        <p:style>
+          <a:lnRef idx="1">
+            <a:schemeClr val="accent1"/>
+          </a:lnRef>
+          <a:fillRef idx="3">
+            <a:schemeClr val="accent1"/>
+          </a:fillRef>
+          <a:effectRef idx="2">
+            <a:schemeClr val="accent1"/>
+          </a:effectRef>
+          <a:fontRef idx="minor">
+            <a:schemeClr val="lt1"/>
+          </a:fontRef>
+        </p:style>
+        <p:txBody>
+          <a:bodyPr rtlCol="0" anchor="ctr"/>
+          <a:lstStyle/>
+          <a:p>
+            <a:pPr algn="ctr"/>
+          </a:p>
+        </p:txBody>
+      </p:sp>
+      <p:sp>
+        <p:nvSpPr>
+          <p:cNvPr id="22" name="Oval 21"/>
+          <p:cNvSpPr/>
+          <p:nvPr/>
+        </p:nvSpPr>
+        <p:spPr>
+          <a:xfrm>
+            <a:off x="5498640" y="3754999"/>
+            <a:ext cx="620000" cy="620000"/>
           </a:xfrm>
           <a:prstGeom prst="ellipse">
             <a:avLst/>
@@ -23542,17 +24053,17 @@
       </p:sp>
       <p:pic>
         <p:nvPicPr>
-          <p:cNvPr id="15" name="Picture 14" descr="smoke_air_w.png"/>
+          <p:cNvPr id="23" name="Picture 22" descr="water_waste_w.png"/>
           <p:cNvPicPr>
             <a:picLocks noChangeAspect="1"/>
           </p:cNvPicPr>
           <p:nvPr/>
         </p:nvPicPr>
         <p:blipFill>
-          <a:blip r:embed="rId5">
+          <a:blip r:embed="rId7">
             <a:extLst>
               <a:ext uri="{96DAC541-7B7A-43D3-8B79-37D633B846F1}">
-                <ns3:svgBlip xmlns:ns3="http://schemas.microsoft.com/office/drawing/2016/SVG/main" r:embed="rId10"/>
+                <ns4:svgBlip xmlns:ns4="http://schemas.microsoft.com/office/drawing/2016/SVG/main" r:embed="rId14"/>
               </a:ext>
             </a:extLst>
           </a:blip>
@@ -23562,8 +24073,8 @@
         </p:blipFill>
         <p:spPr>
           <a:xfrm>
-            <a:off x="2062973" y="2366000"/>
-            <a:ext cx="468000" cy="468000"/>
+            <a:off x="5622640" y="3878999"/>
+            <a:ext cx="372000" cy="372000"/>
           </a:xfrm>
           <a:prstGeom prst="rect">
             <a:avLst/>
@@ -23572,14 +24083,14 @@
       </p:pic>
       <p:sp>
         <p:nvSpPr>
-          <p:cNvPr id="16" name="TextBox 15"/>
+          <p:cNvPr id="24" name="TextBox 23"/>
           <p:cNvSpPr txBox="1"/>
           <p:nvPr/>
         </p:nvSpPr>
         <p:spPr>
           <a:xfrm>
-            <a:off x="728640" y="3080000"/>
-            <a:ext cx="3136666" cy="2870000"/>
+            <a:off x="6438640" y="3396666"/>
+            <a:ext cx="4900000" cy="1336666"/>
           </a:xfrm>
           <a:prstGeom prst="rect">
             <a:avLst/>
@@ -23587,55 +24098,42 @@
           <a:noFill/>
         </p:spPr>
         <p:txBody>
-          <a:bodyPr wrap="square" lIns="50000" rIns="50000" tIns="20000" bIns="20000" anchor="t">
+          <a:bodyPr wrap="square" lIns="50000" rIns="50000" tIns="20000" bIns="20000" anchor="ctr">
             <a:spAutoFit/>
           </a:bodyPr>
           <a:lstStyle/>
           <a:p>
-            <a:pPr algn="ctr"/>
             <a:r>
               <a:rPr sz="2000" b="1" i="0">
                 <a:solidFill>
                   <a:srgbClr val="1F4E3D"/>
                 </a:solidFill>
               </a:rPr>
-              <a:t>Khí thải VOC</a:t>
-            </a:r>
-          </a:p>
-          <a:p>
-            <a:pPr algn="ctr"/>
+              <a:t>Nước thải &amp; dung môi</a:t>
+            </a:r>
+          </a:p>
+          <a:p>
             <a:r>
               <a:rPr sz="2000" b="0" i="0">
                 <a:solidFill>
                   <a:srgbClr val="34404A"/>
                 </a:solidFill>
               </a:rPr>
-              <a:t>Chụp hút → than hoạt</a:t>
-            </a:r>
-          </a:p>
-          <a:p>
-            <a:pPr algn="ctr"/>
-            <a:r>
-              <a:rPr sz="2000" b="0" i="0">
-                <a:solidFill>
-                  <a:srgbClr val="34404A"/>
-                </a:solidFill>
-              </a:rPr>
-              <a:t>tính / buồng đốt</a:t>
-            </a:r>
-          </a:p>
-        </p:txBody>
-      </p:sp>
-      <p:sp>
-        <p:nvSpPr>
-          <p:cNvPr id="17" name="Rounded Rectangle 16"/>
+              <a:t>Lắng tách cặn, thu hồi dung môi tái chưng</a:t>
+            </a:r>
+          </a:p>
+        </p:txBody>
+      </p:sp>
+      <p:sp>
+        <p:nvSpPr>
+          <p:cNvPr id="25" name="Rounded Rectangle 24"/>
           <p:cNvSpPr/>
           <p:nvPr/>
         </p:nvSpPr>
         <p:spPr>
           <a:xfrm>
-            <a:off x="4345306" y="1830000"/>
-            <a:ext cx="3496666" cy="4470000"/>
+            <a:off x="5218640" y="4963332"/>
+            <a:ext cx="6420000" cy="1336666"/>
           </a:xfrm>
           <a:prstGeom prst="roundRect">
             <a:avLst/>
@@ -23672,14 +24170,14 @@
       </p:sp>
       <p:sp>
         <p:nvSpPr>
-          <p:cNvPr id="18" name="Rounded Rectangle 17"/>
+          <p:cNvPr id="26" name="Rounded Rectangle 25"/>
           <p:cNvSpPr/>
           <p:nvPr/>
         </p:nvSpPr>
         <p:spPr>
           <a:xfrm>
-            <a:off x="4345306" y="1830000"/>
-            <a:ext cx="3496666" cy="130000"/>
+            <a:off x="5218640" y="4963332"/>
+            <a:ext cx="80000" cy="1336666"/>
           </a:xfrm>
           <a:prstGeom prst="roundRect">
             <a:avLst/>
@@ -23716,20 +24214,20 @@
       </p:sp>
       <p:sp>
         <p:nvSpPr>
-          <p:cNvPr id="19" name="Oval 18"/>
+          <p:cNvPr id="27" name="Oval 26"/>
           <p:cNvSpPr/>
           <p:nvPr/>
         </p:nvSpPr>
         <p:spPr>
           <a:xfrm>
-            <a:off x="5703639" y="2210000"/>
-            <a:ext cx="780000" cy="780000"/>
+            <a:off x="5498640" y="5321665"/>
+            <a:ext cx="620000" cy="620000"/>
           </a:xfrm>
           <a:prstGeom prst="ellipse">
             <a:avLst/>
           </a:prstGeom>
           <a:solidFill>
-            <a:srgbClr val="2C7A5A"/>
+            <a:srgbClr val="1F4E3D"/>
           </a:solidFill>
           <a:ln>
             <a:noFill/>
@@ -23760,17 +24258,17 @@
       </p:sp>
       <p:pic>
         <p:nvPicPr>
-          <p:cNvPr id="20" name="Picture 19" descr="water_waste_w.png"/>
+          <p:cNvPr id="28" name="Picture 27" descr="solid_waste_w.png"/>
           <p:cNvPicPr>
             <a:picLocks noChangeAspect="1"/>
           </p:cNvPicPr>
           <p:nvPr/>
         </p:nvPicPr>
         <p:blipFill>
-          <a:blip r:embed="rId6">
+          <a:blip r:embed="rId8">
             <a:extLst>
               <a:ext uri="{96DAC541-7B7A-43D3-8B79-37D633B846F1}">
-                <ns4:svgBlip xmlns:ns4="http://schemas.microsoft.com/office/drawing/2016/SVG/main" r:embed="rId13"/>
+                <ns5:svgBlip xmlns:ns5="http://schemas.microsoft.com/office/drawing/2016/SVG/main" r:embed="rId12"/>
               </a:ext>
             </a:extLst>
           </a:blip>
@@ -23780,8 +24278,8 @@
         </p:blipFill>
         <p:spPr>
           <a:xfrm>
-            <a:off x="5859639" y="2366000"/>
-            <a:ext cx="468000" cy="468000"/>
+            <a:off x="5622640" y="5445665"/>
+            <a:ext cx="372000" cy="372000"/>
           </a:xfrm>
           <a:prstGeom prst="rect">
             <a:avLst/>
@@ -23790,14 +24288,14 @@
       </p:pic>
       <p:sp>
         <p:nvSpPr>
-          <p:cNvPr id="21" name="TextBox 20"/>
+          <p:cNvPr id="29" name="TextBox 28"/>
           <p:cNvSpPr txBox="1"/>
           <p:nvPr/>
         </p:nvSpPr>
         <p:spPr>
           <a:xfrm>
-            <a:off x="4525306" y="3080000"/>
-            <a:ext cx="3136666" cy="2870000"/>
+            <a:off x="6438640" y="4963332"/>
+            <a:ext cx="4900000" cy="1336666"/>
           </a:xfrm>
           <a:prstGeom prst="rect">
             <a:avLst/>
@@ -23805,259 +24303,28 @@
           <a:noFill/>
         </p:spPr>
         <p:txBody>
-          <a:bodyPr wrap="square" lIns="50000" rIns="50000" tIns="20000" bIns="20000" anchor="t">
+          <a:bodyPr wrap="square" lIns="50000" rIns="50000" tIns="20000" bIns="20000" anchor="ctr">
             <a:spAutoFit/>
           </a:bodyPr>
           <a:lstStyle/>
           <a:p>
-            <a:pPr algn="ctr"/>
             <a:r>
               <a:rPr sz="2000" b="1" i="0">
                 <a:solidFill>
                   <a:srgbClr val="1F4E3D"/>
                 </a:solidFill>
               </a:rPr>
-              <a:t>Nước thải</a:t>
-            </a:r>
-          </a:p>
-          <a:p>
-            <a:pPr algn="ctr"/>
+              <a:t>Chất thải rắn</a:t>
+            </a:r>
+          </a:p>
+          <a:p>
             <a:r>
               <a:rPr sz="2000" b="0" i="0">
                 <a:solidFill>
                   <a:srgbClr val="34404A"/>
                 </a:solidFill>
               </a:rPr>
-              <a:t>Lắng tách cặn</a:t>
-            </a:r>
-          </a:p>
-          <a:p>
-            <a:pPr algn="ctr"/>
-            <a:r>
-              <a:rPr sz="2000" b="0" i="0">
-                <a:solidFill>
-                  <a:srgbClr val="34404A"/>
-                </a:solidFill>
-              </a:rPr>
-              <a:t>thu hồi dung môi</a:t>
-            </a:r>
-          </a:p>
-        </p:txBody>
-      </p:sp>
-      <p:sp>
-        <p:nvSpPr>
-          <p:cNvPr id="22" name="Rounded Rectangle 21"/>
-          <p:cNvSpPr/>
-          <p:nvPr/>
-        </p:nvSpPr>
-        <p:spPr>
-          <a:xfrm>
-            <a:off x="8141972" y="1830000"/>
-            <a:ext cx="3496666" cy="4470000"/>
-          </a:xfrm>
-          <a:prstGeom prst="roundRect">
-            <a:avLst/>
-          </a:prstGeom>
-          <a:solidFill>
-            <a:srgbClr val="EEF4F0"/>
-          </a:solidFill>
-          <a:ln>
-            <a:noFill/>
-          </a:ln>
-          <a:effectLst/>
-        </p:spPr>
-        <p:style>
-          <a:lnRef idx="1">
-            <a:schemeClr val="accent1"/>
-          </a:lnRef>
-          <a:fillRef idx="3">
-            <a:schemeClr val="accent1"/>
-          </a:fillRef>
-          <a:effectRef idx="2">
-            <a:schemeClr val="accent1"/>
-          </a:effectRef>
-          <a:fontRef idx="minor">
-            <a:schemeClr val="lt1"/>
-          </a:fontRef>
-        </p:style>
-        <p:txBody>
-          <a:bodyPr rtlCol="0" anchor="ctr"/>
-          <a:lstStyle/>
-          <a:p>
-            <a:pPr algn="ctr"/>
-          </a:p>
-        </p:txBody>
-      </p:sp>
-      <p:sp>
-        <p:nvSpPr>
-          <p:cNvPr id="23" name="Rounded Rectangle 22"/>
-          <p:cNvSpPr/>
-          <p:nvPr/>
-        </p:nvSpPr>
-        <p:spPr>
-          <a:xfrm>
-            <a:off x="8141972" y="1830000"/>
-            <a:ext cx="3496666" cy="130000"/>
-          </a:xfrm>
-          <a:prstGeom prst="roundRect">
-            <a:avLst/>
-          </a:prstGeom>
-          <a:solidFill>
-            <a:srgbClr val="7BA893"/>
-          </a:solidFill>
-          <a:ln>
-            <a:noFill/>
-          </a:ln>
-          <a:effectLst/>
-        </p:spPr>
-        <p:style>
-          <a:lnRef idx="1">
-            <a:schemeClr val="accent1"/>
-          </a:lnRef>
-          <a:fillRef idx="3">
-            <a:schemeClr val="accent1"/>
-          </a:fillRef>
-          <a:effectRef idx="2">
-            <a:schemeClr val="accent1"/>
-          </a:effectRef>
-          <a:fontRef idx="minor">
-            <a:schemeClr val="lt1"/>
-          </a:fontRef>
-        </p:style>
-        <p:txBody>
-          <a:bodyPr rtlCol="0" anchor="ctr"/>
-          <a:lstStyle/>
-          <a:p>
-            <a:pPr algn="ctr"/>
-          </a:p>
-        </p:txBody>
-      </p:sp>
-      <p:sp>
-        <p:nvSpPr>
-          <p:cNvPr id="24" name="Oval 23"/>
-          <p:cNvSpPr/>
-          <p:nvPr/>
-        </p:nvSpPr>
-        <p:spPr>
-          <a:xfrm>
-            <a:off x="9500305" y="2210000"/>
-            <a:ext cx="780000" cy="780000"/>
-          </a:xfrm>
-          <a:prstGeom prst="ellipse">
-            <a:avLst/>
-          </a:prstGeom>
-          <a:solidFill>
-            <a:srgbClr val="7BA893"/>
-          </a:solidFill>
-          <a:ln>
-            <a:noFill/>
-          </a:ln>
-          <a:effectLst/>
-        </p:spPr>
-        <p:style>
-          <a:lnRef idx="1">
-            <a:schemeClr val="accent1"/>
-          </a:lnRef>
-          <a:fillRef idx="3">
-            <a:schemeClr val="accent1"/>
-          </a:fillRef>
-          <a:effectRef idx="2">
-            <a:schemeClr val="accent1"/>
-          </a:effectRef>
-          <a:fontRef idx="minor">
-            <a:schemeClr val="lt1"/>
-          </a:fontRef>
-        </p:style>
-        <p:txBody>
-          <a:bodyPr rtlCol="0" anchor="ctr"/>
-          <a:lstStyle/>
-          <a:p>
-            <a:pPr algn="ctr"/>
-          </a:p>
-        </p:txBody>
-      </p:sp>
-      <p:pic>
-        <p:nvPicPr>
-          <p:cNvPr id="25" name="Picture 24" descr="solid_waste_w.png"/>
-          <p:cNvPicPr>
-            <a:picLocks noChangeAspect="1"/>
-          </p:cNvPicPr>
-          <p:nvPr/>
-        </p:nvPicPr>
-        <p:blipFill>
-          <a:blip r:embed="rId7">
-            <a:extLst>
-              <a:ext uri="{96DAC541-7B7A-43D3-8B79-37D633B846F1}">
-                <ns5:svgBlip xmlns:ns5="http://schemas.microsoft.com/office/drawing/2016/SVG/main" r:embed="rId11"/>
-              </a:ext>
-            </a:extLst>
-          </a:blip>
-          <a:stretch>
-            <a:fillRect/>
-          </a:stretch>
-        </p:blipFill>
-        <p:spPr>
-          <a:xfrm>
-            <a:off x="9656305" y="2366000"/>
-            <a:ext cx="468000" cy="468000"/>
-          </a:xfrm>
-          <a:prstGeom prst="rect">
-            <a:avLst/>
-          </a:prstGeom>
-        </p:spPr>
-      </p:pic>
-      <p:sp>
-        <p:nvSpPr>
-          <p:cNvPr id="26" name="TextBox 25"/>
-          <p:cNvSpPr txBox="1"/>
-          <p:nvPr/>
-        </p:nvSpPr>
-        <p:spPr>
-          <a:xfrm>
-            <a:off x="8321972" y="3080000"/>
-            <a:ext cx="3136666" cy="2870000"/>
-          </a:xfrm>
-          <a:prstGeom prst="rect">
-            <a:avLst/>
-          </a:prstGeom>
-          <a:noFill/>
-        </p:spPr>
-        <p:txBody>
-          <a:bodyPr wrap="square" lIns="50000" rIns="50000" tIns="20000" bIns="20000" anchor="t">
-            <a:spAutoFit/>
-          </a:bodyPr>
-          <a:lstStyle/>
-          <a:p>
-            <a:pPr algn="ctr"/>
-            <a:r>
-              <a:rPr sz="2000" b="1" i="0">
-                <a:solidFill>
-                  <a:srgbClr val="1F4E3D"/>
-                </a:solidFill>
-              </a:rPr>
-              <a:t>Chất thải rắn</a:t>
-            </a:r>
-          </a:p>
-          <a:p>
-            <a:pPr algn="ctr"/>
-            <a:r>
-              <a:rPr sz="2000" b="0" i="0">
-                <a:solidFill>
-                  <a:srgbClr val="34404A"/>
-                </a:solidFill>
-              </a:rPr>
-              <a:t>Phân loại tại nguồn</a:t>
-            </a:r>
-          </a:p>
-          <a:p>
-            <a:pPr algn="ctr"/>
-            <a:r>
-              <a:rPr sz="2000" b="0" i="0">
-                <a:solidFill>
-                  <a:srgbClr val="34404A"/>
-                </a:solidFill>
-              </a:rPr>
-              <a:t>đơn vị xử lý</a:t>
+              <a:t>Phân loại tại nguồn, đơn vị xử lý nguy hại</a:t>
             </a:r>
           </a:p>
         </p:txBody>

</xml_diff>

<commit_message>
Redesign QC slides as creative infographic panels
Replace the two plain checkmark-list QC slides (kiểm tra nhanh tại
xưởng / kiểm tra sâu tại phòng LAB) with bespoke, non-repetitive layouts:

- Workshop quick-check: instrument dashboard with 6 distinct measurement
  widgets (density gauge, Stormer dial, coverage fill-bar, Hegman wedge,
  color-match swatches, drying clock) + unit badges.
- Lab deep-test: test-report layout with a coated-panel specimen
  illustration, 60° gloss protractor, and 5 test rows with relative
  duration/intensity bars (salt spray longest, 1000h) + a nghiệm thu
  acceptance footer.

Adds gen_qc.py (SVG panels), wires big_qc_shop/big_qc_lab into the deck,
and refreshes the exported PPTX/PDF.

Co-Authored-By: Claude Opus 4.8 <noreply@anthropic.com>
Claude-Session: https://claude.ai/code/session_01PbbxSyJEYscgmQfTL8vaUX
</commit_message>
<xml_diff>
--- a/SuHeo/Báo cáo thực tập - Sơn Hải Vân.pptx
+++ b/SuHeo/Báo cáo thực tập - Sơn Hải Vân.pptx
@@ -3168,16 +3168,136 @@
           </a:p>
         </p:txBody>
       </p:sp>
-      <p:sp>
-        <p:nvSpPr>
-          <p:cNvPr id="3" name="Rectangle 2"/>
+      <p:pic>
+        <p:nvPicPr>
+          <p:cNvPr id="3" name="Picture 2" descr="hex_pale.png"/>
+          <p:cNvPicPr>
+            <a:picLocks noChangeAspect="1"/>
+          </p:cNvPicPr>
+          <p:nvPr/>
+        </p:nvPicPr>
+        <p:blipFill>
+          <a:blip r:embed="rId2">
+            <a:extLst>
+              <a:ext uri="{96DAC541-7B7A-43D3-8B79-37D633B846F1}">
+                <ns0:svgBlip xmlns:ns0="http://schemas.microsoft.com/office/drawing/2016/SVG/main" r:embed="rId6"/>
+              </a:ext>
+            </a:extLst>
+          </a:blip>
+          <a:stretch>
+            <a:fillRect/>
+          </a:stretch>
+        </p:blipFill>
+        <p:spPr>
+          <a:xfrm>
+            <a:off x="-620000" y="-380000"/>
+            <a:ext cx="3200000" cy="3200000"/>
+          </a:xfrm>
+          <a:prstGeom prst="rect">
+            <a:avLst/>
+          </a:prstGeom>
+        </p:spPr>
+      </p:pic>
+      <p:pic>
+        <p:nvPicPr>
+          <p:cNvPr id="4" name="Picture 3" descr="hex_pale.png"/>
+          <p:cNvPicPr>
+            <a:picLocks noChangeAspect="1"/>
+          </p:cNvPicPr>
+          <p:nvPr/>
+        </p:nvPicPr>
+        <p:blipFill>
+          <a:blip r:embed="rId2">
+            <a:extLst>
+              <a:ext uri="{96DAC541-7B7A-43D3-8B79-37D633B846F1}">
+                <ns1:svgBlip xmlns:ns1="http://schemas.microsoft.com/office/drawing/2016/SVG/main" r:embed="rId6"/>
+              </a:ext>
+            </a:extLst>
+          </a:blip>
+          <a:stretch>
+            <a:fillRect/>
+          </a:stretch>
+        </p:blipFill>
+        <p:spPr>
+          <a:xfrm>
+            <a:off x="9631695" y="4038000"/>
+            <a:ext cx="3200000" cy="3200000"/>
+          </a:xfrm>
+          <a:prstGeom prst="rect">
+            <a:avLst/>
+          </a:prstGeom>
+        </p:spPr>
+      </p:pic>
+      <p:pic>
+        <p:nvPicPr>
+          <p:cNvPr id="5" name="Picture 4" descr="swash_pale.png"/>
+          <p:cNvPicPr>
+            <a:picLocks noChangeAspect="1"/>
+          </p:cNvPicPr>
+          <p:nvPr/>
+        </p:nvPicPr>
+        <p:blipFill>
+          <a:blip r:embed="rId3">
+            <a:extLst>
+              <a:ext uri="{96DAC541-7B7A-43D3-8B79-37D633B846F1}">
+                <ns2:svgBlip xmlns:ns2="http://schemas.microsoft.com/office/drawing/2016/SVG/main" r:embed="rId7"/>
+              </a:ext>
+            </a:extLst>
+          </a:blip>
+          <a:stretch>
+            <a:fillRect/>
+          </a:stretch>
+        </p:blipFill>
+        <p:spPr>
+          <a:xfrm>
+            <a:off x="8841695" y="250000"/>
+            <a:ext cx="3400000" cy="1780000"/>
+          </a:xfrm>
+          <a:prstGeom prst="rect">
+            <a:avLst/>
+          </a:prstGeom>
+        </p:spPr>
+      </p:pic>
+      <p:pic>
+        <p:nvPicPr>
+          <p:cNvPr id="6" name="Picture 5" descr="swash_pale.png"/>
+          <p:cNvPicPr>
+            <a:picLocks noChangeAspect="1"/>
+          </p:cNvPicPr>
+          <p:nvPr/>
+        </p:nvPicPr>
+        <p:blipFill>
+          <a:blip r:embed="rId3">
+            <a:extLst>
+              <a:ext uri="{96DAC541-7B7A-43D3-8B79-37D633B846F1}">
+                <ns3:svgBlip xmlns:ns3="http://schemas.microsoft.com/office/drawing/2016/SVG/main" r:embed="rId7"/>
+              </a:ext>
+            </a:extLst>
+          </a:blip>
+          <a:stretch>
+            <a:fillRect/>
+          </a:stretch>
+        </p:blipFill>
+        <p:spPr>
+          <a:xfrm>
+            <a:off x="-560000" y="4808000"/>
+            <a:ext cx="3400000" cy="1780000"/>
+          </a:xfrm>
+          <a:prstGeom prst="rect">
+            <a:avLst/>
+          </a:prstGeom>
+        </p:spPr>
+      </p:pic>
+      <p:sp>
+        <p:nvSpPr>
+          <p:cNvPr id="7" name="Rectangle 6"/>
           <p:cNvSpPr/>
           <p:nvPr/>
         </p:nvSpPr>
         <p:spPr>
           <a:xfrm>
             <a:off x="0" y="0"/>
-            <a:ext cx="12191695" cy="92000"/>
+            <a:ext cx="150000" cy="6858000"/>
           </a:xfrm>
           <a:prstGeom prst="rect">
             <a:avLst/>
@@ -3214,14 +3334,14 @@
       </p:sp>
       <p:sp>
         <p:nvSpPr>
-          <p:cNvPr id="4" name="Rectangle 3"/>
+          <p:cNvPr id="8" name="Rectangle 7"/>
           <p:cNvSpPr/>
           <p:nvPr/>
         </p:nvSpPr>
         <p:spPr>
           <a:xfrm>
-            <a:off x="0" y="6766000"/>
-            <a:ext cx="12191695" cy="92000"/>
+            <a:off x="12041695" y="0"/>
+            <a:ext cx="150000" cy="6858000"/>
           </a:xfrm>
           <a:prstGeom prst="rect">
             <a:avLst/>
@@ -3256,16 +3376,104 @@
           </a:p>
         </p:txBody>
       </p:sp>
+      <p:sp>
+        <p:nvSpPr>
+          <p:cNvPr id="9" name="Rectangle 8"/>
+          <p:cNvSpPr/>
+          <p:nvPr/>
+        </p:nvSpPr>
+        <p:spPr>
+          <a:xfrm>
+            <a:off x="0" y="0"/>
+            <a:ext cx="12191695" cy="92000"/>
+          </a:xfrm>
+          <a:prstGeom prst="rect">
+            <a:avLst/>
+          </a:prstGeom>
+          <a:solidFill>
+            <a:srgbClr val="1F4E3D"/>
+          </a:solidFill>
+          <a:ln>
+            <a:noFill/>
+          </a:ln>
+          <a:effectLst/>
+        </p:spPr>
+        <p:style>
+          <a:lnRef idx="1">
+            <a:schemeClr val="accent1"/>
+          </a:lnRef>
+          <a:fillRef idx="3">
+            <a:schemeClr val="accent1"/>
+          </a:fillRef>
+          <a:effectRef idx="2">
+            <a:schemeClr val="accent1"/>
+          </a:effectRef>
+          <a:fontRef idx="minor">
+            <a:schemeClr val="lt1"/>
+          </a:fontRef>
+        </p:style>
+        <p:txBody>
+          <a:bodyPr rtlCol="0" anchor="ctr"/>
+          <a:lstStyle/>
+          <a:p>
+            <a:pPr algn="ctr"/>
+          </a:p>
+        </p:txBody>
+      </p:sp>
+      <p:sp>
+        <p:nvSpPr>
+          <p:cNvPr id="10" name="Rectangle 9"/>
+          <p:cNvSpPr/>
+          <p:nvPr/>
+        </p:nvSpPr>
+        <p:spPr>
+          <a:xfrm>
+            <a:off x="0" y="6766000"/>
+            <a:ext cx="12191695" cy="92000"/>
+          </a:xfrm>
+          <a:prstGeom prst="rect">
+            <a:avLst/>
+          </a:prstGeom>
+          <a:solidFill>
+            <a:srgbClr val="1F4E3D"/>
+          </a:solidFill>
+          <a:ln>
+            <a:noFill/>
+          </a:ln>
+          <a:effectLst/>
+        </p:spPr>
+        <p:style>
+          <a:lnRef idx="1">
+            <a:schemeClr val="accent1"/>
+          </a:lnRef>
+          <a:fillRef idx="3">
+            <a:schemeClr val="accent1"/>
+          </a:fillRef>
+          <a:effectRef idx="2">
+            <a:schemeClr val="accent1"/>
+          </a:effectRef>
+          <a:fontRef idx="minor">
+            <a:schemeClr val="lt1"/>
+          </a:fontRef>
+        </p:style>
+        <p:txBody>
+          <a:bodyPr rtlCol="0" anchor="ctr"/>
+          <a:lstStyle/>
+          <a:p>
+            <a:pPr algn="ctr"/>
+          </a:p>
+        </p:txBody>
+      </p:sp>
       <p:pic>
         <p:nvPicPr>
-          <p:cNvPr id="5" name="Picture 4" descr="iuh_logo.png"/>
+          <p:cNvPr id="11" name="Picture 10" descr="iuh_logo.png"/>
           <p:cNvPicPr>
             <a:picLocks noChangeAspect="1"/>
           </p:cNvPicPr>
           <p:nvPr/>
         </p:nvPicPr>
         <p:blipFill>
-          <a:blip r:embed="rId2"/>
+          <a:blip r:embed="rId4"/>
           <a:stretch>
             <a:fillRect/>
           </a:stretch>
@@ -3282,7 +3490,7 @@
       </p:pic>
       <p:sp>
         <p:nvSpPr>
-          <p:cNvPr id="6" name="TextBox 5"/>
+          <p:cNvPr id="12" name="TextBox 11"/>
           <p:cNvSpPr txBox="1"/>
           <p:nvPr/>
         </p:nvSpPr>
@@ -3327,7 +3535,7 @@
       </p:sp>
       <p:sp>
         <p:nvSpPr>
-          <p:cNvPr id="7" name="Rectangle 6"/>
+          <p:cNvPr id="13" name="Rectangle 12"/>
           <p:cNvSpPr/>
           <p:nvPr/>
         </p:nvSpPr>
@@ -3371,7 +3579,7 @@
       </p:sp>
       <p:sp>
         <p:nvSpPr>
-          <p:cNvPr id="8" name="TextBox 7"/>
+          <p:cNvPr id="14" name="TextBox 13"/>
           <p:cNvSpPr txBox="1"/>
           <p:nvPr/>
         </p:nvSpPr>
@@ -3405,7 +3613,7 @@
       </p:sp>
       <p:sp>
         <p:nvSpPr>
-          <p:cNvPr id="9" name="TextBox 8"/>
+          <p:cNvPr id="15" name="TextBox 14"/>
           <p:cNvSpPr txBox="1"/>
           <p:nvPr/>
         </p:nvSpPr>
@@ -3450,7 +3658,7 @@
       </p:sp>
       <p:sp>
         <p:nvSpPr>
-          <p:cNvPr id="10" name="TextBox 9"/>
+          <p:cNvPr id="16" name="TextBox 15"/>
           <p:cNvSpPr txBox="1"/>
           <p:nvPr/>
         </p:nvSpPr>
@@ -3484,14 +3692,14 @@
       </p:sp>
       <p:pic>
         <p:nvPicPr>
-          <p:cNvPr id="11" name="Picture 10" descr="shv_logo.png"/>
+          <p:cNvPr id="17" name="Picture 16" descr="shv_logo.png"/>
           <p:cNvPicPr>
             <a:picLocks noChangeAspect="1"/>
           </p:cNvPicPr>
           <p:nvPr/>
         </p:nvPicPr>
         <p:blipFill>
-          <a:blip r:embed="rId3"/>
+          <a:blip r:embed="rId5"/>
           <a:stretch>
             <a:fillRect/>
           </a:stretch>
@@ -3508,7 +3716,7 @@
       </p:pic>
       <p:sp>
         <p:nvSpPr>
-          <p:cNvPr id="12" name="TextBox 11"/>
+          <p:cNvPr id="18" name="TextBox 17"/>
           <p:cNvSpPr txBox="1"/>
           <p:nvPr/>
         </p:nvSpPr>
@@ -13178,7 +13386,7 @@
           <a:blip r:embed="rId2">
             <a:extLst>
               <a:ext uri="{96DAC541-7B7A-43D3-8B79-37D633B846F1}">
-                <ns0:svgBlip xmlns:ns0="http://schemas.microsoft.com/office/drawing/2016/SVG/main" r:embed="rId7"/>
+                <ns0:svgBlip xmlns:ns0="http://schemas.microsoft.com/office/drawing/2016/SVG/main" r:embed="rId8"/>
               </a:ext>
             </a:extLst>
           </a:blip>
@@ -13356,7 +13564,7 @@
           <a:blip r:embed="rId4">
             <a:extLst>
               <a:ext uri="{96DAC541-7B7A-43D3-8B79-37D633B846F1}">
-                <ns2:svgBlip xmlns:ns2="http://schemas.microsoft.com/office/drawing/2016/SVG/main" r:embed="rId6"/>
+                <ns2:svgBlip xmlns:ns2="http://schemas.microsoft.com/office/drawing/2016/SVG/main" r:embed="rId7"/>
               </a:ext>
             </a:extLst>
           </a:blip>
@@ -13485,53 +13693,9 @@
           </a:p>
         </p:txBody>
       </p:sp>
-      <p:sp>
-        <p:nvSpPr>
-          <p:cNvPr id="12" name="Oval 11"/>
-          <p:cNvSpPr/>
-          <p:nvPr/>
-        </p:nvSpPr>
-        <p:spPr>
-          <a:xfrm>
-            <a:off x="560000" y="1800000"/>
-            <a:ext cx="1350000" cy="1350000"/>
-          </a:xfrm>
-          <a:prstGeom prst="ellipse">
-            <a:avLst/>
-          </a:prstGeom>
-          <a:solidFill>
-            <a:srgbClr val="1F4E3D"/>
-          </a:solidFill>
-          <a:ln>
-            <a:noFill/>
-          </a:ln>
-          <a:effectLst/>
-        </p:spPr>
-        <p:style>
-          <a:lnRef idx="1">
-            <a:schemeClr val="accent1"/>
-          </a:lnRef>
-          <a:fillRef idx="3">
-            <a:schemeClr val="accent1"/>
-          </a:fillRef>
-          <a:effectRef idx="2">
-            <a:schemeClr val="accent1"/>
-          </a:effectRef>
-          <a:fontRef idx="minor">
-            <a:schemeClr val="lt1"/>
-          </a:fontRef>
-        </p:style>
-        <p:txBody>
-          <a:bodyPr rtlCol="0" anchor="ctr"/>
-          <a:lstStyle/>
-          <a:p>
-            <a:pPr algn="ctr"/>
-          </a:p>
-        </p:txBody>
-      </p:sp>
       <p:pic>
         <p:nvPicPr>
-          <p:cNvPr id="13" name="Picture 12" descr="stopwatch_w.png"/>
+          <p:cNvPr id="12" name="Picture 11" descr="big_qc_shop.png"/>
           <p:cNvPicPr>
             <a:picLocks noChangeAspect="1"/>
           </p:cNvPicPr>
@@ -13541,7 +13705,7 @@
           <a:blip r:embed="rId5">
             <a:extLst>
               <a:ext uri="{96DAC541-7B7A-43D3-8B79-37D633B846F1}">
-                <ns3:svgBlip xmlns:ns3="http://schemas.microsoft.com/office/drawing/2016/SVG/main" r:embed="rId8"/>
+                <ns3:svgBlip xmlns:ns3="http://schemas.microsoft.com/office/drawing/2016/SVG/main" r:embed="rId6"/>
               </a:ext>
             </a:extLst>
           </a:blip>
@@ -13551,293 +13715,14 @@
         </p:blipFill>
         <p:spPr>
           <a:xfrm>
-            <a:off x="830000" y="2070000"/>
-            <a:ext cx="810000" cy="810000"/>
+            <a:off x="550847" y="1847000"/>
+            <a:ext cx="11090000" cy="4436000"/>
           </a:xfrm>
           <a:prstGeom prst="rect">
             <a:avLst/>
           </a:prstGeom>
         </p:spPr>
       </p:pic>
-      <p:sp>
-        <p:nvSpPr>
-          <p:cNvPr id="14" name="TextBox 13"/>
-          <p:cNvSpPr txBox="1"/>
-          <p:nvPr/>
-        </p:nvSpPr>
-        <p:spPr>
-          <a:xfrm>
-            <a:off x="2150000" y="1900000"/>
-            <a:ext cx="9400000" cy="1150000"/>
-          </a:xfrm>
-          <a:prstGeom prst="rect">
-            <a:avLst/>
-          </a:prstGeom>
-          <a:noFill/>
-        </p:spPr>
-        <p:txBody>
-          <a:bodyPr wrap="square" lIns="50000" rIns="50000" tIns="20000" bIns="20000">
-            <a:spAutoFit/>
-          </a:bodyPr>
-          <a:lstStyle/>
-          <a:p>
-            <a:r>
-              <a:rPr sz="2000" b="0" i="1">
-                <a:solidFill>
-                  <a:srgbClr val="34404A"/>
-                </a:solidFill>
-              </a:rPr>
-              <a:t>Theo dõi từng mẻ, cho qua công đoạn — dụng cụ đo nhanh cầm tay.</a:t>
-            </a:r>
-          </a:p>
-        </p:txBody>
-      </p:sp>
-      <p:sp>
-        <p:nvSpPr>
-          <p:cNvPr id="15" name="TextBox 14"/>
-          <p:cNvSpPr txBox="1"/>
-          <p:nvPr/>
-        </p:nvSpPr>
-        <p:spPr>
-          <a:xfrm>
-            <a:off x="560000" y="3560000"/>
-            <a:ext cx="5850000" cy="650000"/>
-          </a:xfrm>
-          <a:prstGeom prst="rect">
-            <a:avLst/>
-          </a:prstGeom>
-          <a:noFill/>
-        </p:spPr>
-        <p:txBody>
-          <a:bodyPr wrap="square" lIns="50000" rIns="50000" tIns="20000" bIns="20000" anchor="ctr">
-            <a:spAutoFit/>
-          </a:bodyPr>
-          <a:lstStyle/>
-          <a:p>
-            <a:r>
-              <a:rPr sz="2000" b="1" i="0">
-                <a:solidFill>
-                  <a:srgbClr val="2C7A5A"/>
-                </a:solidFill>
-              </a:rPr>
-              <a:t>✔  </a:t>
-            </a:r>
-            <a:r>
-              <a:rPr sz="2000" b="0" i="0">
-                <a:solidFill>
-                  <a:srgbClr val="14332A"/>
-                </a:solidFill>
-              </a:rPr>
-              <a:t>Tỷ trọng</a:t>
-            </a:r>
-          </a:p>
-        </p:txBody>
-      </p:sp>
-      <p:sp>
-        <p:nvSpPr>
-          <p:cNvPr id="16" name="TextBox 15"/>
-          <p:cNvSpPr txBox="1"/>
-          <p:nvPr/>
-        </p:nvSpPr>
-        <p:spPr>
-          <a:xfrm>
-            <a:off x="6510000" y="3560000"/>
-            <a:ext cx="5850000" cy="650000"/>
-          </a:xfrm>
-          <a:prstGeom prst="rect">
-            <a:avLst/>
-          </a:prstGeom>
-          <a:noFill/>
-        </p:spPr>
-        <p:txBody>
-          <a:bodyPr wrap="square" lIns="50000" rIns="50000" tIns="20000" bIns="20000" anchor="ctr">
-            <a:spAutoFit/>
-          </a:bodyPr>
-          <a:lstStyle/>
-          <a:p>
-            <a:r>
-              <a:rPr sz="2000" b="1" i="0">
-                <a:solidFill>
-                  <a:srgbClr val="2C7A5A"/>
-                </a:solidFill>
-              </a:rPr>
-              <a:t>✔  </a:t>
-            </a:r>
-            <a:r>
-              <a:rPr sz="2000" b="0" i="0">
-                <a:solidFill>
-                  <a:srgbClr val="14332A"/>
-                </a:solidFill>
-              </a:rPr>
-              <a:t>Màu sắc</a:t>
-            </a:r>
-          </a:p>
-        </p:txBody>
-      </p:sp>
-      <p:sp>
-        <p:nvSpPr>
-          <p:cNvPr id="17" name="TextBox 16"/>
-          <p:cNvSpPr txBox="1"/>
-          <p:nvPr/>
-        </p:nvSpPr>
-        <p:spPr>
-          <a:xfrm>
-            <a:off x="560000" y="4210000"/>
-            <a:ext cx="5850000" cy="650000"/>
-          </a:xfrm>
-          <a:prstGeom prst="rect">
-            <a:avLst/>
-          </a:prstGeom>
-          <a:noFill/>
-        </p:spPr>
-        <p:txBody>
-          <a:bodyPr wrap="square" lIns="50000" rIns="50000" tIns="20000" bIns="20000" anchor="ctr">
-            <a:spAutoFit/>
-          </a:bodyPr>
-          <a:lstStyle/>
-          <a:p>
-            <a:r>
-              <a:rPr sz="2000" b="1" i="0">
-                <a:solidFill>
-                  <a:srgbClr val="2C7A5A"/>
-                </a:solidFill>
-              </a:rPr>
-              <a:t>✔  </a:t>
-            </a:r>
-            <a:r>
-              <a:rPr sz="2000" b="0" i="0">
-                <a:solidFill>
-                  <a:srgbClr val="14332A"/>
-                </a:solidFill>
-              </a:rPr>
-              <a:t>Độ phủ</a:t>
-            </a:r>
-          </a:p>
-        </p:txBody>
-      </p:sp>
-      <p:sp>
-        <p:nvSpPr>
-          <p:cNvPr id="18" name="TextBox 17"/>
-          <p:cNvSpPr txBox="1"/>
-          <p:nvPr/>
-        </p:nvSpPr>
-        <p:spPr>
-          <a:xfrm>
-            <a:off x="6510000" y="4210000"/>
-            <a:ext cx="5850000" cy="650000"/>
-          </a:xfrm>
-          <a:prstGeom prst="rect">
-            <a:avLst/>
-          </a:prstGeom>
-          <a:noFill/>
-        </p:spPr>
-        <p:txBody>
-          <a:bodyPr wrap="square" lIns="50000" rIns="50000" tIns="20000" bIns="20000" anchor="ctr">
-            <a:spAutoFit/>
-          </a:bodyPr>
-          <a:lstStyle/>
-          <a:p>
-            <a:r>
-              <a:rPr sz="2000" b="1" i="0">
-                <a:solidFill>
-                  <a:srgbClr val="2C7A5A"/>
-                </a:solidFill>
-              </a:rPr>
-              <a:t>✔  </a:t>
-            </a:r>
-            <a:r>
-              <a:rPr sz="2000" b="0" i="0">
-                <a:solidFill>
-                  <a:srgbClr val="14332A"/>
-                </a:solidFill>
-              </a:rPr>
-              <a:t>Độ mịn (Hegman)</a:t>
-            </a:r>
-          </a:p>
-        </p:txBody>
-      </p:sp>
-      <p:sp>
-        <p:nvSpPr>
-          <p:cNvPr id="19" name="TextBox 18"/>
-          <p:cNvSpPr txBox="1"/>
-          <p:nvPr/>
-        </p:nvSpPr>
-        <p:spPr>
-          <a:xfrm>
-            <a:off x="560000" y="4860000"/>
-            <a:ext cx="5850000" cy="650000"/>
-          </a:xfrm>
-          <a:prstGeom prst="rect">
-            <a:avLst/>
-          </a:prstGeom>
-          <a:noFill/>
-        </p:spPr>
-        <p:txBody>
-          <a:bodyPr wrap="square" lIns="50000" rIns="50000" tIns="20000" bIns="20000" anchor="ctr">
-            <a:spAutoFit/>
-          </a:bodyPr>
-          <a:lstStyle/>
-          <a:p>
-            <a:r>
-              <a:rPr sz="2000" b="1" i="0">
-                <a:solidFill>
-                  <a:srgbClr val="2C7A5A"/>
-                </a:solidFill>
-              </a:rPr>
-              <a:t>✔  </a:t>
-            </a:r>
-            <a:r>
-              <a:rPr sz="2000" b="0" i="0">
-                <a:solidFill>
-                  <a:srgbClr val="14332A"/>
-                </a:solidFill>
-              </a:rPr>
-              <a:t>Thời gian khô</a:t>
-            </a:r>
-          </a:p>
-        </p:txBody>
-      </p:sp>
-      <p:sp>
-        <p:nvSpPr>
-          <p:cNvPr id="20" name="TextBox 19"/>
-          <p:cNvSpPr txBox="1"/>
-          <p:nvPr/>
-        </p:nvSpPr>
-        <p:spPr>
-          <a:xfrm>
-            <a:off x="6510000" y="4860000"/>
-            <a:ext cx="5850000" cy="650000"/>
-          </a:xfrm>
-          <a:prstGeom prst="rect">
-            <a:avLst/>
-          </a:prstGeom>
-          <a:noFill/>
-        </p:spPr>
-        <p:txBody>
-          <a:bodyPr wrap="square" lIns="50000" rIns="50000" tIns="20000" bIns="20000" anchor="ctr">
-            <a:spAutoFit/>
-          </a:bodyPr>
-          <a:lstStyle/>
-          <a:p>
-            <a:r>
-              <a:rPr sz="2000" b="1" i="0">
-                <a:solidFill>
-                  <a:srgbClr val="2C7A5A"/>
-                </a:solidFill>
-              </a:rPr>
-              <a:t>✔  </a:t>
-            </a:r>
-            <a:r>
-              <a:rPr sz="2000" b="0" i="0">
-                <a:solidFill>
-                  <a:srgbClr val="14332A"/>
-                </a:solidFill>
-              </a:rPr>
-              <a:t>Độ nhớt (Stormer)</a:t>
-            </a:r>
-          </a:p>
-        </p:txBody>
-      </p:sp>
     </p:spTree>
   </p:cSld>
   <p:clrMapOvr>
@@ -13912,7 +13797,7 @@
           <a:blip r:embed="rId2">
             <a:extLst>
               <a:ext uri="{96DAC541-7B7A-43D3-8B79-37D633B846F1}">
-                <ns0:svgBlip xmlns:ns0="http://schemas.microsoft.com/office/drawing/2016/SVG/main" r:embed="rId7"/>
+                <ns0:svgBlip xmlns:ns0="http://schemas.microsoft.com/office/drawing/2016/SVG/main" r:embed="rId8"/>
               </a:ext>
             </a:extLst>
           </a:blip>
@@ -14090,7 +13975,7 @@
           <a:blip r:embed="rId4">
             <a:extLst>
               <a:ext uri="{96DAC541-7B7A-43D3-8B79-37D633B846F1}">
-                <ns2:svgBlip xmlns:ns2="http://schemas.microsoft.com/office/drawing/2016/SVG/main" r:embed="rId6"/>
+                <ns2:svgBlip xmlns:ns2="http://schemas.microsoft.com/office/drawing/2016/SVG/main" r:embed="rId7"/>
               </a:ext>
             </a:extLst>
           </a:blip>
@@ -14219,53 +14104,9 @@
           </a:p>
         </p:txBody>
       </p:sp>
-      <p:sp>
-        <p:nvSpPr>
-          <p:cNvPr id="12" name="Oval 11"/>
-          <p:cNvSpPr/>
-          <p:nvPr/>
-        </p:nvSpPr>
-        <p:spPr>
-          <a:xfrm>
-            <a:off x="560000" y="1800000"/>
-            <a:ext cx="1350000" cy="1350000"/>
-          </a:xfrm>
-          <a:prstGeom prst="ellipse">
-            <a:avLst/>
-          </a:prstGeom>
-          <a:solidFill>
-            <a:srgbClr val="1F4E3D"/>
-          </a:solidFill>
-          <a:ln>
-            <a:noFill/>
-          </a:ln>
-          <a:effectLst/>
-        </p:spPr>
-        <p:style>
-          <a:lnRef idx="1">
-            <a:schemeClr val="accent1"/>
-          </a:lnRef>
-          <a:fillRef idx="3">
-            <a:schemeClr val="accent1"/>
-          </a:fillRef>
-          <a:effectRef idx="2">
-            <a:schemeClr val="accent1"/>
-          </a:effectRef>
-          <a:fontRef idx="minor">
-            <a:schemeClr val="lt1"/>
-          </a:fontRef>
-        </p:style>
-        <p:txBody>
-          <a:bodyPr rtlCol="0" anchor="ctr"/>
-          <a:lstStyle/>
-          <a:p>
-            <a:pPr algn="ctr"/>
-          </a:p>
-        </p:txBody>
-      </p:sp>
       <p:pic>
         <p:nvPicPr>
-          <p:cNvPr id="13" name="Picture 12" descr="microscope_w.png"/>
+          <p:cNvPr id="12" name="Picture 11" descr="big_qc_lab.png"/>
           <p:cNvPicPr>
             <a:picLocks noChangeAspect="1"/>
           </p:cNvPicPr>
@@ -14275,7 +14116,7 @@
           <a:blip r:embed="rId5">
             <a:extLst>
               <a:ext uri="{96DAC541-7B7A-43D3-8B79-37D633B846F1}">
-                <ns3:svgBlip xmlns:ns3="http://schemas.microsoft.com/office/drawing/2016/SVG/main" r:embed="rId8"/>
+                <ns3:svgBlip xmlns:ns3="http://schemas.microsoft.com/office/drawing/2016/SVG/main" r:embed="rId6"/>
               </a:ext>
             </a:extLst>
           </a:blip>
@@ -14285,293 +14126,14 @@
         </p:blipFill>
         <p:spPr>
           <a:xfrm>
-            <a:off x="830000" y="2070000"/>
-            <a:ext cx="810000" cy="810000"/>
+            <a:off x="550847" y="1847000"/>
+            <a:ext cx="11090000" cy="4436000"/>
           </a:xfrm>
           <a:prstGeom prst="rect">
             <a:avLst/>
           </a:prstGeom>
         </p:spPr>
       </p:pic>
-      <p:sp>
-        <p:nvSpPr>
-          <p:cNvPr id="14" name="TextBox 13"/>
-          <p:cNvSpPr txBox="1"/>
-          <p:nvPr/>
-        </p:nvSpPr>
-        <p:spPr>
-          <a:xfrm>
-            <a:off x="2150000" y="1900000"/>
-            <a:ext cx="9400000" cy="1150000"/>
-          </a:xfrm>
-          <a:prstGeom prst="rect">
-            <a:avLst/>
-          </a:prstGeom>
-          <a:noFill/>
-        </p:spPr>
-        <p:txBody>
-          <a:bodyPr wrap="square" lIns="50000" rIns="50000" tIns="20000" bIns="20000">
-            <a:spAutoFit/>
-          </a:bodyPr>
-          <a:lstStyle/>
-          <a:p>
-            <a:r>
-              <a:rPr sz="2000" b="0" i="1">
-                <a:solidFill>
-                  <a:srgbClr val="34404A"/>
-                </a:solidFill>
-              </a:rPr>
-              <a:t>Đánh giá độ bền dài hạn của màng sơn — cơ sở nghiệm thu.</a:t>
-            </a:r>
-          </a:p>
-        </p:txBody>
-      </p:sp>
-      <p:sp>
-        <p:nvSpPr>
-          <p:cNvPr id="15" name="TextBox 14"/>
-          <p:cNvSpPr txBox="1"/>
-          <p:nvPr/>
-        </p:nvSpPr>
-        <p:spPr>
-          <a:xfrm>
-            <a:off x="560000" y="3560000"/>
-            <a:ext cx="5850000" cy="650000"/>
-          </a:xfrm>
-          <a:prstGeom prst="rect">
-            <a:avLst/>
-          </a:prstGeom>
-          <a:noFill/>
-        </p:spPr>
-        <p:txBody>
-          <a:bodyPr wrap="square" lIns="50000" rIns="50000" tIns="20000" bIns="20000" anchor="ctr">
-            <a:spAutoFit/>
-          </a:bodyPr>
-          <a:lstStyle/>
-          <a:p>
-            <a:r>
-              <a:rPr sz="2000" b="1" i="0">
-                <a:solidFill>
-                  <a:srgbClr val="2C7A5A"/>
-                </a:solidFill>
-              </a:rPr>
-              <a:t>✔  </a:t>
-            </a:r>
-            <a:r>
-              <a:rPr sz="2000" b="0" i="0">
-                <a:solidFill>
-                  <a:srgbClr val="14332A"/>
-                </a:solidFill>
-              </a:rPr>
-              <a:t>Độ bám dính (Pull-off)</a:t>
-            </a:r>
-          </a:p>
-        </p:txBody>
-      </p:sp>
-      <p:sp>
-        <p:nvSpPr>
-          <p:cNvPr id="16" name="TextBox 15"/>
-          <p:cNvSpPr txBox="1"/>
-          <p:nvPr/>
-        </p:nvSpPr>
-        <p:spPr>
-          <a:xfrm>
-            <a:off x="6510000" y="3560000"/>
-            <a:ext cx="5850000" cy="650000"/>
-          </a:xfrm>
-          <a:prstGeom prst="rect">
-            <a:avLst/>
-          </a:prstGeom>
-          <a:noFill/>
-        </p:spPr>
-        <p:txBody>
-          <a:bodyPr wrap="square" lIns="50000" rIns="50000" tIns="20000" bIns="20000" anchor="ctr">
-            <a:spAutoFit/>
-          </a:bodyPr>
-          <a:lstStyle/>
-          <a:p>
-            <a:r>
-              <a:rPr sz="2000" b="1" i="0">
-                <a:solidFill>
-                  <a:srgbClr val="2C7A5A"/>
-                </a:solidFill>
-              </a:rPr>
-              <a:t>✔  </a:t>
-            </a:r>
-            <a:r>
-              <a:rPr sz="2000" b="0" i="0">
-                <a:solidFill>
-                  <a:srgbClr val="14332A"/>
-                </a:solidFill>
-              </a:rPr>
-              <a:t>Bền uốn · va đập</a:t>
-            </a:r>
-          </a:p>
-        </p:txBody>
-      </p:sp>
-      <p:sp>
-        <p:nvSpPr>
-          <p:cNvPr id="17" name="TextBox 16"/>
-          <p:cNvSpPr txBox="1"/>
-          <p:nvPr/>
-        </p:nvSpPr>
-        <p:spPr>
-          <a:xfrm>
-            <a:off x="560000" y="4210000"/>
-            <a:ext cx="5850000" cy="650000"/>
-          </a:xfrm>
-          <a:prstGeom prst="rect">
-            <a:avLst/>
-          </a:prstGeom>
-          <a:noFill/>
-        </p:spPr>
-        <p:txBody>
-          <a:bodyPr wrap="square" lIns="50000" rIns="50000" tIns="20000" bIns="20000" anchor="ctr">
-            <a:spAutoFit/>
-          </a:bodyPr>
-          <a:lstStyle/>
-          <a:p>
-            <a:r>
-              <a:rPr sz="2000" b="1" i="0">
-                <a:solidFill>
-                  <a:srgbClr val="2C7A5A"/>
-                </a:solidFill>
-              </a:rPr>
-              <a:t>✔  </a:t>
-            </a:r>
-            <a:r>
-              <a:rPr sz="2000" b="0" i="0">
-                <a:solidFill>
-                  <a:srgbClr val="14332A"/>
-                </a:solidFill>
-              </a:rPr>
-              <a:t>Độ bóng · hàm rắn</a:t>
-            </a:r>
-          </a:p>
-        </p:txBody>
-      </p:sp>
-      <p:sp>
-        <p:nvSpPr>
-          <p:cNvPr id="18" name="TextBox 17"/>
-          <p:cNvSpPr txBox="1"/>
-          <p:nvPr/>
-        </p:nvSpPr>
-        <p:spPr>
-          <a:xfrm>
-            <a:off x="6510000" y="4210000"/>
-            <a:ext cx="5850000" cy="650000"/>
-          </a:xfrm>
-          <a:prstGeom prst="rect">
-            <a:avLst/>
-          </a:prstGeom>
-          <a:noFill/>
-        </p:spPr>
-        <p:txBody>
-          <a:bodyPr wrap="square" lIns="50000" rIns="50000" tIns="20000" bIns="20000" anchor="ctr">
-            <a:spAutoFit/>
-          </a:bodyPr>
-          <a:lstStyle/>
-          <a:p>
-            <a:r>
-              <a:rPr sz="2000" b="1" i="0">
-                <a:solidFill>
-                  <a:srgbClr val="2C7A5A"/>
-                </a:solidFill>
-              </a:rPr>
-              <a:t>✔  </a:t>
-            </a:r>
-            <a:r>
-              <a:rPr sz="2000" b="0" i="0">
-                <a:solidFill>
-                  <a:srgbClr val="14332A"/>
-                </a:solidFill>
-              </a:rPr>
-              <a:t>Phun sương muối</a:t>
-            </a:r>
-          </a:p>
-        </p:txBody>
-      </p:sp>
-      <p:sp>
-        <p:nvSpPr>
-          <p:cNvPr id="19" name="TextBox 18"/>
-          <p:cNvSpPr txBox="1"/>
-          <p:nvPr/>
-        </p:nvSpPr>
-        <p:spPr>
-          <a:xfrm>
-            <a:off x="560000" y="4860000"/>
-            <a:ext cx="5850000" cy="650000"/>
-          </a:xfrm>
-          <a:prstGeom prst="rect">
-            <a:avLst/>
-          </a:prstGeom>
-          <a:noFill/>
-        </p:spPr>
-        <p:txBody>
-          <a:bodyPr wrap="square" lIns="50000" rIns="50000" tIns="20000" bIns="20000" anchor="ctr">
-            <a:spAutoFit/>
-          </a:bodyPr>
-          <a:lstStyle/>
-          <a:p>
-            <a:r>
-              <a:rPr sz="2000" b="1" i="0">
-                <a:solidFill>
-                  <a:srgbClr val="2C7A5A"/>
-                </a:solidFill>
-              </a:rPr>
-              <a:t>✔  </a:t>
-            </a:r>
-            <a:r>
-              <a:rPr sz="2000" b="0" i="0">
-                <a:solidFill>
-                  <a:srgbClr val="14332A"/>
-                </a:solidFill>
-              </a:rPr>
-              <a:t>Lão hóa UV / QUV</a:t>
-            </a:r>
-          </a:p>
-        </p:txBody>
-      </p:sp>
-      <p:sp>
-        <p:nvSpPr>
-          <p:cNvPr id="20" name="TextBox 19"/>
-          <p:cNvSpPr txBox="1"/>
-          <p:nvPr/>
-        </p:nvSpPr>
-        <p:spPr>
-          <a:xfrm>
-            <a:off x="6510000" y="4860000"/>
-            <a:ext cx="5850000" cy="650000"/>
-          </a:xfrm>
-          <a:prstGeom prst="rect">
-            <a:avLst/>
-          </a:prstGeom>
-          <a:noFill/>
-        </p:spPr>
-        <p:txBody>
-          <a:bodyPr wrap="square" lIns="50000" rIns="50000" tIns="20000" bIns="20000" anchor="ctr">
-            <a:spAutoFit/>
-          </a:bodyPr>
-          <a:lstStyle/>
-          <a:p>
-            <a:r>
-              <a:rPr sz="2000" b="1" i="0">
-                <a:solidFill>
-                  <a:srgbClr val="2C7A5A"/>
-                </a:solidFill>
-              </a:rPr>
-              <a:t>✔  </a:t>
-            </a:r>
-            <a:r>
-              <a:rPr sz="2000" b="0" i="0">
-                <a:solidFill>
-                  <a:srgbClr val="14332A"/>
-                </a:solidFill>
-              </a:rPr>
-              <a:t>Đối chiếu TCVN / ASTM</a:t>
-            </a:r>
-          </a:p>
-        </p:txBody>
-      </p:sp>
     </p:spTree>
   </p:cSld>
   <p:clrMapOvr>

</xml_diff>

<commit_message>
Fix slide display bugs found in full visual review
- Radar chart (Sơn tàu biển vs trang trí): widen viewBox and recenter so
  the left/right axis labels ("Độ bền màng", "Chống ăn mòn") are no longer
  clipped at the edges.
- Agenda slide: replace the stray "0" section badge with a contents/list
  glyph (header now renders a list mark when num is 0).

Refreshes exported PPTX/PDF.

Co-Authored-By: Claude Opus 4.8 <noreply@anthropic.com>
Claude-Session: https://claude.ai/code/session_01PbbxSyJEYscgmQfTL8vaUX
</commit_message>
<xml_diff>
--- a/SuHeo/Báo cáo thực tập - Sơn Hải Vân.pptx
+++ b/SuHeo/Báo cáo thực tập - Sơn Hải Vân.pptx
@@ -14537,8 +14537,8 @@
         </p:blipFill>
         <p:spPr>
           <a:xfrm>
-            <a:off x="4033347" y="1865000"/>
-            <a:ext cx="4125000" cy="4400000"/>
+            <a:off x="3483347" y="1865000"/>
+            <a:ext cx="5225000" cy="4400000"/>
           </a:xfrm>
           <a:prstGeom prst="rect">
             <a:avLst/>
@@ -18292,20 +18292,276 @@
           <a:lstStyle/>
           <a:p>
             <a:pPr algn="ctr"/>
-            <a:r>
-              <a:rPr sz="2600" b="1" i="0">
-                <a:solidFill>
-                  <a:srgbClr val="FFFFFF"/>
-                </a:solidFill>
-              </a:rPr>
-              <a:t>0</a:t>
-            </a:r>
-          </a:p>
-        </p:txBody>
-      </p:sp>
-      <p:sp>
-        <p:nvSpPr>
-          <p:cNvPr id="6" name="TextBox 5"/>
+          </a:p>
+        </p:txBody>
+      </p:sp>
+      <p:sp>
+        <p:nvSpPr>
+          <p:cNvPr id="6" name="Oval 5"/>
+          <p:cNvSpPr/>
+          <p:nvPr/>
+        </p:nvSpPr>
+        <p:spPr>
+          <a:xfrm>
+            <a:off x="762000" y="690000"/>
+            <a:ext cx="66000" cy="66000"/>
+          </a:xfrm>
+          <a:prstGeom prst="ellipse">
+            <a:avLst/>
+          </a:prstGeom>
+          <a:solidFill>
+            <a:srgbClr val="FFFFFF"/>
+          </a:solidFill>
+          <a:ln>
+            <a:noFill/>
+          </a:ln>
+          <a:effectLst/>
+        </p:spPr>
+        <p:style>
+          <a:lnRef idx="1">
+            <a:schemeClr val="accent1"/>
+          </a:lnRef>
+          <a:fillRef idx="3">
+            <a:schemeClr val="accent1"/>
+          </a:fillRef>
+          <a:effectRef idx="2">
+            <a:schemeClr val="accent1"/>
+          </a:effectRef>
+          <a:fontRef idx="minor">
+            <a:schemeClr val="lt1"/>
+          </a:fontRef>
+        </p:style>
+        <p:txBody>
+          <a:bodyPr rtlCol="0" anchor="ctr"/>
+          <a:lstStyle/>
+          <a:p>
+            <a:pPr algn="ctr"/>
+          </a:p>
+        </p:txBody>
+      </p:sp>
+      <p:sp>
+        <p:nvSpPr>
+          <p:cNvPr id="7" name="Rounded Rectangle 6"/>
+          <p:cNvSpPr/>
+          <p:nvPr/>
+        </p:nvSpPr>
+        <p:spPr>
+          <a:xfrm>
+            <a:off x="872000" y="700000"/>
+            <a:ext cx="300000" cy="46000"/>
+          </a:xfrm>
+          <a:prstGeom prst="roundRect">
+            <a:avLst/>
+          </a:prstGeom>
+          <a:solidFill>
+            <a:srgbClr val="FFFFFF"/>
+          </a:solidFill>
+          <a:ln>
+            <a:noFill/>
+          </a:ln>
+          <a:effectLst/>
+        </p:spPr>
+        <p:style>
+          <a:lnRef idx="1">
+            <a:schemeClr val="accent1"/>
+          </a:lnRef>
+          <a:fillRef idx="3">
+            <a:schemeClr val="accent1"/>
+          </a:fillRef>
+          <a:effectRef idx="2">
+            <a:schemeClr val="accent1"/>
+          </a:effectRef>
+          <a:fontRef idx="minor">
+            <a:schemeClr val="lt1"/>
+          </a:fontRef>
+        </p:style>
+        <p:txBody>
+          <a:bodyPr rtlCol="0" anchor="ctr"/>
+          <a:lstStyle/>
+          <a:p>
+            <a:pPr algn="ctr"/>
+          </a:p>
+        </p:txBody>
+      </p:sp>
+      <p:sp>
+        <p:nvSpPr>
+          <p:cNvPr id="8" name="Oval 7"/>
+          <p:cNvSpPr/>
+          <p:nvPr/>
+        </p:nvSpPr>
+        <p:spPr>
+          <a:xfrm>
+            <a:off x="762000" y="830000"/>
+            <a:ext cx="66000" cy="66000"/>
+          </a:xfrm>
+          <a:prstGeom prst="ellipse">
+            <a:avLst/>
+          </a:prstGeom>
+          <a:solidFill>
+            <a:srgbClr val="FFFFFF"/>
+          </a:solidFill>
+          <a:ln>
+            <a:noFill/>
+          </a:ln>
+          <a:effectLst/>
+        </p:spPr>
+        <p:style>
+          <a:lnRef idx="1">
+            <a:schemeClr val="accent1"/>
+          </a:lnRef>
+          <a:fillRef idx="3">
+            <a:schemeClr val="accent1"/>
+          </a:fillRef>
+          <a:effectRef idx="2">
+            <a:schemeClr val="accent1"/>
+          </a:effectRef>
+          <a:fontRef idx="minor">
+            <a:schemeClr val="lt1"/>
+          </a:fontRef>
+        </p:style>
+        <p:txBody>
+          <a:bodyPr rtlCol="0" anchor="ctr"/>
+          <a:lstStyle/>
+          <a:p>
+            <a:pPr algn="ctr"/>
+          </a:p>
+        </p:txBody>
+      </p:sp>
+      <p:sp>
+        <p:nvSpPr>
+          <p:cNvPr id="9" name="Rounded Rectangle 8"/>
+          <p:cNvSpPr/>
+          <p:nvPr/>
+        </p:nvSpPr>
+        <p:spPr>
+          <a:xfrm>
+            <a:off x="872000" y="840000"/>
+            <a:ext cx="300000" cy="46000"/>
+          </a:xfrm>
+          <a:prstGeom prst="roundRect">
+            <a:avLst/>
+          </a:prstGeom>
+          <a:solidFill>
+            <a:srgbClr val="FFFFFF"/>
+          </a:solidFill>
+          <a:ln>
+            <a:noFill/>
+          </a:ln>
+          <a:effectLst/>
+        </p:spPr>
+        <p:style>
+          <a:lnRef idx="1">
+            <a:schemeClr val="accent1"/>
+          </a:lnRef>
+          <a:fillRef idx="3">
+            <a:schemeClr val="accent1"/>
+          </a:fillRef>
+          <a:effectRef idx="2">
+            <a:schemeClr val="accent1"/>
+          </a:effectRef>
+          <a:fontRef idx="minor">
+            <a:schemeClr val="lt1"/>
+          </a:fontRef>
+        </p:style>
+        <p:txBody>
+          <a:bodyPr rtlCol="0" anchor="ctr"/>
+          <a:lstStyle/>
+          <a:p>
+            <a:pPr algn="ctr"/>
+          </a:p>
+        </p:txBody>
+      </p:sp>
+      <p:sp>
+        <p:nvSpPr>
+          <p:cNvPr id="10" name="Oval 9"/>
+          <p:cNvSpPr/>
+          <p:nvPr/>
+        </p:nvSpPr>
+        <p:spPr>
+          <a:xfrm>
+            <a:off x="762000" y="970000"/>
+            <a:ext cx="66000" cy="66000"/>
+          </a:xfrm>
+          <a:prstGeom prst="ellipse">
+            <a:avLst/>
+          </a:prstGeom>
+          <a:solidFill>
+            <a:srgbClr val="FFFFFF"/>
+          </a:solidFill>
+          <a:ln>
+            <a:noFill/>
+          </a:ln>
+          <a:effectLst/>
+        </p:spPr>
+        <p:style>
+          <a:lnRef idx="1">
+            <a:schemeClr val="accent1"/>
+          </a:lnRef>
+          <a:fillRef idx="3">
+            <a:schemeClr val="accent1"/>
+          </a:fillRef>
+          <a:effectRef idx="2">
+            <a:schemeClr val="accent1"/>
+          </a:effectRef>
+          <a:fontRef idx="minor">
+            <a:schemeClr val="lt1"/>
+          </a:fontRef>
+        </p:style>
+        <p:txBody>
+          <a:bodyPr rtlCol="0" anchor="ctr"/>
+          <a:lstStyle/>
+          <a:p>
+            <a:pPr algn="ctr"/>
+          </a:p>
+        </p:txBody>
+      </p:sp>
+      <p:sp>
+        <p:nvSpPr>
+          <p:cNvPr id="11" name="Rounded Rectangle 10"/>
+          <p:cNvSpPr/>
+          <p:nvPr/>
+        </p:nvSpPr>
+        <p:spPr>
+          <a:xfrm>
+            <a:off x="872000" y="980000"/>
+            <a:ext cx="300000" cy="46000"/>
+          </a:xfrm>
+          <a:prstGeom prst="roundRect">
+            <a:avLst/>
+          </a:prstGeom>
+          <a:solidFill>
+            <a:srgbClr val="FFFFFF"/>
+          </a:solidFill>
+          <a:ln>
+            <a:noFill/>
+          </a:ln>
+          <a:effectLst/>
+        </p:spPr>
+        <p:style>
+          <a:lnRef idx="1">
+            <a:schemeClr val="accent1"/>
+          </a:lnRef>
+          <a:fillRef idx="3">
+            <a:schemeClr val="accent1"/>
+          </a:fillRef>
+          <a:effectRef idx="2">
+            <a:schemeClr val="accent1"/>
+          </a:effectRef>
+          <a:fontRef idx="minor">
+            <a:schemeClr val="lt1"/>
+          </a:fontRef>
+        </p:style>
+        <p:txBody>
+          <a:bodyPr rtlCol="0" anchor="ctr"/>
+          <a:lstStyle/>
+          <a:p>
+            <a:pPr algn="ctr"/>
+          </a:p>
+        </p:txBody>
+      </p:sp>
+      <p:sp>
+        <p:nvSpPr>
+          <p:cNvPr id="12" name="TextBox 11"/>
           <p:cNvSpPr txBox="1"/>
           <p:nvPr/>
         </p:nvSpPr>
@@ -18338,7 +18594,7 @@
       </p:sp>
       <p:sp>
         <p:nvSpPr>
-          <p:cNvPr id="7" name="TextBox 6"/>
+          <p:cNvPr id="13" name="TextBox 12"/>
           <p:cNvSpPr txBox="1"/>
           <p:nvPr/>
         </p:nvSpPr>
@@ -18371,7 +18627,7 @@
       </p:sp>
       <p:pic>
         <p:nvPicPr>
-          <p:cNvPr id="8" name="Picture 7" descr="brush_amber.png"/>
+          <p:cNvPr id="14" name="Picture 13" descr="brush_amber.png"/>
           <p:cNvPicPr>
             <a:picLocks noChangeAspect="1"/>
           </p:cNvPicPr>
@@ -18401,7 +18657,7 @@
       </p:pic>
       <p:sp>
         <p:nvSpPr>
-          <p:cNvPr id="9" name="Rectangle 8"/>
+          <p:cNvPr id="15" name="Rectangle 14"/>
           <p:cNvSpPr/>
           <p:nvPr/>
         </p:nvSpPr>
@@ -18445,7 +18701,7 @@
       </p:sp>
       <p:sp>
         <p:nvSpPr>
-          <p:cNvPr id="10" name="TextBox 9"/>
+          <p:cNvPr id="16" name="TextBox 15"/>
           <p:cNvSpPr txBox="1"/>
           <p:nvPr/>
         </p:nvSpPr>
@@ -18478,7 +18734,7 @@
       </p:sp>
       <p:sp>
         <p:nvSpPr>
-          <p:cNvPr id="11" name="TextBox 10"/>
+          <p:cNvPr id="17" name="TextBox 16"/>
           <p:cNvSpPr txBox="1"/>
           <p:nvPr/>
         </p:nvSpPr>
@@ -18512,7 +18768,7 @@
       </p:sp>
       <p:sp>
         <p:nvSpPr>
-          <p:cNvPr id="12" name="Rounded Rectangle 11"/>
+          <p:cNvPr id="18" name="Rounded Rectangle 17"/>
           <p:cNvSpPr/>
           <p:nvPr/>
         </p:nvSpPr>
@@ -18556,7 +18812,7 @@
       </p:sp>
       <p:sp>
         <p:nvSpPr>
-          <p:cNvPr id="13" name="Rounded Rectangle 12"/>
+          <p:cNvPr id="19" name="Rounded Rectangle 18"/>
           <p:cNvSpPr/>
           <p:nvPr/>
         </p:nvSpPr>
@@ -18600,7 +18856,7 @@
       </p:sp>
       <p:sp>
         <p:nvSpPr>
-          <p:cNvPr id="14" name="Oval 13"/>
+          <p:cNvPr id="20" name="Oval 19"/>
           <p:cNvSpPr/>
           <p:nvPr/>
         </p:nvSpPr>
@@ -18644,7 +18900,7 @@
       </p:sp>
       <p:pic>
         <p:nvPicPr>
-          <p:cNvPr id="15" name="Picture 14" descr="company_w.png"/>
+          <p:cNvPr id="21" name="Picture 20" descr="company_w.png"/>
           <p:cNvPicPr>
             <a:picLocks noChangeAspect="1"/>
           </p:cNvPicPr>
@@ -18674,7 +18930,7 @@
       </p:pic>
       <p:sp>
         <p:nvSpPr>
-          <p:cNvPr id="16" name="TextBox 15"/>
+          <p:cNvPr id="22" name="TextBox 21"/>
           <p:cNvSpPr txBox="1"/>
           <p:nvPr/>
         </p:nvSpPr>
@@ -18708,7 +18964,7 @@
       </p:sp>
       <p:sp>
         <p:nvSpPr>
-          <p:cNvPr id="17" name="Rounded Rectangle 16"/>
+          <p:cNvPr id="23" name="Rounded Rectangle 22"/>
           <p:cNvSpPr/>
           <p:nvPr/>
         </p:nvSpPr>
@@ -18752,7 +19008,7 @@
       </p:sp>
       <p:sp>
         <p:nvSpPr>
-          <p:cNvPr id="18" name="Rounded Rectangle 17"/>
+          <p:cNvPr id="24" name="Rounded Rectangle 23"/>
           <p:cNvSpPr/>
           <p:nvPr/>
         </p:nvSpPr>
@@ -18796,7 +19052,7 @@
       </p:sp>
       <p:sp>
         <p:nvSpPr>
-          <p:cNvPr id="19" name="Oval 18"/>
+          <p:cNvPr id="25" name="Oval 24"/>
           <p:cNvSpPr/>
           <p:nvPr/>
         </p:nvSpPr>
@@ -18840,7 +19096,7 @@
       </p:sp>
       <p:pic>
         <p:nvPicPr>
-          <p:cNvPr id="20" name="Picture 19" descr="materials_w.png"/>
+          <p:cNvPr id="26" name="Picture 25" descr="materials_w.png"/>
           <p:cNvPicPr>
             <a:picLocks noChangeAspect="1"/>
           </p:cNvPicPr>
@@ -18870,7 +19126,7 @@
       </p:pic>
       <p:sp>
         <p:nvSpPr>
-          <p:cNvPr id="21" name="TextBox 20"/>
+          <p:cNvPr id="27" name="TextBox 26"/>
           <p:cNvSpPr txBox="1"/>
           <p:nvPr/>
         </p:nvSpPr>
@@ -18904,7 +19160,7 @@
       </p:sp>
       <p:sp>
         <p:nvSpPr>
-          <p:cNvPr id="22" name="Rounded Rectangle 21"/>
+          <p:cNvPr id="28" name="Rounded Rectangle 27"/>
           <p:cNvSpPr/>
           <p:nvPr/>
         </p:nvSpPr>
@@ -18948,7 +19204,7 @@
       </p:sp>
       <p:sp>
         <p:nvSpPr>
-          <p:cNvPr id="23" name="Rounded Rectangle 22"/>
+          <p:cNvPr id="29" name="Rounded Rectangle 28"/>
           <p:cNvSpPr/>
           <p:nvPr/>
         </p:nvSpPr>
@@ -18992,7 +19248,7 @@
       </p:sp>
       <p:sp>
         <p:nvSpPr>
-          <p:cNvPr id="24" name="Oval 23"/>
+          <p:cNvPr id="30" name="Oval 29"/>
           <p:cNvSpPr/>
           <p:nvPr/>
         </p:nvSpPr>
@@ -19036,7 +19292,7 @@
       </p:sp>
       <p:pic>
         <p:nvPicPr>
-          <p:cNvPr id="25" name="Picture 24" descr="gear_proc_w.png"/>
+          <p:cNvPr id="31" name="Picture 30" descr="gear_proc_w.png"/>
           <p:cNvPicPr>
             <a:picLocks noChangeAspect="1"/>
           </p:cNvPicPr>
@@ -19066,7 +19322,7 @@
       </p:pic>
       <p:sp>
         <p:nvSpPr>
-          <p:cNvPr id="26" name="TextBox 25"/>
+          <p:cNvPr id="32" name="TextBox 31"/>
           <p:cNvSpPr txBox="1"/>
           <p:nvPr/>
         </p:nvSpPr>
@@ -19100,7 +19356,7 @@
       </p:sp>
       <p:sp>
         <p:nvSpPr>
-          <p:cNvPr id="27" name="Rounded Rectangle 26"/>
+          <p:cNvPr id="33" name="Rounded Rectangle 32"/>
           <p:cNvSpPr/>
           <p:nvPr/>
         </p:nvSpPr>
@@ -19144,7 +19400,7 @@
       </p:sp>
       <p:sp>
         <p:nvSpPr>
-          <p:cNvPr id="28" name="Rounded Rectangle 27"/>
+          <p:cNvPr id="34" name="Rounded Rectangle 33"/>
           <p:cNvSpPr/>
           <p:nvPr/>
         </p:nvSpPr>
@@ -19188,7 +19444,7 @@
       </p:sp>
       <p:sp>
         <p:nvSpPr>
-          <p:cNvPr id="29" name="Oval 28"/>
+          <p:cNvPr id="35" name="Oval 34"/>
           <p:cNvSpPr/>
           <p:nvPr/>
         </p:nvSpPr>
@@ -19232,7 +19488,7 @@
       </p:sp>
       <p:pic>
         <p:nvPicPr>
-          <p:cNvPr id="30" name="Picture 29" descr="quality_check_w.png"/>
+          <p:cNvPr id="36" name="Picture 35" descr="quality_check_w.png"/>
           <p:cNvPicPr>
             <a:picLocks noChangeAspect="1"/>
           </p:cNvPicPr>
@@ -19262,7 +19518,7 @@
       </p:pic>
       <p:sp>
         <p:nvSpPr>
-          <p:cNvPr id="31" name="TextBox 30"/>
+          <p:cNvPr id="37" name="TextBox 36"/>
           <p:cNvSpPr txBox="1"/>
           <p:nvPr/>
         </p:nvSpPr>
@@ -19296,7 +19552,7 @@
       </p:sp>
       <p:sp>
         <p:nvSpPr>
-          <p:cNvPr id="32" name="Rounded Rectangle 31"/>
+          <p:cNvPr id="38" name="Rounded Rectangle 37"/>
           <p:cNvSpPr/>
           <p:nvPr/>
         </p:nvSpPr>
@@ -19340,7 +19596,7 @@
       </p:sp>
       <p:sp>
         <p:nvSpPr>
-          <p:cNvPr id="33" name="Rounded Rectangle 32"/>
+          <p:cNvPr id="39" name="Rounded Rectangle 38"/>
           <p:cNvSpPr/>
           <p:nvPr/>
         </p:nvSpPr>
@@ -19384,7 +19640,7 @@
       </p:sp>
       <p:sp>
         <p:nvSpPr>
-          <p:cNvPr id="34" name="Oval 33"/>
+          <p:cNvPr id="40" name="Oval 39"/>
           <p:cNvSpPr/>
           <p:nvPr/>
         </p:nvSpPr>
@@ -19428,7 +19684,7 @@
       </p:sp>
       <p:pic>
         <p:nvPicPr>
-          <p:cNvPr id="35" name="Picture 34" descr="warning_tri_w.png"/>
+          <p:cNvPr id="41" name="Picture 40" descr="warning_tri_w.png"/>
           <p:cNvPicPr>
             <a:picLocks noChangeAspect="1"/>
           </p:cNvPicPr>
@@ -19458,7 +19714,7 @@
       </p:pic>
       <p:sp>
         <p:nvSpPr>
-          <p:cNvPr id="36" name="TextBox 35"/>
+          <p:cNvPr id="42" name="TextBox 41"/>
           <p:cNvSpPr txBox="1"/>
           <p:nvPr/>
         </p:nvSpPr>
@@ -19492,7 +19748,7 @@
       </p:sp>
       <p:sp>
         <p:nvSpPr>
-          <p:cNvPr id="37" name="Rounded Rectangle 36"/>
+          <p:cNvPr id="43" name="Rounded Rectangle 42"/>
           <p:cNvSpPr/>
           <p:nvPr/>
         </p:nvSpPr>
@@ -19536,7 +19792,7 @@
       </p:sp>
       <p:sp>
         <p:nvSpPr>
-          <p:cNvPr id="38" name="Rounded Rectangle 37"/>
+          <p:cNvPr id="44" name="Rounded Rectangle 43"/>
           <p:cNvSpPr/>
           <p:nvPr/>
         </p:nvSpPr>
@@ -19580,7 +19836,7 @@
       </p:sp>
       <p:sp>
         <p:nvSpPr>
-          <p:cNvPr id="39" name="Oval 38"/>
+          <p:cNvPr id="45" name="Oval 44"/>
           <p:cNvSpPr/>
           <p:nvPr/>
         </p:nvSpPr>
@@ -19624,7 +19880,7 @@
       </p:sp>
       <p:pic>
         <p:nvPicPr>
-          <p:cNvPr id="40" name="Picture 39" descr="safety_shield_w.png"/>
+          <p:cNvPr id="46" name="Picture 45" descr="safety_shield_w.png"/>
           <p:cNvPicPr>
             <a:picLocks noChangeAspect="1"/>
           </p:cNvPicPr>
@@ -19654,7 +19910,7 @@
       </p:pic>
       <p:sp>
         <p:nvSpPr>
-          <p:cNvPr id="41" name="TextBox 40"/>
+          <p:cNvPr id="47" name="TextBox 46"/>
           <p:cNvSpPr txBox="1"/>
           <p:nvPr/>
         </p:nvSpPr>

</xml_diff>

<commit_message>
Redesign cover slide as split two-column layout
Replace the fully-centered cover with a side-weighted design: a dark
green brand panel on the left (IUH logo card, university/faculty names,
amber divider, company logo card, city/year) separated by an amber seam,
and a left-aligned content column on the right (kicker, title, brush
underline, company line, and a labeled info rail for GVHD/CBHD/group).

Refreshes exported PPTX/PDF.

Co-Authored-By: Claude Opus 4.8 <noreply@anthropic.com>
Claude-Session: https://claude.ai/code/session_01PbbxSyJEYscgmQfTL8vaUX
</commit_message>
<xml_diff>
--- a/SuHeo/Báo cáo thực tập - Sơn Hải Vân.pptx
+++ b/SuHeo/Báo cáo thực tập - Sơn Hải Vân.pptx
@@ -3180,7 +3180,7 @@
           <a:blip r:embed="rId2">
             <a:extLst>
               <a:ext uri="{96DAC541-7B7A-43D3-8B79-37D633B846F1}">
-                <ns0:svgBlip xmlns:ns0="http://schemas.microsoft.com/office/drawing/2016/SVG/main" r:embed="rId6"/>
+                <ns0:svgBlip xmlns:ns0="http://schemas.microsoft.com/office/drawing/2016/SVG/main" r:embed="rId8"/>
               </a:ext>
             </a:extLst>
           </a:blip>
@@ -3190,8 +3190,8 @@
         </p:blipFill>
         <p:spPr>
           <a:xfrm>
-            <a:off x="-620000" y="-380000"/>
-            <a:ext cx="3200000" cy="3200000"/>
+            <a:off x="10141695" y="-450000"/>
+            <a:ext cx="2600000" cy="2600000"/>
           </a:xfrm>
           <a:prstGeom prst="rect">
             <a:avLst/>
@@ -3200,17 +3200,17 @@
       </p:pic>
       <p:pic>
         <p:nvPicPr>
-          <p:cNvPr id="4" name="Picture 3" descr="hex_pale.png"/>
+          <p:cNvPr id="4" name="Picture 3" descr="swash_pale.png"/>
           <p:cNvPicPr>
             <a:picLocks noChangeAspect="1"/>
           </p:cNvPicPr>
           <p:nvPr/>
         </p:nvPicPr>
         <p:blipFill>
-          <a:blip r:embed="rId2">
+          <a:blip r:embed="rId3">
             <a:extLst>
               <a:ext uri="{96DAC541-7B7A-43D3-8B79-37D633B846F1}">
-                <ns1:svgBlip xmlns:ns1="http://schemas.microsoft.com/office/drawing/2016/SVG/main" r:embed="rId6"/>
+                <ns1:svgBlip xmlns:ns1="http://schemas.microsoft.com/office/drawing/2016/SVG/main" r:embed="rId9"/>
               </a:ext>
             </a:extLst>
           </a:blip>
@@ -3220,24 +3220,526 @@
         </p:blipFill>
         <p:spPr>
           <a:xfrm>
-            <a:off x="9631695" y="4038000"/>
-            <a:ext cx="3200000" cy="3200000"/>
+            <a:off x="8991695" y="5358000"/>
+            <a:ext cx="3300000" cy="1730000"/>
           </a:xfrm>
           <a:prstGeom prst="rect">
             <a:avLst/>
           </a:prstGeom>
         </p:spPr>
       </p:pic>
+      <p:sp>
+        <p:nvSpPr>
+          <p:cNvPr id="5" name="Rectangle 4"/>
+          <p:cNvSpPr/>
+          <p:nvPr/>
+        </p:nvSpPr>
+        <p:spPr>
+          <a:xfrm>
+            <a:off x="0" y="0"/>
+            <a:ext cx="4600000" cy="6858000"/>
+          </a:xfrm>
+          <a:prstGeom prst="rect">
+            <a:avLst/>
+          </a:prstGeom>
+          <a:solidFill>
+            <a:srgbClr val="1F4E3D"/>
+          </a:solidFill>
+          <a:ln>
+            <a:noFill/>
+          </a:ln>
+          <a:effectLst/>
+        </p:spPr>
+        <p:style>
+          <a:lnRef idx="1">
+            <a:schemeClr val="accent1"/>
+          </a:lnRef>
+          <a:fillRef idx="3">
+            <a:schemeClr val="accent1"/>
+          </a:fillRef>
+          <a:effectRef idx="2">
+            <a:schemeClr val="accent1"/>
+          </a:effectRef>
+          <a:fontRef idx="minor">
+            <a:schemeClr val="lt1"/>
+          </a:fontRef>
+        </p:style>
+        <p:txBody>
+          <a:bodyPr rtlCol="0" anchor="ctr"/>
+          <a:lstStyle/>
+          <a:p>
+            <a:pPr algn="ctr"/>
+          </a:p>
+        </p:txBody>
+      </p:sp>
+      <p:sp>
+        <p:nvSpPr>
+          <p:cNvPr id="6" name="Rectangle 5"/>
+          <p:cNvSpPr/>
+          <p:nvPr/>
+        </p:nvSpPr>
+        <p:spPr>
+          <a:xfrm>
+            <a:off x="4600000" y="0"/>
+            <a:ext cx="70000" cy="6858000"/>
+          </a:xfrm>
+          <a:prstGeom prst="rect">
+            <a:avLst/>
+          </a:prstGeom>
+          <a:solidFill>
+            <a:srgbClr val="C88A2E"/>
+          </a:solidFill>
+          <a:ln>
+            <a:noFill/>
+          </a:ln>
+          <a:effectLst/>
+        </p:spPr>
+        <p:style>
+          <a:lnRef idx="1">
+            <a:schemeClr val="accent1"/>
+          </a:lnRef>
+          <a:fillRef idx="3">
+            <a:schemeClr val="accent1"/>
+          </a:fillRef>
+          <a:effectRef idx="2">
+            <a:schemeClr val="accent1"/>
+          </a:effectRef>
+          <a:fontRef idx="minor">
+            <a:schemeClr val="lt1"/>
+          </a:fontRef>
+        </p:style>
+        <p:txBody>
+          <a:bodyPr rtlCol="0" anchor="ctr"/>
+          <a:lstStyle/>
+          <a:p>
+            <a:pPr algn="ctr"/>
+          </a:p>
+        </p:txBody>
+      </p:sp>
+      <p:sp>
+        <p:nvSpPr>
+          <p:cNvPr id="7" name="Rounded Rectangle 6"/>
+          <p:cNvSpPr/>
+          <p:nvPr/>
+        </p:nvSpPr>
+        <p:spPr>
+          <a:xfrm>
+            <a:off x="650000" y="620000"/>
+            <a:ext cx="3300000" cy="1150000"/>
+          </a:xfrm>
+          <a:prstGeom prst="roundRect">
+            <a:avLst/>
+          </a:prstGeom>
+          <a:solidFill>
+            <a:srgbClr val="FFFFFF"/>
+          </a:solidFill>
+          <a:ln>
+            <a:noFill/>
+          </a:ln>
+          <a:effectLst/>
+        </p:spPr>
+        <p:style>
+          <a:lnRef idx="1">
+            <a:schemeClr val="accent1"/>
+          </a:lnRef>
+          <a:fillRef idx="3">
+            <a:schemeClr val="accent1"/>
+          </a:fillRef>
+          <a:effectRef idx="2">
+            <a:schemeClr val="accent1"/>
+          </a:effectRef>
+          <a:fontRef idx="minor">
+            <a:schemeClr val="lt1"/>
+          </a:fontRef>
+        </p:style>
+        <p:txBody>
+          <a:bodyPr rtlCol="0" anchor="ctr"/>
+          <a:lstStyle/>
+          <a:p>
+            <a:pPr algn="ctr"/>
+          </a:p>
+        </p:txBody>
+      </p:sp>
       <p:pic>
         <p:nvPicPr>
-          <p:cNvPr id="5" name="Picture 4" descr="swash_pale.png"/>
+          <p:cNvPr id="8" name="Picture 7" descr="iuh_logo.png"/>
           <p:cNvPicPr>
             <a:picLocks noChangeAspect="1"/>
           </p:cNvPicPr>
           <p:nvPr/>
         </p:nvPicPr>
         <p:blipFill>
-          <a:blip r:embed="rId3">
+          <a:blip r:embed="rId4"/>
+          <a:stretch>
+            <a:fillRect/>
+          </a:stretch>
+        </p:blipFill>
+        <p:spPr>
+          <a:xfrm>
+            <a:off x="875000" y="789000"/>
+            <a:ext cx="2850000" cy="812250"/>
+          </a:xfrm>
+          <a:prstGeom prst="rect">
+            <a:avLst/>
+          </a:prstGeom>
+        </p:spPr>
+      </p:pic>
+      <p:sp>
+        <p:nvSpPr>
+          <p:cNvPr id="9" name="TextBox 8"/>
+          <p:cNvSpPr txBox="1"/>
+          <p:nvPr/>
+        </p:nvSpPr>
+        <p:spPr>
+          <a:xfrm>
+            <a:off x="300000" y="1990000"/>
+            <a:ext cx="4000000" cy="980000"/>
+          </a:xfrm>
+          <a:prstGeom prst="rect">
+            <a:avLst/>
+          </a:prstGeom>
+          <a:noFill/>
+        </p:spPr>
+        <p:txBody>
+          <a:bodyPr wrap="square" lIns="50000" rIns="50000" tIns="20000" bIns="20000">
+            <a:spAutoFit/>
+          </a:bodyPr>
+          <a:lstStyle/>
+          <a:p>
+            <a:pPr algn="ctr"/>
+            <a:r>
+              <a:rPr sz="1600" b="1" i="0">
+                <a:solidFill>
+                  <a:srgbClr val="FFFFFF"/>
+                </a:solidFill>
+              </a:rPr>
+              <a:t>TRƯỜNG ĐẠI HỌC CÔNG NGHIỆP</a:t>
+            </a:r>
+          </a:p>
+          <a:p>
+            <a:pPr algn="ctr"/>
+            <a:r>
+              <a:rPr sz="1600" b="1" i="0">
+                <a:solidFill>
+                  <a:srgbClr val="FFFFFF"/>
+                </a:solidFill>
+              </a:rPr>
+              <a:t>TP. HỒ CHÍ MINH</a:t>
+            </a:r>
+          </a:p>
+          <a:p>
+            <a:pPr algn="ctr"/>
+            <a:r>
+              <a:rPr sz="1400" b="1" i="0">
+                <a:solidFill>
+                  <a:srgbClr val="CFE2D8"/>
+                </a:solidFill>
+              </a:rPr>
+              <a:t>KHOA CÔNG NGHỆ HÓA HỌC</a:t>
+            </a:r>
+          </a:p>
+        </p:txBody>
+      </p:sp>
+      <p:sp>
+        <p:nvSpPr>
+          <p:cNvPr id="10" name="Rectangle 9"/>
+          <p:cNvSpPr/>
+          <p:nvPr/>
+        </p:nvSpPr>
+        <p:spPr>
+          <a:xfrm>
+            <a:off x="1850000" y="3080000"/>
+            <a:ext cx="900000" cy="24000"/>
+          </a:xfrm>
+          <a:prstGeom prst="rect">
+            <a:avLst/>
+          </a:prstGeom>
+          <a:solidFill>
+            <a:srgbClr val="C88A2E"/>
+          </a:solidFill>
+          <a:ln>
+            <a:noFill/>
+          </a:ln>
+          <a:effectLst/>
+        </p:spPr>
+        <p:style>
+          <a:lnRef idx="1">
+            <a:schemeClr val="accent1"/>
+          </a:lnRef>
+          <a:fillRef idx="3">
+            <a:schemeClr val="accent1"/>
+          </a:fillRef>
+          <a:effectRef idx="2">
+            <a:schemeClr val="accent1"/>
+          </a:effectRef>
+          <a:fontRef idx="minor">
+            <a:schemeClr val="lt1"/>
+          </a:fontRef>
+        </p:style>
+        <p:txBody>
+          <a:bodyPr rtlCol="0" anchor="ctr"/>
+          <a:lstStyle/>
+          <a:p>
+            <a:pPr algn="ctr"/>
+          </a:p>
+        </p:txBody>
+      </p:sp>
+      <p:sp>
+        <p:nvSpPr>
+          <p:cNvPr id="11" name="TextBox 10"/>
+          <p:cNvSpPr txBox="1"/>
+          <p:nvPr/>
+        </p:nvSpPr>
+        <p:spPr>
+          <a:xfrm>
+            <a:off x="300000" y="3200000"/>
+            <a:ext cx="4000000" cy="320000"/>
+          </a:xfrm>
+          <a:prstGeom prst="rect">
+            <a:avLst/>
+          </a:prstGeom>
+          <a:noFill/>
+        </p:spPr>
+        <p:txBody>
+          <a:bodyPr wrap="square" lIns="50000" rIns="50000" tIns="20000" bIns="20000">
+            <a:spAutoFit/>
+          </a:bodyPr>
+          <a:lstStyle/>
+          <a:p>
+            <a:pPr algn="ctr"/>
+            <a:r>
+              <a:rPr sz="1300" b="1" i="0">
+                <a:solidFill>
+                  <a:srgbClr val="CFE2D8"/>
+                </a:solidFill>
+              </a:rPr>
+              <a:t>ĐƠN VỊ THỰC TẬP</a:t>
+            </a:r>
+          </a:p>
+        </p:txBody>
+      </p:sp>
+      <p:sp>
+        <p:nvSpPr>
+          <p:cNvPr id="12" name="Rounded Rectangle 11"/>
+          <p:cNvSpPr/>
+          <p:nvPr/>
+        </p:nvSpPr>
+        <p:spPr>
+          <a:xfrm>
+            <a:off x="650000" y="3560000"/>
+            <a:ext cx="3300000" cy="1000000"/>
+          </a:xfrm>
+          <a:prstGeom prst="roundRect">
+            <a:avLst/>
+          </a:prstGeom>
+          <a:solidFill>
+            <a:srgbClr val="FFFFFF"/>
+          </a:solidFill>
+          <a:ln>
+            <a:noFill/>
+          </a:ln>
+          <a:effectLst/>
+        </p:spPr>
+        <p:style>
+          <a:lnRef idx="1">
+            <a:schemeClr val="accent1"/>
+          </a:lnRef>
+          <a:fillRef idx="3">
+            <a:schemeClr val="accent1"/>
+          </a:fillRef>
+          <a:effectRef idx="2">
+            <a:schemeClr val="accent1"/>
+          </a:effectRef>
+          <a:fontRef idx="minor">
+            <a:schemeClr val="lt1"/>
+          </a:fontRef>
+        </p:style>
+        <p:txBody>
+          <a:bodyPr rtlCol="0" anchor="ctr"/>
+          <a:lstStyle/>
+          <a:p>
+            <a:pPr algn="ctr"/>
+          </a:p>
+        </p:txBody>
+      </p:sp>
+      <p:pic>
+        <p:nvPicPr>
+          <p:cNvPr id="13" name="Picture 12" descr="shv_logo.png"/>
+          <p:cNvPicPr>
+            <a:picLocks noChangeAspect="1"/>
+          </p:cNvPicPr>
+          <p:nvPr/>
+        </p:nvPicPr>
+        <p:blipFill>
+          <a:blip r:embed="rId5"/>
+          <a:stretch>
+            <a:fillRect/>
+          </a:stretch>
+        </p:blipFill>
+        <p:spPr>
+          <a:xfrm>
+            <a:off x="1100000" y="3667000"/>
+            <a:ext cx="2400000" cy="786000"/>
+          </a:xfrm>
+          <a:prstGeom prst="rect">
+            <a:avLst/>
+          </a:prstGeom>
+        </p:spPr>
+      </p:pic>
+      <p:sp>
+        <p:nvSpPr>
+          <p:cNvPr id="14" name="TextBox 13"/>
+          <p:cNvSpPr txBox="1"/>
+          <p:nvPr/>
+        </p:nvSpPr>
+        <p:spPr>
+          <a:xfrm>
+            <a:off x="300000" y="4680000"/>
+            <a:ext cx="4000000" cy="350000"/>
+          </a:xfrm>
+          <a:prstGeom prst="rect">
+            <a:avLst/>
+          </a:prstGeom>
+          <a:noFill/>
+        </p:spPr>
+        <p:txBody>
+          <a:bodyPr wrap="square" lIns="50000" rIns="50000" tIns="20000" bIns="20000">
+            <a:spAutoFit/>
+          </a:bodyPr>
+          <a:lstStyle/>
+          <a:p>
+            <a:pPr algn="ctr"/>
+            <a:r>
+              <a:rPr sz="1500" b="1" i="0">
+                <a:solidFill>
+                  <a:srgbClr val="FFFFFF"/>
+                </a:solidFill>
+              </a:rPr>
+              <a:t>Công ty TNHH Sơn Hải Vân</a:t>
+            </a:r>
+          </a:p>
+        </p:txBody>
+      </p:sp>
+      <p:sp>
+        <p:nvSpPr>
+          <p:cNvPr id="15" name="TextBox 14"/>
+          <p:cNvSpPr txBox="1"/>
+          <p:nvPr/>
+        </p:nvSpPr>
+        <p:spPr>
+          <a:xfrm>
+            <a:off x="300000" y="6260000"/>
+            <a:ext cx="4000000" cy="320000"/>
+          </a:xfrm>
+          <a:prstGeom prst="rect">
+            <a:avLst/>
+          </a:prstGeom>
+          <a:noFill/>
+        </p:spPr>
+        <p:txBody>
+          <a:bodyPr wrap="square" lIns="50000" rIns="50000" tIns="20000" bIns="20000">
+            <a:spAutoFit/>
+          </a:bodyPr>
+          <a:lstStyle/>
+          <a:p>
+            <a:pPr algn="ctr"/>
+            <a:r>
+              <a:rPr sz="1300" b="0" i="1">
+                <a:solidFill>
+                  <a:srgbClr val="CFE2D8"/>
+                </a:solidFill>
+              </a:rPr>
+              <a:t>TP. Hồ Chí Minh — 2026</a:t>
+            </a:r>
+          </a:p>
+        </p:txBody>
+      </p:sp>
+      <p:sp>
+        <p:nvSpPr>
+          <p:cNvPr id="16" name="TextBox 15"/>
+          <p:cNvSpPr txBox="1"/>
+          <p:nvPr/>
+        </p:nvSpPr>
+        <p:spPr>
+          <a:xfrm>
+            <a:off x="5150000" y="1150000"/>
+            <a:ext cx="6300000" cy="400000"/>
+          </a:xfrm>
+          <a:prstGeom prst="rect">
+            <a:avLst/>
+          </a:prstGeom>
+          <a:noFill/>
+        </p:spPr>
+        <p:txBody>
+          <a:bodyPr wrap="square" lIns="50000" rIns="50000" tIns="20000" bIns="20000">
+            <a:spAutoFit/>
+          </a:bodyPr>
+          <a:lstStyle/>
+          <a:p>
+            <a:r>
+              <a:rPr sz="1700" b="1" i="0">
+                <a:solidFill>
+                  <a:srgbClr val="C88A2E"/>
+                </a:solidFill>
+              </a:rPr>
+              <a:t>BÁO CÁO THỰC TẬP TỐT NGHIỆP</a:t>
+            </a:r>
+          </a:p>
+        </p:txBody>
+      </p:sp>
+      <p:sp>
+        <p:nvSpPr>
+          <p:cNvPr id="17" name="TextBox 16"/>
+          <p:cNvSpPr txBox="1"/>
+          <p:nvPr/>
+        </p:nvSpPr>
+        <p:spPr>
+          <a:xfrm>
+            <a:off x="5150000" y="1620000"/>
+            <a:ext cx="6500000" cy="1500000"/>
+          </a:xfrm>
+          <a:prstGeom prst="rect">
+            <a:avLst/>
+          </a:prstGeom>
+          <a:noFill/>
+        </p:spPr>
+        <p:txBody>
+          <a:bodyPr wrap="square" lIns="50000" rIns="50000" tIns="20000" bIns="20000">
+            <a:spAutoFit/>
+          </a:bodyPr>
+          <a:lstStyle/>
+          <a:p>
+            <a:r>
+              <a:rPr sz="3100" b="1" i="0">
+                <a:solidFill>
+                  <a:srgbClr val="1F4E3D"/>
+                </a:solidFill>
+              </a:rPr>
+              <a:t>Quy trình sản xuất &amp;</a:t>
+            </a:r>
+          </a:p>
+          <a:p>
+            <a:r>
+              <a:rPr sz="3100" b="1" i="0">
+                <a:solidFill>
+                  <a:srgbClr val="1F4E3D"/>
+                </a:solidFill>
+              </a:rPr>
+              <a:t>kiểm soát chất lượng sơn</a:t>
+            </a:r>
+          </a:p>
+        </p:txBody>
+      </p:sp>
+      <p:pic>
+        <p:nvPicPr>
+          <p:cNvPr id="18" name="Picture 17" descr="brush_amber.png"/>
+          <p:cNvPicPr>
+            <a:picLocks noChangeAspect="1"/>
+          </p:cNvPicPr>
+          <p:nvPr/>
+        </p:nvPicPr>
+        <p:blipFill>
+          <a:blip r:embed="rId6">
             <a:extLst>
               <a:ext uri="{96DAC541-7B7A-43D3-8B79-37D633B846F1}">
                 <ns2:svgBlip xmlns:ns2="http://schemas.microsoft.com/office/drawing/2016/SVG/main" r:embed="rId7"/>
@@ -3250,254 +3752,24 @@
         </p:blipFill>
         <p:spPr>
           <a:xfrm>
-            <a:off x="8841695" y="250000"/>
-            <a:ext cx="3400000" cy="1780000"/>
+            <a:off x="5190000" y="3170000"/>
+            <a:ext cx="1500000" cy="281000"/>
           </a:xfrm>
           <a:prstGeom prst="rect">
             <a:avLst/>
           </a:prstGeom>
         </p:spPr>
       </p:pic>
-      <p:pic>
-        <p:nvPicPr>
-          <p:cNvPr id="6" name="Picture 5" descr="swash_pale.png"/>
-          <p:cNvPicPr>
-            <a:picLocks noChangeAspect="1"/>
-          </p:cNvPicPr>
-          <p:nvPr/>
-        </p:nvPicPr>
-        <p:blipFill>
-          <a:blip r:embed="rId3">
-            <a:extLst>
-              <a:ext uri="{96DAC541-7B7A-43D3-8B79-37D633B846F1}">
-                <ns3:svgBlip xmlns:ns3="http://schemas.microsoft.com/office/drawing/2016/SVG/main" r:embed="rId7"/>
-              </a:ext>
-            </a:extLst>
-          </a:blip>
-          <a:stretch>
-            <a:fillRect/>
-          </a:stretch>
-        </p:blipFill>
-        <p:spPr>
-          <a:xfrm>
-            <a:off x="-560000" y="4808000"/>
-            <a:ext cx="3400000" cy="1780000"/>
-          </a:xfrm>
-          <a:prstGeom prst="rect">
-            <a:avLst/>
-          </a:prstGeom>
-        </p:spPr>
-      </p:pic>
-      <p:sp>
-        <p:nvSpPr>
-          <p:cNvPr id="7" name="Rectangle 6"/>
-          <p:cNvSpPr/>
-          <p:nvPr/>
-        </p:nvSpPr>
-        <p:spPr>
-          <a:xfrm>
-            <a:off x="0" y="0"/>
-            <a:ext cx="150000" cy="6858000"/>
-          </a:xfrm>
-          <a:prstGeom prst="rect">
-            <a:avLst/>
-          </a:prstGeom>
-          <a:solidFill>
-            <a:srgbClr val="1F4E3D"/>
-          </a:solidFill>
-          <a:ln>
-            <a:noFill/>
-          </a:ln>
-          <a:effectLst/>
-        </p:spPr>
-        <p:style>
-          <a:lnRef idx="1">
-            <a:schemeClr val="accent1"/>
-          </a:lnRef>
-          <a:fillRef idx="3">
-            <a:schemeClr val="accent1"/>
-          </a:fillRef>
-          <a:effectRef idx="2">
-            <a:schemeClr val="accent1"/>
-          </a:effectRef>
-          <a:fontRef idx="minor">
-            <a:schemeClr val="lt1"/>
-          </a:fontRef>
-        </p:style>
-        <p:txBody>
-          <a:bodyPr rtlCol="0" anchor="ctr"/>
-          <a:lstStyle/>
-          <a:p>
-            <a:pPr algn="ctr"/>
-          </a:p>
-        </p:txBody>
-      </p:sp>
-      <p:sp>
-        <p:nvSpPr>
-          <p:cNvPr id="8" name="Rectangle 7"/>
-          <p:cNvSpPr/>
-          <p:nvPr/>
-        </p:nvSpPr>
-        <p:spPr>
-          <a:xfrm>
-            <a:off x="12041695" y="0"/>
-            <a:ext cx="150000" cy="6858000"/>
-          </a:xfrm>
-          <a:prstGeom prst="rect">
-            <a:avLst/>
-          </a:prstGeom>
-          <a:solidFill>
-            <a:srgbClr val="1F4E3D"/>
-          </a:solidFill>
-          <a:ln>
-            <a:noFill/>
-          </a:ln>
-          <a:effectLst/>
-        </p:spPr>
-        <p:style>
-          <a:lnRef idx="1">
-            <a:schemeClr val="accent1"/>
-          </a:lnRef>
-          <a:fillRef idx="3">
-            <a:schemeClr val="accent1"/>
-          </a:fillRef>
-          <a:effectRef idx="2">
-            <a:schemeClr val="accent1"/>
-          </a:effectRef>
-          <a:fontRef idx="minor">
-            <a:schemeClr val="lt1"/>
-          </a:fontRef>
-        </p:style>
-        <p:txBody>
-          <a:bodyPr rtlCol="0" anchor="ctr"/>
-          <a:lstStyle/>
-          <a:p>
-            <a:pPr algn="ctr"/>
-          </a:p>
-        </p:txBody>
-      </p:sp>
-      <p:sp>
-        <p:nvSpPr>
-          <p:cNvPr id="9" name="Rectangle 8"/>
-          <p:cNvSpPr/>
-          <p:nvPr/>
-        </p:nvSpPr>
-        <p:spPr>
-          <a:xfrm>
-            <a:off x="0" y="0"/>
-            <a:ext cx="12191695" cy="92000"/>
-          </a:xfrm>
-          <a:prstGeom prst="rect">
-            <a:avLst/>
-          </a:prstGeom>
-          <a:solidFill>
-            <a:srgbClr val="1F4E3D"/>
-          </a:solidFill>
-          <a:ln>
-            <a:noFill/>
-          </a:ln>
-          <a:effectLst/>
-        </p:spPr>
-        <p:style>
-          <a:lnRef idx="1">
-            <a:schemeClr val="accent1"/>
-          </a:lnRef>
-          <a:fillRef idx="3">
-            <a:schemeClr val="accent1"/>
-          </a:fillRef>
-          <a:effectRef idx="2">
-            <a:schemeClr val="accent1"/>
-          </a:effectRef>
-          <a:fontRef idx="minor">
-            <a:schemeClr val="lt1"/>
-          </a:fontRef>
-        </p:style>
-        <p:txBody>
-          <a:bodyPr rtlCol="0" anchor="ctr"/>
-          <a:lstStyle/>
-          <a:p>
-            <a:pPr algn="ctr"/>
-          </a:p>
-        </p:txBody>
-      </p:sp>
-      <p:sp>
-        <p:nvSpPr>
-          <p:cNvPr id="10" name="Rectangle 9"/>
-          <p:cNvSpPr/>
-          <p:nvPr/>
-        </p:nvSpPr>
-        <p:spPr>
-          <a:xfrm>
-            <a:off x="0" y="6766000"/>
-            <a:ext cx="12191695" cy="92000"/>
-          </a:xfrm>
-          <a:prstGeom prst="rect">
-            <a:avLst/>
-          </a:prstGeom>
-          <a:solidFill>
-            <a:srgbClr val="1F4E3D"/>
-          </a:solidFill>
-          <a:ln>
-            <a:noFill/>
-          </a:ln>
-          <a:effectLst/>
-        </p:spPr>
-        <p:style>
-          <a:lnRef idx="1">
-            <a:schemeClr val="accent1"/>
-          </a:lnRef>
-          <a:fillRef idx="3">
-            <a:schemeClr val="accent1"/>
-          </a:fillRef>
-          <a:effectRef idx="2">
-            <a:schemeClr val="accent1"/>
-          </a:effectRef>
-          <a:fontRef idx="minor">
-            <a:schemeClr val="lt1"/>
-          </a:fontRef>
-        </p:style>
-        <p:txBody>
-          <a:bodyPr rtlCol="0" anchor="ctr"/>
-          <a:lstStyle/>
-          <a:p>
-            <a:pPr algn="ctr"/>
-          </a:p>
-        </p:txBody>
-      </p:sp>
-      <p:pic>
-        <p:nvPicPr>
-          <p:cNvPr id="11" name="Picture 10" descr="iuh_logo.png"/>
-          <p:cNvPicPr>
-            <a:picLocks noChangeAspect="1"/>
-          </p:cNvPicPr>
-          <p:nvPr/>
-        </p:nvPicPr>
-        <p:blipFill>
-          <a:blip r:embed="rId4"/>
-          <a:stretch>
-            <a:fillRect/>
-          </a:stretch>
-        </p:blipFill>
-        <p:spPr>
-          <a:xfrm>
-            <a:off x="4070847" y="380000"/>
-            <a:ext cx="4050000" cy="1154250"/>
-          </a:xfrm>
-          <a:prstGeom prst="rect">
-            <a:avLst/>
-          </a:prstGeom>
-        </p:spPr>
-      </p:pic>
-      <p:sp>
-        <p:nvSpPr>
-          <p:cNvPr id="12" name="TextBox 11"/>
+      <p:sp>
+        <p:nvSpPr>
+          <p:cNvPr id="19" name="TextBox 18"/>
           <p:cNvSpPr txBox="1"/>
           <p:nvPr/>
         </p:nvSpPr>
         <p:spPr>
           <a:xfrm>
-            <a:off x="900000" y="1660000"/>
-            <a:ext cx="10391695" cy="720000"/>
+            <a:off x="5150000" y="3620000"/>
+            <a:ext cx="6300000" cy="420000"/>
           </a:xfrm>
           <a:prstGeom prst="rect">
             <a:avLst/>
@@ -3510,39 +3782,27 @@
           </a:bodyPr>
           <a:lstStyle/>
           <a:p>
-            <a:pPr algn="ctr"/>
-            <a:r>
-              <a:rPr sz="1800" b="1" i="0">
-                <a:solidFill>
-                  <a:srgbClr val="1F4E3D"/>
-                </a:solidFill>
-              </a:rPr>
-              <a:t>TRƯỜNG ĐẠI HỌC CÔNG NGHIỆP TP. HỒ CHÍ MINH</a:t>
-            </a:r>
-          </a:p>
-          <a:p>
-            <a:pPr algn="ctr"/>
-            <a:r>
-              <a:rPr sz="1500" b="1" i="0">
-                <a:solidFill>
-                  <a:srgbClr val="5B6E66"/>
-                </a:solidFill>
-              </a:rPr>
-              <a:t>KHOA CÔNG NGHỆ HÓA HỌC</a:t>
-            </a:r>
-          </a:p>
-        </p:txBody>
-      </p:sp>
-      <p:sp>
-        <p:nvSpPr>
-          <p:cNvPr id="13" name="Rectangle 12"/>
+            <a:r>
+              <a:rPr sz="2100" b="1" i="0">
+                <a:solidFill>
+                  <a:srgbClr val="2C7A5A"/>
+                </a:solidFill>
+              </a:rPr>
+              <a:t>tại Công ty TNHH Sơn Hải Vân</a:t>
+            </a:r>
+          </a:p>
+        </p:txBody>
+      </p:sp>
+      <p:sp>
+        <p:nvSpPr>
+          <p:cNvPr id="20" name="Rectangle 19"/>
           <p:cNvSpPr/>
           <p:nvPr/>
         </p:nvSpPr>
         <p:spPr>
           <a:xfrm>
-            <a:off x="5195847" y="2410000"/>
-            <a:ext cx="1800000" cy="26000"/>
+            <a:off x="5150000" y="4430000"/>
+            <a:ext cx="50000" cy="1360000"/>
           </a:xfrm>
           <a:prstGeom prst="rect">
             <a:avLst/>
@@ -3579,14 +3839,14 @@
       </p:sp>
       <p:sp>
         <p:nvSpPr>
-          <p:cNvPr id="14" name="TextBox 13"/>
+          <p:cNvPr id="21" name="TextBox 20"/>
           <p:cNvSpPr txBox="1"/>
           <p:nvPr/>
         </p:nvSpPr>
         <p:spPr>
           <a:xfrm>
-            <a:off x="900000" y="2520000"/>
-            <a:ext cx="10391695" cy="360000"/>
+            <a:off x="5410000" y="4430000"/>
+            <a:ext cx="6200000" cy="1450000"/>
           </a:xfrm>
           <a:prstGeom prst="rect">
             <a:avLst/>
@@ -3599,173 +3859,75 @@
           </a:bodyPr>
           <a:lstStyle/>
           <a:p>
-            <a:pPr algn="ctr"/>
             <a:r>
               <a:rPr sz="1600" b="1" i="0">
                 <a:solidFill>
-                  <a:srgbClr val="C88A2E"/>
-                </a:solidFill>
-              </a:rPr>
-              <a:t>BÁO CÁO THỰC TẬP TỐT NGHIỆP</a:t>
-            </a:r>
-          </a:p>
-        </p:txBody>
-      </p:sp>
-      <p:sp>
-        <p:nvSpPr>
-          <p:cNvPr id="15" name="TextBox 14"/>
-          <p:cNvSpPr txBox="1"/>
-          <p:nvPr/>
-        </p:nvSpPr>
-        <p:spPr>
-          <a:xfrm>
-            <a:off x="800000" y="2880000"/>
-            <a:ext cx="10591695" cy="1120000"/>
-          </a:xfrm>
-          <a:prstGeom prst="rect">
-            <a:avLst/>
-          </a:prstGeom>
-          <a:noFill/>
-        </p:spPr>
-        <p:txBody>
-          <a:bodyPr wrap="square" lIns="50000" rIns="50000" tIns="20000" bIns="20000">
-            <a:spAutoFit/>
-          </a:bodyPr>
-          <a:lstStyle/>
-          <a:p>
-            <a:pPr algn="ctr"/>
-            <a:r>
-              <a:rPr sz="3100" b="1" i="0">
-                <a:solidFill>
                   <a:srgbClr val="1F4E3D"/>
                 </a:solidFill>
               </a:rPr>
-              <a:t>Quy trình sản xuất &amp; kiểm soát</a:t>
-            </a:r>
-          </a:p>
-          <a:p>
-            <a:pPr algn="ctr"/>
-            <a:r>
-              <a:rPr sz="3100" b="1" i="0">
+              <a:t>GVHD:  </a:t>
+            </a:r>
+            <a:r>
+              <a:rPr sz="1600" b="0" i="0">
+                <a:solidFill>
+                  <a:srgbClr val="14332A"/>
+                </a:solidFill>
+              </a:rPr>
+              <a:t>Lê Nhất Thống</a:t>
+            </a:r>
+          </a:p>
+          <a:p>
+            <a:r>
+              <a:rPr sz="1600" b="1" i="0">
                 <a:solidFill>
                   <a:srgbClr val="1F4E3D"/>
                 </a:solidFill>
               </a:rPr>
-              <a:t>chất lượng sơn</a:t>
-            </a:r>
-          </a:p>
-        </p:txBody>
-      </p:sp>
-      <p:sp>
-        <p:nvSpPr>
-          <p:cNvPr id="16" name="TextBox 15"/>
-          <p:cNvSpPr txBox="1"/>
-          <p:nvPr/>
-        </p:nvSpPr>
-        <p:spPr>
-          <a:xfrm>
-            <a:off x="800000" y="4080000"/>
-            <a:ext cx="10591695" cy="400000"/>
-          </a:xfrm>
-          <a:prstGeom prst="rect">
-            <a:avLst/>
-          </a:prstGeom>
-          <a:noFill/>
-        </p:spPr>
-        <p:txBody>
-          <a:bodyPr wrap="square" lIns="50000" rIns="50000" tIns="20000" bIns="20000">
-            <a:spAutoFit/>
-          </a:bodyPr>
-          <a:lstStyle/>
-          <a:p>
-            <a:pPr algn="ctr"/>
-            <a:r>
-              <a:rPr sz="2200" b="1" i="0">
-                <a:solidFill>
-                  <a:srgbClr val="2C7A5A"/>
-                </a:solidFill>
-              </a:rPr>
-              <a:t>tại Công ty TNHH Sơn Hải Vân</a:t>
-            </a:r>
-          </a:p>
-        </p:txBody>
-      </p:sp>
-      <p:pic>
-        <p:nvPicPr>
-          <p:cNvPr id="17" name="Picture 16" descr="shv_logo.png"/>
-          <p:cNvPicPr>
-            <a:picLocks noChangeAspect="1"/>
-          </p:cNvPicPr>
-          <p:nvPr/>
-        </p:nvPicPr>
-        <p:blipFill>
-          <a:blip r:embed="rId5"/>
-          <a:stretch>
-            <a:fillRect/>
-          </a:stretch>
-        </p:blipFill>
-        <p:spPr>
-          <a:xfrm>
-            <a:off x="4870847" y="4560000"/>
-            <a:ext cx="2450000" cy="802375"/>
-          </a:xfrm>
-          <a:prstGeom prst="rect">
-            <a:avLst/>
-          </a:prstGeom>
-        </p:spPr>
-      </p:pic>
-      <p:sp>
-        <p:nvSpPr>
-          <p:cNvPr id="18" name="TextBox 17"/>
-          <p:cNvSpPr txBox="1"/>
-          <p:nvPr/>
-        </p:nvSpPr>
-        <p:spPr>
-          <a:xfrm>
-            <a:off x="900000" y="5560000"/>
-            <a:ext cx="10391695" cy="760000"/>
-          </a:xfrm>
-          <a:prstGeom prst="rect">
-            <a:avLst/>
-          </a:prstGeom>
-          <a:noFill/>
-        </p:spPr>
-        <p:txBody>
-          <a:bodyPr wrap="square" lIns="50000" rIns="50000" tIns="20000" bIns="20000">
-            <a:spAutoFit/>
-          </a:bodyPr>
-          <a:lstStyle/>
-          <a:p>
-            <a:pPr algn="ctr"/>
+              <a:t>CBHD:  </a:t>
+            </a:r>
             <a:r>
               <a:rPr sz="1600" b="0" i="0">
                 <a:solidFill>
                   <a:srgbClr val="14332A"/>
                 </a:solidFill>
               </a:rPr>
-              <a:t>GVHD: Lê Nhất Thống        CBHD: Lê Quốc</a:t>
-            </a:r>
-          </a:p>
-          <a:p>
-            <a:pPr algn="ctr"/>
+              <a:t>Lê Quốc</a:t>
+            </a:r>
+          </a:p>
+          <a:p>
+            <a:r>
+              <a:rPr sz="1600" b="1" i="0">
+                <a:solidFill>
+                  <a:srgbClr val="1F4E3D"/>
+                </a:solidFill>
+              </a:rPr>
+              <a:t>Thực hiện:  </a:t>
+            </a:r>
             <a:r>
               <a:rPr sz="1600" b="0" i="0">
                 <a:solidFill>
                   <a:srgbClr val="14332A"/>
                 </a:solidFill>
               </a:rPr>
-              <a:t>Nhóm 8 SV thực tập  ·  Lớp DHHO18A–D  ·  Năm học 2025–2026</a:t>
-            </a:r>
-          </a:p>
-          <a:p>
-            <a:pPr algn="ctr"/>
-            <a:r>
-              <a:rPr sz="1400" b="0" i="1">
-                <a:solidFill>
-                  <a:srgbClr val="5B6E66"/>
-                </a:solidFill>
-              </a:rPr>
-              <a:t>TP. Hồ Chí Minh — 2026</a:t>
+              <a:t>Nhóm 8 SV thực tập · Lớp DHHO18A–D</a:t>
+            </a:r>
+          </a:p>
+          <a:p>
+            <a:r>
+              <a:rPr sz="1600" b="1" i="0">
+                <a:solidFill>
+                  <a:srgbClr val="1F4E3D"/>
+                </a:solidFill>
+              </a:rPr>
+              <a:t>Năm học:  </a:t>
+            </a:r>
+            <a:r>
+              <a:rPr sz="1600" b="0" i="0">
+                <a:solidFill>
+                  <a:srgbClr val="14332A"/>
+                </a:solidFill>
+              </a:rPr>
+              <a:t>2025–2026</a:t>
             </a:r>
           </a:p>
         </p:txBody>

</xml_diff>

<commit_message>
Redesign agenda slide as a polymer-chain infographic
Replace the plain 3x2 card grid on the contents slide with a chemistry-
themed polymer chain: six hexagon "benzene rings" (gradient green, white
inner stroke, section icon inside) bonded in a zigzag sequence with
electron-dot links, amber numbered vertices, and section labels
alternating above/below the chain.

Adds gen_agenda.py and refreshes the exported PPTX/PDF.

Co-Authored-By: Claude Opus 4.8 <noreply@anthropic.com>
Claude-Session: https://claude.ai/code/session_01PbbxSyJEYscgmQfTL8vaUX
</commit_message>
<xml_diff>
--- a/SuHeo/Báo cáo thực tập - Sơn Hải Vân.pptx
+++ b/SuHeo/Báo cáo thực tập - Sơn Hải Vân.pptx
@@ -18365,7 +18365,7 @@
           <a:blip r:embed="rId2">
             <a:extLst>
               <a:ext uri="{96DAC541-7B7A-43D3-8B79-37D633B846F1}">
-                <ns0:svgBlip xmlns:ns0="http://schemas.microsoft.com/office/drawing/2016/SVG/main" r:embed="rId14"/>
+                <ns0:svgBlip xmlns:ns0="http://schemas.microsoft.com/office/drawing/2016/SVG/main" r:embed="rId8"/>
               </a:ext>
             </a:extLst>
           </a:blip>
@@ -18395,7 +18395,7 @@
           <a:blip r:embed="rId3">
             <a:extLst>
               <a:ext uri="{96DAC541-7B7A-43D3-8B79-37D633B846F1}">
-                <ns1:svgBlip xmlns:ns1="http://schemas.microsoft.com/office/drawing/2016/SVG/main" r:embed="rId18"/>
+                <ns1:svgBlip xmlns:ns1="http://schemas.microsoft.com/office/drawing/2016/SVG/main" r:embed="rId9"/>
               </a:ext>
             </a:extLst>
           </a:blip>
@@ -18799,7 +18799,7 @@
           <a:blip r:embed="rId4">
             <a:extLst>
               <a:ext uri="{96DAC541-7B7A-43D3-8B79-37D633B846F1}">
-                <ns2:svgBlip xmlns:ns2="http://schemas.microsoft.com/office/drawing/2016/SVG/main" r:embed="rId11"/>
+                <ns2:svgBlip xmlns:ns2="http://schemas.microsoft.com/office/drawing/2016/SVG/main" r:embed="rId7"/>
               </a:ext>
             </a:extLst>
           </a:blip>
@@ -18928,141 +18928,9 @@
           </a:p>
         </p:txBody>
       </p:sp>
-      <p:sp>
-        <p:nvSpPr>
-          <p:cNvPr id="18" name="Rounded Rectangle 17"/>
-          <p:cNvSpPr/>
-          <p:nvPr/>
-        </p:nvSpPr>
-        <p:spPr>
-          <a:xfrm>
-            <a:off x="548640" y="1830000"/>
-            <a:ext cx="3510000" cy="2100000"/>
-          </a:xfrm>
-          <a:prstGeom prst="roundRect">
-            <a:avLst/>
-          </a:prstGeom>
-          <a:solidFill>
-            <a:srgbClr val="EEF4F0"/>
-          </a:solidFill>
-          <a:ln>
-            <a:noFill/>
-          </a:ln>
-          <a:effectLst/>
-        </p:spPr>
-        <p:style>
-          <a:lnRef idx="1">
-            <a:schemeClr val="accent1"/>
-          </a:lnRef>
-          <a:fillRef idx="3">
-            <a:schemeClr val="accent1"/>
-          </a:fillRef>
-          <a:effectRef idx="2">
-            <a:schemeClr val="accent1"/>
-          </a:effectRef>
-          <a:fontRef idx="minor">
-            <a:schemeClr val="lt1"/>
-          </a:fontRef>
-        </p:style>
-        <p:txBody>
-          <a:bodyPr rtlCol="0" anchor="ctr"/>
-          <a:lstStyle/>
-          <a:p>
-            <a:pPr algn="ctr"/>
-          </a:p>
-        </p:txBody>
-      </p:sp>
-      <p:sp>
-        <p:nvSpPr>
-          <p:cNvPr id="19" name="Rounded Rectangle 18"/>
-          <p:cNvSpPr/>
-          <p:nvPr/>
-        </p:nvSpPr>
-        <p:spPr>
-          <a:xfrm>
-            <a:off x="548640" y="1830000"/>
-            <a:ext cx="3510000" cy="70000"/>
-          </a:xfrm>
-          <a:prstGeom prst="roundRect">
-            <a:avLst/>
-          </a:prstGeom>
-          <a:solidFill>
-            <a:srgbClr val="2C7A5A"/>
-          </a:solidFill>
-          <a:ln>
-            <a:noFill/>
-          </a:ln>
-          <a:effectLst/>
-        </p:spPr>
-        <p:style>
-          <a:lnRef idx="1">
-            <a:schemeClr val="accent1"/>
-          </a:lnRef>
-          <a:fillRef idx="3">
-            <a:schemeClr val="accent1"/>
-          </a:fillRef>
-          <a:effectRef idx="2">
-            <a:schemeClr val="accent1"/>
-          </a:effectRef>
-          <a:fontRef idx="minor">
-            <a:schemeClr val="lt1"/>
-          </a:fontRef>
-        </p:style>
-        <p:txBody>
-          <a:bodyPr rtlCol="0" anchor="ctr"/>
-          <a:lstStyle/>
-          <a:p>
-            <a:pPr algn="ctr"/>
-          </a:p>
-        </p:txBody>
-      </p:sp>
-      <p:sp>
-        <p:nvSpPr>
-          <p:cNvPr id="20" name="Oval 19"/>
-          <p:cNvSpPr/>
-          <p:nvPr/>
-        </p:nvSpPr>
-        <p:spPr>
-          <a:xfrm>
-            <a:off x="1893640" y="2060000"/>
-            <a:ext cx="820000" cy="820000"/>
-          </a:xfrm>
-          <a:prstGeom prst="ellipse">
-            <a:avLst/>
-          </a:prstGeom>
-          <a:solidFill>
-            <a:srgbClr val="1F4E3D"/>
-          </a:solidFill>
-          <a:ln>
-            <a:noFill/>
-          </a:ln>
-          <a:effectLst/>
-        </p:spPr>
-        <p:style>
-          <a:lnRef idx="1">
-            <a:schemeClr val="accent1"/>
-          </a:lnRef>
-          <a:fillRef idx="3">
-            <a:schemeClr val="accent1"/>
-          </a:fillRef>
-          <a:effectRef idx="2">
-            <a:schemeClr val="accent1"/>
-          </a:effectRef>
-          <a:fontRef idx="minor">
-            <a:schemeClr val="lt1"/>
-          </a:fontRef>
-        </p:style>
-        <p:txBody>
-          <a:bodyPr rtlCol="0" anchor="ctr"/>
-          <a:lstStyle/>
-          <a:p>
-            <a:pPr algn="ctr"/>
-          </a:p>
-        </p:txBody>
-      </p:sp>
       <p:pic>
         <p:nvPicPr>
-          <p:cNvPr id="21" name="Picture 20" descr="company_w.png"/>
+          <p:cNvPr id="18" name="Picture 17" descr="big_agenda.png"/>
           <p:cNvPicPr>
             <a:picLocks noChangeAspect="1"/>
           </p:cNvPicPr>
@@ -19072,7 +18940,7 @@
           <a:blip r:embed="rId5">
             <a:extLst>
               <a:ext uri="{96DAC541-7B7A-43D3-8B79-37D633B846F1}">
-                <ns3:svgBlip xmlns:ns3="http://schemas.microsoft.com/office/drawing/2016/SVG/main" r:embed="rId12"/>
+                <ns3:svgBlip xmlns:ns3="http://schemas.microsoft.com/office/drawing/2016/SVG/main" r:embed="rId6"/>
               </a:ext>
             </a:extLst>
           </a:blip>
@@ -19082,1028 +18950,14 @@
         </p:blipFill>
         <p:spPr>
           <a:xfrm>
-            <a:off x="2057640" y="2224000"/>
-            <a:ext cx="492000" cy="492000"/>
+            <a:off x="550847" y="1939417"/>
+            <a:ext cx="11090000" cy="4251166"/>
           </a:xfrm>
           <a:prstGeom prst="rect">
             <a:avLst/>
           </a:prstGeom>
         </p:spPr>
       </p:pic>
-      <p:sp>
-        <p:nvSpPr>
-          <p:cNvPr id="22" name="TextBox 21"/>
-          <p:cNvSpPr txBox="1"/>
-          <p:nvPr/>
-        </p:nvSpPr>
-        <p:spPr>
-          <a:xfrm>
-            <a:off x="668640" y="2940000"/>
-            <a:ext cx="3270000" cy="920000"/>
-          </a:xfrm>
-          <a:prstGeom prst="rect">
-            <a:avLst/>
-          </a:prstGeom>
-          <a:noFill/>
-        </p:spPr>
-        <p:txBody>
-          <a:bodyPr wrap="square" lIns="50000" rIns="50000" tIns="20000" bIns="20000" anchor="t">
-            <a:spAutoFit/>
-          </a:bodyPr>
-          <a:lstStyle/>
-          <a:p>
-            <a:pPr algn="ctr"/>
-            <a:r>
-              <a:rPr sz="2000" b="1" i="0">
-                <a:solidFill>
-                  <a:srgbClr val="1F4E3D"/>
-                </a:solidFill>
-              </a:rPr>
-              <a:t>Tổng quan về công ty</a:t>
-            </a:r>
-          </a:p>
-        </p:txBody>
-      </p:sp>
-      <p:sp>
-        <p:nvSpPr>
-          <p:cNvPr id="23" name="Rounded Rectangle 22"/>
-          <p:cNvSpPr/>
-          <p:nvPr/>
-        </p:nvSpPr>
-        <p:spPr>
-          <a:xfrm>
-            <a:off x="4338640" y="1830000"/>
-            <a:ext cx="3510000" cy="2100000"/>
-          </a:xfrm>
-          <a:prstGeom prst="roundRect">
-            <a:avLst/>
-          </a:prstGeom>
-          <a:solidFill>
-            <a:srgbClr val="EEF4F0"/>
-          </a:solidFill>
-          <a:ln>
-            <a:noFill/>
-          </a:ln>
-          <a:effectLst/>
-        </p:spPr>
-        <p:style>
-          <a:lnRef idx="1">
-            <a:schemeClr val="accent1"/>
-          </a:lnRef>
-          <a:fillRef idx="3">
-            <a:schemeClr val="accent1"/>
-          </a:fillRef>
-          <a:effectRef idx="2">
-            <a:schemeClr val="accent1"/>
-          </a:effectRef>
-          <a:fontRef idx="minor">
-            <a:schemeClr val="lt1"/>
-          </a:fontRef>
-        </p:style>
-        <p:txBody>
-          <a:bodyPr rtlCol="0" anchor="ctr"/>
-          <a:lstStyle/>
-          <a:p>
-            <a:pPr algn="ctr"/>
-          </a:p>
-        </p:txBody>
-      </p:sp>
-      <p:sp>
-        <p:nvSpPr>
-          <p:cNvPr id="24" name="Rounded Rectangle 23"/>
-          <p:cNvSpPr/>
-          <p:nvPr/>
-        </p:nvSpPr>
-        <p:spPr>
-          <a:xfrm>
-            <a:off x="4338640" y="1830000"/>
-            <a:ext cx="3510000" cy="70000"/>
-          </a:xfrm>
-          <a:prstGeom prst="roundRect">
-            <a:avLst/>
-          </a:prstGeom>
-          <a:solidFill>
-            <a:srgbClr val="2C7A5A"/>
-          </a:solidFill>
-          <a:ln>
-            <a:noFill/>
-          </a:ln>
-          <a:effectLst/>
-        </p:spPr>
-        <p:style>
-          <a:lnRef idx="1">
-            <a:schemeClr val="accent1"/>
-          </a:lnRef>
-          <a:fillRef idx="3">
-            <a:schemeClr val="accent1"/>
-          </a:fillRef>
-          <a:effectRef idx="2">
-            <a:schemeClr val="accent1"/>
-          </a:effectRef>
-          <a:fontRef idx="minor">
-            <a:schemeClr val="lt1"/>
-          </a:fontRef>
-        </p:style>
-        <p:txBody>
-          <a:bodyPr rtlCol="0" anchor="ctr"/>
-          <a:lstStyle/>
-          <a:p>
-            <a:pPr algn="ctr"/>
-          </a:p>
-        </p:txBody>
-      </p:sp>
-      <p:sp>
-        <p:nvSpPr>
-          <p:cNvPr id="25" name="Oval 24"/>
-          <p:cNvSpPr/>
-          <p:nvPr/>
-        </p:nvSpPr>
-        <p:spPr>
-          <a:xfrm>
-            <a:off x="5683640" y="2060000"/>
-            <a:ext cx="820000" cy="820000"/>
-          </a:xfrm>
-          <a:prstGeom prst="ellipse">
-            <a:avLst/>
-          </a:prstGeom>
-          <a:solidFill>
-            <a:srgbClr val="1F4E3D"/>
-          </a:solidFill>
-          <a:ln>
-            <a:noFill/>
-          </a:ln>
-          <a:effectLst/>
-        </p:spPr>
-        <p:style>
-          <a:lnRef idx="1">
-            <a:schemeClr val="accent1"/>
-          </a:lnRef>
-          <a:fillRef idx="3">
-            <a:schemeClr val="accent1"/>
-          </a:fillRef>
-          <a:effectRef idx="2">
-            <a:schemeClr val="accent1"/>
-          </a:effectRef>
-          <a:fontRef idx="minor">
-            <a:schemeClr val="lt1"/>
-          </a:fontRef>
-        </p:style>
-        <p:txBody>
-          <a:bodyPr rtlCol="0" anchor="ctr"/>
-          <a:lstStyle/>
-          <a:p>
-            <a:pPr algn="ctr"/>
-          </a:p>
-        </p:txBody>
-      </p:sp>
-      <p:pic>
-        <p:nvPicPr>
-          <p:cNvPr id="26" name="Picture 25" descr="materials_w.png"/>
-          <p:cNvPicPr>
-            <a:picLocks noChangeAspect="1"/>
-          </p:cNvPicPr>
-          <p:nvPr/>
-        </p:nvPicPr>
-        <p:blipFill>
-          <a:blip r:embed="rId6">
-            <a:extLst>
-              <a:ext uri="{96DAC541-7B7A-43D3-8B79-37D633B846F1}">
-                <ns4:svgBlip xmlns:ns4="http://schemas.microsoft.com/office/drawing/2016/SVG/main" r:embed="rId15"/>
-              </a:ext>
-            </a:extLst>
-          </a:blip>
-          <a:stretch>
-            <a:fillRect/>
-          </a:stretch>
-        </p:blipFill>
-        <p:spPr>
-          <a:xfrm>
-            <a:off x="5847640" y="2224000"/>
-            <a:ext cx="492000" cy="492000"/>
-          </a:xfrm>
-          <a:prstGeom prst="rect">
-            <a:avLst/>
-          </a:prstGeom>
-        </p:spPr>
-      </p:pic>
-      <p:sp>
-        <p:nvSpPr>
-          <p:cNvPr id="27" name="TextBox 26"/>
-          <p:cNvSpPr txBox="1"/>
-          <p:nvPr/>
-        </p:nvSpPr>
-        <p:spPr>
-          <a:xfrm>
-            <a:off x="4458640" y="2940000"/>
-            <a:ext cx="3270000" cy="920000"/>
-          </a:xfrm>
-          <a:prstGeom prst="rect">
-            <a:avLst/>
-          </a:prstGeom>
-          <a:noFill/>
-        </p:spPr>
-        <p:txBody>
-          <a:bodyPr wrap="square" lIns="50000" rIns="50000" tIns="20000" bIns="20000" anchor="t">
-            <a:spAutoFit/>
-          </a:bodyPr>
-          <a:lstStyle/>
-          <a:p>
-            <a:pPr algn="ctr"/>
-            <a:r>
-              <a:rPr sz="2000" b="1" i="0">
-                <a:solidFill>
-                  <a:srgbClr val="1F4E3D"/>
-                </a:solidFill>
-              </a:rPr>
-              <a:t>Nguyên vật liệu</a:t>
-            </a:r>
-          </a:p>
-        </p:txBody>
-      </p:sp>
-      <p:sp>
-        <p:nvSpPr>
-          <p:cNvPr id="28" name="Rounded Rectangle 27"/>
-          <p:cNvSpPr/>
-          <p:nvPr/>
-        </p:nvSpPr>
-        <p:spPr>
-          <a:xfrm>
-            <a:off x="8128640" y="1830000"/>
-            <a:ext cx="3510000" cy="2100000"/>
-          </a:xfrm>
-          <a:prstGeom prst="roundRect">
-            <a:avLst/>
-          </a:prstGeom>
-          <a:solidFill>
-            <a:srgbClr val="EEF4F0"/>
-          </a:solidFill>
-          <a:ln>
-            <a:noFill/>
-          </a:ln>
-          <a:effectLst/>
-        </p:spPr>
-        <p:style>
-          <a:lnRef idx="1">
-            <a:schemeClr val="accent1"/>
-          </a:lnRef>
-          <a:fillRef idx="3">
-            <a:schemeClr val="accent1"/>
-          </a:fillRef>
-          <a:effectRef idx="2">
-            <a:schemeClr val="accent1"/>
-          </a:effectRef>
-          <a:fontRef idx="minor">
-            <a:schemeClr val="lt1"/>
-          </a:fontRef>
-        </p:style>
-        <p:txBody>
-          <a:bodyPr rtlCol="0" anchor="ctr"/>
-          <a:lstStyle/>
-          <a:p>
-            <a:pPr algn="ctr"/>
-          </a:p>
-        </p:txBody>
-      </p:sp>
-      <p:sp>
-        <p:nvSpPr>
-          <p:cNvPr id="29" name="Rounded Rectangle 28"/>
-          <p:cNvSpPr/>
-          <p:nvPr/>
-        </p:nvSpPr>
-        <p:spPr>
-          <a:xfrm>
-            <a:off x="8128640" y="1830000"/>
-            <a:ext cx="3510000" cy="70000"/>
-          </a:xfrm>
-          <a:prstGeom prst="roundRect">
-            <a:avLst/>
-          </a:prstGeom>
-          <a:solidFill>
-            <a:srgbClr val="2C7A5A"/>
-          </a:solidFill>
-          <a:ln>
-            <a:noFill/>
-          </a:ln>
-          <a:effectLst/>
-        </p:spPr>
-        <p:style>
-          <a:lnRef idx="1">
-            <a:schemeClr val="accent1"/>
-          </a:lnRef>
-          <a:fillRef idx="3">
-            <a:schemeClr val="accent1"/>
-          </a:fillRef>
-          <a:effectRef idx="2">
-            <a:schemeClr val="accent1"/>
-          </a:effectRef>
-          <a:fontRef idx="minor">
-            <a:schemeClr val="lt1"/>
-          </a:fontRef>
-        </p:style>
-        <p:txBody>
-          <a:bodyPr rtlCol="0" anchor="ctr"/>
-          <a:lstStyle/>
-          <a:p>
-            <a:pPr algn="ctr"/>
-          </a:p>
-        </p:txBody>
-      </p:sp>
-      <p:sp>
-        <p:nvSpPr>
-          <p:cNvPr id="30" name="Oval 29"/>
-          <p:cNvSpPr/>
-          <p:nvPr/>
-        </p:nvSpPr>
-        <p:spPr>
-          <a:xfrm>
-            <a:off x="9473640" y="2060000"/>
-            <a:ext cx="820000" cy="820000"/>
-          </a:xfrm>
-          <a:prstGeom prst="ellipse">
-            <a:avLst/>
-          </a:prstGeom>
-          <a:solidFill>
-            <a:srgbClr val="1F4E3D"/>
-          </a:solidFill>
-          <a:ln>
-            <a:noFill/>
-          </a:ln>
-          <a:effectLst/>
-        </p:spPr>
-        <p:style>
-          <a:lnRef idx="1">
-            <a:schemeClr val="accent1"/>
-          </a:lnRef>
-          <a:fillRef idx="3">
-            <a:schemeClr val="accent1"/>
-          </a:fillRef>
-          <a:effectRef idx="2">
-            <a:schemeClr val="accent1"/>
-          </a:effectRef>
-          <a:fontRef idx="minor">
-            <a:schemeClr val="lt1"/>
-          </a:fontRef>
-        </p:style>
-        <p:txBody>
-          <a:bodyPr rtlCol="0" anchor="ctr"/>
-          <a:lstStyle/>
-          <a:p>
-            <a:pPr algn="ctr"/>
-          </a:p>
-        </p:txBody>
-      </p:sp>
-      <p:pic>
-        <p:nvPicPr>
-          <p:cNvPr id="31" name="Picture 30" descr="gear_proc_w.png"/>
-          <p:cNvPicPr>
-            <a:picLocks noChangeAspect="1"/>
-          </p:cNvPicPr>
-          <p:nvPr/>
-        </p:nvPicPr>
-        <p:blipFill>
-          <a:blip r:embed="rId7">
-            <a:extLst>
-              <a:ext uri="{96DAC541-7B7A-43D3-8B79-37D633B846F1}">
-                <ns5:svgBlip xmlns:ns5="http://schemas.microsoft.com/office/drawing/2016/SVG/main" r:embed="rId13"/>
-              </a:ext>
-            </a:extLst>
-          </a:blip>
-          <a:stretch>
-            <a:fillRect/>
-          </a:stretch>
-        </p:blipFill>
-        <p:spPr>
-          <a:xfrm>
-            <a:off x="9637640" y="2224000"/>
-            <a:ext cx="492000" cy="492000"/>
-          </a:xfrm>
-          <a:prstGeom prst="rect">
-            <a:avLst/>
-          </a:prstGeom>
-        </p:spPr>
-      </p:pic>
-      <p:sp>
-        <p:nvSpPr>
-          <p:cNvPr id="32" name="TextBox 31"/>
-          <p:cNvSpPr txBox="1"/>
-          <p:nvPr/>
-        </p:nvSpPr>
-        <p:spPr>
-          <a:xfrm>
-            <a:off x="8248640" y="2940000"/>
-            <a:ext cx="3270000" cy="920000"/>
-          </a:xfrm>
-          <a:prstGeom prst="rect">
-            <a:avLst/>
-          </a:prstGeom>
-          <a:noFill/>
-        </p:spPr>
-        <p:txBody>
-          <a:bodyPr wrap="square" lIns="50000" rIns="50000" tIns="20000" bIns="20000" anchor="t">
-            <a:spAutoFit/>
-          </a:bodyPr>
-          <a:lstStyle/>
-          <a:p>
-            <a:pPr algn="ctr"/>
-            <a:r>
-              <a:rPr sz="2000" b="1" i="0">
-                <a:solidFill>
-                  <a:srgbClr val="1F4E3D"/>
-                </a:solidFill>
-              </a:rPr>
-              <a:t>Quy trình công nghệ &amp; thiết bị</a:t>
-            </a:r>
-          </a:p>
-        </p:txBody>
-      </p:sp>
-      <p:sp>
-        <p:nvSpPr>
-          <p:cNvPr id="33" name="Rounded Rectangle 32"/>
-          <p:cNvSpPr/>
-          <p:nvPr/>
-        </p:nvSpPr>
-        <p:spPr>
-          <a:xfrm>
-            <a:off x="548640" y="4200000"/>
-            <a:ext cx="3510000" cy="2100000"/>
-          </a:xfrm>
-          <a:prstGeom prst="roundRect">
-            <a:avLst/>
-          </a:prstGeom>
-          <a:solidFill>
-            <a:srgbClr val="EEF4F0"/>
-          </a:solidFill>
-          <a:ln>
-            <a:noFill/>
-          </a:ln>
-          <a:effectLst/>
-        </p:spPr>
-        <p:style>
-          <a:lnRef idx="1">
-            <a:schemeClr val="accent1"/>
-          </a:lnRef>
-          <a:fillRef idx="3">
-            <a:schemeClr val="accent1"/>
-          </a:fillRef>
-          <a:effectRef idx="2">
-            <a:schemeClr val="accent1"/>
-          </a:effectRef>
-          <a:fontRef idx="minor">
-            <a:schemeClr val="lt1"/>
-          </a:fontRef>
-        </p:style>
-        <p:txBody>
-          <a:bodyPr rtlCol="0" anchor="ctr"/>
-          <a:lstStyle/>
-          <a:p>
-            <a:pPr algn="ctr"/>
-          </a:p>
-        </p:txBody>
-      </p:sp>
-      <p:sp>
-        <p:nvSpPr>
-          <p:cNvPr id="34" name="Rounded Rectangle 33"/>
-          <p:cNvSpPr/>
-          <p:nvPr/>
-        </p:nvSpPr>
-        <p:spPr>
-          <a:xfrm>
-            <a:off x="548640" y="4200000"/>
-            <a:ext cx="3510000" cy="70000"/>
-          </a:xfrm>
-          <a:prstGeom prst="roundRect">
-            <a:avLst/>
-          </a:prstGeom>
-          <a:solidFill>
-            <a:srgbClr val="2C7A5A"/>
-          </a:solidFill>
-          <a:ln>
-            <a:noFill/>
-          </a:ln>
-          <a:effectLst/>
-        </p:spPr>
-        <p:style>
-          <a:lnRef idx="1">
-            <a:schemeClr val="accent1"/>
-          </a:lnRef>
-          <a:fillRef idx="3">
-            <a:schemeClr val="accent1"/>
-          </a:fillRef>
-          <a:effectRef idx="2">
-            <a:schemeClr val="accent1"/>
-          </a:effectRef>
-          <a:fontRef idx="minor">
-            <a:schemeClr val="lt1"/>
-          </a:fontRef>
-        </p:style>
-        <p:txBody>
-          <a:bodyPr rtlCol="0" anchor="ctr"/>
-          <a:lstStyle/>
-          <a:p>
-            <a:pPr algn="ctr"/>
-          </a:p>
-        </p:txBody>
-      </p:sp>
-      <p:sp>
-        <p:nvSpPr>
-          <p:cNvPr id="35" name="Oval 34"/>
-          <p:cNvSpPr/>
-          <p:nvPr/>
-        </p:nvSpPr>
-        <p:spPr>
-          <a:xfrm>
-            <a:off x="1893640" y="4430000"/>
-            <a:ext cx="820000" cy="820000"/>
-          </a:xfrm>
-          <a:prstGeom prst="ellipse">
-            <a:avLst/>
-          </a:prstGeom>
-          <a:solidFill>
-            <a:srgbClr val="1F4E3D"/>
-          </a:solidFill>
-          <a:ln>
-            <a:noFill/>
-          </a:ln>
-          <a:effectLst/>
-        </p:spPr>
-        <p:style>
-          <a:lnRef idx="1">
-            <a:schemeClr val="accent1"/>
-          </a:lnRef>
-          <a:fillRef idx="3">
-            <a:schemeClr val="accent1"/>
-          </a:fillRef>
-          <a:effectRef idx="2">
-            <a:schemeClr val="accent1"/>
-          </a:effectRef>
-          <a:fontRef idx="minor">
-            <a:schemeClr val="lt1"/>
-          </a:fontRef>
-        </p:style>
-        <p:txBody>
-          <a:bodyPr rtlCol="0" anchor="ctr"/>
-          <a:lstStyle/>
-          <a:p>
-            <a:pPr algn="ctr"/>
-          </a:p>
-        </p:txBody>
-      </p:sp>
-      <p:pic>
-        <p:nvPicPr>
-          <p:cNvPr id="36" name="Picture 35" descr="quality_check_w.png"/>
-          <p:cNvPicPr>
-            <a:picLocks noChangeAspect="1"/>
-          </p:cNvPicPr>
-          <p:nvPr/>
-        </p:nvPicPr>
-        <p:blipFill>
-          <a:blip r:embed="rId8">
-            <a:extLst>
-              <a:ext uri="{96DAC541-7B7A-43D3-8B79-37D633B846F1}">
-                <ns6:svgBlip xmlns:ns6="http://schemas.microsoft.com/office/drawing/2016/SVG/main" r:embed="rId16"/>
-              </a:ext>
-            </a:extLst>
-          </a:blip>
-          <a:stretch>
-            <a:fillRect/>
-          </a:stretch>
-        </p:blipFill>
-        <p:spPr>
-          <a:xfrm>
-            <a:off x="2057640" y="4594000"/>
-            <a:ext cx="492000" cy="492000"/>
-          </a:xfrm>
-          <a:prstGeom prst="rect">
-            <a:avLst/>
-          </a:prstGeom>
-        </p:spPr>
-      </p:pic>
-      <p:sp>
-        <p:nvSpPr>
-          <p:cNvPr id="37" name="TextBox 36"/>
-          <p:cNvSpPr txBox="1"/>
-          <p:nvPr/>
-        </p:nvSpPr>
-        <p:spPr>
-          <a:xfrm>
-            <a:off x="668640" y="5310000"/>
-            <a:ext cx="3270000" cy="920000"/>
-          </a:xfrm>
-          <a:prstGeom prst="rect">
-            <a:avLst/>
-          </a:prstGeom>
-          <a:noFill/>
-        </p:spPr>
-        <p:txBody>
-          <a:bodyPr wrap="square" lIns="50000" rIns="50000" tIns="20000" bIns="20000" anchor="t">
-            <a:spAutoFit/>
-          </a:bodyPr>
-          <a:lstStyle/>
-          <a:p>
-            <a:pPr algn="ctr"/>
-            <a:r>
-              <a:rPr sz="2000" b="1" i="0">
-                <a:solidFill>
-                  <a:srgbClr val="1F4E3D"/>
-                </a:solidFill>
-              </a:rPr>
-              <a:t>Kiểm soát chất lượng (KCS)</a:t>
-            </a:r>
-          </a:p>
-        </p:txBody>
-      </p:sp>
-      <p:sp>
-        <p:nvSpPr>
-          <p:cNvPr id="38" name="Rounded Rectangle 37"/>
-          <p:cNvSpPr/>
-          <p:nvPr/>
-        </p:nvSpPr>
-        <p:spPr>
-          <a:xfrm>
-            <a:off x="4338640" y="4200000"/>
-            <a:ext cx="3510000" cy="2100000"/>
-          </a:xfrm>
-          <a:prstGeom prst="roundRect">
-            <a:avLst/>
-          </a:prstGeom>
-          <a:solidFill>
-            <a:srgbClr val="EEF4F0"/>
-          </a:solidFill>
-          <a:ln>
-            <a:noFill/>
-          </a:ln>
-          <a:effectLst/>
-        </p:spPr>
-        <p:style>
-          <a:lnRef idx="1">
-            <a:schemeClr val="accent1"/>
-          </a:lnRef>
-          <a:fillRef idx="3">
-            <a:schemeClr val="accent1"/>
-          </a:fillRef>
-          <a:effectRef idx="2">
-            <a:schemeClr val="accent1"/>
-          </a:effectRef>
-          <a:fontRef idx="minor">
-            <a:schemeClr val="lt1"/>
-          </a:fontRef>
-        </p:style>
-        <p:txBody>
-          <a:bodyPr rtlCol="0" anchor="ctr"/>
-          <a:lstStyle/>
-          <a:p>
-            <a:pPr algn="ctr"/>
-          </a:p>
-        </p:txBody>
-      </p:sp>
-      <p:sp>
-        <p:nvSpPr>
-          <p:cNvPr id="39" name="Rounded Rectangle 38"/>
-          <p:cNvSpPr/>
-          <p:nvPr/>
-        </p:nvSpPr>
-        <p:spPr>
-          <a:xfrm>
-            <a:off x="4338640" y="4200000"/>
-            <a:ext cx="3510000" cy="70000"/>
-          </a:xfrm>
-          <a:prstGeom prst="roundRect">
-            <a:avLst/>
-          </a:prstGeom>
-          <a:solidFill>
-            <a:srgbClr val="2C7A5A"/>
-          </a:solidFill>
-          <a:ln>
-            <a:noFill/>
-          </a:ln>
-          <a:effectLst/>
-        </p:spPr>
-        <p:style>
-          <a:lnRef idx="1">
-            <a:schemeClr val="accent1"/>
-          </a:lnRef>
-          <a:fillRef idx="3">
-            <a:schemeClr val="accent1"/>
-          </a:fillRef>
-          <a:effectRef idx="2">
-            <a:schemeClr val="accent1"/>
-          </a:effectRef>
-          <a:fontRef idx="minor">
-            <a:schemeClr val="lt1"/>
-          </a:fontRef>
-        </p:style>
-        <p:txBody>
-          <a:bodyPr rtlCol="0" anchor="ctr"/>
-          <a:lstStyle/>
-          <a:p>
-            <a:pPr algn="ctr"/>
-          </a:p>
-        </p:txBody>
-      </p:sp>
-      <p:sp>
-        <p:nvSpPr>
-          <p:cNvPr id="40" name="Oval 39"/>
-          <p:cNvSpPr/>
-          <p:nvPr/>
-        </p:nvSpPr>
-        <p:spPr>
-          <a:xfrm>
-            <a:off x="5683640" y="4430000"/>
-            <a:ext cx="820000" cy="820000"/>
-          </a:xfrm>
-          <a:prstGeom prst="ellipse">
-            <a:avLst/>
-          </a:prstGeom>
-          <a:solidFill>
-            <a:srgbClr val="1F4E3D"/>
-          </a:solidFill>
-          <a:ln>
-            <a:noFill/>
-          </a:ln>
-          <a:effectLst/>
-        </p:spPr>
-        <p:style>
-          <a:lnRef idx="1">
-            <a:schemeClr val="accent1"/>
-          </a:lnRef>
-          <a:fillRef idx="3">
-            <a:schemeClr val="accent1"/>
-          </a:fillRef>
-          <a:effectRef idx="2">
-            <a:schemeClr val="accent1"/>
-          </a:effectRef>
-          <a:fontRef idx="minor">
-            <a:schemeClr val="lt1"/>
-          </a:fontRef>
-        </p:style>
-        <p:txBody>
-          <a:bodyPr rtlCol="0" anchor="ctr"/>
-          <a:lstStyle/>
-          <a:p>
-            <a:pPr algn="ctr"/>
-          </a:p>
-        </p:txBody>
-      </p:sp>
-      <p:pic>
-        <p:nvPicPr>
-          <p:cNvPr id="41" name="Picture 40" descr="warning_tri_w.png"/>
-          <p:cNvPicPr>
-            <a:picLocks noChangeAspect="1"/>
-          </p:cNvPicPr>
-          <p:nvPr/>
-        </p:nvPicPr>
-        <p:blipFill>
-          <a:blip r:embed="rId9">
-            <a:extLst>
-              <a:ext uri="{96DAC541-7B7A-43D3-8B79-37D633B846F1}">
-                <ns7:svgBlip xmlns:ns7="http://schemas.microsoft.com/office/drawing/2016/SVG/main" r:embed="rId19"/>
-              </a:ext>
-            </a:extLst>
-          </a:blip>
-          <a:stretch>
-            <a:fillRect/>
-          </a:stretch>
-        </p:blipFill>
-        <p:spPr>
-          <a:xfrm>
-            <a:off x="5847640" y="4594000"/>
-            <a:ext cx="492000" cy="492000"/>
-          </a:xfrm>
-          <a:prstGeom prst="rect">
-            <a:avLst/>
-          </a:prstGeom>
-        </p:spPr>
-      </p:pic>
-      <p:sp>
-        <p:nvSpPr>
-          <p:cNvPr id="42" name="TextBox 41"/>
-          <p:cNvSpPr txBox="1"/>
-          <p:nvPr/>
-        </p:nvSpPr>
-        <p:spPr>
-          <a:xfrm>
-            <a:off x="4458640" y="5310000"/>
-            <a:ext cx="3270000" cy="920000"/>
-          </a:xfrm>
-          <a:prstGeom prst="rect">
-            <a:avLst/>
-          </a:prstGeom>
-          <a:noFill/>
-        </p:spPr>
-        <p:txBody>
-          <a:bodyPr wrap="square" lIns="50000" rIns="50000" tIns="20000" bIns="20000" anchor="t">
-            <a:spAutoFit/>
-          </a:bodyPr>
-          <a:lstStyle/>
-          <a:p>
-            <a:pPr algn="ctr"/>
-            <a:r>
-              <a:rPr sz="2000" b="1" i="0">
-                <a:solidFill>
-                  <a:srgbClr val="1F4E3D"/>
-                </a:solidFill>
-              </a:rPr>
-              <a:t>Những sự cố thường gặp</a:t>
-            </a:r>
-          </a:p>
-        </p:txBody>
-      </p:sp>
-      <p:sp>
-        <p:nvSpPr>
-          <p:cNvPr id="43" name="Rounded Rectangle 42"/>
-          <p:cNvSpPr/>
-          <p:nvPr/>
-        </p:nvSpPr>
-        <p:spPr>
-          <a:xfrm>
-            <a:off x="8128640" y="4200000"/>
-            <a:ext cx="3510000" cy="2100000"/>
-          </a:xfrm>
-          <a:prstGeom prst="roundRect">
-            <a:avLst/>
-          </a:prstGeom>
-          <a:solidFill>
-            <a:srgbClr val="EEF4F0"/>
-          </a:solidFill>
-          <a:ln>
-            <a:noFill/>
-          </a:ln>
-          <a:effectLst/>
-        </p:spPr>
-        <p:style>
-          <a:lnRef idx="1">
-            <a:schemeClr val="accent1"/>
-          </a:lnRef>
-          <a:fillRef idx="3">
-            <a:schemeClr val="accent1"/>
-          </a:fillRef>
-          <a:effectRef idx="2">
-            <a:schemeClr val="accent1"/>
-          </a:effectRef>
-          <a:fontRef idx="minor">
-            <a:schemeClr val="lt1"/>
-          </a:fontRef>
-        </p:style>
-        <p:txBody>
-          <a:bodyPr rtlCol="0" anchor="ctr"/>
-          <a:lstStyle/>
-          <a:p>
-            <a:pPr algn="ctr"/>
-          </a:p>
-        </p:txBody>
-      </p:sp>
-      <p:sp>
-        <p:nvSpPr>
-          <p:cNvPr id="44" name="Rounded Rectangle 43"/>
-          <p:cNvSpPr/>
-          <p:nvPr/>
-        </p:nvSpPr>
-        <p:spPr>
-          <a:xfrm>
-            <a:off x="8128640" y="4200000"/>
-            <a:ext cx="3510000" cy="70000"/>
-          </a:xfrm>
-          <a:prstGeom prst="roundRect">
-            <a:avLst/>
-          </a:prstGeom>
-          <a:solidFill>
-            <a:srgbClr val="2C7A5A"/>
-          </a:solidFill>
-          <a:ln>
-            <a:noFill/>
-          </a:ln>
-          <a:effectLst/>
-        </p:spPr>
-        <p:style>
-          <a:lnRef idx="1">
-            <a:schemeClr val="accent1"/>
-          </a:lnRef>
-          <a:fillRef idx="3">
-            <a:schemeClr val="accent1"/>
-          </a:fillRef>
-          <a:effectRef idx="2">
-            <a:schemeClr val="accent1"/>
-          </a:effectRef>
-          <a:fontRef idx="minor">
-            <a:schemeClr val="lt1"/>
-          </a:fontRef>
-        </p:style>
-        <p:txBody>
-          <a:bodyPr rtlCol="0" anchor="ctr"/>
-          <a:lstStyle/>
-          <a:p>
-            <a:pPr algn="ctr"/>
-          </a:p>
-        </p:txBody>
-      </p:sp>
-      <p:sp>
-        <p:nvSpPr>
-          <p:cNvPr id="45" name="Oval 44"/>
-          <p:cNvSpPr/>
-          <p:nvPr/>
-        </p:nvSpPr>
-        <p:spPr>
-          <a:xfrm>
-            <a:off x="9473640" y="4430000"/>
-            <a:ext cx="820000" cy="820000"/>
-          </a:xfrm>
-          <a:prstGeom prst="ellipse">
-            <a:avLst/>
-          </a:prstGeom>
-          <a:solidFill>
-            <a:srgbClr val="1F4E3D"/>
-          </a:solidFill>
-          <a:ln>
-            <a:noFill/>
-          </a:ln>
-          <a:effectLst/>
-        </p:spPr>
-        <p:style>
-          <a:lnRef idx="1">
-            <a:schemeClr val="accent1"/>
-          </a:lnRef>
-          <a:fillRef idx="3">
-            <a:schemeClr val="accent1"/>
-          </a:fillRef>
-          <a:effectRef idx="2">
-            <a:schemeClr val="accent1"/>
-          </a:effectRef>
-          <a:fontRef idx="minor">
-            <a:schemeClr val="lt1"/>
-          </a:fontRef>
-        </p:style>
-        <p:txBody>
-          <a:bodyPr rtlCol="0" anchor="ctr"/>
-          <a:lstStyle/>
-          <a:p>
-            <a:pPr algn="ctr"/>
-          </a:p>
-        </p:txBody>
-      </p:sp>
-      <p:pic>
-        <p:nvPicPr>
-          <p:cNvPr id="46" name="Picture 45" descr="safety_shield_w.png"/>
-          <p:cNvPicPr>
-            <a:picLocks noChangeAspect="1"/>
-          </p:cNvPicPr>
-          <p:nvPr/>
-        </p:nvPicPr>
-        <p:blipFill>
-          <a:blip r:embed="rId10">
-            <a:extLst>
-              <a:ext uri="{96DAC541-7B7A-43D3-8B79-37D633B846F1}">
-                <ns8:svgBlip xmlns:ns8="http://schemas.microsoft.com/office/drawing/2016/SVG/main" r:embed="rId17"/>
-              </a:ext>
-            </a:extLst>
-          </a:blip>
-          <a:stretch>
-            <a:fillRect/>
-          </a:stretch>
-        </p:blipFill>
-        <p:spPr>
-          <a:xfrm>
-            <a:off x="9637640" y="4594000"/>
-            <a:ext cx="492000" cy="492000"/>
-          </a:xfrm>
-          <a:prstGeom prst="rect">
-            <a:avLst/>
-          </a:prstGeom>
-        </p:spPr>
-      </p:pic>
-      <p:sp>
-        <p:nvSpPr>
-          <p:cNvPr id="47" name="TextBox 46"/>
-          <p:cNvSpPr txBox="1"/>
-          <p:nvPr/>
-        </p:nvSpPr>
-        <p:spPr>
-          <a:xfrm>
-            <a:off x="8248640" y="5310000"/>
-            <a:ext cx="3270000" cy="920000"/>
-          </a:xfrm>
-          <a:prstGeom prst="rect">
-            <a:avLst/>
-          </a:prstGeom>
-          <a:noFill/>
-        </p:spPr>
-        <p:txBody>
-          <a:bodyPr wrap="square" lIns="50000" rIns="50000" tIns="20000" bIns="20000" anchor="t">
-            <a:spAutoFit/>
-          </a:bodyPr>
-          <a:lstStyle/>
-          <a:p>
-            <a:pPr algn="ctr"/>
-            <a:r>
-              <a:rPr sz="2000" b="1" i="0">
-                <a:solidFill>
-                  <a:srgbClr val="1F4E3D"/>
-                </a:solidFill>
-              </a:rPr>
-              <a:t>An toàn lao động &amp; môi trường</a:t>
-            </a:r>
-          </a:p>
-        </p:txBody>
-      </p:sp>
     </p:spTree>
   </p:cSld>
   <p:clrMapOvr>

</xml_diff>